<commit_message>
design: template styles use three content sizes (trick 17)
Each gallery template now defines its content sizes in its own layouts:
display 60 for KPI values, body 20 for every other content text (card
headings, labels, quotes, markers, decisions) and the title size, plus a
108 pt hero display. The renderer reads them from the built layouts and
scales them per type step. Rebuilt all seven templates; this also syncs
the default card padding (14 pt) in the editing geometry.
</commit_message>
<xml_diff>
--- a/design/templates/facet-dark/template.pptx
+++ b/design/templates/facet-dark/template.pptx
@@ -826,7 +826,7 @@
           <a:bodyPr/>
           <a:lstStyle/>
           <a:p>
-            <a:fld id="{74813003-FBAE-4237-BD99-D6E83252122A}" type="datetimeFigureOut">
+            <a:fld id="{26B7F381-F10E-4587-B886-8036B7268BA3}" type="datetimeFigureOut">
               <a:rPr lang="en-US" smtClean="0"/>
               <a:t>10/3/2026</a:t>
             </a:fld>
@@ -868,7 +868,7 @@
           <a:bodyPr/>
           <a:lstStyle/>
           <a:p>
-            <a:fld id="{BEFED7E7-52D0-4F8A-AF4C-DA16AD6E5F6D}" type="slidenum">
+            <a:fld id="{C8D4D1C8-8C5D-4FFA-950C-FD08A0718FA9}" type="slidenum">
               <a:rPr lang="en-US" smtClean="0"/>
               <a:t>‹#›</a:t>
             </a:fld>
@@ -879,7 +879,7 @@
     </p:spTree>
     <p:extLst>
       <p:ext uri="{BB962C8B-B14F-4D97-AF65-F5344CB8AC3E}">
-        <p14:creationId xmlns:p14="http://schemas.microsoft.com/office/powerpoint/2010/main" val="3897660845"/>
+        <p14:creationId xmlns:p14="http://schemas.microsoft.com/office/powerpoint/2010/main" val="1183391218"/>
       </p:ext>
     </p:extLst>
   </p:cSld>
@@ -953,7 +953,7 @@
           <a:bodyPr/>
           <a:lstStyle/>
           <a:p>
-            <a:fld id="{74813003-FBAE-4237-BD99-D6E83252122A}" type="datetimeFigureOut">
+            <a:fld id="{26B7F381-F10E-4587-B886-8036B7268BA3}" type="datetimeFigureOut">
               <a:rPr lang="en-US" smtClean="0"/>
               <a:t>10/3/2026</a:t>
             </a:fld>
@@ -995,7 +995,7 @@
           <a:bodyPr/>
           <a:lstStyle/>
           <a:p>
-            <a:fld id="{BEFED7E7-52D0-4F8A-AF4C-DA16AD6E5F6D}" type="slidenum">
+            <a:fld id="{C8D4D1C8-8C5D-4FFA-950C-FD08A0718FA9}" type="slidenum">
               <a:rPr lang="en-US" smtClean="0"/>
               <a:t>‹#›</a:t>
             </a:fld>
@@ -1008,7 +1008,7 @@
           <p:cNvPr id="6" name="body">
             <a:extLst>
               <a:ext uri="{FF2B5EF4-FFF2-40B4-BE49-F238E27FC236}">
-                <a16:creationId xmlns:a16="http://schemas.microsoft.com/office/drawing/2014/main" id="{F607CA6E-94F2-0320-FABD-591B14F49D7D}"/>
+                <a16:creationId xmlns:a16="http://schemas.microsoft.com/office/drawing/2014/main" id="{9C9EC024-062E-D56C-5295-14A2C28735A7}"/>
               </a:ext>
             </a:extLst>
           </p:cNvPr>
@@ -1048,7 +1048,7 @@
           <p:cNvPr id="7" name="source">
             <a:extLst>
               <a:ext uri="{FF2B5EF4-FFF2-40B4-BE49-F238E27FC236}">
-                <a16:creationId xmlns:a16="http://schemas.microsoft.com/office/drawing/2014/main" id="{004C1B89-B380-2EB8-64CA-F079B441A85C}"/>
+                <a16:creationId xmlns:a16="http://schemas.microsoft.com/office/drawing/2014/main" id="{B882BDD1-7279-01EB-B01F-4F26D7CDBF2B}"/>
               </a:ext>
             </a:extLst>
           </p:cNvPr>
@@ -1103,7 +1103,7 @@
     </p:spTree>
     <p:extLst>
       <p:ext uri="{BB962C8B-B14F-4D97-AF65-F5344CB8AC3E}">
-        <p14:creationId xmlns:p14="http://schemas.microsoft.com/office/powerpoint/2010/main" val="3706026239"/>
+        <p14:creationId xmlns:p14="http://schemas.microsoft.com/office/powerpoint/2010/main" val="4262518983"/>
       </p:ext>
     </p:extLst>
   </p:cSld>
@@ -1177,7 +1177,7 @@
           <a:bodyPr/>
           <a:lstStyle/>
           <a:p>
-            <a:fld id="{74813003-FBAE-4237-BD99-D6E83252122A}" type="datetimeFigureOut">
+            <a:fld id="{26B7F381-F10E-4587-B886-8036B7268BA3}" type="datetimeFigureOut">
               <a:rPr lang="en-US" smtClean="0"/>
               <a:t>10/3/2026</a:t>
             </a:fld>
@@ -1219,7 +1219,7 @@
           <a:bodyPr/>
           <a:lstStyle/>
           <a:p>
-            <a:fld id="{BEFED7E7-52D0-4F8A-AF4C-DA16AD6E5F6D}" type="slidenum">
+            <a:fld id="{C8D4D1C8-8C5D-4FFA-950C-FD08A0718FA9}" type="slidenum">
               <a:rPr lang="en-US" smtClean="0"/>
               <a:t>‹#›</a:t>
             </a:fld>
@@ -1232,7 +1232,7 @@
           <p:cNvPr id="6" name="body">
             <a:extLst>
               <a:ext uri="{FF2B5EF4-FFF2-40B4-BE49-F238E27FC236}">
-                <a16:creationId xmlns:a16="http://schemas.microsoft.com/office/drawing/2014/main" id="{EABC30AE-DF0B-2FFA-3983-0A4F8E3F0DB4}"/>
+                <a16:creationId xmlns:a16="http://schemas.microsoft.com/office/drawing/2014/main" id="{B7A1DA59-320F-B5AA-B3F4-7B9C78FB5B36}"/>
               </a:ext>
             </a:extLst>
           </p:cNvPr>
@@ -1275,7 +1275,7 @@
     </p:spTree>
     <p:extLst>
       <p:ext uri="{BB962C8B-B14F-4D97-AF65-F5344CB8AC3E}">
-        <p14:creationId xmlns:p14="http://schemas.microsoft.com/office/powerpoint/2010/main" val="1407380357"/>
+        <p14:creationId xmlns:p14="http://schemas.microsoft.com/office/powerpoint/2010/main" val="2746796488"/>
       </p:ext>
     </p:extLst>
   </p:cSld>
@@ -1351,7 +1351,7 @@
           <p:cNvPr id="6" name="section_number">
             <a:extLst>
               <a:ext uri="{FF2B5EF4-FFF2-40B4-BE49-F238E27FC236}">
-                <a16:creationId xmlns:a16="http://schemas.microsoft.com/office/drawing/2014/main" id="{F65BF83B-C170-8DCB-2BD5-643BA88F911B}"/>
+                <a16:creationId xmlns:a16="http://schemas.microsoft.com/office/drawing/2014/main" id="{DF35805A-5A40-8CA5-91C7-CC874ED83579}"/>
               </a:ext>
             </a:extLst>
           </p:cNvPr>
@@ -1404,7 +1404,7 @@
           <p:cNvPr id="7" name="subtitle">
             <a:extLst>
               <a:ext uri="{FF2B5EF4-FFF2-40B4-BE49-F238E27FC236}">
-                <a16:creationId xmlns:a16="http://schemas.microsoft.com/office/drawing/2014/main" id="{C526D05A-52E1-313F-5BE4-78421236B81F}"/>
+                <a16:creationId xmlns:a16="http://schemas.microsoft.com/office/drawing/2014/main" id="{8B999D09-A412-6754-DE86-96ABC9584364}"/>
               </a:ext>
             </a:extLst>
           </p:cNvPr>
@@ -1454,7 +1454,7 @@
     </p:spTree>
     <p:extLst>
       <p:ext uri="{BB962C8B-B14F-4D97-AF65-F5344CB8AC3E}">
-        <p14:creationId xmlns:p14="http://schemas.microsoft.com/office/powerpoint/2010/main" val="2938324963"/>
+        <p14:creationId xmlns:p14="http://schemas.microsoft.com/office/powerpoint/2010/main" val="1049055003"/>
       </p:ext>
     </p:extLst>
   </p:cSld>
@@ -1528,7 +1528,7 @@
           <a:bodyPr/>
           <a:lstStyle/>
           <a:p>
-            <a:fld id="{74813003-FBAE-4237-BD99-D6E83252122A}" type="datetimeFigureOut">
+            <a:fld id="{26B7F381-F10E-4587-B886-8036B7268BA3}" type="datetimeFigureOut">
               <a:rPr lang="en-US" smtClean="0"/>
               <a:t>10/3/2026</a:t>
             </a:fld>
@@ -1570,7 +1570,7 @@
           <a:bodyPr/>
           <a:lstStyle/>
           <a:p>
-            <a:fld id="{BEFED7E7-52D0-4F8A-AF4C-DA16AD6E5F6D}" type="slidenum">
+            <a:fld id="{C8D4D1C8-8C5D-4FFA-950C-FD08A0718FA9}" type="slidenum">
               <a:rPr lang="en-US" smtClean="0"/>
               <a:t>‹#›</a:t>
             </a:fld>
@@ -1583,7 +1583,7 @@
           <p:cNvPr id="6" name="item_1_title">
             <a:extLst>
               <a:ext uri="{FF2B5EF4-FFF2-40B4-BE49-F238E27FC236}">
-                <a16:creationId xmlns:a16="http://schemas.microsoft.com/office/drawing/2014/main" id="{EBA75AC2-FB0F-ECA4-1040-0C0C9394CE4E}"/>
+                <a16:creationId xmlns:a16="http://schemas.microsoft.com/office/drawing/2014/main" id="{099ED3A7-5ED8-0946-16DB-E967C959E47E}"/>
               </a:ext>
             </a:extLst>
           </p:cNvPr>
@@ -1611,7 +1611,7 @@
               </a:spcBef>
               <a:buFontTx/>
               <a:buNone/>
-              <a:defRPr sz="2200" b="1">
+              <a:defRPr sz="2000" b="1">
                 <a:solidFill>
                   <a:schemeClr val="accent1"/>
                 </a:solidFill>
@@ -1633,7 +1633,7 @@
           <p:cNvPr id="7" name="item_1">
             <a:extLst>
               <a:ext uri="{FF2B5EF4-FFF2-40B4-BE49-F238E27FC236}">
-                <a16:creationId xmlns:a16="http://schemas.microsoft.com/office/drawing/2014/main" id="{382E78B7-5F87-E0E7-4AA0-CB3156851A5F}"/>
+                <a16:creationId xmlns:a16="http://schemas.microsoft.com/office/drawing/2014/main" id="{7BF2CCB5-FA95-6CF3-E2BF-9745C7223AEF}"/>
               </a:ext>
             </a:extLst>
           </p:cNvPr>
@@ -1681,7 +1681,7 @@
           <p:cNvPr id="8" name="item_2_title">
             <a:extLst>
               <a:ext uri="{FF2B5EF4-FFF2-40B4-BE49-F238E27FC236}">
-                <a16:creationId xmlns:a16="http://schemas.microsoft.com/office/drawing/2014/main" id="{6B76D110-52B1-860C-4D06-E54C186CA309}"/>
+                <a16:creationId xmlns:a16="http://schemas.microsoft.com/office/drawing/2014/main" id="{653751BA-BC73-5499-CF4C-F8E2035CB522}"/>
               </a:ext>
             </a:extLst>
           </p:cNvPr>
@@ -1712,7 +1712,7 @@
               </a:spcBef>
               <a:buFontTx/>
               <a:buNone/>
-              <a:defRPr sz="2200" b="1">
+              <a:defRPr sz="2000" b="1">
                 <a:solidFill>
                   <a:schemeClr val="accent1"/>
                 </a:solidFill>
@@ -1734,7 +1734,7 @@
           <p:cNvPr id="9" name="item_2">
             <a:extLst>
               <a:ext uri="{FF2B5EF4-FFF2-40B4-BE49-F238E27FC236}">
-                <a16:creationId xmlns:a16="http://schemas.microsoft.com/office/drawing/2014/main" id="{0F45229A-8BF4-CA12-1D36-58AD19BC0AC5}"/>
+                <a16:creationId xmlns:a16="http://schemas.microsoft.com/office/drawing/2014/main" id="{98CCEA9E-ECD6-6834-5C5A-24BC83D9EEDE}"/>
               </a:ext>
             </a:extLst>
           </p:cNvPr>
@@ -1782,7 +1782,7 @@
           <p:cNvPr id="10" name="item_3_title">
             <a:extLst>
               <a:ext uri="{FF2B5EF4-FFF2-40B4-BE49-F238E27FC236}">
-                <a16:creationId xmlns:a16="http://schemas.microsoft.com/office/drawing/2014/main" id="{40D443F4-A7E4-E919-B742-59634171C04B}"/>
+                <a16:creationId xmlns:a16="http://schemas.microsoft.com/office/drawing/2014/main" id="{26D9F120-817E-8864-A7E8-4C2F9F081058}"/>
               </a:ext>
             </a:extLst>
           </p:cNvPr>
@@ -1813,7 +1813,7 @@
               </a:spcBef>
               <a:buFontTx/>
               <a:buNone/>
-              <a:defRPr sz="2200" b="1">
+              <a:defRPr sz="2000" b="1">
                 <a:solidFill>
                   <a:schemeClr val="accent1"/>
                 </a:solidFill>
@@ -1835,7 +1835,7 @@
           <p:cNvPr id="11" name="item_3">
             <a:extLst>
               <a:ext uri="{FF2B5EF4-FFF2-40B4-BE49-F238E27FC236}">
-                <a16:creationId xmlns:a16="http://schemas.microsoft.com/office/drawing/2014/main" id="{3850B5F2-53A8-C415-2417-3000E434F4A3}"/>
+                <a16:creationId xmlns:a16="http://schemas.microsoft.com/office/drawing/2014/main" id="{FEDF8FCE-DD20-8EA3-392E-9C510C5A7B3B}"/>
               </a:ext>
             </a:extLst>
           </p:cNvPr>
@@ -1883,7 +1883,7 @@
           <p:cNvPr id="12" name="item_4_title">
             <a:extLst>
               <a:ext uri="{FF2B5EF4-FFF2-40B4-BE49-F238E27FC236}">
-                <a16:creationId xmlns:a16="http://schemas.microsoft.com/office/drawing/2014/main" id="{1A664599-E787-68A7-F51A-4285BD0796E2}"/>
+                <a16:creationId xmlns:a16="http://schemas.microsoft.com/office/drawing/2014/main" id="{11267FBB-8474-3129-F95C-463DE2970F4E}"/>
               </a:ext>
             </a:extLst>
           </p:cNvPr>
@@ -1914,7 +1914,7 @@
               </a:spcBef>
               <a:buFontTx/>
               <a:buNone/>
-              <a:defRPr sz="2200" b="1">
+              <a:defRPr sz="2000" b="1">
                 <a:solidFill>
                   <a:schemeClr val="accent1"/>
                 </a:solidFill>
@@ -1936,7 +1936,7 @@
           <p:cNvPr id="13" name="item_4">
             <a:extLst>
               <a:ext uri="{FF2B5EF4-FFF2-40B4-BE49-F238E27FC236}">
-                <a16:creationId xmlns:a16="http://schemas.microsoft.com/office/drawing/2014/main" id="{02A4E058-A191-2E10-5ABA-5B49A5C7B31E}"/>
+                <a16:creationId xmlns:a16="http://schemas.microsoft.com/office/drawing/2014/main" id="{E691977C-9DCE-D016-DFB1-B0D5EF715562}"/>
               </a:ext>
             </a:extLst>
           </p:cNvPr>
@@ -1984,7 +1984,7 @@
           <p:cNvPr id="14" name="source">
             <a:extLst>
               <a:ext uri="{FF2B5EF4-FFF2-40B4-BE49-F238E27FC236}">
-                <a16:creationId xmlns:a16="http://schemas.microsoft.com/office/drawing/2014/main" id="{98B142BD-7C81-32FB-984E-64422A395A39}"/>
+                <a16:creationId xmlns:a16="http://schemas.microsoft.com/office/drawing/2014/main" id="{2E47E91C-AF4F-0B99-D888-09BEDFF83C98}"/>
               </a:ext>
             </a:extLst>
           </p:cNvPr>
@@ -2039,7 +2039,7 @@
     </p:spTree>
     <p:extLst>
       <p:ext uri="{BB962C8B-B14F-4D97-AF65-F5344CB8AC3E}">
-        <p14:creationId xmlns:p14="http://schemas.microsoft.com/office/powerpoint/2010/main" val="3983987772"/>
+        <p14:creationId xmlns:p14="http://schemas.microsoft.com/office/powerpoint/2010/main" val="3066513673"/>
       </p:ext>
     </p:extLst>
   </p:cSld>
@@ -2113,7 +2113,7 @@
           <a:bodyPr/>
           <a:lstStyle/>
           <a:p>
-            <a:fld id="{74813003-FBAE-4237-BD99-D6E83252122A}" type="datetimeFigureOut">
+            <a:fld id="{26B7F381-F10E-4587-B886-8036B7268BA3}" type="datetimeFigureOut">
               <a:rPr lang="en-US" smtClean="0"/>
               <a:t>10/3/2026</a:t>
             </a:fld>
@@ -2155,7 +2155,7 @@
           <a:bodyPr/>
           <a:lstStyle/>
           <a:p>
-            <a:fld id="{BEFED7E7-52D0-4F8A-AF4C-DA16AD6E5F6D}" type="slidenum">
+            <a:fld id="{C8D4D1C8-8C5D-4FFA-950C-FD08A0718FA9}" type="slidenum">
               <a:rPr lang="en-US" smtClean="0"/>
               <a:t>‹#›</a:t>
             </a:fld>
@@ -2168,7 +2168,7 @@
           <p:cNvPr id="6" name="body">
             <a:extLst>
               <a:ext uri="{FF2B5EF4-FFF2-40B4-BE49-F238E27FC236}">
-                <a16:creationId xmlns:a16="http://schemas.microsoft.com/office/drawing/2014/main" id="{2F8F0E78-2674-A930-9143-0086C13CD886}"/>
+                <a16:creationId xmlns:a16="http://schemas.microsoft.com/office/drawing/2014/main" id="{86BBE796-5FA3-C998-4156-464C4EC0307D}"/>
               </a:ext>
             </a:extLst>
           </p:cNvPr>
@@ -2213,7 +2213,7 @@
           <p:cNvPr id="7" name="source">
             <a:extLst>
               <a:ext uri="{FF2B5EF4-FFF2-40B4-BE49-F238E27FC236}">
-                <a16:creationId xmlns:a16="http://schemas.microsoft.com/office/drawing/2014/main" id="{6B1A7DF2-DF5E-D300-9954-5757C18E6282}"/>
+                <a16:creationId xmlns:a16="http://schemas.microsoft.com/office/drawing/2014/main" id="{33A3DE09-AAEA-4FDA-35F6-9EED03596787}"/>
               </a:ext>
             </a:extLst>
           </p:cNvPr>
@@ -2268,7 +2268,7 @@
     </p:spTree>
     <p:extLst>
       <p:ext uri="{BB962C8B-B14F-4D97-AF65-F5344CB8AC3E}">
-        <p14:creationId xmlns:p14="http://schemas.microsoft.com/office/powerpoint/2010/main" val="1552768939"/>
+        <p14:creationId xmlns:p14="http://schemas.microsoft.com/office/powerpoint/2010/main" val="813020238"/>
       </p:ext>
     </p:extLst>
   </p:cSld>
@@ -2342,7 +2342,7 @@
           <a:bodyPr/>
           <a:lstStyle/>
           <a:p>
-            <a:fld id="{74813003-FBAE-4237-BD99-D6E83252122A}" type="datetimeFigureOut">
+            <a:fld id="{26B7F381-F10E-4587-B886-8036B7268BA3}" type="datetimeFigureOut">
               <a:rPr lang="en-US" smtClean="0"/>
               <a:t>10/3/2026</a:t>
             </a:fld>
@@ -2384,7 +2384,7 @@
           <a:bodyPr/>
           <a:lstStyle/>
           <a:p>
-            <a:fld id="{BEFED7E7-52D0-4F8A-AF4C-DA16AD6E5F6D}" type="slidenum">
+            <a:fld id="{C8D4D1C8-8C5D-4FFA-950C-FD08A0718FA9}" type="slidenum">
               <a:rPr lang="en-US" smtClean="0"/>
               <a:t>‹#›</a:t>
             </a:fld>
@@ -2397,7 +2397,7 @@
           <p:cNvPr id="6" name="item_1_title">
             <a:extLst>
               <a:ext uri="{FF2B5EF4-FFF2-40B4-BE49-F238E27FC236}">
-                <a16:creationId xmlns:a16="http://schemas.microsoft.com/office/drawing/2014/main" id="{85D17D49-9553-788B-95DC-BEE0C52975BE}"/>
+                <a16:creationId xmlns:a16="http://schemas.microsoft.com/office/drawing/2014/main" id="{CB82C127-10AC-A4C9-19B9-C2B7C35123F5}"/>
               </a:ext>
             </a:extLst>
           </p:cNvPr>
@@ -2410,8 +2410,8 @@
         </p:nvSpPr>
         <p:spPr>
           <a:xfrm>
-            <a:off x="853677" y="2364972"/>
-            <a:ext cx="3857479" cy="356920"/>
+            <a:off x="831634" y="2339424"/>
+            <a:ext cx="3901565" cy="371948"/>
           </a:xfrm>
         </p:spPr>
         <p:txBody>
@@ -2425,7 +2425,7 @@
               </a:spcBef>
               <a:buFontTx/>
               <a:buNone/>
-              <a:defRPr sz="2200" b="1">
+              <a:defRPr sz="2000" b="1">
                 <a:solidFill>
                   <a:schemeClr val="accent1"/>
                 </a:solidFill>
@@ -2447,7 +2447,7 @@
           <p:cNvPr id="7" name="item_1">
             <a:extLst>
               <a:ext uri="{FF2B5EF4-FFF2-40B4-BE49-F238E27FC236}">
-                <a16:creationId xmlns:a16="http://schemas.microsoft.com/office/drawing/2014/main" id="{493E70DC-AEEC-5944-F512-840B026453D4}"/>
+                <a16:creationId xmlns:a16="http://schemas.microsoft.com/office/drawing/2014/main" id="{C70BDAE8-EC80-5F04-DE55-AB38E56EC288}"/>
               </a:ext>
             </a:extLst>
           </p:cNvPr>
@@ -2460,8 +2460,8 @@
         </p:nvSpPr>
         <p:spPr>
           <a:xfrm>
-            <a:off x="853677" y="2721892"/>
-            <a:ext cx="3857479" cy="856608"/>
+            <a:off x="831634" y="2711373"/>
+            <a:ext cx="3901565" cy="892675"/>
           </a:xfrm>
           <a:prstGeom prst="rect">
             <a:avLst/>
@@ -2495,7 +2495,7 @@
           <p:cNvPr id="8" name="item_2_title">
             <a:extLst>
               <a:ext uri="{FF2B5EF4-FFF2-40B4-BE49-F238E27FC236}">
-                <a16:creationId xmlns:a16="http://schemas.microsoft.com/office/drawing/2014/main" id="{BB3B91B7-EF8B-66AE-26A2-BE1A3EA82C2A}"/>
+                <a16:creationId xmlns:a16="http://schemas.microsoft.com/office/drawing/2014/main" id="{435E9CBC-D7AD-FCAB-53FF-B7A49FD2CCD1}"/>
               </a:ext>
             </a:extLst>
           </p:cNvPr>
@@ -2508,8 +2508,8 @@
         </p:nvSpPr>
         <p:spPr>
           <a:xfrm>
-            <a:off x="5240182" y="2364972"/>
-            <a:ext cx="3857479" cy="356920"/>
+            <a:off x="5218139" y="2339424"/>
+            <a:ext cx="3901565" cy="371948"/>
           </a:xfrm>
           <a:prstGeom prst="rect">
             <a:avLst/>
@@ -2526,7 +2526,7 @@
               </a:spcBef>
               <a:buFontTx/>
               <a:buNone/>
-              <a:defRPr sz="2200" b="1">
+              <a:defRPr sz="2000" b="1">
                 <a:solidFill>
                   <a:schemeClr val="accent1"/>
                 </a:solidFill>
@@ -2548,7 +2548,7 @@
           <p:cNvPr id="9" name="item_2">
             <a:extLst>
               <a:ext uri="{FF2B5EF4-FFF2-40B4-BE49-F238E27FC236}">
-                <a16:creationId xmlns:a16="http://schemas.microsoft.com/office/drawing/2014/main" id="{6936C320-66F4-A412-E777-D800C0B9F067}"/>
+                <a16:creationId xmlns:a16="http://schemas.microsoft.com/office/drawing/2014/main" id="{822E5604-47B1-CFB4-5A10-5902B5D4D29F}"/>
               </a:ext>
             </a:extLst>
           </p:cNvPr>
@@ -2561,8 +2561,8 @@
         </p:nvSpPr>
         <p:spPr>
           <a:xfrm>
-            <a:off x="5240182" y="2721892"/>
-            <a:ext cx="3857479" cy="856608"/>
+            <a:off x="5218139" y="2711373"/>
+            <a:ext cx="3901565" cy="892675"/>
           </a:xfrm>
           <a:prstGeom prst="rect">
             <a:avLst/>
@@ -2596,7 +2596,7 @@
           <p:cNvPr id="10" name="item_3_title">
             <a:extLst>
               <a:ext uri="{FF2B5EF4-FFF2-40B4-BE49-F238E27FC236}">
-                <a16:creationId xmlns:a16="http://schemas.microsoft.com/office/drawing/2014/main" id="{778E1760-1C8E-4A9B-19C5-CA4F9F611484}"/>
+                <a16:creationId xmlns:a16="http://schemas.microsoft.com/office/drawing/2014/main" id="{8D02C104-F8F3-853B-EA21-CF4376694627}"/>
               </a:ext>
             </a:extLst>
           </p:cNvPr>
@@ -2609,8 +2609,8 @@
         </p:nvSpPr>
         <p:spPr>
           <a:xfrm>
-            <a:off x="853677" y="4191650"/>
-            <a:ext cx="3857479" cy="356920"/>
+            <a:off x="831634" y="4166103"/>
+            <a:ext cx="3901565" cy="371948"/>
           </a:xfrm>
           <a:prstGeom prst="rect">
             <a:avLst/>
@@ -2627,7 +2627,7 @@
               </a:spcBef>
               <a:buFontTx/>
               <a:buNone/>
-              <a:defRPr sz="2200" b="1">
+              <a:defRPr sz="2000" b="1">
                 <a:solidFill>
                   <a:schemeClr val="accent1"/>
                 </a:solidFill>
@@ -2649,7 +2649,7 @@
           <p:cNvPr id="11" name="item_3">
             <a:extLst>
               <a:ext uri="{FF2B5EF4-FFF2-40B4-BE49-F238E27FC236}">
-                <a16:creationId xmlns:a16="http://schemas.microsoft.com/office/drawing/2014/main" id="{28147270-1241-C56C-9EBD-4BC333D8E740}"/>
+                <a16:creationId xmlns:a16="http://schemas.microsoft.com/office/drawing/2014/main" id="{F01602EE-50BE-9113-FE96-97D391CC3D15}"/>
               </a:ext>
             </a:extLst>
           </p:cNvPr>
@@ -2662,8 +2662,8 @@
         </p:nvSpPr>
         <p:spPr>
           <a:xfrm>
-            <a:off x="853677" y="4548570"/>
-            <a:ext cx="3857479" cy="856608"/>
+            <a:off x="831634" y="4538052"/>
+            <a:ext cx="3901565" cy="892675"/>
           </a:xfrm>
           <a:prstGeom prst="rect">
             <a:avLst/>
@@ -2697,7 +2697,7 @@
           <p:cNvPr id="12" name="item_4_title">
             <a:extLst>
               <a:ext uri="{FF2B5EF4-FFF2-40B4-BE49-F238E27FC236}">
-                <a16:creationId xmlns:a16="http://schemas.microsoft.com/office/drawing/2014/main" id="{9D30C242-BACA-D1E7-902C-F44F93AADD12}"/>
+                <a16:creationId xmlns:a16="http://schemas.microsoft.com/office/drawing/2014/main" id="{7328D983-2942-34F2-937F-EA0A9840EFCB}"/>
               </a:ext>
             </a:extLst>
           </p:cNvPr>
@@ -2710,8 +2710,8 @@
         </p:nvSpPr>
         <p:spPr>
           <a:xfrm>
-            <a:off x="5240182" y="4191650"/>
-            <a:ext cx="3857479" cy="356920"/>
+            <a:off x="5218139" y="4166103"/>
+            <a:ext cx="3901565" cy="371948"/>
           </a:xfrm>
           <a:prstGeom prst="rect">
             <a:avLst/>
@@ -2728,7 +2728,7 @@
               </a:spcBef>
               <a:buFontTx/>
               <a:buNone/>
-              <a:defRPr sz="2200" b="1">
+              <a:defRPr sz="2000" b="1">
                 <a:solidFill>
                   <a:schemeClr val="accent1"/>
                 </a:solidFill>
@@ -2750,7 +2750,7 @@
           <p:cNvPr id="13" name="item_4">
             <a:extLst>
               <a:ext uri="{FF2B5EF4-FFF2-40B4-BE49-F238E27FC236}">
-                <a16:creationId xmlns:a16="http://schemas.microsoft.com/office/drawing/2014/main" id="{39709595-4160-10A5-2AE1-A9A6CEB0D868}"/>
+                <a16:creationId xmlns:a16="http://schemas.microsoft.com/office/drawing/2014/main" id="{1AC3810F-F6DB-189A-DDB8-4C5C03D208FF}"/>
               </a:ext>
             </a:extLst>
           </p:cNvPr>
@@ -2763,8 +2763,8 @@
         </p:nvSpPr>
         <p:spPr>
           <a:xfrm>
-            <a:off x="5240182" y="4548570"/>
-            <a:ext cx="3857479" cy="856608"/>
+            <a:off x="5218139" y="4538052"/>
+            <a:ext cx="3901565" cy="892675"/>
           </a:xfrm>
           <a:prstGeom prst="rect">
             <a:avLst/>
@@ -2798,7 +2798,7 @@
           <p:cNvPr id="14" name="source">
             <a:extLst>
               <a:ext uri="{FF2B5EF4-FFF2-40B4-BE49-F238E27FC236}">
-                <a16:creationId xmlns:a16="http://schemas.microsoft.com/office/drawing/2014/main" id="{B5F618CB-5157-5C59-B4FD-F6582345DE3F}"/>
+                <a16:creationId xmlns:a16="http://schemas.microsoft.com/office/drawing/2014/main" id="{74F0914E-E37C-C396-BD1E-27245BB29D40}"/>
               </a:ext>
             </a:extLst>
           </p:cNvPr>
@@ -2853,7 +2853,7 @@
     </p:spTree>
     <p:extLst>
       <p:ext uri="{BB962C8B-B14F-4D97-AF65-F5344CB8AC3E}">
-        <p14:creationId xmlns:p14="http://schemas.microsoft.com/office/powerpoint/2010/main" val="10855702"/>
+        <p14:creationId xmlns:p14="http://schemas.microsoft.com/office/powerpoint/2010/main" val="1059659461"/>
       </p:ext>
     </p:extLst>
   </p:cSld>
@@ -2927,7 +2927,7 @@
           <a:bodyPr/>
           <a:lstStyle/>
           <a:p>
-            <a:fld id="{74813003-FBAE-4237-BD99-D6E83252122A}" type="datetimeFigureOut">
+            <a:fld id="{26B7F381-F10E-4587-B886-8036B7268BA3}" type="datetimeFigureOut">
               <a:rPr lang="en-US" smtClean="0"/>
               <a:t>10/3/2026</a:t>
             </a:fld>
@@ -2969,7 +2969,7 @@
           <a:bodyPr/>
           <a:lstStyle/>
           <a:p>
-            <a:fld id="{BEFED7E7-52D0-4F8A-AF4C-DA16AD6E5F6D}" type="slidenum">
+            <a:fld id="{C8D4D1C8-8C5D-4FFA-950C-FD08A0718FA9}" type="slidenum">
               <a:rPr lang="en-US" smtClean="0"/>
               <a:t>‹#›</a:t>
             </a:fld>
@@ -2982,7 +2982,7 @@
           <p:cNvPr id="6" name="body">
             <a:extLst>
               <a:ext uri="{FF2B5EF4-FFF2-40B4-BE49-F238E27FC236}">
-                <a16:creationId xmlns:a16="http://schemas.microsoft.com/office/drawing/2014/main" id="{7D28D390-EC9B-F235-EFD8-FD01E44CFDBE}"/>
+                <a16:creationId xmlns:a16="http://schemas.microsoft.com/office/drawing/2014/main" id="{5115B060-CB87-46E8-2AA6-E75494D0C70E}"/>
               </a:ext>
             </a:extLst>
           </p:cNvPr>
@@ -3022,7 +3022,7 @@
           <p:cNvPr id="7" name="kpi_value_1">
             <a:extLst>
               <a:ext uri="{FF2B5EF4-FFF2-40B4-BE49-F238E27FC236}">
-                <a16:creationId xmlns:a16="http://schemas.microsoft.com/office/drawing/2014/main" id="{BEB22059-F22E-72C1-B336-C7E169C4B76A}"/>
+                <a16:creationId xmlns:a16="http://schemas.microsoft.com/office/drawing/2014/main" id="{CF55A9CE-6A05-4B6D-3F30-55190D0589CF}"/>
               </a:ext>
             </a:extLst>
           </p:cNvPr>
@@ -3075,7 +3075,7 @@
           <p:cNvPr id="8" name="kpi_label_1">
             <a:extLst>
               <a:ext uri="{FF2B5EF4-FFF2-40B4-BE49-F238E27FC236}">
-                <a16:creationId xmlns:a16="http://schemas.microsoft.com/office/drawing/2014/main" id="{4F550B56-A9A6-02D9-6770-848D3EE4C973}"/>
+                <a16:creationId xmlns:a16="http://schemas.microsoft.com/office/drawing/2014/main" id="{E9392286-B90E-9A2A-C27F-4555D8A76535}"/>
               </a:ext>
             </a:extLst>
           </p:cNvPr>
@@ -3106,7 +3106,7 @@
               </a:spcBef>
               <a:buFontTx/>
               <a:buNone/>
-              <a:defRPr sz="1800"/>
+              <a:defRPr sz="2000"/>
             </a:lvl1pPr>
           </a:lstStyle>
           <a:p>
@@ -3123,7 +3123,7 @@
           <p:cNvPr id="9" name="source">
             <a:extLst>
               <a:ext uri="{FF2B5EF4-FFF2-40B4-BE49-F238E27FC236}">
-                <a16:creationId xmlns:a16="http://schemas.microsoft.com/office/drawing/2014/main" id="{72B168FE-F1B3-7178-BBF9-F425012724A1}"/>
+                <a16:creationId xmlns:a16="http://schemas.microsoft.com/office/drawing/2014/main" id="{D8BDE8C9-6B57-321B-B324-800F3D51B52F}"/>
               </a:ext>
             </a:extLst>
           </p:cNvPr>
@@ -3178,7 +3178,7 @@
     </p:spTree>
     <p:extLst>
       <p:ext uri="{BB962C8B-B14F-4D97-AF65-F5344CB8AC3E}">
-        <p14:creationId xmlns:p14="http://schemas.microsoft.com/office/powerpoint/2010/main" val="2507880583"/>
+        <p14:creationId xmlns:p14="http://schemas.microsoft.com/office/powerpoint/2010/main" val="3570562179"/>
       </p:ext>
     </p:extLst>
   </p:cSld>
@@ -3252,7 +3252,7 @@
           <a:bodyPr/>
           <a:lstStyle/>
           <a:p>
-            <a:fld id="{74813003-FBAE-4237-BD99-D6E83252122A}" type="datetimeFigureOut">
+            <a:fld id="{26B7F381-F10E-4587-B886-8036B7268BA3}" type="datetimeFigureOut">
               <a:rPr lang="en-US" smtClean="0"/>
               <a:t>10/3/2026</a:t>
             </a:fld>
@@ -3294,7 +3294,7 @@
           <a:bodyPr/>
           <a:lstStyle/>
           <a:p>
-            <a:fld id="{BEFED7E7-52D0-4F8A-AF4C-DA16AD6E5F6D}" type="slidenum">
+            <a:fld id="{C8D4D1C8-8C5D-4FFA-950C-FD08A0718FA9}" type="slidenum">
               <a:rPr lang="en-US" smtClean="0"/>
               <a:t>‹#›</a:t>
             </a:fld>
@@ -3307,7 +3307,7 @@
           <p:cNvPr id="6" name="body">
             <a:extLst>
               <a:ext uri="{FF2B5EF4-FFF2-40B4-BE49-F238E27FC236}">
-                <a16:creationId xmlns:a16="http://schemas.microsoft.com/office/drawing/2014/main" id="{0B6FED3C-04D4-2882-187B-5500C283F6E9}"/>
+                <a16:creationId xmlns:a16="http://schemas.microsoft.com/office/drawing/2014/main" id="{4A02F0D3-845A-3B1A-ECF8-96E9BB2A7F9C}"/>
               </a:ext>
             </a:extLst>
           </p:cNvPr>
@@ -3347,7 +3347,7 @@
           <p:cNvPr id="7" name="kpi_value_1">
             <a:extLst>
               <a:ext uri="{FF2B5EF4-FFF2-40B4-BE49-F238E27FC236}">
-                <a16:creationId xmlns:a16="http://schemas.microsoft.com/office/drawing/2014/main" id="{0853CC8B-DB92-4A5A-6DB0-4EAB09EF3B25}"/>
+                <a16:creationId xmlns:a16="http://schemas.microsoft.com/office/drawing/2014/main" id="{B0239973-C0B1-5DC1-2CC8-2039AD9B257A}"/>
               </a:ext>
             </a:extLst>
           </p:cNvPr>
@@ -3360,109 +3360,8 @@
         </p:nvSpPr>
         <p:spPr>
           <a:xfrm>
-            <a:off x="853676" y="2364973"/>
-            <a:ext cx="3945650" cy="1466635"/>
-          </a:xfrm>
-          <a:prstGeom prst="rect">
-            <a:avLst/>
-          </a:prstGeom>
-        </p:spPr>
-        <p:txBody>
-          <a:bodyPr wrap="square" anchor="t">
-            <a:noAutofit/>
-          </a:bodyPr>
-          <a:lstStyle>
-            <a:lvl1pPr marL="0" indent="0">
-              <a:spcBef>
-                <a:spcPts val="0"/>
-              </a:spcBef>
-              <a:buFontTx/>
-              <a:buNone/>
-              <a:defRPr sz="8400" b="1">
-                <a:solidFill>
-                  <a:schemeClr val="accent1"/>
-                </a:solidFill>
-                <a:latin typeface="+mj-lt"/>
-              </a:defRPr>
-            </a:lvl1pPr>
-          </a:lstStyle>
-          <a:p>
-            <a:pPr lvl="0"/>
-            <a:r>
-              <a:rPr lang="en-US"/>
-              <a:t>kpi_value_1</a:t>
-            </a:r>
-          </a:p>
-        </p:txBody>
-      </p:sp>
-      <p:sp>
-        <p:nvSpPr>
-          <p:cNvPr id="8" name="kpi_label_1">
-            <a:extLst>
-              <a:ext uri="{FF2B5EF4-FFF2-40B4-BE49-F238E27FC236}">
-                <a16:creationId xmlns:a16="http://schemas.microsoft.com/office/drawing/2014/main" id="{EBC0D5AC-957A-3735-BFD7-AC586C82FDC2}"/>
-              </a:ext>
-            </a:extLst>
-          </p:cNvPr>
-          <p:cNvSpPr>
-            <a:spLocks noGrp="1"/>
-          </p:cNvSpPr>
-          <p:nvPr>
-            <p:ph type="body" sz="quarter" idx="15" hasCustomPrompt="1"/>
-          </p:nvPr>
-        </p:nvSpPr>
-        <p:spPr>
-          <a:xfrm>
-            <a:off x="853676" y="3831608"/>
-            <a:ext cx="3945650" cy="814797"/>
-          </a:xfrm>
-          <a:prstGeom prst="rect">
-            <a:avLst/>
-          </a:prstGeom>
-        </p:spPr>
-        <p:txBody>
-          <a:bodyPr wrap="square" anchor="t">
-            <a:noAutofit/>
-          </a:bodyPr>
-          <a:lstStyle>
-            <a:lvl1pPr marL="0" indent="0">
-              <a:spcBef>
-                <a:spcPts val="0"/>
-              </a:spcBef>
-              <a:buFontTx/>
-              <a:buNone/>
-              <a:defRPr sz="1800"/>
-            </a:lvl1pPr>
-          </a:lstStyle>
-          <a:p>
-            <a:pPr lvl="0"/>
-            <a:r>
-              <a:rPr lang="en-US"/>
-              <a:t>kpi_label_1</a:t>
-            </a:r>
-          </a:p>
-        </p:txBody>
-      </p:sp>
-      <p:sp>
-        <p:nvSpPr>
-          <p:cNvPr id="9" name="kpi_value_2">
-            <a:extLst>
-              <a:ext uri="{FF2B5EF4-FFF2-40B4-BE49-F238E27FC236}">
-                <a16:creationId xmlns:a16="http://schemas.microsoft.com/office/drawing/2014/main" id="{A02C6EAC-2A00-184F-83D8-4B31DAC66DEB}"/>
-              </a:ext>
-            </a:extLst>
-          </p:cNvPr>
-          <p:cNvSpPr>
-            <a:spLocks noGrp="1"/>
-          </p:cNvSpPr>
-          <p:nvPr>
-            <p:ph type="body" sz="quarter" idx="16" hasCustomPrompt="1"/>
-          </p:nvPr>
-        </p:nvSpPr>
-        <p:spPr>
-          <a:xfrm>
-            <a:off x="5328352" y="2364973"/>
-            <a:ext cx="3769308" cy="536233"/>
+            <a:off x="831633" y="2339424"/>
+            <a:ext cx="3989736" cy="1499482"/>
           </a:xfrm>
           <a:prstGeom prst="rect">
             <a:avLst/>
@@ -3491,31 +3390,31 @@
             <a:pPr lvl="0"/>
             <a:r>
               <a:rPr lang="en-US"/>
-              <a:t>kpi_value_2</a:t>
-            </a:r>
-          </a:p>
-        </p:txBody>
-      </p:sp>
-      <p:sp>
-        <p:nvSpPr>
-          <p:cNvPr id="10" name="kpi_label_2">
-            <a:extLst>
-              <a:ext uri="{FF2B5EF4-FFF2-40B4-BE49-F238E27FC236}">
-                <a16:creationId xmlns:a16="http://schemas.microsoft.com/office/drawing/2014/main" id="{4E350FF9-0915-A65B-59F4-850FF8AD07AF}"/>
-              </a:ext>
-            </a:extLst>
-          </p:cNvPr>
-          <p:cNvSpPr>
-            <a:spLocks noGrp="1"/>
-          </p:cNvSpPr>
-          <p:nvPr>
-            <p:ph type="body" sz="quarter" idx="17" hasCustomPrompt="1"/>
-          </p:nvPr>
-        </p:nvSpPr>
-        <p:spPr>
-          <a:xfrm>
-            <a:off x="5328352" y="2901206"/>
-            <a:ext cx="3769308" cy="297907"/>
+              <a:t>kpi_value_1</a:t>
+            </a:r>
+          </a:p>
+        </p:txBody>
+      </p:sp>
+      <p:sp>
+        <p:nvSpPr>
+          <p:cNvPr id="8" name="kpi_label_1">
+            <a:extLst>
+              <a:ext uri="{FF2B5EF4-FFF2-40B4-BE49-F238E27FC236}">
+                <a16:creationId xmlns:a16="http://schemas.microsoft.com/office/drawing/2014/main" id="{8BF2E44B-5092-2A45-E4B0-A571342B34DE}"/>
+              </a:ext>
+            </a:extLst>
+          </p:cNvPr>
+          <p:cNvSpPr>
+            <a:spLocks noGrp="1"/>
+          </p:cNvSpPr>
+          <p:nvPr>
+            <p:ph type="body" sz="quarter" idx="15" hasCustomPrompt="1"/>
+          </p:nvPr>
+        </p:nvSpPr>
+        <p:spPr>
+          <a:xfrm>
+            <a:off x="831633" y="3838906"/>
+            <a:ext cx="3989736" cy="833046"/>
           </a:xfrm>
           <a:prstGeom prst="rect">
             <a:avLst/>
@@ -3532,38 +3431,38 @@
               </a:spcBef>
               <a:buFontTx/>
               <a:buNone/>
-              <a:defRPr sz="1800"/>
-            </a:lvl1pPr>
-          </a:lstStyle>
-          <a:p>
-            <a:pPr lvl="0"/>
-            <a:r>
-              <a:rPr lang="en-US"/>
-              <a:t>kpi_label_2</a:t>
-            </a:r>
-          </a:p>
-        </p:txBody>
-      </p:sp>
-      <p:sp>
-        <p:nvSpPr>
-          <p:cNvPr id="11" name="kpi_value_3">
-            <a:extLst>
-              <a:ext uri="{FF2B5EF4-FFF2-40B4-BE49-F238E27FC236}">
-                <a16:creationId xmlns:a16="http://schemas.microsoft.com/office/drawing/2014/main" id="{42B878FE-0CF7-9E17-2D7A-DFB0D6D6CEF2}"/>
-              </a:ext>
-            </a:extLst>
-          </p:cNvPr>
-          <p:cNvSpPr>
-            <a:spLocks noGrp="1"/>
-          </p:cNvSpPr>
-          <p:nvPr>
-            <p:ph type="body" sz="quarter" idx="18" hasCustomPrompt="1"/>
-          </p:nvPr>
-        </p:nvSpPr>
-        <p:spPr>
-          <a:xfrm>
-            <a:off x="5328353" y="3812264"/>
-            <a:ext cx="1620141" cy="536233"/>
+              <a:defRPr sz="2000"/>
+            </a:lvl1pPr>
+          </a:lstStyle>
+          <a:p>
+            <a:pPr lvl="0"/>
+            <a:r>
+              <a:rPr lang="en-US"/>
+              <a:t>kpi_label_1</a:t>
+            </a:r>
+          </a:p>
+        </p:txBody>
+      </p:sp>
+      <p:sp>
+        <p:nvSpPr>
+          <p:cNvPr id="9" name="kpi_value_2">
+            <a:extLst>
+              <a:ext uri="{FF2B5EF4-FFF2-40B4-BE49-F238E27FC236}">
+                <a16:creationId xmlns:a16="http://schemas.microsoft.com/office/drawing/2014/main" id="{D40F6B9D-CF05-016D-42EB-D43C53D79729}"/>
+              </a:ext>
+            </a:extLst>
+          </p:cNvPr>
+          <p:cNvSpPr>
+            <a:spLocks noGrp="1"/>
+          </p:cNvSpPr>
+          <p:nvPr>
+            <p:ph type="body" sz="quarter" idx="16" hasCustomPrompt="1"/>
+          </p:nvPr>
+        </p:nvSpPr>
+        <p:spPr>
+          <a:xfrm>
+            <a:off x="5306309" y="2339425"/>
+            <a:ext cx="3813394" cy="569081"/>
           </a:xfrm>
           <a:prstGeom prst="rect">
             <a:avLst/>
@@ -3592,31 +3491,31 @@
             <a:pPr lvl="0"/>
             <a:r>
               <a:rPr lang="en-US"/>
-              <a:t>kpi_value_3</a:t>
-            </a:r>
-          </a:p>
-        </p:txBody>
-      </p:sp>
-      <p:sp>
-        <p:nvSpPr>
-          <p:cNvPr id="12" name="kpi_label_3">
-            <a:extLst>
-              <a:ext uri="{FF2B5EF4-FFF2-40B4-BE49-F238E27FC236}">
-                <a16:creationId xmlns:a16="http://schemas.microsoft.com/office/drawing/2014/main" id="{52FA2850-7E13-4D38-22AF-DC34652379A1}"/>
-              </a:ext>
-            </a:extLst>
-          </p:cNvPr>
-          <p:cNvSpPr>
-            <a:spLocks noGrp="1"/>
-          </p:cNvSpPr>
-          <p:nvPr>
-            <p:ph type="body" sz="quarter" idx="19" hasCustomPrompt="1"/>
-          </p:nvPr>
-        </p:nvSpPr>
-        <p:spPr>
-          <a:xfrm>
-            <a:off x="5328353" y="4348498"/>
-            <a:ext cx="1620141" cy="297907"/>
+              <a:t>kpi_value_2</a:t>
+            </a:r>
+          </a:p>
+        </p:txBody>
+      </p:sp>
+      <p:sp>
+        <p:nvSpPr>
+          <p:cNvPr id="10" name="kpi_label_2">
+            <a:extLst>
+              <a:ext uri="{FF2B5EF4-FFF2-40B4-BE49-F238E27FC236}">
+                <a16:creationId xmlns:a16="http://schemas.microsoft.com/office/drawing/2014/main" id="{2CFBC110-B522-0851-C98F-E54D14A7F8D9}"/>
+              </a:ext>
+            </a:extLst>
+          </p:cNvPr>
+          <p:cNvSpPr>
+            <a:spLocks noGrp="1"/>
+          </p:cNvSpPr>
+          <p:nvPr>
+            <p:ph type="body" sz="quarter" idx="17" hasCustomPrompt="1"/>
+          </p:nvPr>
+        </p:nvSpPr>
+        <p:spPr>
+          <a:xfrm>
+            <a:off x="5306309" y="2908505"/>
+            <a:ext cx="3813394" cy="316156"/>
           </a:xfrm>
           <a:prstGeom prst="rect">
             <a:avLst/>
@@ -3633,38 +3532,38 @@
               </a:spcBef>
               <a:buFontTx/>
               <a:buNone/>
-              <a:defRPr sz="1800"/>
-            </a:lvl1pPr>
-          </a:lstStyle>
-          <a:p>
-            <a:pPr lvl="0"/>
-            <a:r>
-              <a:rPr lang="en-US"/>
-              <a:t>kpi_label_3</a:t>
-            </a:r>
-          </a:p>
-        </p:txBody>
-      </p:sp>
-      <p:sp>
-        <p:nvSpPr>
-          <p:cNvPr id="13" name="kpi_value_4">
-            <a:extLst>
-              <a:ext uri="{FF2B5EF4-FFF2-40B4-BE49-F238E27FC236}">
-                <a16:creationId xmlns:a16="http://schemas.microsoft.com/office/drawing/2014/main" id="{37D0F9F2-977B-D634-9855-A4AB5DA1CE25}"/>
-              </a:ext>
-            </a:extLst>
-          </p:cNvPr>
-          <p:cNvSpPr>
-            <a:spLocks noGrp="1"/>
-          </p:cNvSpPr>
-          <p:nvPr>
-            <p:ph type="body" sz="quarter" idx="20" hasCustomPrompt="1"/>
-          </p:nvPr>
-        </p:nvSpPr>
-        <p:spPr>
-          <a:xfrm>
-            <a:off x="7477520" y="3812264"/>
-            <a:ext cx="1620141" cy="536233"/>
+              <a:defRPr sz="2000"/>
+            </a:lvl1pPr>
+          </a:lstStyle>
+          <a:p>
+            <a:pPr lvl="0"/>
+            <a:r>
+              <a:rPr lang="en-US"/>
+              <a:t>kpi_label_2</a:t>
+            </a:r>
+          </a:p>
+        </p:txBody>
+      </p:sp>
+      <p:sp>
+        <p:nvSpPr>
+          <p:cNvPr id="11" name="kpi_value_3">
+            <a:extLst>
+              <a:ext uri="{FF2B5EF4-FFF2-40B4-BE49-F238E27FC236}">
+                <a16:creationId xmlns:a16="http://schemas.microsoft.com/office/drawing/2014/main" id="{0EF70FD3-DAFB-7FD3-A16F-B2F8009DDB0A}"/>
+              </a:ext>
+            </a:extLst>
+          </p:cNvPr>
+          <p:cNvSpPr>
+            <a:spLocks noGrp="1"/>
+          </p:cNvSpPr>
+          <p:nvPr>
+            <p:ph type="body" sz="quarter" idx="18" hasCustomPrompt="1"/>
+          </p:nvPr>
+        </p:nvSpPr>
+        <p:spPr>
+          <a:xfrm>
+            <a:off x="5306310" y="3786717"/>
+            <a:ext cx="1664227" cy="569081"/>
           </a:xfrm>
           <a:prstGeom prst="rect">
             <a:avLst/>
@@ -3693,31 +3592,31 @@
             <a:pPr lvl="0"/>
             <a:r>
               <a:rPr lang="en-US"/>
-              <a:t>kpi_value_4</a:t>
-            </a:r>
-          </a:p>
-        </p:txBody>
-      </p:sp>
-      <p:sp>
-        <p:nvSpPr>
-          <p:cNvPr id="14" name="kpi_label_4">
-            <a:extLst>
-              <a:ext uri="{FF2B5EF4-FFF2-40B4-BE49-F238E27FC236}">
-                <a16:creationId xmlns:a16="http://schemas.microsoft.com/office/drawing/2014/main" id="{C352E6E1-AA8F-0DC0-EB47-602E077FEFF5}"/>
-              </a:ext>
-            </a:extLst>
-          </p:cNvPr>
-          <p:cNvSpPr>
-            <a:spLocks noGrp="1"/>
-          </p:cNvSpPr>
-          <p:nvPr>
-            <p:ph type="body" sz="quarter" idx="21" hasCustomPrompt="1"/>
-          </p:nvPr>
-        </p:nvSpPr>
-        <p:spPr>
-          <a:xfrm>
-            <a:off x="7477520" y="4348498"/>
-            <a:ext cx="1620141" cy="297907"/>
+              <a:t>kpi_value_3</a:t>
+            </a:r>
+          </a:p>
+        </p:txBody>
+      </p:sp>
+      <p:sp>
+        <p:nvSpPr>
+          <p:cNvPr id="12" name="kpi_label_3">
+            <a:extLst>
+              <a:ext uri="{FF2B5EF4-FFF2-40B4-BE49-F238E27FC236}">
+                <a16:creationId xmlns:a16="http://schemas.microsoft.com/office/drawing/2014/main" id="{92A03E05-B9C3-8C61-E383-A0B438C3998B}"/>
+              </a:ext>
+            </a:extLst>
+          </p:cNvPr>
+          <p:cNvSpPr>
+            <a:spLocks noGrp="1"/>
+          </p:cNvSpPr>
+          <p:nvPr>
+            <p:ph type="body" sz="quarter" idx="19" hasCustomPrompt="1"/>
+          </p:nvPr>
+        </p:nvSpPr>
+        <p:spPr>
+          <a:xfrm>
+            <a:off x="5306310" y="4355796"/>
+            <a:ext cx="1664227" cy="316156"/>
           </a:xfrm>
           <a:prstGeom prst="rect">
             <a:avLst/>
@@ -3734,7 +3633,108 @@
               </a:spcBef>
               <a:buFontTx/>
               <a:buNone/>
-              <a:defRPr sz="1800"/>
+              <a:defRPr sz="2000"/>
+            </a:lvl1pPr>
+          </a:lstStyle>
+          <a:p>
+            <a:pPr lvl="0"/>
+            <a:r>
+              <a:rPr lang="en-US"/>
+              <a:t>kpi_label_3</a:t>
+            </a:r>
+          </a:p>
+        </p:txBody>
+      </p:sp>
+      <p:sp>
+        <p:nvSpPr>
+          <p:cNvPr id="13" name="kpi_value_4">
+            <a:extLst>
+              <a:ext uri="{FF2B5EF4-FFF2-40B4-BE49-F238E27FC236}">
+                <a16:creationId xmlns:a16="http://schemas.microsoft.com/office/drawing/2014/main" id="{B9D4728F-2CF6-1E02-349D-7F5AC1CCCBDC}"/>
+              </a:ext>
+            </a:extLst>
+          </p:cNvPr>
+          <p:cNvSpPr>
+            <a:spLocks noGrp="1"/>
+          </p:cNvSpPr>
+          <p:nvPr>
+            <p:ph type="body" sz="quarter" idx="20" hasCustomPrompt="1"/>
+          </p:nvPr>
+        </p:nvSpPr>
+        <p:spPr>
+          <a:xfrm>
+            <a:off x="7455477" y="3786717"/>
+            <a:ext cx="1664227" cy="569081"/>
+          </a:xfrm>
+          <a:prstGeom prst="rect">
+            <a:avLst/>
+          </a:prstGeom>
+        </p:spPr>
+        <p:txBody>
+          <a:bodyPr wrap="square" anchor="t">
+            <a:noAutofit/>
+          </a:bodyPr>
+          <a:lstStyle>
+            <a:lvl1pPr marL="0" indent="0">
+              <a:spcBef>
+                <a:spcPts val="0"/>
+              </a:spcBef>
+              <a:buFontTx/>
+              <a:buNone/>
+              <a:defRPr sz="6000" b="1">
+                <a:solidFill>
+                  <a:schemeClr val="accent1"/>
+                </a:solidFill>
+                <a:latin typeface="+mj-lt"/>
+              </a:defRPr>
+            </a:lvl1pPr>
+          </a:lstStyle>
+          <a:p>
+            <a:pPr lvl="0"/>
+            <a:r>
+              <a:rPr lang="en-US"/>
+              <a:t>kpi_value_4</a:t>
+            </a:r>
+          </a:p>
+        </p:txBody>
+      </p:sp>
+      <p:sp>
+        <p:nvSpPr>
+          <p:cNvPr id="14" name="kpi_label_4">
+            <a:extLst>
+              <a:ext uri="{FF2B5EF4-FFF2-40B4-BE49-F238E27FC236}">
+                <a16:creationId xmlns:a16="http://schemas.microsoft.com/office/drawing/2014/main" id="{CC683DA5-4AE5-D205-DAC7-E9F5E9AC6D13}"/>
+              </a:ext>
+            </a:extLst>
+          </p:cNvPr>
+          <p:cNvSpPr>
+            <a:spLocks noGrp="1"/>
+          </p:cNvSpPr>
+          <p:nvPr>
+            <p:ph type="body" sz="quarter" idx="21" hasCustomPrompt="1"/>
+          </p:nvPr>
+        </p:nvSpPr>
+        <p:spPr>
+          <a:xfrm>
+            <a:off x="7455477" y="4355796"/>
+            <a:ext cx="1664227" cy="316156"/>
+          </a:xfrm>
+          <a:prstGeom prst="rect">
+            <a:avLst/>
+          </a:prstGeom>
+        </p:spPr>
+        <p:txBody>
+          <a:bodyPr wrap="square" anchor="t">
+            <a:noAutofit/>
+          </a:bodyPr>
+          <a:lstStyle>
+            <a:lvl1pPr marL="0" indent="0">
+              <a:spcBef>
+                <a:spcPts val="0"/>
+              </a:spcBef>
+              <a:buFontTx/>
+              <a:buNone/>
+              <a:defRPr sz="2000"/>
             </a:lvl1pPr>
           </a:lstStyle>
           <a:p>
@@ -3751,7 +3751,7 @@
           <p:cNvPr id="15" name="source">
             <a:extLst>
               <a:ext uri="{FF2B5EF4-FFF2-40B4-BE49-F238E27FC236}">
-                <a16:creationId xmlns:a16="http://schemas.microsoft.com/office/drawing/2014/main" id="{B2EE9FA8-D973-3391-6043-8D91F2356034}"/>
+                <a16:creationId xmlns:a16="http://schemas.microsoft.com/office/drawing/2014/main" id="{0D550027-5297-6421-CE57-66A769827FEF}"/>
               </a:ext>
             </a:extLst>
           </p:cNvPr>
@@ -3806,7 +3806,7 @@
     </p:spTree>
     <p:extLst>
       <p:ext uri="{BB962C8B-B14F-4D97-AF65-F5344CB8AC3E}">
-        <p14:creationId xmlns:p14="http://schemas.microsoft.com/office/powerpoint/2010/main" val="1022344304"/>
+        <p14:creationId xmlns:p14="http://schemas.microsoft.com/office/powerpoint/2010/main" val="3472289302"/>
       </p:ext>
     </p:extLst>
   </p:cSld>
@@ -3880,7 +3880,7 @@
           <a:bodyPr/>
           <a:lstStyle/>
           <a:p>
-            <a:fld id="{74813003-FBAE-4237-BD99-D6E83252122A}" type="datetimeFigureOut">
+            <a:fld id="{26B7F381-F10E-4587-B886-8036B7268BA3}" type="datetimeFigureOut">
               <a:rPr lang="en-US" smtClean="0"/>
               <a:t>10/3/2026</a:t>
             </a:fld>
@@ -3922,7 +3922,7 @@
           <a:bodyPr/>
           <a:lstStyle/>
           <a:p>
-            <a:fld id="{BEFED7E7-52D0-4F8A-AF4C-DA16AD6E5F6D}" type="slidenum">
+            <a:fld id="{C8D4D1C8-8C5D-4FFA-950C-FD08A0718FA9}" type="slidenum">
               <a:rPr lang="en-US" smtClean="0"/>
               <a:t>‹#›</a:t>
             </a:fld>
@@ -3935,7 +3935,7 @@
           <p:cNvPr id="6" name="body">
             <a:extLst>
               <a:ext uri="{FF2B5EF4-FFF2-40B4-BE49-F238E27FC236}">
-                <a16:creationId xmlns:a16="http://schemas.microsoft.com/office/drawing/2014/main" id="{CB809473-65E2-4C74-08B7-33CA40AA3366}"/>
+                <a16:creationId xmlns:a16="http://schemas.microsoft.com/office/drawing/2014/main" id="{45CF22A6-5BB9-3933-D993-F33D4F955839}"/>
               </a:ext>
             </a:extLst>
           </p:cNvPr>
@@ -3975,7 +3975,7 @@
           <p:cNvPr id="7" name="kpi_value_1">
             <a:extLst>
               <a:ext uri="{FF2B5EF4-FFF2-40B4-BE49-F238E27FC236}">
-                <a16:creationId xmlns:a16="http://schemas.microsoft.com/office/drawing/2014/main" id="{479EB899-B605-432D-63DF-D88C7DCAFE2B}"/>
+                <a16:creationId xmlns:a16="http://schemas.microsoft.com/office/drawing/2014/main" id="{F3E005A2-9C92-2B37-93BC-8E5028AB5382}"/>
               </a:ext>
             </a:extLst>
           </p:cNvPr>
@@ -3988,8 +3988,8 @@
         </p:nvSpPr>
         <p:spPr>
           <a:xfrm>
-            <a:off x="853677" y="2364972"/>
-            <a:ext cx="3857479" cy="1109886"/>
+            <a:off x="831634" y="2339425"/>
+            <a:ext cx="3901565" cy="1134743"/>
           </a:xfrm>
           <a:prstGeom prst="rect">
             <a:avLst/>
@@ -4028,7 +4028,7 @@
           <p:cNvPr id="8" name="kpi_label_1">
             <a:extLst>
               <a:ext uri="{FF2B5EF4-FFF2-40B4-BE49-F238E27FC236}">
-                <a16:creationId xmlns:a16="http://schemas.microsoft.com/office/drawing/2014/main" id="{DC3B135C-6618-9600-6106-1CE5525820A2}"/>
+                <a16:creationId xmlns:a16="http://schemas.microsoft.com/office/drawing/2014/main" id="{C1F62EDF-2956-06C0-36EF-1051F7E60FEF}"/>
               </a:ext>
             </a:extLst>
           </p:cNvPr>
@@ -4041,8 +4041,8 @@
         </p:nvSpPr>
         <p:spPr>
           <a:xfrm>
-            <a:off x="853677" y="3474859"/>
-            <a:ext cx="3857479" cy="616603"/>
+            <a:off x="831634" y="3474168"/>
+            <a:ext cx="3901565" cy="630413"/>
           </a:xfrm>
           <a:prstGeom prst="rect">
             <a:avLst/>
@@ -4059,7 +4059,7 @@
               </a:spcBef>
               <a:buFontTx/>
               <a:buNone/>
-              <a:defRPr sz="1800"/>
+              <a:defRPr sz="2000"/>
             </a:lvl1pPr>
           </a:lstStyle>
           <a:p>
@@ -4076,7 +4076,7 @@
           <p:cNvPr id="9" name="kpi_value_2">
             <a:extLst>
               <a:ext uri="{FF2B5EF4-FFF2-40B4-BE49-F238E27FC236}">
-                <a16:creationId xmlns:a16="http://schemas.microsoft.com/office/drawing/2014/main" id="{D512E37C-DE9C-3474-7A03-8BBFF5C3F700}"/>
+                <a16:creationId xmlns:a16="http://schemas.microsoft.com/office/drawing/2014/main" id="{5B404464-8E57-37DF-ED93-1AA92077AA66}"/>
               </a:ext>
             </a:extLst>
           </p:cNvPr>
@@ -4089,8 +4089,8 @@
         </p:nvSpPr>
         <p:spPr>
           <a:xfrm>
-            <a:off x="5240182" y="2364972"/>
-            <a:ext cx="3857479" cy="1109886"/>
+            <a:off x="5218139" y="2339425"/>
+            <a:ext cx="3901565" cy="1134743"/>
           </a:xfrm>
           <a:prstGeom prst="rect">
             <a:avLst/>
@@ -4129,7 +4129,7 @@
           <p:cNvPr id="10" name="kpi_label_2">
             <a:extLst>
               <a:ext uri="{FF2B5EF4-FFF2-40B4-BE49-F238E27FC236}">
-                <a16:creationId xmlns:a16="http://schemas.microsoft.com/office/drawing/2014/main" id="{E62ACB94-DA5D-EA87-2877-CA25DF4DC800}"/>
+                <a16:creationId xmlns:a16="http://schemas.microsoft.com/office/drawing/2014/main" id="{35FD6CBB-8AC1-834B-66C4-F1750A35FA3D}"/>
               </a:ext>
             </a:extLst>
           </p:cNvPr>
@@ -4142,8 +4142,8 @@
         </p:nvSpPr>
         <p:spPr>
           <a:xfrm>
-            <a:off x="5240182" y="3474859"/>
-            <a:ext cx="3857479" cy="616603"/>
+            <a:off x="5218139" y="3474168"/>
+            <a:ext cx="3901565" cy="630413"/>
           </a:xfrm>
           <a:prstGeom prst="rect">
             <a:avLst/>
@@ -4160,7 +4160,7 @@
               </a:spcBef>
               <a:buFontTx/>
               <a:buNone/>
-              <a:defRPr sz="1800"/>
+              <a:defRPr sz="2000"/>
             </a:lvl1pPr>
           </a:lstStyle>
           <a:p>
@@ -4177,7 +4177,7 @@
           <p:cNvPr id="11" name="source">
             <a:extLst>
               <a:ext uri="{FF2B5EF4-FFF2-40B4-BE49-F238E27FC236}">
-                <a16:creationId xmlns:a16="http://schemas.microsoft.com/office/drawing/2014/main" id="{069316E3-4E65-F3D0-C318-5DBD4518E250}"/>
+                <a16:creationId xmlns:a16="http://schemas.microsoft.com/office/drawing/2014/main" id="{B157EB0A-08FB-8F5E-1B9D-FAC1CAE1948B}"/>
               </a:ext>
             </a:extLst>
           </p:cNvPr>
@@ -4232,7 +4232,7 @@
     </p:spTree>
     <p:extLst>
       <p:ext uri="{BB962C8B-B14F-4D97-AF65-F5344CB8AC3E}">
-        <p14:creationId xmlns:p14="http://schemas.microsoft.com/office/powerpoint/2010/main" val="3212090147"/>
+        <p14:creationId xmlns:p14="http://schemas.microsoft.com/office/powerpoint/2010/main" val="2512687381"/>
       </p:ext>
     </p:extLst>
   </p:cSld>
@@ -4306,7 +4306,7 @@
           <a:bodyPr/>
           <a:lstStyle/>
           <a:p>
-            <a:fld id="{74813003-FBAE-4237-BD99-D6E83252122A}" type="datetimeFigureOut">
+            <a:fld id="{26B7F381-F10E-4587-B886-8036B7268BA3}" type="datetimeFigureOut">
               <a:rPr lang="en-US" smtClean="0"/>
               <a:t>10/3/2026</a:t>
             </a:fld>
@@ -4348,7 +4348,7 @@
           <a:bodyPr/>
           <a:lstStyle/>
           <a:p>
-            <a:fld id="{BEFED7E7-52D0-4F8A-AF4C-DA16AD6E5F6D}" type="slidenum">
+            <a:fld id="{C8D4D1C8-8C5D-4FFA-950C-FD08A0718FA9}" type="slidenum">
               <a:rPr lang="en-US" smtClean="0"/>
               <a:t>‹#›</a:t>
             </a:fld>
@@ -4361,7 +4361,7 @@
           <p:cNvPr id="6" name="body">
             <a:extLst>
               <a:ext uri="{FF2B5EF4-FFF2-40B4-BE49-F238E27FC236}">
-                <a16:creationId xmlns:a16="http://schemas.microsoft.com/office/drawing/2014/main" id="{B34C38EC-089E-5DDD-ABE4-04E54C9CD368}"/>
+                <a16:creationId xmlns:a16="http://schemas.microsoft.com/office/drawing/2014/main" id="{9B605351-DB64-0863-52D4-C7F0B2853A91}"/>
               </a:ext>
             </a:extLst>
           </p:cNvPr>
@@ -4401,7 +4401,7 @@
           <p:cNvPr id="7" name="kpi_value_1">
             <a:extLst>
               <a:ext uri="{FF2B5EF4-FFF2-40B4-BE49-F238E27FC236}">
-                <a16:creationId xmlns:a16="http://schemas.microsoft.com/office/drawing/2014/main" id="{7D28AB77-F8CB-82DC-A72F-19B460FE7357}"/>
+                <a16:creationId xmlns:a16="http://schemas.microsoft.com/office/drawing/2014/main" id="{789ED6AB-D2D7-C66B-B193-D8F21C57E559}"/>
               </a:ext>
             </a:extLst>
           </p:cNvPr>
@@ -4432,7 +4432,7 @@
               </a:spcBef>
               <a:buFontTx/>
               <a:buNone/>
-              <a:defRPr sz="4000" b="1">
+              <a:defRPr sz="6000" b="1">
                 <a:solidFill>
                   <a:schemeClr val="accent1"/>
                 </a:solidFill>
@@ -4454,7 +4454,7 @@
           <p:cNvPr id="8" name="kpi_label_1">
             <a:extLst>
               <a:ext uri="{FF2B5EF4-FFF2-40B4-BE49-F238E27FC236}">
-                <a16:creationId xmlns:a16="http://schemas.microsoft.com/office/drawing/2014/main" id="{112A393F-9EB0-7DDB-17B1-90241ACF19DF}"/>
+                <a16:creationId xmlns:a16="http://schemas.microsoft.com/office/drawing/2014/main" id="{058AD109-593F-79CB-F551-71CEF9E67001}"/>
               </a:ext>
             </a:extLst>
           </p:cNvPr>
@@ -4485,7 +4485,7 @@
               </a:spcBef>
               <a:buFontTx/>
               <a:buNone/>
-              <a:defRPr sz="1800"/>
+              <a:defRPr sz="2000"/>
             </a:lvl1pPr>
           </a:lstStyle>
           <a:p>
@@ -4502,7 +4502,7 @@
           <p:cNvPr id="9" name="kpi_value_2">
             <a:extLst>
               <a:ext uri="{FF2B5EF4-FFF2-40B4-BE49-F238E27FC236}">
-                <a16:creationId xmlns:a16="http://schemas.microsoft.com/office/drawing/2014/main" id="{A07D7D76-6247-E6BA-B40A-B3FE49DE4D47}"/>
+                <a16:creationId xmlns:a16="http://schemas.microsoft.com/office/drawing/2014/main" id="{21E7E175-6E2A-B855-77DC-0C017882BA14}"/>
               </a:ext>
             </a:extLst>
           </p:cNvPr>
@@ -4533,7 +4533,7 @@
               </a:spcBef>
               <a:buFontTx/>
               <a:buNone/>
-              <a:defRPr sz="4000" b="1">
+              <a:defRPr sz="6000" b="1">
                 <a:solidFill>
                   <a:schemeClr val="accent1"/>
                 </a:solidFill>
@@ -4555,7 +4555,7 @@
           <p:cNvPr id="10" name="kpi_label_2">
             <a:extLst>
               <a:ext uri="{FF2B5EF4-FFF2-40B4-BE49-F238E27FC236}">
-                <a16:creationId xmlns:a16="http://schemas.microsoft.com/office/drawing/2014/main" id="{1B1323D0-E9FC-5AC6-B5C4-4E801FA43EF6}"/>
+                <a16:creationId xmlns:a16="http://schemas.microsoft.com/office/drawing/2014/main" id="{067DB137-1919-CAE7-19A2-9707EED1436F}"/>
               </a:ext>
             </a:extLst>
           </p:cNvPr>
@@ -4586,7 +4586,7 @@
               </a:spcBef>
               <a:buFontTx/>
               <a:buNone/>
-              <a:defRPr sz="1800"/>
+              <a:defRPr sz="2000"/>
             </a:lvl1pPr>
           </a:lstStyle>
           <a:p>
@@ -4603,7 +4603,7 @@
           <p:cNvPr id="11" name="kpi_value_3">
             <a:extLst>
               <a:ext uri="{FF2B5EF4-FFF2-40B4-BE49-F238E27FC236}">
-                <a16:creationId xmlns:a16="http://schemas.microsoft.com/office/drawing/2014/main" id="{7E39FA6E-457A-7522-EEA7-C986F9434DF1}"/>
+                <a16:creationId xmlns:a16="http://schemas.microsoft.com/office/drawing/2014/main" id="{CBDBE9F9-594F-68EC-A5CB-815E6E62CC1F}"/>
               </a:ext>
             </a:extLst>
           </p:cNvPr>
@@ -4634,7 +4634,7 @@
               </a:spcBef>
               <a:buFontTx/>
               <a:buNone/>
-              <a:defRPr sz="4000" b="1">
+              <a:defRPr sz="6000" b="1">
                 <a:solidFill>
                   <a:schemeClr val="accent1"/>
                 </a:solidFill>
@@ -4656,7 +4656,7 @@
           <p:cNvPr id="12" name="kpi_label_3">
             <a:extLst>
               <a:ext uri="{FF2B5EF4-FFF2-40B4-BE49-F238E27FC236}">
-                <a16:creationId xmlns:a16="http://schemas.microsoft.com/office/drawing/2014/main" id="{D06A9D46-713C-3ECD-1CC2-33E5CEB8F6DE}"/>
+                <a16:creationId xmlns:a16="http://schemas.microsoft.com/office/drawing/2014/main" id="{E95B0704-BDE7-F839-CC95-71D56274EED3}"/>
               </a:ext>
             </a:extLst>
           </p:cNvPr>
@@ -4687,7 +4687,7 @@
               </a:spcBef>
               <a:buFontTx/>
               <a:buNone/>
-              <a:defRPr sz="1800"/>
+              <a:defRPr sz="2000"/>
             </a:lvl1pPr>
           </a:lstStyle>
           <a:p>
@@ -4704,7 +4704,7 @@
           <p:cNvPr id="13" name="kpi_value_4">
             <a:extLst>
               <a:ext uri="{FF2B5EF4-FFF2-40B4-BE49-F238E27FC236}">
-                <a16:creationId xmlns:a16="http://schemas.microsoft.com/office/drawing/2014/main" id="{272E8C9F-FA86-6842-E72A-10FA14C62635}"/>
+                <a16:creationId xmlns:a16="http://schemas.microsoft.com/office/drawing/2014/main" id="{F0243AB2-22EE-7A2C-61BF-BF4731E1AF74}"/>
               </a:ext>
             </a:extLst>
           </p:cNvPr>
@@ -4735,7 +4735,7 @@
               </a:spcBef>
               <a:buFontTx/>
               <a:buNone/>
-              <a:defRPr sz="4000" b="1">
+              <a:defRPr sz="6000" b="1">
                 <a:solidFill>
                   <a:schemeClr val="accent1"/>
                 </a:solidFill>
@@ -4757,7 +4757,7 @@
           <p:cNvPr id="14" name="kpi_label_4">
             <a:extLst>
               <a:ext uri="{FF2B5EF4-FFF2-40B4-BE49-F238E27FC236}">
-                <a16:creationId xmlns:a16="http://schemas.microsoft.com/office/drawing/2014/main" id="{C78B4E8F-78CD-F3A2-A9EE-5D1DE3FDE33E}"/>
+                <a16:creationId xmlns:a16="http://schemas.microsoft.com/office/drawing/2014/main" id="{4037D0AE-D5A1-9339-CEB7-F157241186B5}"/>
               </a:ext>
             </a:extLst>
           </p:cNvPr>
@@ -4788,7 +4788,7 @@
               </a:spcBef>
               <a:buFontTx/>
               <a:buNone/>
-              <a:defRPr sz="1800"/>
+              <a:defRPr sz="2000"/>
             </a:lvl1pPr>
           </a:lstStyle>
           <a:p>
@@ -4805,7 +4805,7 @@
           <p:cNvPr id="15" name="source">
             <a:extLst>
               <a:ext uri="{FF2B5EF4-FFF2-40B4-BE49-F238E27FC236}">
-                <a16:creationId xmlns:a16="http://schemas.microsoft.com/office/drawing/2014/main" id="{C47728BD-C613-579B-5307-C91C80822315}"/>
+                <a16:creationId xmlns:a16="http://schemas.microsoft.com/office/drawing/2014/main" id="{5744B48C-899F-8342-1352-359816CFED06}"/>
               </a:ext>
             </a:extLst>
           </p:cNvPr>
@@ -4860,7 +4860,7 @@
     </p:spTree>
     <p:extLst>
       <p:ext uri="{BB962C8B-B14F-4D97-AF65-F5344CB8AC3E}">
-        <p14:creationId xmlns:p14="http://schemas.microsoft.com/office/powerpoint/2010/main" val="527442430"/>
+        <p14:creationId xmlns:p14="http://schemas.microsoft.com/office/powerpoint/2010/main" val="4028751659"/>
       </p:ext>
     </p:extLst>
   </p:cSld>
@@ -4934,7 +4934,7 @@
           <a:bodyPr/>
           <a:lstStyle/>
           <a:p>
-            <a:fld id="{74813003-FBAE-4237-BD99-D6E83252122A}" type="datetimeFigureOut">
+            <a:fld id="{26B7F381-F10E-4587-B886-8036B7268BA3}" type="datetimeFigureOut">
               <a:rPr lang="en-US" smtClean="0"/>
               <a:t>10/3/2026</a:t>
             </a:fld>
@@ -4976,7 +4976,7 @@
           <a:bodyPr/>
           <a:lstStyle/>
           <a:p>
-            <a:fld id="{BEFED7E7-52D0-4F8A-AF4C-DA16AD6E5F6D}" type="slidenum">
+            <a:fld id="{C8D4D1C8-8C5D-4FFA-950C-FD08A0718FA9}" type="slidenum">
               <a:rPr lang="en-US" smtClean="0"/>
               <a:t>‹#›</a:t>
             </a:fld>
@@ -4989,7 +4989,7 @@
           <p:cNvPr id="6" name="item_1_title">
             <a:extLst>
               <a:ext uri="{FF2B5EF4-FFF2-40B4-BE49-F238E27FC236}">
-                <a16:creationId xmlns:a16="http://schemas.microsoft.com/office/drawing/2014/main" id="{412C1686-5542-66AF-EB6A-700F373F9A43}"/>
+                <a16:creationId xmlns:a16="http://schemas.microsoft.com/office/drawing/2014/main" id="{A7606C95-1DAA-814C-F71B-A10FF6BE4A76}"/>
               </a:ext>
             </a:extLst>
           </p:cNvPr>
@@ -5017,7 +5017,7 @@
               </a:spcBef>
               <a:buFontTx/>
               <a:buNone/>
-              <a:defRPr sz="2200" b="1">
+              <a:defRPr sz="2000" b="1">
                 <a:solidFill>
                   <a:schemeClr val="accent1"/>
                 </a:solidFill>
@@ -5039,7 +5039,7 @@
           <p:cNvPr id="7" name="item_1">
             <a:extLst>
               <a:ext uri="{FF2B5EF4-FFF2-40B4-BE49-F238E27FC236}">
-                <a16:creationId xmlns:a16="http://schemas.microsoft.com/office/drawing/2014/main" id="{8D8A307D-940B-94B8-3EA4-FC0CDB66E1E6}"/>
+                <a16:creationId xmlns:a16="http://schemas.microsoft.com/office/drawing/2014/main" id="{C983904D-4C83-BF98-2389-E4640EED472C}"/>
               </a:ext>
             </a:extLst>
           </p:cNvPr>
@@ -5087,7 +5087,7 @@
           <p:cNvPr id="8" name="item_2_title">
             <a:extLst>
               <a:ext uri="{FF2B5EF4-FFF2-40B4-BE49-F238E27FC236}">
-                <a16:creationId xmlns:a16="http://schemas.microsoft.com/office/drawing/2014/main" id="{3577C691-BDF9-EA07-06E2-EBDE1B4FBE4A}"/>
+                <a16:creationId xmlns:a16="http://schemas.microsoft.com/office/drawing/2014/main" id="{766FF3D8-7AD1-4B23-159F-1A857F68B71B}"/>
               </a:ext>
             </a:extLst>
           </p:cNvPr>
@@ -5118,7 +5118,7 @@
               </a:spcBef>
               <a:buFontTx/>
               <a:buNone/>
-              <a:defRPr sz="2200" b="1">
+              <a:defRPr sz="2000" b="1">
                 <a:solidFill>
                   <a:schemeClr val="accent1"/>
                 </a:solidFill>
@@ -5140,7 +5140,7 @@
           <p:cNvPr id="9" name="item_2">
             <a:extLst>
               <a:ext uri="{FF2B5EF4-FFF2-40B4-BE49-F238E27FC236}">
-                <a16:creationId xmlns:a16="http://schemas.microsoft.com/office/drawing/2014/main" id="{203A2C82-A74F-E2B6-DC03-12302899467F}"/>
+                <a16:creationId xmlns:a16="http://schemas.microsoft.com/office/drawing/2014/main" id="{DF670475-66DE-C4B2-B0E9-6231FBC461F1}"/>
               </a:ext>
             </a:extLst>
           </p:cNvPr>
@@ -5188,7 +5188,7 @@
           <p:cNvPr id="10" name="item_3_title">
             <a:extLst>
               <a:ext uri="{FF2B5EF4-FFF2-40B4-BE49-F238E27FC236}">
-                <a16:creationId xmlns:a16="http://schemas.microsoft.com/office/drawing/2014/main" id="{2C3B0198-2002-8884-7F30-05302B9913AD}"/>
+                <a16:creationId xmlns:a16="http://schemas.microsoft.com/office/drawing/2014/main" id="{08727338-C9C6-F3C7-0A96-DF8D521A1E57}"/>
               </a:ext>
             </a:extLst>
           </p:cNvPr>
@@ -5219,7 +5219,7 @@
               </a:spcBef>
               <a:buFontTx/>
               <a:buNone/>
-              <a:defRPr sz="2200" b="1">
+              <a:defRPr sz="2000" b="1">
                 <a:solidFill>
                   <a:schemeClr val="accent1"/>
                 </a:solidFill>
@@ -5241,7 +5241,7 @@
           <p:cNvPr id="11" name="item_3">
             <a:extLst>
               <a:ext uri="{FF2B5EF4-FFF2-40B4-BE49-F238E27FC236}">
-                <a16:creationId xmlns:a16="http://schemas.microsoft.com/office/drawing/2014/main" id="{48A99400-B17F-7DB2-0950-7C70C741FC9D}"/>
+                <a16:creationId xmlns:a16="http://schemas.microsoft.com/office/drawing/2014/main" id="{E2850BE1-98D0-5448-5952-0AEF28A8A74B}"/>
               </a:ext>
             </a:extLst>
           </p:cNvPr>
@@ -5289,7 +5289,7 @@
           <p:cNvPr id="12" name="item_4_title">
             <a:extLst>
               <a:ext uri="{FF2B5EF4-FFF2-40B4-BE49-F238E27FC236}">
-                <a16:creationId xmlns:a16="http://schemas.microsoft.com/office/drawing/2014/main" id="{5581BF28-1338-23C9-5D7B-61CF5027F8EC}"/>
+                <a16:creationId xmlns:a16="http://schemas.microsoft.com/office/drawing/2014/main" id="{807586DF-7BC3-F188-22C7-66F8C7055BA4}"/>
               </a:ext>
             </a:extLst>
           </p:cNvPr>
@@ -5320,7 +5320,7 @@
               </a:spcBef>
               <a:buFontTx/>
               <a:buNone/>
-              <a:defRPr sz="2200" b="1">
+              <a:defRPr sz="2000" b="1">
                 <a:solidFill>
                   <a:schemeClr val="accent1"/>
                 </a:solidFill>
@@ -5342,7 +5342,7 @@
           <p:cNvPr id="13" name="item_4">
             <a:extLst>
               <a:ext uri="{FF2B5EF4-FFF2-40B4-BE49-F238E27FC236}">
-                <a16:creationId xmlns:a16="http://schemas.microsoft.com/office/drawing/2014/main" id="{35DB7CD8-9FEB-57FE-0359-E553B31C99CF}"/>
+                <a16:creationId xmlns:a16="http://schemas.microsoft.com/office/drawing/2014/main" id="{390BA500-B99E-4B5D-5AEC-EED99136C4D3}"/>
               </a:ext>
             </a:extLst>
           </p:cNvPr>
@@ -5390,7 +5390,7 @@
           <p:cNvPr id="14" name="source">
             <a:extLst>
               <a:ext uri="{FF2B5EF4-FFF2-40B4-BE49-F238E27FC236}">
-                <a16:creationId xmlns:a16="http://schemas.microsoft.com/office/drawing/2014/main" id="{A3767D43-64FF-9A76-84DC-305BE29328C2}"/>
+                <a16:creationId xmlns:a16="http://schemas.microsoft.com/office/drawing/2014/main" id="{E26020ED-BDCC-7B61-23D0-39964F443A33}"/>
               </a:ext>
             </a:extLst>
           </p:cNvPr>
@@ -5445,7 +5445,7 @@
     </p:spTree>
     <p:extLst>
       <p:ext uri="{BB962C8B-B14F-4D97-AF65-F5344CB8AC3E}">
-        <p14:creationId xmlns:p14="http://schemas.microsoft.com/office/powerpoint/2010/main" val="2673614083"/>
+        <p14:creationId xmlns:p14="http://schemas.microsoft.com/office/powerpoint/2010/main" val="293900728"/>
       </p:ext>
     </p:extLst>
   </p:cSld>
@@ -5519,7 +5519,7 @@
           <a:bodyPr/>
           <a:lstStyle/>
           <a:p>
-            <a:fld id="{74813003-FBAE-4237-BD99-D6E83252122A}" type="datetimeFigureOut">
+            <a:fld id="{26B7F381-F10E-4587-B886-8036B7268BA3}" type="datetimeFigureOut">
               <a:rPr lang="en-US" smtClean="0"/>
               <a:t>10/3/2026</a:t>
             </a:fld>
@@ -5561,7 +5561,7 @@
           <a:bodyPr/>
           <a:lstStyle/>
           <a:p>
-            <a:fld id="{BEFED7E7-52D0-4F8A-AF4C-DA16AD6E5F6D}" type="slidenum">
+            <a:fld id="{C8D4D1C8-8C5D-4FFA-950C-FD08A0718FA9}" type="slidenum">
               <a:rPr lang="en-US" smtClean="0"/>
               <a:t>‹#›</a:t>
             </a:fld>
@@ -5574,7 +5574,7 @@
           <p:cNvPr id="6" name="marker_1">
             <a:extLst>
               <a:ext uri="{FF2B5EF4-FFF2-40B4-BE49-F238E27FC236}">
-                <a16:creationId xmlns:a16="http://schemas.microsoft.com/office/drawing/2014/main" id="{34F0CD23-5099-9970-51BF-2034A12AD919}"/>
+                <a16:creationId xmlns:a16="http://schemas.microsoft.com/office/drawing/2014/main" id="{14CBB1D0-2C7E-B749-A80F-A76763246774}"/>
               </a:ext>
             </a:extLst>
           </p:cNvPr>
@@ -5587,7 +5587,7 @@
         </p:nvSpPr>
         <p:spPr>
           <a:xfrm>
-            <a:off x="853676" y="2364972"/>
+            <a:off x="831633" y="2339424"/>
             <a:ext cx="484940" cy="562055"/>
           </a:xfrm>
           <a:prstGeom prst="ellipse">
@@ -5608,7 +5608,7 @@
               </a:spcBef>
               <a:buFontTx/>
               <a:buNone/>
-              <a:defRPr sz="2400" b="1">
+              <a:defRPr sz="2000" b="1">
                 <a:solidFill>
                   <a:schemeClr val="bg1"/>
                 </a:solidFill>
@@ -5630,7 +5630,7 @@
           <p:cNvPr id="7" name="item_1_title">
             <a:extLst>
               <a:ext uri="{FF2B5EF4-FFF2-40B4-BE49-F238E27FC236}">
-                <a16:creationId xmlns:a16="http://schemas.microsoft.com/office/drawing/2014/main" id="{3D39065C-2BEB-04DD-D6AB-0F14C296918E}"/>
+                <a16:creationId xmlns:a16="http://schemas.microsoft.com/office/drawing/2014/main" id="{31923198-A9E6-4A2B-6B8D-D9C581B56BB8}"/>
               </a:ext>
             </a:extLst>
           </p:cNvPr>
@@ -5643,8 +5643,8 @@
         </p:nvSpPr>
         <p:spPr>
           <a:xfrm>
-            <a:off x="1426788" y="2364972"/>
-            <a:ext cx="7670873" cy="356920"/>
+            <a:off x="1404745" y="2339424"/>
+            <a:ext cx="7714959" cy="371948"/>
           </a:xfrm>
           <a:prstGeom prst="rect">
             <a:avLst/>
@@ -5661,7 +5661,7 @@
               </a:spcBef>
               <a:buFontTx/>
               <a:buNone/>
-              <a:defRPr sz="2200" b="1">
+              <a:defRPr sz="2000" b="1">
                 <a:solidFill>
                   <a:schemeClr val="accent1"/>
                 </a:solidFill>
@@ -5683,7 +5683,7 @@
           <p:cNvPr id="8" name="item_1">
             <a:extLst>
               <a:ext uri="{FF2B5EF4-FFF2-40B4-BE49-F238E27FC236}">
-                <a16:creationId xmlns:a16="http://schemas.microsoft.com/office/drawing/2014/main" id="{D1984206-7C60-BB67-0214-3884EC277445}"/>
+                <a16:creationId xmlns:a16="http://schemas.microsoft.com/office/drawing/2014/main" id="{887FBC3A-5674-A713-4D1E-9298D1437FC1}"/>
               </a:ext>
             </a:extLst>
           </p:cNvPr>
@@ -5696,8 +5696,8 @@
         </p:nvSpPr>
         <p:spPr>
           <a:xfrm>
-            <a:off x="1426788" y="2721892"/>
-            <a:ext cx="7670873" cy="856608"/>
+            <a:off x="1404745" y="2711373"/>
+            <a:ext cx="7714959" cy="892675"/>
           </a:xfrm>
           <a:prstGeom prst="rect">
             <a:avLst/>
@@ -5731,7 +5731,7 @@
           <p:cNvPr id="9" name="marker_2">
             <a:extLst>
               <a:ext uri="{FF2B5EF4-FFF2-40B4-BE49-F238E27FC236}">
-                <a16:creationId xmlns:a16="http://schemas.microsoft.com/office/drawing/2014/main" id="{AD2DA39F-8749-6466-389E-649431534B7E}"/>
+                <a16:creationId xmlns:a16="http://schemas.microsoft.com/office/drawing/2014/main" id="{D2F1487B-72B1-37AA-9262-5DA5E9EE7524}"/>
               </a:ext>
             </a:extLst>
           </p:cNvPr>
@@ -5744,7 +5744,7 @@
         </p:nvSpPr>
         <p:spPr>
           <a:xfrm>
-            <a:off x="853676" y="4191651"/>
+            <a:off x="831633" y="4166104"/>
             <a:ext cx="484940" cy="562055"/>
           </a:xfrm>
           <a:prstGeom prst="ellipse">
@@ -5765,7 +5765,7 @@
               </a:spcBef>
               <a:buFontTx/>
               <a:buNone/>
-              <a:defRPr sz="2400" b="1">
+              <a:defRPr sz="2000" b="1">
                 <a:solidFill>
                   <a:schemeClr val="bg1"/>
                 </a:solidFill>
@@ -5787,7 +5787,7 @@
           <p:cNvPr id="10" name="item_2_title">
             <a:extLst>
               <a:ext uri="{FF2B5EF4-FFF2-40B4-BE49-F238E27FC236}">
-                <a16:creationId xmlns:a16="http://schemas.microsoft.com/office/drawing/2014/main" id="{D55FB865-5DF1-BBB0-9FB0-9FFEA0B2A478}"/>
+                <a16:creationId xmlns:a16="http://schemas.microsoft.com/office/drawing/2014/main" id="{98AF1A03-D4E8-4709-B583-26EF6B175A95}"/>
               </a:ext>
             </a:extLst>
           </p:cNvPr>
@@ -5800,8 +5800,8 @@
         </p:nvSpPr>
         <p:spPr>
           <a:xfrm>
-            <a:off x="1426788" y="4191650"/>
-            <a:ext cx="7670873" cy="356920"/>
+            <a:off x="1404745" y="4166103"/>
+            <a:ext cx="7714959" cy="371948"/>
           </a:xfrm>
           <a:prstGeom prst="rect">
             <a:avLst/>
@@ -5818,7 +5818,7 @@
               </a:spcBef>
               <a:buFontTx/>
               <a:buNone/>
-              <a:defRPr sz="2200" b="1">
+              <a:defRPr sz="2000" b="1">
                 <a:solidFill>
                   <a:schemeClr val="accent1"/>
                 </a:solidFill>
@@ -5840,7 +5840,7 @@
           <p:cNvPr id="11" name="item_2">
             <a:extLst>
               <a:ext uri="{FF2B5EF4-FFF2-40B4-BE49-F238E27FC236}">
-                <a16:creationId xmlns:a16="http://schemas.microsoft.com/office/drawing/2014/main" id="{159C1873-745D-7255-6461-52E605A8515A}"/>
+                <a16:creationId xmlns:a16="http://schemas.microsoft.com/office/drawing/2014/main" id="{183EECB4-AE09-8F8F-7B9E-1D497DEA6593}"/>
               </a:ext>
             </a:extLst>
           </p:cNvPr>
@@ -5853,8 +5853,8 @@
         </p:nvSpPr>
         <p:spPr>
           <a:xfrm>
-            <a:off x="1426788" y="4548570"/>
-            <a:ext cx="7670873" cy="856608"/>
+            <a:off x="1404745" y="4538052"/>
+            <a:ext cx="7714959" cy="892675"/>
           </a:xfrm>
           <a:prstGeom prst="rect">
             <a:avLst/>
@@ -5888,7 +5888,7 @@
           <p:cNvPr id="12" name="source">
             <a:extLst>
               <a:ext uri="{FF2B5EF4-FFF2-40B4-BE49-F238E27FC236}">
-                <a16:creationId xmlns:a16="http://schemas.microsoft.com/office/drawing/2014/main" id="{EADBCFE2-4E31-11AD-63A0-5D096FFEF739}"/>
+                <a16:creationId xmlns:a16="http://schemas.microsoft.com/office/drawing/2014/main" id="{5E8511AD-1B89-6C54-E0FB-537210790DBF}"/>
               </a:ext>
             </a:extLst>
           </p:cNvPr>
@@ -5943,7 +5943,7 @@
     </p:spTree>
     <p:extLst>
       <p:ext uri="{BB962C8B-B14F-4D97-AF65-F5344CB8AC3E}">
-        <p14:creationId xmlns:p14="http://schemas.microsoft.com/office/powerpoint/2010/main" val="1414828381"/>
+        <p14:creationId xmlns:p14="http://schemas.microsoft.com/office/powerpoint/2010/main" val="1248967992"/>
       </p:ext>
     </p:extLst>
   </p:cSld>
@@ -6017,7 +6017,7 @@
           <a:bodyPr/>
           <a:lstStyle/>
           <a:p>
-            <a:fld id="{74813003-FBAE-4237-BD99-D6E83252122A}" type="datetimeFigureOut">
+            <a:fld id="{26B7F381-F10E-4587-B886-8036B7268BA3}" type="datetimeFigureOut">
               <a:rPr lang="en-US" smtClean="0"/>
               <a:t>10/3/2026</a:t>
             </a:fld>
@@ -6059,7 +6059,7 @@
           <a:bodyPr/>
           <a:lstStyle/>
           <a:p>
-            <a:fld id="{BEFED7E7-52D0-4F8A-AF4C-DA16AD6E5F6D}" type="slidenum">
+            <a:fld id="{C8D4D1C8-8C5D-4FFA-950C-FD08A0718FA9}" type="slidenum">
               <a:rPr lang="en-US" smtClean="0"/>
               <a:t>‹#›</a:t>
             </a:fld>
@@ -6072,7 +6072,7 @@
           <p:cNvPr id="6" name="item_1_title">
             <a:extLst>
               <a:ext uri="{FF2B5EF4-FFF2-40B4-BE49-F238E27FC236}">
-                <a16:creationId xmlns:a16="http://schemas.microsoft.com/office/drawing/2014/main" id="{45D7E80F-CDC2-0CDE-A3F3-E5E260179493}"/>
+                <a16:creationId xmlns:a16="http://schemas.microsoft.com/office/drawing/2014/main" id="{A66F4B1D-19F6-6762-36D8-D11FA335D019}"/>
               </a:ext>
             </a:extLst>
           </p:cNvPr>
@@ -6085,8 +6085,8 @@
         </p:nvSpPr>
         <p:spPr>
           <a:xfrm>
-            <a:off x="853677" y="2364972"/>
-            <a:ext cx="3857479" cy="356920"/>
+            <a:off x="831634" y="2339424"/>
+            <a:ext cx="3901565" cy="371948"/>
           </a:xfrm>
         </p:spPr>
         <p:txBody>
@@ -6100,7 +6100,7 @@
               </a:spcBef>
               <a:buFontTx/>
               <a:buNone/>
-              <a:defRPr sz="2200" b="1">
+              <a:defRPr sz="2000" b="1">
                 <a:solidFill>
                   <a:schemeClr val="accent1"/>
                 </a:solidFill>
@@ -6122,7 +6122,7 @@
           <p:cNvPr id="7" name="item_1">
             <a:extLst>
               <a:ext uri="{FF2B5EF4-FFF2-40B4-BE49-F238E27FC236}">
-                <a16:creationId xmlns:a16="http://schemas.microsoft.com/office/drawing/2014/main" id="{E7A855FD-DDAE-0847-0E79-CC730050C0A0}"/>
+                <a16:creationId xmlns:a16="http://schemas.microsoft.com/office/drawing/2014/main" id="{A263FFF8-6947-C6A0-5C42-6BB851036126}"/>
               </a:ext>
             </a:extLst>
           </p:cNvPr>
@@ -6135,8 +6135,8 @@
         </p:nvSpPr>
         <p:spPr>
           <a:xfrm>
-            <a:off x="853677" y="2721892"/>
-            <a:ext cx="3857479" cy="856608"/>
+            <a:off x="831634" y="2711373"/>
+            <a:ext cx="3901565" cy="892675"/>
           </a:xfrm>
           <a:prstGeom prst="rect">
             <a:avLst/>
@@ -6170,7 +6170,7 @@
           <p:cNvPr id="8" name="item_2_title">
             <a:extLst>
               <a:ext uri="{FF2B5EF4-FFF2-40B4-BE49-F238E27FC236}">
-                <a16:creationId xmlns:a16="http://schemas.microsoft.com/office/drawing/2014/main" id="{74284B31-AF3E-142C-5BAC-B1FBDD04D79A}"/>
+                <a16:creationId xmlns:a16="http://schemas.microsoft.com/office/drawing/2014/main" id="{082CD3A4-340D-E67E-FA9F-9A28CD9416C9}"/>
               </a:ext>
             </a:extLst>
           </p:cNvPr>
@@ -6183,8 +6183,8 @@
         </p:nvSpPr>
         <p:spPr>
           <a:xfrm>
-            <a:off x="5240182" y="2364972"/>
-            <a:ext cx="3857479" cy="356920"/>
+            <a:off x="5218139" y="2339424"/>
+            <a:ext cx="3901565" cy="371948"/>
           </a:xfrm>
           <a:prstGeom prst="rect">
             <a:avLst/>
@@ -6201,7 +6201,7 @@
               </a:spcBef>
               <a:buFontTx/>
               <a:buNone/>
-              <a:defRPr sz="2200" b="1">
+              <a:defRPr sz="2000" b="1">
                 <a:solidFill>
                   <a:schemeClr val="accent1"/>
                 </a:solidFill>
@@ -6223,7 +6223,7 @@
           <p:cNvPr id="9" name="item_2">
             <a:extLst>
               <a:ext uri="{FF2B5EF4-FFF2-40B4-BE49-F238E27FC236}">
-                <a16:creationId xmlns:a16="http://schemas.microsoft.com/office/drawing/2014/main" id="{D20609F1-02EC-DB89-F189-CF3EA354BB0A}"/>
+                <a16:creationId xmlns:a16="http://schemas.microsoft.com/office/drawing/2014/main" id="{EA924E16-6D15-B4F0-8A94-7CD592170700}"/>
               </a:ext>
             </a:extLst>
           </p:cNvPr>
@@ -6236,8 +6236,8 @@
         </p:nvSpPr>
         <p:spPr>
           <a:xfrm>
-            <a:off x="5240182" y="2721892"/>
-            <a:ext cx="3857479" cy="856608"/>
+            <a:off x="5218139" y="2711373"/>
+            <a:ext cx="3901565" cy="892675"/>
           </a:xfrm>
           <a:prstGeom prst="rect">
             <a:avLst/>
@@ -6271,7 +6271,7 @@
           <p:cNvPr id="10" name="item_3_title">
             <a:extLst>
               <a:ext uri="{FF2B5EF4-FFF2-40B4-BE49-F238E27FC236}">
-                <a16:creationId xmlns:a16="http://schemas.microsoft.com/office/drawing/2014/main" id="{3F22F937-2BE9-1395-CC1C-4369B6E31C3F}"/>
+                <a16:creationId xmlns:a16="http://schemas.microsoft.com/office/drawing/2014/main" id="{0D817769-5C9D-1A71-A1D2-B0C4CA7A419B}"/>
               </a:ext>
             </a:extLst>
           </p:cNvPr>
@@ -6284,8 +6284,8 @@
         </p:nvSpPr>
         <p:spPr>
           <a:xfrm>
-            <a:off x="853677" y="4191650"/>
-            <a:ext cx="3857479" cy="356920"/>
+            <a:off x="831634" y="4166103"/>
+            <a:ext cx="3901565" cy="371948"/>
           </a:xfrm>
           <a:prstGeom prst="rect">
             <a:avLst/>
@@ -6302,7 +6302,7 @@
               </a:spcBef>
               <a:buFontTx/>
               <a:buNone/>
-              <a:defRPr sz="2200" b="1">
+              <a:defRPr sz="2000" b="1">
                 <a:solidFill>
                   <a:schemeClr val="accent1"/>
                 </a:solidFill>
@@ -6324,7 +6324,7 @@
           <p:cNvPr id="11" name="item_3">
             <a:extLst>
               <a:ext uri="{FF2B5EF4-FFF2-40B4-BE49-F238E27FC236}">
-                <a16:creationId xmlns:a16="http://schemas.microsoft.com/office/drawing/2014/main" id="{6D179C19-612E-BD20-6E41-968F95AA3EED}"/>
+                <a16:creationId xmlns:a16="http://schemas.microsoft.com/office/drawing/2014/main" id="{83006CB0-99EB-5CC7-5914-F6E5ADAF9C83}"/>
               </a:ext>
             </a:extLst>
           </p:cNvPr>
@@ -6337,8 +6337,8 @@
         </p:nvSpPr>
         <p:spPr>
           <a:xfrm>
-            <a:off x="853677" y="4548570"/>
-            <a:ext cx="3857479" cy="856608"/>
+            <a:off x="831634" y="4538052"/>
+            <a:ext cx="3901565" cy="892675"/>
           </a:xfrm>
           <a:prstGeom prst="rect">
             <a:avLst/>
@@ -6372,7 +6372,7 @@
           <p:cNvPr id="12" name="item_4_title">
             <a:extLst>
               <a:ext uri="{FF2B5EF4-FFF2-40B4-BE49-F238E27FC236}">
-                <a16:creationId xmlns:a16="http://schemas.microsoft.com/office/drawing/2014/main" id="{6DC226D1-99DF-CADC-F89A-6050E84CDD4B}"/>
+                <a16:creationId xmlns:a16="http://schemas.microsoft.com/office/drawing/2014/main" id="{EB59D658-6E6D-8C42-0075-D3883F0933E7}"/>
               </a:ext>
             </a:extLst>
           </p:cNvPr>
@@ -6385,8 +6385,8 @@
         </p:nvSpPr>
         <p:spPr>
           <a:xfrm>
-            <a:off x="5240182" y="4191650"/>
-            <a:ext cx="3857479" cy="356920"/>
+            <a:off x="5218139" y="4166103"/>
+            <a:ext cx="3901565" cy="371948"/>
           </a:xfrm>
           <a:prstGeom prst="rect">
             <a:avLst/>
@@ -6403,7 +6403,7 @@
               </a:spcBef>
               <a:buFontTx/>
               <a:buNone/>
-              <a:defRPr sz="2200" b="1">
+              <a:defRPr sz="2000" b="1">
                 <a:solidFill>
                   <a:schemeClr val="accent1"/>
                 </a:solidFill>
@@ -6425,7 +6425,7 @@
           <p:cNvPr id="13" name="item_4">
             <a:extLst>
               <a:ext uri="{FF2B5EF4-FFF2-40B4-BE49-F238E27FC236}">
-                <a16:creationId xmlns:a16="http://schemas.microsoft.com/office/drawing/2014/main" id="{E62C9BBD-6319-F1DE-E3B1-904C2E4E4B8D}"/>
+                <a16:creationId xmlns:a16="http://schemas.microsoft.com/office/drawing/2014/main" id="{F79CBF55-483D-2A25-954D-0939568EF304}"/>
               </a:ext>
             </a:extLst>
           </p:cNvPr>
@@ -6438,8 +6438,8 @@
         </p:nvSpPr>
         <p:spPr>
           <a:xfrm>
-            <a:off x="5240182" y="4548570"/>
-            <a:ext cx="3857479" cy="856608"/>
+            <a:off x="5218139" y="4538052"/>
+            <a:ext cx="3901565" cy="892675"/>
           </a:xfrm>
           <a:prstGeom prst="rect">
             <a:avLst/>
@@ -6473,7 +6473,7 @@
           <p:cNvPr id="14" name="source">
             <a:extLst>
               <a:ext uri="{FF2B5EF4-FFF2-40B4-BE49-F238E27FC236}">
-                <a16:creationId xmlns:a16="http://schemas.microsoft.com/office/drawing/2014/main" id="{580E4FF6-BF76-B968-092D-6ECFDEC7053F}"/>
+                <a16:creationId xmlns:a16="http://schemas.microsoft.com/office/drawing/2014/main" id="{D213DFB0-2533-9B2C-70B2-64655D39A0EF}"/>
               </a:ext>
             </a:extLst>
           </p:cNvPr>
@@ -6528,7 +6528,7 @@
     </p:spTree>
     <p:extLst>
       <p:ext uri="{BB962C8B-B14F-4D97-AF65-F5344CB8AC3E}">
-        <p14:creationId xmlns:p14="http://schemas.microsoft.com/office/powerpoint/2010/main" val="1618360736"/>
+        <p14:creationId xmlns:p14="http://schemas.microsoft.com/office/powerpoint/2010/main" val="3295304285"/>
       </p:ext>
     </p:extLst>
   </p:cSld>
@@ -6602,7 +6602,7 @@
           <a:bodyPr/>
           <a:lstStyle/>
           <a:p>
-            <a:fld id="{74813003-FBAE-4237-BD99-D6E83252122A}" type="datetimeFigureOut">
+            <a:fld id="{26B7F381-F10E-4587-B886-8036B7268BA3}" type="datetimeFigureOut">
               <a:rPr lang="en-US" smtClean="0"/>
               <a:t>10/3/2026</a:t>
             </a:fld>
@@ -6644,7 +6644,7 @@
           <a:bodyPr/>
           <a:lstStyle/>
           <a:p>
-            <a:fld id="{BEFED7E7-52D0-4F8A-AF4C-DA16AD6E5F6D}" type="slidenum">
+            <a:fld id="{C8D4D1C8-8C5D-4FFA-950C-FD08A0718FA9}" type="slidenum">
               <a:rPr lang="en-US" smtClean="0"/>
               <a:t>‹#›</a:t>
             </a:fld>
@@ -6657,7 +6657,7 @@
           <p:cNvPr id="6" name="item_1_title">
             <a:extLst>
               <a:ext uri="{FF2B5EF4-FFF2-40B4-BE49-F238E27FC236}">
-                <a16:creationId xmlns:a16="http://schemas.microsoft.com/office/drawing/2014/main" id="{B424EA7F-4248-DED1-1CEB-1357045455CD}"/>
+                <a16:creationId xmlns:a16="http://schemas.microsoft.com/office/drawing/2014/main" id="{A82B557C-F9E6-2909-95B2-F3324198C925}"/>
               </a:ext>
             </a:extLst>
           </p:cNvPr>
@@ -6670,8 +6670,8 @@
         </p:nvSpPr>
         <p:spPr>
           <a:xfrm>
-            <a:off x="677335" y="2523639"/>
-            <a:ext cx="2016911" cy="907624"/>
+            <a:off x="831633" y="2664825"/>
+            <a:ext cx="1708312" cy="813500"/>
           </a:xfrm>
         </p:spPr>
         <p:txBody>
@@ -6685,7 +6685,7 @@
               </a:spcBef>
               <a:buFontTx/>
               <a:buNone/>
-              <a:defRPr sz="2200" b="1">
+              <a:defRPr sz="2000" b="1">
                 <a:solidFill>
                   <a:schemeClr val="accent1"/>
                 </a:solidFill>
@@ -6707,7 +6707,7 @@
           <p:cNvPr id="7" name="item_1">
             <a:extLst>
               <a:ext uri="{FF2B5EF4-FFF2-40B4-BE49-F238E27FC236}">
-                <a16:creationId xmlns:a16="http://schemas.microsoft.com/office/drawing/2014/main" id="{4A8F3A48-B1CF-C1BC-1F6A-7616BD0CE99D}"/>
+                <a16:creationId xmlns:a16="http://schemas.microsoft.com/office/drawing/2014/main" id="{1759F181-5CBF-9AAF-E2D2-1A0C3FB9CC85}"/>
               </a:ext>
             </a:extLst>
           </p:cNvPr>
@@ -6720,8 +6720,8 @@
         </p:nvSpPr>
         <p:spPr>
           <a:xfrm>
-            <a:off x="677335" y="3431264"/>
-            <a:ext cx="2016911" cy="2178299"/>
+            <a:off x="831633" y="3478326"/>
+            <a:ext cx="1708312" cy="1952401"/>
           </a:xfrm>
           <a:prstGeom prst="rect">
             <a:avLst/>
@@ -6755,7 +6755,7 @@
           <p:cNvPr id="8" name="item_2_title">
             <a:extLst>
               <a:ext uri="{FF2B5EF4-FFF2-40B4-BE49-F238E27FC236}">
-                <a16:creationId xmlns:a16="http://schemas.microsoft.com/office/drawing/2014/main" id="{650E491F-D2F1-8B28-8DDF-9CD2E7239F59}"/>
+                <a16:creationId xmlns:a16="http://schemas.microsoft.com/office/drawing/2014/main" id="{985234E0-875D-62EE-D7B5-9B5E1C770BA0}"/>
               </a:ext>
             </a:extLst>
           </p:cNvPr>
@@ -6768,8 +6768,8 @@
         </p:nvSpPr>
         <p:spPr>
           <a:xfrm>
-            <a:off x="2870588" y="2523639"/>
-            <a:ext cx="2016911" cy="907624"/>
+            <a:off x="3024886" y="2664825"/>
+            <a:ext cx="1708312" cy="813500"/>
           </a:xfrm>
           <a:prstGeom prst="rect">
             <a:avLst/>
@@ -6786,7 +6786,7 @@
               </a:spcBef>
               <a:buFontTx/>
               <a:buNone/>
-              <a:defRPr sz="2200" b="1">
+              <a:defRPr sz="2000" b="1">
                 <a:solidFill>
                   <a:schemeClr val="accent1"/>
                 </a:solidFill>
@@ -6808,7 +6808,7 @@
           <p:cNvPr id="9" name="item_2">
             <a:extLst>
               <a:ext uri="{FF2B5EF4-FFF2-40B4-BE49-F238E27FC236}">
-                <a16:creationId xmlns:a16="http://schemas.microsoft.com/office/drawing/2014/main" id="{6699035F-1899-4A17-553C-83CF119943E4}"/>
+                <a16:creationId xmlns:a16="http://schemas.microsoft.com/office/drawing/2014/main" id="{E2C2FD0F-7CF8-73CD-6AA8-A9CDB1FF5447}"/>
               </a:ext>
             </a:extLst>
           </p:cNvPr>
@@ -6821,8 +6821,8 @@
         </p:nvSpPr>
         <p:spPr>
           <a:xfrm>
-            <a:off x="2870588" y="3431264"/>
-            <a:ext cx="2016911" cy="2178299"/>
+            <a:off x="3024886" y="3478326"/>
+            <a:ext cx="1708312" cy="1952401"/>
           </a:xfrm>
           <a:prstGeom prst="rect">
             <a:avLst/>
@@ -6856,7 +6856,7 @@
           <p:cNvPr id="10" name="item_3_title">
             <a:extLst>
               <a:ext uri="{FF2B5EF4-FFF2-40B4-BE49-F238E27FC236}">
-                <a16:creationId xmlns:a16="http://schemas.microsoft.com/office/drawing/2014/main" id="{96B264CE-268E-5C11-BE69-9450712A8930}"/>
+                <a16:creationId xmlns:a16="http://schemas.microsoft.com/office/drawing/2014/main" id="{6534B3C1-DD7D-67BF-014C-D43E33DB2CEC}"/>
               </a:ext>
             </a:extLst>
           </p:cNvPr>
@@ -6869,8 +6869,8 @@
         </p:nvSpPr>
         <p:spPr>
           <a:xfrm>
-            <a:off x="5063840" y="2523639"/>
-            <a:ext cx="2016911" cy="907624"/>
+            <a:off x="5218138" y="2664825"/>
+            <a:ext cx="1708312" cy="813500"/>
           </a:xfrm>
           <a:prstGeom prst="rect">
             <a:avLst/>
@@ -6887,7 +6887,7 @@
               </a:spcBef>
               <a:buFontTx/>
               <a:buNone/>
-              <a:defRPr sz="2200" b="1">
+              <a:defRPr sz="2000" b="1">
                 <a:solidFill>
                   <a:schemeClr val="accent1"/>
                 </a:solidFill>
@@ -6909,7 +6909,7 @@
           <p:cNvPr id="11" name="item_3">
             <a:extLst>
               <a:ext uri="{FF2B5EF4-FFF2-40B4-BE49-F238E27FC236}">
-                <a16:creationId xmlns:a16="http://schemas.microsoft.com/office/drawing/2014/main" id="{4BAC1D25-B1DC-2E88-A401-566C0056DC3E}"/>
+                <a16:creationId xmlns:a16="http://schemas.microsoft.com/office/drawing/2014/main" id="{F2674D97-6271-5B56-1671-6A0E757AA5A3}"/>
               </a:ext>
             </a:extLst>
           </p:cNvPr>
@@ -6922,8 +6922,8 @@
         </p:nvSpPr>
         <p:spPr>
           <a:xfrm>
-            <a:off x="5063840" y="3431264"/>
-            <a:ext cx="2016911" cy="2178299"/>
+            <a:off x="5218138" y="3478326"/>
+            <a:ext cx="1708312" cy="1952401"/>
           </a:xfrm>
           <a:prstGeom prst="rect">
             <a:avLst/>
@@ -6957,7 +6957,7 @@
           <p:cNvPr id="12" name="item_4_title">
             <a:extLst>
               <a:ext uri="{FF2B5EF4-FFF2-40B4-BE49-F238E27FC236}">
-                <a16:creationId xmlns:a16="http://schemas.microsoft.com/office/drawing/2014/main" id="{CC51308F-3CBA-DE1D-C12C-B1C777DCC981}"/>
+                <a16:creationId xmlns:a16="http://schemas.microsoft.com/office/drawing/2014/main" id="{CA4EB01F-6326-7CD2-2B1F-2B46B09543B6}"/>
               </a:ext>
             </a:extLst>
           </p:cNvPr>
@@ -6970,8 +6970,8 @@
         </p:nvSpPr>
         <p:spPr>
           <a:xfrm>
-            <a:off x="7257093" y="2523639"/>
-            <a:ext cx="2016911" cy="907624"/>
+            <a:off x="7411391" y="2664825"/>
+            <a:ext cx="1708312" cy="813500"/>
           </a:xfrm>
           <a:prstGeom prst="rect">
             <a:avLst/>
@@ -6988,7 +6988,7 @@
               </a:spcBef>
               <a:buFontTx/>
               <a:buNone/>
-              <a:defRPr sz="2200" b="1">
+              <a:defRPr sz="2000" b="1">
                 <a:solidFill>
                   <a:schemeClr val="accent1"/>
                 </a:solidFill>
@@ -7010,7 +7010,7 @@
           <p:cNvPr id="13" name="item_4">
             <a:extLst>
               <a:ext uri="{FF2B5EF4-FFF2-40B4-BE49-F238E27FC236}">
-                <a16:creationId xmlns:a16="http://schemas.microsoft.com/office/drawing/2014/main" id="{5DF74259-F030-EF29-0BD8-951FE64CA2F6}"/>
+                <a16:creationId xmlns:a16="http://schemas.microsoft.com/office/drawing/2014/main" id="{AB8B51CF-0A59-0149-BCEF-8F147FBA4342}"/>
               </a:ext>
             </a:extLst>
           </p:cNvPr>
@@ -7023,8 +7023,8 @@
         </p:nvSpPr>
         <p:spPr>
           <a:xfrm>
-            <a:off x="7257093" y="3431264"/>
-            <a:ext cx="2016911" cy="2178299"/>
+            <a:off x="7411391" y="3478326"/>
+            <a:ext cx="1708312" cy="1952401"/>
           </a:xfrm>
           <a:prstGeom prst="rect">
             <a:avLst/>
@@ -7058,7 +7058,7 @@
           <p:cNvPr id="14" name="source">
             <a:extLst>
               <a:ext uri="{FF2B5EF4-FFF2-40B4-BE49-F238E27FC236}">
-                <a16:creationId xmlns:a16="http://schemas.microsoft.com/office/drawing/2014/main" id="{A6BE486C-0FF8-357F-C23E-D17C7224A692}"/>
+                <a16:creationId xmlns:a16="http://schemas.microsoft.com/office/drawing/2014/main" id="{8A94C8F4-FF07-CFAF-B12A-BC3F6660AE5C}"/>
               </a:ext>
             </a:extLst>
           </p:cNvPr>
@@ -7113,7 +7113,7 @@
     </p:spTree>
     <p:extLst>
       <p:ext uri="{BB962C8B-B14F-4D97-AF65-F5344CB8AC3E}">
-        <p14:creationId xmlns:p14="http://schemas.microsoft.com/office/powerpoint/2010/main" val="3048684986"/>
+        <p14:creationId xmlns:p14="http://schemas.microsoft.com/office/powerpoint/2010/main" val="2081088695"/>
       </p:ext>
     </p:extLst>
   </p:cSld>
@@ -7187,7 +7187,7 @@
           <a:bodyPr/>
           <a:lstStyle/>
           <a:p>
-            <a:fld id="{74813003-FBAE-4237-BD99-D6E83252122A}" type="datetimeFigureOut">
+            <a:fld id="{26B7F381-F10E-4587-B886-8036B7268BA3}" type="datetimeFigureOut">
               <a:rPr lang="en-US" smtClean="0"/>
               <a:t>10/3/2026</a:t>
             </a:fld>
@@ -7229,7 +7229,7 @@
           <a:bodyPr/>
           <a:lstStyle/>
           <a:p>
-            <a:fld id="{BEFED7E7-52D0-4F8A-AF4C-DA16AD6E5F6D}" type="slidenum">
+            <a:fld id="{C8D4D1C8-8C5D-4FFA-950C-FD08A0718FA9}" type="slidenum">
               <a:rPr lang="en-US" smtClean="0"/>
               <a:t>‹#›</a:t>
             </a:fld>
@@ -7242,7 +7242,7 @@
           <p:cNvPr id="6" name="kpi_value_1">
             <a:extLst>
               <a:ext uri="{FF2B5EF4-FFF2-40B4-BE49-F238E27FC236}">
-                <a16:creationId xmlns:a16="http://schemas.microsoft.com/office/drawing/2014/main" id="{3F187785-5FA3-D558-AAE6-E8BA18B1A71D}"/>
+                <a16:creationId xmlns:a16="http://schemas.microsoft.com/office/drawing/2014/main" id="{FE02A1D8-B591-2A41-6217-49EA82328153}"/>
               </a:ext>
             </a:extLst>
           </p:cNvPr>
@@ -7255,8 +7255,8 @@
         </p:nvSpPr>
         <p:spPr>
           <a:xfrm>
-            <a:off x="853676" y="2364972"/>
-            <a:ext cx="4117584" cy="1884928"/>
+            <a:off x="831634" y="2339424"/>
+            <a:ext cx="4161669" cy="1916607"/>
           </a:xfrm>
         </p:spPr>
         <p:txBody>
@@ -7292,7 +7292,7 @@
           <p:cNvPr id="7" name="kpi_label_1">
             <a:extLst>
               <a:ext uri="{FF2B5EF4-FFF2-40B4-BE49-F238E27FC236}">
-                <a16:creationId xmlns:a16="http://schemas.microsoft.com/office/drawing/2014/main" id="{4D570DB9-EA92-3235-DFB1-BDB7BA294E87}"/>
+                <a16:creationId xmlns:a16="http://schemas.microsoft.com/office/drawing/2014/main" id="{382DAD34-C861-6147-B9D2-A7CC0C008190}"/>
               </a:ext>
             </a:extLst>
           </p:cNvPr>
@@ -7305,8 +7305,8 @@
         </p:nvSpPr>
         <p:spPr>
           <a:xfrm>
-            <a:off x="853676" y="4310704"/>
-            <a:ext cx="4117584" cy="1094474"/>
+            <a:off x="831634" y="4317858"/>
+            <a:ext cx="4161669" cy="1112869"/>
           </a:xfrm>
           <a:prstGeom prst="rect">
             <a:avLst/>
@@ -7323,7 +7323,7 @@
               </a:spcBef>
               <a:buFontTx/>
               <a:buNone/>
-              <a:defRPr sz="1800"/>
+              <a:defRPr sz="2000"/>
             </a:lvl1pPr>
           </a:lstStyle>
           <a:p>
@@ -7340,7 +7340,7 @@
           <p:cNvPr id="8" name="quote">
             <a:extLst>
               <a:ext uri="{FF2B5EF4-FFF2-40B4-BE49-F238E27FC236}">
-                <a16:creationId xmlns:a16="http://schemas.microsoft.com/office/drawing/2014/main" id="{CBD339B4-A5D6-2D1A-2BED-94D89A57A67C}"/>
+                <a16:creationId xmlns:a16="http://schemas.microsoft.com/office/drawing/2014/main" id="{8A056F37-A2FB-8C95-E56F-898FB3F85079}"/>
               </a:ext>
             </a:extLst>
           </p:cNvPr>
@@ -7353,8 +7353,8 @@
         </p:nvSpPr>
         <p:spPr>
           <a:xfrm>
-            <a:off x="853676" y="2364972"/>
-            <a:ext cx="4117584" cy="2371360"/>
+            <a:off x="831634" y="2339425"/>
+            <a:ext cx="4161669" cy="2411215"/>
           </a:xfrm>
           <a:prstGeom prst="rect">
             <a:avLst/>
@@ -7371,7 +7371,7 @@
               </a:spcBef>
               <a:buFontTx/>
               <a:buNone/>
-              <a:defRPr sz="2400" i="1">
+              <a:defRPr sz="2000" i="1">
                 <a:latin typeface="+mj-lt"/>
               </a:defRPr>
             </a:lvl1pPr>
@@ -7390,7 +7390,7 @@
           <p:cNvPr id="9" name="attribution">
             <a:extLst>
               <a:ext uri="{FF2B5EF4-FFF2-40B4-BE49-F238E27FC236}">
-                <a16:creationId xmlns:a16="http://schemas.microsoft.com/office/drawing/2014/main" id="{CAF3667D-C677-75BE-2840-7969A8E7277C}"/>
+                <a16:creationId xmlns:a16="http://schemas.microsoft.com/office/drawing/2014/main" id="{D937CD50-2404-C18F-DAD7-4E34FBF9128E}"/>
               </a:ext>
             </a:extLst>
           </p:cNvPr>
@@ -7403,8 +7403,8 @@
         </p:nvSpPr>
         <p:spPr>
           <a:xfrm>
-            <a:off x="853676" y="4797138"/>
-            <a:ext cx="4117584" cy="608041"/>
+            <a:off x="831634" y="4812466"/>
+            <a:ext cx="4161669" cy="618260"/>
           </a:xfrm>
           <a:prstGeom prst="rect">
             <a:avLst/>
@@ -7421,7 +7421,7 @@
               </a:spcBef>
               <a:buFontTx/>
               <a:buNone/>
-              <a:defRPr sz="1400"/>
+              <a:defRPr sz="2000"/>
             </a:lvl1pPr>
           </a:lstStyle>
           <a:p>
@@ -7438,7 +7438,7 @@
           <p:cNvPr id="10" name="item_1_title">
             <a:extLst>
               <a:ext uri="{FF2B5EF4-FFF2-40B4-BE49-F238E27FC236}">
-                <a16:creationId xmlns:a16="http://schemas.microsoft.com/office/drawing/2014/main" id="{4E0FCC8A-9F2D-9A58-9F10-CC90FF42DE86}"/>
+                <a16:creationId xmlns:a16="http://schemas.microsoft.com/office/drawing/2014/main" id="{73B9E58C-0E95-CF30-40FD-15B6E9C4F5B2}"/>
               </a:ext>
             </a:extLst>
           </p:cNvPr>
@@ -7469,7 +7469,7 @@
               </a:spcBef>
               <a:buFontTx/>
               <a:buNone/>
-              <a:defRPr sz="2200" b="1">
+              <a:defRPr sz="2000" b="1">
                 <a:solidFill>
                   <a:schemeClr val="accent1"/>
                 </a:solidFill>
@@ -7491,7 +7491,7 @@
           <p:cNvPr id="11" name="item_1">
             <a:extLst>
               <a:ext uri="{FF2B5EF4-FFF2-40B4-BE49-F238E27FC236}">
-                <a16:creationId xmlns:a16="http://schemas.microsoft.com/office/drawing/2014/main" id="{A9FE6B4E-24E2-BF37-42A9-0510B2920FAE}"/>
+                <a16:creationId xmlns:a16="http://schemas.microsoft.com/office/drawing/2014/main" id="{EBC12DED-1740-2DA4-328D-94CFD931D04C}"/>
               </a:ext>
             </a:extLst>
           </p:cNvPr>
@@ -7539,7 +7539,7 @@
           <p:cNvPr id="12" name="source">
             <a:extLst>
               <a:ext uri="{FF2B5EF4-FFF2-40B4-BE49-F238E27FC236}">
-                <a16:creationId xmlns:a16="http://schemas.microsoft.com/office/drawing/2014/main" id="{1F5EAD83-048B-C871-B6A3-EEA17EB28A14}"/>
+                <a16:creationId xmlns:a16="http://schemas.microsoft.com/office/drawing/2014/main" id="{7D1FE783-D7E1-EFAC-3662-617F994FC883}"/>
               </a:ext>
             </a:extLst>
           </p:cNvPr>
@@ -7594,7 +7594,7 @@
     </p:spTree>
     <p:extLst>
       <p:ext uri="{BB962C8B-B14F-4D97-AF65-F5344CB8AC3E}">
-        <p14:creationId xmlns:p14="http://schemas.microsoft.com/office/powerpoint/2010/main" val="924900273"/>
+        <p14:creationId xmlns:p14="http://schemas.microsoft.com/office/powerpoint/2010/main" val="2916170524"/>
       </p:ext>
     </p:extLst>
   </p:cSld>
@@ -7668,7 +7668,7 @@
           <a:bodyPr/>
           <a:lstStyle/>
           <a:p>
-            <a:fld id="{74813003-FBAE-4237-BD99-D6E83252122A}" type="datetimeFigureOut">
+            <a:fld id="{26B7F381-F10E-4587-B886-8036B7268BA3}" type="datetimeFigureOut">
               <a:rPr lang="en-US" smtClean="0"/>
               <a:t>10/3/2026</a:t>
             </a:fld>
@@ -7710,7 +7710,7 @@
           <a:bodyPr/>
           <a:lstStyle/>
           <a:p>
-            <a:fld id="{BEFED7E7-52D0-4F8A-AF4C-DA16AD6E5F6D}" type="slidenum">
+            <a:fld id="{C8D4D1C8-8C5D-4FFA-950C-FD08A0718FA9}" type="slidenum">
               <a:rPr lang="en-US" smtClean="0"/>
               <a:t>‹#›</a:t>
             </a:fld>
@@ -7723,7 +7723,7 @@
           <p:cNvPr id="6" name="item_1_title">
             <a:extLst>
               <a:ext uri="{FF2B5EF4-FFF2-40B4-BE49-F238E27FC236}">
-                <a16:creationId xmlns:a16="http://schemas.microsoft.com/office/drawing/2014/main" id="{3ED4452D-82AD-7797-A94D-75921636A1A1}"/>
+                <a16:creationId xmlns:a16="http://schemas.microsoft.com/office/drawing/2014/main" id="{4CE38480-4F6E-8CCA-03BE-2AFD8984B10A}"/>
               </a:ext>
             </a:extLst>
           </p:cNvPr>
@@ -7736,8 +7736,8 @@
         </p:nvSpPr>
         <p:spPr>
           <a:xfrm>
-            <a:off x="853677" y="2364972"/>
-            <a:ext cx="2395311" cy="894178"/>
+            <a:off x="831633" y="2339424"/>
+            <a:ext cx="2439396" cy="909206"/>
           </a:xfrm>
         </p:spPr>
         <p:txBody>
@@ -7751,7 +7751,7 @@
               </a:spcBef>
               <a:buFontTx/>
               <a:buNone/>
-              <a:defRPr sz="2200" b="1">
+              <a:defRPr sz="2000" b="1">
                 <a:solidFill>
                   <a:schemeClr val="accent1"/>
                 </a:solidFill>
@@ -7773,7 +7773,7 @@
           <p:cNvPr id="7" name="item_1">
             <a:extLst>
               <a:ext uri="{FF2B5EF4-FFF2-40B4-BE49-F238E27FC236}">
-                <a16:creationId xmlns:a16="http://schemas.microsoft.com/office/drawing/2014/main" id="{E06A0743-CBAF-0D47-B2BA-793CA4651E18}"/>
+                <a16:creationId xmlns:a16="http://schemas.microsoft.com/office/drawing/2014/main" id="{4518BC07-8CF6-A598-542A-F143B970ADA2}"/>
               </a:ext>
             </a:extLst>
           </p:cNvPr>
@@ -7786,8 +7786,8 @@
         </p:nvSpPr>
         <p:spPr>
           <a:xfrm>
-            <a:off x="853677" y="3259150"/>
-            <a:ext cx="2395311" cy="2146028"/>
+            <a:off x="831633" y="3248632"/>
+            <a:ext cx="2439396" cy="2182095"/>
           </a:xfrm>
           <a:prstGeom prst="rect">
             <a:avLst/>
@@ -7821,7 +7821,7 @@
           <p:cNvPr id="8" name="item_2_title">
             <a:extLst>
               <a:ext uri="{FF2B5EF4-FFF2-40B4-BE49-F238E27FC236}">
-                <a16:creationId xmlns:a16="http://schemas.microsoft.com/office/drawing/2014/main" id="{391191B0-B271-D9EE-2315-5B5F58349D1E}"/>
+                <a16:creationId xmlns:a16="http://schemas.microsoft.com/office/drawing/2014/main" id="{980F8E42-F78B-9FED-66EF-E8452D57B8D1}"/>
               </a:ext>
             </a:extLst>
           </p:cNvPr>
@@ -7834,8 +7834,8 @@
         </p:nvSpPr>
         <p:spPr>
           <a:xfrm>
-            <a:off x="3778014" y="2364972"/>
-            <a:ext cx="2395311" cy="894178"/>
+            <a:off x="3755970" y="2339424"/>
+            <a:ext cx="2439396" cy="909206"/>
           </a:xfrm>
           <a:prstGeom prst="rect">
             <a:avLst/>
@@ -7852,7 +7852,7 @@
               </a:spcBef>
               <a:buFontTx/>
               <a:buNone/>
-              <a:defRPr sz="2200" b="1">
+              <a:defRPr sz="2000" b="1">
                 <a:solidFill>
                   <a:schemeClr val="accent1"/>
                 </a:solidFill>
@@ -7874,7 +7874,7 @@
           <p:cNvPr id="9" name="item_2">
             <a:extLst>
               <a:ext uri="{FF2B5EF4-FFF2-40B4-BE49-F238E27FC236}">
-                <a16:creationId xmlns:a16="http://schemas.microsoft.com/office/drawing/2014/main" id="{FA549014-39B1-B203-17B3-22368D1AAEE3}"/>
+                <a16:creationId xmlns:a16="http://schemas.microsoft.com/office/drawing/2014/main" id="{37B211D8-27A4-3CAA-E7DD-74CFC3175072}"/>
               </a:ext>
             </a:extLst>
           </p:cNvPr>
@@ -7887,8 +7887,8 @@
         </p:nvSpPr>
         <p:spPr>
           <a:xfrm>
-            <a:off x="3778014" y="3259150"/>
-            <a:ext cx="2395311" cy="2146028"/>
+            <a:off x="3755970" y="3248632"/>
+            <a:ext cx="2439396" cy="2182095"/>
           </a:xfrm>
           <a:prstGeom prst="rect">
             <a:avLst/>
@@ -7922,7 +7922,7 @@
           <p:cNvPr id="10" name="item_3_title">
             <a:extLst>
               <a:ext uri="{FF2B5EF4-FFF2-40B4-BE49-F238E27FC236}">
-                <a16:creationId xmlns:a16="http://schemas.microsoft.com/office/drawing/2014/main" id="{304111A8-C19A-EE7B-09AB-8CE18ED997CB}"/>
+                <a16:creationId xmlns:a16="http://schemas.microsoft.com/office/drawing/2014/main" id="{90A760BD-0709-7BC5-6878-C12217801D43}"/>
               </a:ext>
             </a:extLst>
           </p:cNvPr>
@@ -7935,8 +7935,8 @@
         </p:nvSpPr>
         <p:spPr>
           <a:xfrm>
-            <a:off x="6702350" y="2364972"/>
-            <a:ext cx="2395311" cy="894178"/>
+            <a:off x="6680306" y="2339424"/>
+            <a:ext cx="2439396" cy="909206"/>
           </a:xfrm>
           <a:prstGeom prst="rect">
             <a:avLst/>
@@ -7953,7 +7953,7 @@
               </a:spcBef>
               <a:buFontTx/>
               <a:buNone/>
-              <a:defRPr sz="2200" b="1">
+              <a:defRPr sz="2000" b="1">
                 <a:solidFill>
                   <a:schemeClr val="accent1"/>
                 </a:solidFill>
@@ -7975,7 +7975,7 @@
           <p:cNvPr id="11" name="item_3">
             <a:extLst>
               <a:ext uri="{FF2B5EF4-FFF2-40B4-BE49-F238E27FC236}">
-                <a16:creationId xmlns:a16="http://schemas.microsoft.com/office/drawing/2014/main" id="{96C0ED82-A595-6B6B-A74E-805B7398B34F}"/>
+                <a16:creationId xmlns:a16="http://schemas.microsoft.com/office/drawing/2014/main" id="{82955BC4-66A5-6D0B-8D44-865A6FBAA95B}"/>
               </a:ext>
             </a:extLst>
           </p:cNvPr>
@@ -7988,8 +7988,8 @@
         </p:nvSpPr>
         <p:spPr>
           <a:xfrm>
-            <a:off x="6702350" y="3259150"/>
-            <a:ext cx="2395311" cy="2146028"/>
+            <a:off x="6680306" y="3248632"/>
+            <a:ext cx="2439396" cy="2182095"/>
           </a:xfrm>
           <a:prstGeom prst="rect">
             <a:avLst/>
@@ -8023,7 +8023,7 @@
           <p:cNvPr id="12" name="source">
             <a:extLst>
               <a:ext uri="{FF2B5EF4-FFF2-40B4-BE49-F238E27FC236}">
-                <a16:creationId xmlns:a16="http://schemas.microsoft.com/office/drawing/2014/main" id="{9053EC5A-B18B-1EA3-B972-05177DB0D77A}"/>
+                <a16:creationId xmlns:a16="http://schemas.microsoft.com/office/drawing/2014/main" id="{DD4AC4BA-5C71-F09B-BD24-20E58D1B22C0}"/>
               </a:ext>
             </a:extLst>
           </p:cNvPr>
@@ -8078,7 +8078,7 @@
     </p:spTree>
     <p:extLst>
       <p:ext uri="{BB962C8B-B14F-4D97-AF65-F5344CB8AC3E}">
-        <p14:creationId xmlns:p14="http://schemas.microsoft.com/office/powerpoint/2010/main" val="2844798065"/>
+        <p14:creationId xmlns:p14="http://schemas.microsoft.com/office/powerpoint/2010/main" val="3279616881"/>
       </p:ext>
     </p:extLst>
   </p:cSld>
@@ -8152,7 +8152,7 @@
           <a:bodyPr/>
           <a:lstStyle/>
           <a:p>
-            <a:fld id="{74813003-FBAE-4237-BD99-D6E83252122A}" type="datetimeFigureOut">
+            <a:fld id="{26B7F381-F10E-4587-B886-8036B7268BA3}" type="datetimeFigureOut">
               <a:rPr lang="en-US" smtClean="0"/>
               <a:t>10/3/2026</a:t>
             </a:fld>
@@ -8194,7 +8194,7 @@
           <a:bodyPr/>
           <a:lstStyle/>
           <a:p>
-            <a:fld id="{BEFED7E7-52D0-4F8A-AF4C-DA16AD6E5F6D}" type="slidenum">
+            <a:fld id="{C8D4D1C8-8C5D-4FFA-950C-FD08A0718FA9}" type="slidenum">
               <a:rPr lang="en-US" smtClean="0"/>
               <a:t>‹#›</a:t>
             </a:fld>
@@ -8207,7 +8207,7 @@
           <p:cNvPr id="6" name="marker_1">
             <a:extLst>
               <a:ext uri="{FF2B5EF4-FFF2-40B4-BE49-F238E27FC236}">
-                <a16:creationId xmlns:a16="http://schemas.microsoft.com/office/drawing/2014/main" id="{C48DB426-1DB8-74DE-1EF4-9035E5E38D7B}"/>
+                <a16:creationId xmlns:a16="http://schemas.microsoft.com/office/drawing/2014/main" id="{C61F946C-C802-6F70-BF0B-6BCD5556267F}"/>
               </a:ext>
             </a:extLst>
           </p:cNvPr>
@@ -8220,7 +8220,7 @@
         </p:nvSpPr>
         <p:spPr>
           <a:xfrm>
-            <a:off x="853676" y="2364972"/>
+            <a:off x="831633" y="2339424"/>
             <a:ext cx="484940" cy="562055"/>
           </a:xfrm>
           <a:prstGeom prst="ellipse">
@@ -8241,7 +8241,7 @@
               </a:spcBef>
               <a:buFontTx/>
               <a:buNone/>
-              <a:defRPr sz="2400" b="1">
+              <a:defRPr sz="2000" b="1">
                 <a:solidFill>
                   <a:schemeClr val="bg1"/>
                 </a:solidFill>
@@ -8263,7 +8263,7 @@
           <p:cNvPr id="7" name="item_1_title">
             <a:extLst>
               <a:ext uri="{FF2B5EF4-FFF2-40B4-BE49-F238E27FC236}">
-                <a16:creationId xmlns:a16="http://schemas.microsoft.com/office/drawing/2014/main" id="{2CC4D461-BD10-1BBC-3F2E-7ACC99F723AD}"/>
+                <a16:creationId xmlns:a16="http://schemas.microsoft.com/office/drawing/2014/main" id="{F611958B-6E13-5990-86E3-13F2831BF46F}"/>
               </a:ext>
             </a:extLst>
           </p:cNvPr>
@@ -8276,8 +8276,8 @@
         </p:nvSpPr>
         <p:spPr>
           <a:xfrm>
-            <a:off x="1426788" y="2364972"/>
-            <a:ext cx="7670873" cy="356920"/>
+            <a:off x="1404745" y="2339424"/>
+            <a:ext cx="7714959" cy="371948"/>
           </a:xfrm>
           <a:prstGeom prst="rect">
             <a:avLst/>
@@ -8294,7 +8294,7 @@
               </a:spcBef>
               <a:buFontTx/>
               <a:buNone/>
-              <a:defRPr sz="2200" b="1">
+              <a:defRPr sz="2000" b="1">
                 <a:solidFill>
                   <a:schemeClr val="accent1"/>
                 </a:solidFill>
@@ -8316,7 +8316,7 @@
           <p:cNvPr id="8" name="item_1">
             <a:extLst>
               <a:ext uri="{FF2B5EF4-FFF2-40B4-BE49-F238E27FC236}">
-                <a16:creationId xmlns:a16="http://schemas.microsoft.com/office/drawing/2014/main" id="{9239BA51-CBCB-90C9-C510-575C427A5391}"/>
+                <a16:creationId xmlns:a16="http://schemas.microsoft.com/office/drawing/2014/main" id="{B84976C9-C14C-6CB0-BCC5-AD3BDE6A7F50}"/>
               </a:ext>
             </a:extLst>
           </p:cNvPr>
@@ -8329,8 +8329,8 @@
         </p:nvSpPr>
         <p:spPr>
           <a:xfrm>
-            <a:off x="1426788" y="2721892"/>
-            <a:ext cx="7670873" cy="856608"/>
+            <a:off x="1404745" y="2711373"/>
+            <a:ext cx="7714959" cy="892675"/>
           </a:xfrm>
           <a:prstGeom prst="rect">
             <a:avLst/>
@@ -8364,7 +8364,7 @@
           <p:cNvPr id="9" name="marker_2">
             <a:extLst>
               <a:ext uri="{FF2B5EF4-FFF2-40B4-BE49-F238E27FC236}">
-                <a16:creationId xmlns:a16="http://schemas.microsoft.com/office/drawing/2014/main" id="{615F6D76-F7C7-560F-CDD2-45CFFDDA3F6C}"/>
+                <a16:creationId xmlns:a16="http://schemas.microsoft.com/office/drawing/2014/main" id="{3FA7B98F-0A0B-B9FB-B7E8-96766BCB2D8F}"/>
               </a:ext>
             </a:extLst>
           </p:cNvPr>
@@ -8377,7 +8377,7 @@
         </p:nvSpPr>
         <p:spPr>
           <a:xfrm>
-            <a:off x="853676" y="4191651"/>
+            <a:off x="831633" y="4166104"/>
             <a:ext cx="484940" cy="562055"/>
           </a:xfrm>
           <a:prstGeom prst="ellipse">
@@ -8398,7 +8398,7 @@
               </a:spcBef>
               <a:buFontTx/>
               <a:buNone/>
-              <a:defRPr sz="2400" b="1">
+              <a:defRPr sz="2000" b="1">
                 <a:solidFill>
                   <a:schemeClr val="bg1"/>
                 </a:solidFill>
@@ -8420,7 +8420,7 @@
           <p:cNvPr id="10" name="item_2_title">
             <a:extLst>
               <a:ext uri="{FF2B5EF4-FFF2-40B4-BE49-F238E27FC236}">
-                <a16:creationId xmlns:a16="http://schemas.microsoft.com/office/drawing/2014/main" id="{3A21830C-F614-53E9-6F54-6D0633B644D9}"/>
+                <a16:creationId xmlns:a16="http://schemas.microsoft.com/office/drawing/2014/main" id="{2FB787C2-FD44-4C6E-771A-509805599D76}"/>
               </a:ext>
             </a:extLst>
           </p:cNvPr>
@@ -8433,8 +8433,8 @@
         </p:nvSpPr>
         <p:spPr>
           <a:xfrm>
-            <a:off x="1426788" y="4191650"/>
-            <a:ext cx="7670873" cy="356920"/>
+            <a:off x="1404745" y="4166103"/>
+            <a:ext cx="7714959" cy="371948"/>
           </a:xfrm>
           <a:prstGeom prst="rect">
             <a:avLst/>
@@ -8451,7 +8451,7 @@
               </a:spcBef>
               <a:buFontTx/>
               <a:buNone/>
-              <a:defRPr sz="2200" b="1">
+              <a:defRPr sz="2000" b="1">
                 <a:solidFill>
                   <a:schemeClr val="accent1"/>
                 </a:solidFill>
@@ -8473,7 +8473,7 @@
           <p:cNvPr id="11" name="item_2">
             <a:extLst>
               <a:ext uri="{FF2B5EF4-FFF2-40B4-BE49-F238E27FC236}">
-                <a16:creationId xmlns:a16="http://schemas.microsoft.com/office/drawing/2014/main" id="{C3942562-9507-B224-A0B5-88F6E74F27F4}"/>
+                <a16:creationId xmlns:a16="http://schemas.microsoft.com/office/drawing/2014/main" id="{215EE49E-AFDC-BFDB-B13A-F376F5CDAEF0}"/>
               </a:ext>
             </a:extLst>
           </p:cNvPr>
@@ -8486,8 +8486,8 @@
         </p:nvSpPr>
         <p:spPr>
           <a:xfrm>
-            <a:off x="1426788" y="4548570"/>
-            <a:ext cx="7670873" cy="856608"/>
+            <a:off x="1404745" y="4538052"/>
+            <a:ext cx="7714959" cy="892675"/>
           </a:xfrm>
           <a:prstGeom prst="rect">
             <a:avLst/>
@@ -8521,7 +8521,7 @@
           <p:cNvPr id="12" name="source">
             <a:extLst>
               <a:ext uri="{FF2B5EF4-FFF2-40B4-BE49-F238E27FC236}">
-                <a16:creationId xmlns:a16="http://schemas.microsoft.com/office/drawing/2014/main" id="{93B9455A-3428-2E5F-E030-D993E563BDD8}"/>
+                <a16:creationId xmlns:a16="http://schemas.microsoft.com/office/drawing/2014/main" id="{ED015F40-2362-9BD0-7EF3-090FAFF50D08}"/>
               </a:ext>
             </a:extLst>
           </p:cNvPr>
@@ -8576,7 +8576,7 @@
     </p:spTree>
     <p:extLst>
       <p:ext uri="{BB962C8B-B14F-4D97-AF65-F5344CB8AC3E}">
-        <p14:creationId xmlns:p14="http://schemas.microsoft.com/office/powerpoint/2010/main" val="1445994818"/>
+        <p14:creationId xmlns:p14="http://schemas.microsoft.com/office/powerpoint/2010/main" val="783422959"/>
       </p:ext>
     </p:extLst>
   </p:cSld>
@@ -8650,7 +8650,7 @@
           <a:bodyPr/>
           <a:lstStyle/>
           <a:p>
-            <a:fld id="{74813003-FBAE-4237-BD99-D6E83252122A}" type="datetimeFigureOut">
+            <a:fld id="{26B7F381-F10E-4587-B886-8036B7268BA3}" type="datetimeFigureOut">
               <a:rPr lang="en-US" smtClean="0"/>
               <a:t>10/3/2026</a:t>
             </a:fld>
@@ -8692,7 +8692,7 @@
           <a:bodyPr/>
           <a:lstStyle/>
           <a:p>
-            <a:fld id="{BEFED7E7-52D0-4F8A-AF4C-DA16AD6E5F6D}" type="slidenum">
+            <a:fld id="{C8D4D1C8-8C5D-4FFA-950C-FD08A0718FA9}" type="slidenum">
               <a:rPr lang="en-US" smtClean="0"/>
               <a:t>‹#›</a:t>
             </a:fld>
@@ -8705,7 +8705,7 @@
           <p:cNvPr id="6" name="kpi_value_1">
             <a:extLst>
               <a:ext uri="{FF2B5EF4-FFF2-40B4-BE49-F238E27FC236}">
-                <a16:creationId xmlns:a16="http://schemas.microsoft.com/office/drawing/2014/main" id="{8AC15E80-223F-5AE4-00CB-72EB36DE23EF}"/>
+                <a16:creationId xmlns:a16="http://schemas.microsoft.com/office/drawing/2014/main" id="{AD8E9D6D-0766-05A6-1AC0-C482D5329549}"/>
               </a:ext>
             </a:extLst>
           </p:cNvPr>
@@ -8718,8 +8718,8 @@
         </p:nvSpPr>
         <p:spPr>
           <a:xfrm>
-            <a:off x="853676" y="2364972"/>
-            <a:ext cx="4117584" cy="1884928"/>
+            <a:off x="831634" y="2339424"/>
+            <a:ext cx="4161669" cy="1916607"/>
           </a:xfrm>
         </p:spPr>
         <p:txBody>
@@ -8755,7 +8755,7 @@
           <p:cNvPr id="7" name="kpi_label_1">
             <a:extLst>
               <a:ext uri="{FF2B5EF4-FFF2-40B4-BE49-F238E27FC236}">
-                <a16:creationId xmlns:a16="http://schemas.microsoft.com/office/drawing/2014/main" id="{228D49E5-5F25-EDFB-3907-D29997FE8545}"/>
+                <a16:creationId xmlns:a16="http://schemas.microsoft.com/office/drawing/2014/main" id="{379ACE35-00F9-CD5E-8344-395E40325889}"/>
               </a:ext>
             </a:extLst>
           </p:cNvPr>
@@ -8768,8 +8768,8 @@
         </p:nvSpPr>
         <p:spPr>
           <a:xfrm>
-            <a:off x="853676" y="4310704"/>
-            <a:ext cx="4117584" cy="1094474"/>
+            <a:off x="831634" y="4317858"/>
+            <a:ext cx="4161669" cy="1112869"/>
           </a:xfrm>
           <a:prstGeom prst="rect">
             <a:avLst/>
@@ -8786,7 +8786,7 @@
               </a:spcBef>
               <a:buFontTx/>
               <a:buNone/>
-              <a:defRPr sz="1800"/>
+              <a:defRPr sz="2000"/>
             </a:lvl1pPr>
           </a:lstStyle>
           <a:p>
@@ -8803,7 +8803,7 @@
           <p:cNvPr id="8" name="quote">
             <a:extLst>
               <a:ext uri="{FF2B5EF4-FFF2-40B4-BE49-F238E27FC236}">
-                <a16:creationId xmlns:a16="http://schemas.microsoft.com/office/drawing/2014/main" id="{033D7B39-B49B-4C49-0414-C3B446509256}"/>
+                <a16:creationId xmlns:a16="http://schemas.microsoft.com/office/drawing/2014/main" id="{CD6C2888-1AFC-3C38-B671-A65BE0509541}"/>
               </a:ext>
             </a:extLst>
           </p:cNvPr>
@@ -8816,8 +8816,8 @@
         </p:nvSpPr>
         <p:spPr>
           <a:xfrm>
-            <a:off x="853676" y="2364972"/>
-            <a:ext cx="4117584" cy="2371360"/>
+            <a:off x="831634" y="2339425"/>
+            <a:ext cx="4161669" cy="2411215"/>
           </a:xfrm>
           <a:prstGeom prst="rect">
             <a:avLst/>
@@ -8834,7 +8834,7 @@
               </a:spcBef>
               <a:buFontTx/>
               <a:buNone/>
-              <a:defRPr sz="2400" i="1">
+              <a:defRPr sz="2000" i="1">
                 <a:latin typeface="+mj-lt"/>
               </a:defRPr>
             </a:lvl1pPr>
@@ -8853,7 +8853,7 @@
           <p:cNvPr id="9" name="attribution">
             <a:extLst>
               <a:ext uri="{FF2B5EF4-FFF2-40B4-BE49-F238E27FC236}">
-                <a16:creationId xmlns:a16="http://schemas.microsoft.com/office/drawing/2014/main" id="{DB8009E8-0E23-F38E-7A21-CBB77812444B}"/>
+                <a16:creationId xmlns:a16="http://schemas.microsoft.com/office/drawing/2014/main" id="{E3F22928-B66C-F0B3-162D-5BE8ADCE5AFC}"/>
               </a:ext>
             </a:extLst>
           </p:cNvPr>
@@ -8866,8 +8866,8 @@
         </p:nvSpPr>
         <p:spPr>
           <a:xfrm>
-            <a:off x="853676" y="4797138"/>
-            <a:ext cx="4117584" cy="608041"/>
+            <a:off x="831634" y="4812466"/>
+            <a:ext cx="4161669" cy="618260"/>
           </a:xfrm>
           <a:prstGeom prst="rect">
             <a:avLst/>
@@ -8884,7 +8884,7 @@
               </a:spcBef>
               <a:buFontTx/>
               <a:buNone/>
-              <a:defRPr sz="1400"/>
+              <a:defRPr sz="2000"/>
             </a:lvl1pPr>
           </a:lstStyle>
           <a:p>
@@ -8901,7 +8901,7 @@
           <p:cNvPr id="10" name="item_1_title">
             <a:extLst>
               <a:ext uri="{FF2B5EF4-FFF2-40B4-BE49-F238E27FC236}">
-                <a16:creationId xmlns:a16="http://schemas.microsoft.com/office/drawing/2014/main" id="{65B82EC7-3857-1D72-378F-9296C1F45D69}"/>
+                <a16:creationId xmlns:a16="http://schemas.microsoft.com/office/drawing/2014/main" id="{E51C3FB3-811E-FE83-FA03-EF2F99B67A8A}"/>
               </a:ext>
             </a:extLst>
           </p:cNvPr>
@@ -8932,7 +8932,7 @@
               </a:spcBef>
               <a:buFontTx/>
               <a:buNone/>
-              <a:defRPr sz="2200" b="1">
+              <a:defRPr sz="2000" b="1">
                 <a:solidFill>
                   <a:schemeClr val="accent1"/>
                 </a:solidFill>
@@ -8954,7 +8954,7 @@
           <p:cNvPr id="11" name="item_1">
             <a:extLst>
               <a:ext uri="{FF2B5EF4-FFF2-40B4-BE49-F238E27FC236}">
-                <a16:creationId xmlns:a16="http://schemas.microsoft.com/office/drawing/2014/main" id="{E44380EF-518E-689D-C765-9ECEFD40407E}"/>
+                <a16:creationId xmlns:a16="http://schemas.microsoft.com/office/drawing/2014/main" id="{8FFC08C0-2827-28EC-DAE6-578D1625477E}"/>
               </a:ext>
             </a:extLst>
           </p:cNvPr>
@@ -9002,7 +9002,7 @@
           <p:cNvPr id="12" name="source">
             <a:extLst>
               <a:ext uri="{FF2B5EF4-FFF2-40B4-BE49-F238E27FC236}">
-                <a16:creationId xmlns:a16="http://schemas.microsoft.com/office/drawing/2014/main" id="{24CB6079-817B-861E-C7F4-EA60B384E85F}"/>
+                <a16:creationId xmlns:a16="http://schemas.microsoft.com/office/drawing/2014/main" id="{64B61E8B-EF79-B9D8-0C8F-26ABAC7897B9}"/>
               </a:ext>
             </a:extLst>
           </p:cNvPr>
@@ -9057,7 +9057,7 @@
     </p:spTree>
     <p:extLst>
       <p:ext uri="{BB962C8B-B14F-4D97-AF65-F5344CB8AC3E}">
-        <p14:creationId xmlns:p14="http://schemas.microsoft.com/office/powerpoint/2010/main" val="683519528"/>
+        <p14:creationId xmlns:p14="http://schemas.microsoft.com/office/powerpoint/2010/main" val="2749940874"/>
       </p:ext>
     </p:extLst>
   </p:cSld>
@@ -9131,7 +9131,7 @@
           <a:bodyPr/>
           <a:lstStyle/>
           <a:p>
-            <a:fld id="{74813003-FBAE-4237-BD99-D6E83252122A}" type="datetimeFigureOut">
+            <a:fld id="{26B7F381-F10E-4587-B886-8036B7268BA3}" type="datetimeFigureOut">
               <a:rPr lang="en-US" smtClean="0"/>
               <a:t>10/3/2026</a:t>
             </a:fld>
@@ -9173,7 +9173,7 @@
           <a:bodyPr/>
           <a:lstStyle/>
           <a:p>
-            <a:fld id="{BEFED7E7-52D0-4F8A-AF4C-DA16AD6E5F6D}" type="slidenum">
+            <a:fld id="{C8D4D1C8-8C5D-4FFA-950C-FD08A0718FA9}" type="slidenum">
               <a:rPr lang="en-US" smtClean="0"/>
               <a:t>‹#›</a:t>
             </a:fld>
@@ -9186,7 +9186,7 @@
           <p:cNvPr id="6" name="marker_1">
             <a:extLst>
               <a:ext uri="{FF2B5EF4-FFF2-40B4-BE49-F238E27FC236}">
-                <a16:creationId xmlns:a16="http://schemas.microsoft.com/office/drawing/2014/main" id="{654FA487-5CDD-72AE-14EB-41295B0DDDFE}"/>
+                <a16:creationId xmlns:a16="http://schemas.microsoft.com/office/drawing/2014/main" id="{E369C00B-C8FC-DCAB-1D0B-E135C9E51053}"/>
               </a:ext>
             </a:extLst>
           </p:cNvPr>
@@ -9220,7 +9220,7 @@
               </a:spcBef>
               <a:buFontTx/>
               <a:buNone/>
-              <a:defRPr sz="2400" b="1">
+              <a:defRPr sz="2000" b="1">
                 <a:solidFill>
                   <a:schemeClr val="bg1"/>
                 </a:solidFill>
@@ -9242,7 +9242,7 @@
           <p:cNvPr id="7" name="item_1">
             <a:extLst>
               <a:ext uri="{FF2B5EF4-FFF2-40B4-BE49-F238E27FC236}">
-                <a16:creationId xmlns:a16="http://schemas.microsoft.com/office/drawing/2014/main" id="{53CA34C2-9997-2029-9E84-DF38DB98A652}"/>
+                <a16:creationId xmlns:a16="http://schemas.microsoft.com/office/drawing/2014/main" id="{AD2B44E2-2616-6658-A638-333575E7B8DA}"/>
               </a:ext>
             </a:extLst>
           </p:cNvPr>
@@ -9290,7 +9290,7 @@
           <p:cNvPr id="8" name="marker_2">
             <a:extLst>
               <a:ext uri="{FF2B5EF4-FFF2-40B4-BE49-F238E27FC236}">
-                <a16:creationId xmlns:a16="http://schemas.microsoft.com/office/drawing/2014/main" id="{9B2FA84C-71CD-3682-12F0-905D9D8BA41A}"/>
+                <a16:creationId xmlns:a16="http://schemas.microsoft.com/office/drawing/2014/main" id="{A52A2BFB-AE7A-1311-6EDF-A79F2F5C897F}"/>
               </a:ext>
             </a:extLst>
           </p:cNvPr>
@@ -9324,7 +9324,7 @@
               </a:spcBef>
               <a:buFontTx/>
               <a:buNone/>
-              <a:defRPr sz="2400" b="1">
+              <a:defRPr sz="2000" b="1">
                 <a:solidFill>
                   <a:schemeClr val="bg1"/>
                 </a:solidFill>
@@ -9346,7 +9346,7 @@
           <p:cNvPr id="9" name="item_2">
             <a:extLst>
               <a:ext uri="{FF2B5EF4-FFF2-40B4-BE49-F238E27FC236}">
-                <a16:creationId xmlns:a16="http://schemas.microsoft.com/office/drawing/2014/main" id="{019B6C6C-DDC4-980C-520F-0ECE9CD5421A}"/>
+                <a16:creationId xmlns:a16="http://schemas.microsoft.com/office/drawing/2014/main" id="{DDD97C91-5FC5-BFD9-73D2-798AB3EB0978}"/>
               </a:ext>
             </a:extLst>
           </p:cNvPr>
@@ -9394,7 +9394,7 @@
           <p:cNvPr id="10" name="marker_3">
             <a:extLst>
               <a:ext uri="{FF2B5EF4-FFF2-40B4-BE49-F238E27FC236}">
-                <a16:creationId xmlns:a16="http://schemas.microsoft.com/office/drawing/2014/main" id="{5F1D49E5-734D-38A6-23D2-0A84D09EF68C}"/>
+                <a16:creationId xmlns:a16="http://schemas.microsoft.com/office/drawing/2014/main" id="{3D4F3060-6909-A303-CF0D-60A550C8CD97}"/>
               </a:ext>
             </a:extLst>
           </p:cNvPr>
@@ -9428,7 +9428,7 @@
               </a:spcBef>
               <a:buFontTx/>
               <a:buNone/>
-              <a:defRPr sz="2400" b="1">
+              <a:defRPr sz="2000" b="1">
                 <a:solidFill>
                   <a:schemeClr val="bg1"/>
                 </a:solidFill>
@@ -9450,7 +9450,7 @@
           <p:cNvPr id="11" name="item_3">
             <a:extLst>
               <a:ext uri="{FF2B5EF4-FFF2-40B4-BE49-F238E27FC236}">
-                <a16:creationId xmlns:a16="http://schemas.microsoft.com/office/drawing/2014/main" id="{767EF7FA-8551-6E38-88AD-E6A98555F5D0}"/>
+                <a16:creationId xmlns:a16="http://schemas.microsoft.com/office/drawing/2014/main" id="{DAB1D38D-C39C-639B-9D87-179B00ED3D14}"/>
               </a:ext>
             </a:extLst>
           </p:cNvPr>
@@ -9498,7 +9498,7 @@
           <p:cNvPr id="12" name="marker_4">
             <a:extLst>
               <a:ext uri="{FF2B5EF4-FFF2-40B4-BE49-F238E27FC236}">
-                <a16:creationId xmlns:a16="http://schemas.microsoft.com/office/drawing/2014/main" id="{1104A68C-3668-BD9B-082E-944BC9B7237D}"/>
+                <a16:creationId xmlns:a16="http://schemas.microsoft.com/office/drawing/2014/main" id="{3D826790-F8CB-4162-8EC9-BD989836C59A}"/>
               </a:ext>
             </a:extLst>
           </p:cNvPr>
@@ -9532,7 +9532,7 @@
               </a:spcBef>
               <a:buFontTx/>
               <a:buNone/>
-              <a:defRPr sz="2400" b="1">
+              <a:defRPr sz="2000" b="1">
                 <a:solidFill>
                   <a:schemeClr val="bg1"/>
                 </a:solidFill>
@@ -9554,7 +9554,7 @@
           <p:cNvPr id="13" name="item_4">
             <a:extLst>
               <a:ext uri="{FF2B5EF4-FFF2-40B4-BE49-F238E27FC236}">
-                <a16:creationId xmlns:a16="http://schemas.microsoft.com/office/drawing/2014/main" id="{F3801F2B-85FE-20D1-DEA7-DA1B09193EB1}"/>
+                <a16:creationId xmlns:a16="http://schemas.microsoft.com/office/drawing/2014/main" id="{74AD0345-7031-D2C7-F004-D782EB800CAC}"/>
               </a:ext>
             </a:extLst>
           </p:cNvPr>
@@ -9602,7 +9602,7 @@
           <p:cNvPr id="14" name="source">
             <a:extLst>
               <a:ext uri="{FF2B5EF4-FFF2-40B4-BE49-F238E27FC236}">
-                <a16:creationId xmlns:a16="http://schemas.microsoft.com/office/drawing/2014/main" id="{6AFE224C-AFB1-EE06-023F-D6FA39307344}"/>
+                <a16:creationId xmlns:a16="http://schemas.microsoft.com/office/drawing/2014/main" id="{96038124-6942-2C15-E20C-01D5ED7609B4}"/>
               </a:ext>
             </a:extLst>
           </p:cNvPr>
@@ -9657,7 +9657,7 @@
     </p:spTree>
     <p:extLst>
       <p:ext uri="{BB962C8B-B14F-4D97-AF65-F5344CB8AC3E}">
-        <p14:creationId xmlns:p14="http://schemas.microsoft.com/office/powerpoint/2010/main" val="3776381690"/>
+        <p14:creationId xmlns:p14="http://schemas.microsoft.com/office/powerpoint/2010/main" val="1121562776"/>
       </p:ext>
     </p:extLst>
   </p:cSld>
@@ -9731,7 +9731,7 @@
           <a:bodyPr/>
           <a:lstStyle/>
           <a:p>
-            <a:fld id="{74813003-FBAE-4237-BD99-D6E83252122A}" type="datetimeFigureOut">
+            <a:fld id="{26B7F381-F10E-4587-B886-8036B7268BA3}" type="datetimeFigureOut">
               <a:rPr lang="en-US" smtClean="0"/>
               <a:t>10/3/2026</a:t>
             </a:fld>
@@ -9773,7 +9773,7 @@
           <a:bodyPr/>
           <a:lstStyle/>
           <a:p>
-            <a:fld id="{BEFED7E7-52D0-4F8A-AF4C-DA16AD6E5F6D}" type="slidenum">
+            <a:fld id="{C8D4D1C8-8C5D-4FFA-950C-FD08A0718FA9}" type="slidenum">
               <a:rPr lang="en-US" smtClean="0"/>
               <a:t>‹#›</a:t>
             </a:fld>
@@ -9786,7 +9786,7 @@
           <p:cNvPr id="6" name="decisions_title">
             <a:extLst>
               <a:ext uri="{FF2B5EF4-FFF2-40B4-BE49-F238E27FC236}">
-                <a16:creationId xmlns:a16="http://schemas.microsoft.com/office/drawing/2014/main" id="{B6D8716B-5608-FFE3-4E9C-9E1846EF1591}"/>
+                <a16:creationId xmlns:a16="http://schemas.microsoft.com/office/drawing/2014/main" id="{38C87AFA-5448-81C5-553E-453440B80969}"/>
               </a:ext>
             </a:extLst>
           </p:cNvPr>
@@ -9799,8 +9799,8 @@
         </p:nvSpPr>
         <p:spPr>
           <a:xfrm>
-            <a:off x="853676" y="4641294"/>
-            <a:ext cx="1882450" cy="763884"/>
+            <a:off x="831634" y="4615747"/>
+            <a:ext cx="2080835" cy="814980"/>
           </a:xfrm>
         </p:spPr>
         <p:txBody>
@@ -9836,7 +9836,7 @@
           <p:cNvPr id="7" name="decisions">
             <a:extLst>
               <a:ext uri="{FF2B5EF4-FFF2-40B4-BE49-F238E27FC236}">
-                <a16:creationId xmlns:a16="http://schemas.microsoft.com/office/drawing/2014/main" id="{2702F971-9D1C-9A52-1A43-46EFEF4F0F5E}"/>
+                <a16:creationId xmlns:a16="http://schemas.microsoft.com/office/drawing/2014/main" id="{C53CF140-2C51-CCB4-D38D-FAB64B60224A}"/>
               </a:ext>
             </a:extLst>
           </p:cNvPr>
@@ -9849,8 +9849,8 @@
         </p:nvSpPr>
         <p:spPr>
           <a:xfrm>
-            <a:off x="3174776" y="4641294"/>
-            <a:ext cx="5922884" cy="763884"/>
+            <a:off x="2998435" y="4615747"/>
+            <a:ext cx="6121269" cy="814980"/>
           </a:xfrm>
           <a:prstGeom prst="rect">
             <a:avLst/>
@@ -9862,7 +9862,7 @@
           </a:bodyPr>
           <a:lstStyle>
             <a:lvl1pPr>
-              <a:defRPr sz="1800"/>
+              <a:defRPr sz="2000"/>
             </a:lvl1pPr>
           </a:lstStyle>
           <a:p>
@@ -9879,7 +9879,7 @@
           <p:cNvPr id="8" name="item_1_title">
             <a:extLst>
               <a:ext uri="{FF2B5EF4-FFF2-40B4-BE49-F238E27FC236}">
-                <a16:creationId xmlns:a16="http://schemas.microsoft.com/office/drawing/2014/main" id="{D78D8F97-12E7-26AB-9E07-8E0D7153C58D}"/>
+                <a16:creationId xmlns:a16="http://schemas.microsoft.com/office/drawing/2014/main" id="{FD48DA34-9606-6508-046A-FB86B8AF79EC}"/>
               </a:ext>
             </a:extLst>
           </p:cNvPr>
@@ -9892,8 +9892,8 @@
         </p:nvSpPr>
         <p:spPr>
           <a:xfrm>
-            <a:off x="853677" y="2364973"/>
-            <a:ext cx="2395311" cy="488417"/>
+            <a:off x="831633" y="2339425"/>
+            <a:ext cx="2439396" cy="503445"/>
           </a:xfrm>
           <a:prstGeom prst="rect">
             <a:avLst/>
@@ -9910,7 +9910,7 @@
               </a:spcBef>
               <a:buFontTx/>
               <a:buNone/>
-              <a:defRPr sz="2200" b="1">
+              <a:defRPr sz="2000" b="1">
                 <a:solidFill>
                   <a:schemeClr val="accent1"/>
                 </a:solidFill>
@@ -9932,7 +9932,7 @@
           <p:cNvPr id="9" name="item_1">
             <a:extLst>
               <a:ext uri="{FF2B5EF4-FFF2-40B4-BE49-F238E27FC236}">
-                <a16:creationId xmlns:a16="http://schemas.microsoft.com/office/drawing/2014/main" id="{D89C9DBB-8023-E6D2-6B5B-8541C2DB2D36}"/>
+                <a16:creationId xmlns:a16="http://schemas.microsoft.com/office/drawing/2014/main" id="{14F949A1-5C63-33B6-29AD-70BD34E9FAEA}"/>
               </a:ext>
             </a:extLst>
           </p:cNvPr>
@@ -9945,8 +9945,8 @@
         </p:nvSpPr>
         <p:spPr>
           <a:xfrm>
-            <a:off x="853677" y="2853389"/>
-            <a:ext cx="2395311" cy="1172200"/>
+            <a:off x="831633" y="2842869"/>
+            <a:ext cx="2439396" cy="1208268"/>
           </a:xfrm>
           <a:prstGeom prst="rect">
             <a:avLst/>
@@ -9980,7 +9980,7 @@
           <p:cNvPr id="10" name="item_2_title">
             <a:extLst>
               <a:ext uri="{FF2B5EF4-FFF2-40B4-BE49-F238E27FC236}">
-                <a16:creationId xmlns:a16="http://schemas.microsoft.com/office/drawing/2014/main" id="{97DDE6F8-1820-1750-2379-1246F7290DAB}"/>
+                <a16:creationId xmlns:a16="http://schemas.microsoft.com/office/drawing/2014/main" id="{9A9F334B-3F03-2EB8-9F24-273066F32895}"/>
               </a:ext>
             </a:extLst>
           </p:cNvPr>
@@ -9993,8 +9993,8 @@
         </p:nvSpPr>
         <p:spPr>
           <a:xfrm>
-            <a:off x="3778014" y="2364973"/>
-            <a:ext cx="2395311" cy="488417"/>
+            <a:off x="3755970" y="2339425"/>
+            <a:ext cx="2439396" cy="503445"/>
           </a:xfrm>
           <a:prstGeom prst="rect">
             <a:avLst/>
@@ -10011,7 +10011,7 @@
               </a:spcBef>
               <a:buFontTx/>
               <a:buNone/>
-              <a:defRPr sz="2200" b="1">
+              <a:defRPr sz="2000" b="1">
                 <a:solidFill>
                   <a:schemeClr val="accent1"/>
                 </a:solidFill>
@@ -10033,7 +10033,7 @@
           <p:cNvPr id="11" name="item_2">
             <a:extLst>
               <a:ext uri="{FF2B5EF4-FFF2-40B4-BE49-F238E27FC236}">
-                <a16:creationId xmlns:a16="http://schemas.microsoft.com/office/drawing/2014/main" id="{8D8F4AC3-D830-8398-53DB-9881E960B774}"/>
+                <a16:creationId xmlns:a16="http://schemas.microsoft.com/office/drawing/2014/main" id="{D248CECD-9157-1D59-4DDA-D6B7F121B2AB}"/>
               </a:ext>
             </a:extLst>
           </p:cNvPr>
@@ -10046,8 +10046,8 @@
         </p:nvSpPr>
         <p:spPr>
           <a:xfrm>
-            <a:off x="3778014" y="2853389"/>
-            <a:ext cx="2395311" cy="1172200"/>
+            <a:off x="3755970" y="2842869"/>
+            <a:ext cx="2439396" cy="1208268"/>
           </a:xfrm>
           <a:prstGeom prst="rect">
             <a:avLst/>
@@ -10081,7 +10081,7 @@
           <p:cNvPr id="12" name="item_3_title">
             <a:extLst>
               <a:ext uri="{FF2B5EF4-FFF2-40B4-BE49-F238E27FC236}">
-                <a16:creationId xmlns:a16="http://schemas.microsoft.com/office/drawing/2014/main" id="{10937DDC-4249-718F-F917-5F637CDC2FF4}"/>
+                <a16:creationId xmlns:a16="http://schemas.microsoft.com/office/drawing/2014/main" id="{8ACE4377-C6B2-27C4-21CA-BEDEB3EB9004}"/>
               </a:ext>
             </a:extLst>
           </p:cNvPr>
@@ -10094,8 +10094,8 @@
         </p:nvSpPr>
         <p:spPr>
           <a:xfrm>
-            <a:off x="6702350" y="2364973"/>
-            <a:ext cx="2395311" cy="488417"/>
+            <a:off x="6680306" y="2339425"/>
+            <a:ext cx="2439396" cy="503445"/>
           </a:xfrm>
           <a:prstGeom prst="rect">
             <a:avLst/>
@@ -10112,7 +10112,7 @@
               </a:spcBef>
               <a:buFontTx/>
               <a:buNone/>
-              <a:defRPr sz="2200" b="1">
+              <a:defRPr sz="2000" b="1">
                 <a:solidFill>
                   <a:schemeClr val="accent1"/>
                 </a:solidFill>
@@ -10134,7 +10134,7 @@
           <p:cNvPr id="13" name="item_3">
             <a:extLst>
               <a:ext uri="{FF2B5EF4-FFF2-40B4-BE49-F238E27FC236}">
-                <a16:creationId xmlns:a16="http://schemas.microsoft.com/office/drawing/2014/main" id="{F92D6E19-D4C7-24A7-7D68-CFDD805519FC}"/>
+                <a16:creationId xmlns:a16="http://schemas.microsoft.com/office/drawing/2014/main" id="{B9E6C604-4268-92AF-2C86-C1F50AA770C3}"/>
               </a:ext>
             </a:extLst>
           </p:cNvPr>
@@ -10147,8 +10147,8 @@
         </p:nvSpPr>
         <p:spPr>
           <a:xfrm>
-            <a:off x="6702350" y="2853389"/>
-            <a:ext cx="2395311" cy="1172200"/>
+            <a:off x="6680306" y="2842869"/>
+            <a:ext cx="2439396" cy="1208268"/>
           </a:xfrm>
           <a:prstGeom prst="rect">
             <a:avLst/>
@@ -10182,7 +10182,7 @@
           <p:cNvPr id="14" name="source">
             <a:extLst>
               <a:ext uri="{FF2B5EF4-FFF2-40B4-BE49-F238E27FC236}">
-                <a16:creationId xmlns:a16="http://schemas.microsoft.com/office/drawing/2014/main" id="{3EEB049A-3783-15CD-3F21-4E2CDD9A0D83}"/>
+                <a16:creationId xmlns:a16="http://schemas.microsoft.com/office/drawing/2014/main" id="{13430725-B331-F185-F040-74553DA61CE7}"/>
               </a:ext>
             </a:extLst>
           </p:cNvPr>
@@ -10237,7 +10237,7 @@
     </p:spTree>
     <p:extLst>
       <p:ext uri="{BB962C8B-B14F-4D97-AF65-F5344CB8AC3E}">
-        <p14:creationId xmlns:p14="http://schemas.microsoft.com/office/powerpoint/2010/main" val="495308697"/>
+        <p14:creationId xmlns:p14="http://schemas.microsoft.com/office/powerpoint/2010/main" val="2332867634"/>
       </p:ext>
     </p:extLst>
   </p:cSld>
@@ -10311,7 +10311,7 @@
           <a:bodyPr/>
           <a:lstStyle/>
           <a:p>
-            <a:fld id="{74813003-FBAE-4237-BD99-D6E83252122A}" type="datetimeFigureOut">
+            <a:fld id="{26B7F381-F10E-4587-B886-8036B7268BA3}" type="datetimeFigureOut">
               <a:rPr lang="en-US" smtClean="0"/>
               <a:t>10/3/2026</a:t>
             </a:fld>
@@ -10353,7 +10353,7 @@
           <a:bodyPr/>
           <a:lstStyle/>
           <a:p>
-            <a:fld id="{BEFED7E7-52D0-4F8A-AF4C-DA16AD6E5F6D}" type="slidenum">
+            <a:fld id="{C8D4D1C8-8C5D-4FFA-950C-FD08A0718FA9}" type="slidenum">
               <a:rPr lang="en-US" smtClean="0"/>
               <a:t>‹#›</a:t>
             </a:fld>
@@ -10366,7 +10366,7 @@
           <p:cNvPr id="6" name="body">
             <a:extLst>
               <a:ext uri="{FF2B5EF4-FFF2-40B4-BE49-F238E27FC236}">
-                <a16:creationId xmlns:a16="http://schemas.microsoft.com/office/drawing/2014/main" id="{D6D293D8-C766-136F-81C0-219003CB719C}"/>
+                <a16:creationId xmlns:a16="http://schemas.microsoft.com/office/drawing/2014/main" id="{3E2A8ED6-E850-0065-8C6E-7F87F5C300B9}"/>
               </a:ext>
             </a:extLst>
           </p:cNvPr>
@@ -10406,7 +10406,7 @@
           <p:cNvPr id="7" name="kpi_value_1">
             <a:extLst>
               <a:ext uri="{FF2B5EF4-FFF2-40B4-BE49-F238E27FC236}">
-                <a16:creationId xmlns:a16="http://schemas.microsoft.com/office/drawing/2014/main" id="{5E503071-9235-EE35-4243-609F30A4EE72}"/>
+                <a16:creationId xmlns:a16="http://schemas.microsoft.com/office/drawing/2014/main" id="{D8D1CCE9-7479-07B1-6861-0F2A7777D42E}"/>
               </a:ext>
             </a:extLst>
           </p:cNvPr>
@@ -10419,8 +10419,8 @@
         </p:nvSpPr>
         <p:spPr>
           <a:xfrm>
-            <a:off x="853677" y="2364973"/>
-            <a:ext cx="3857479" cy="1422291"/>
+            <a:off x="831634" y="2339424"/>
+            <a:ext cx="3901565" cy="1455138"/>
           </a:xfrm>
           <a:prstGeom prst="rect">
             <a:avLst/>
@@ -10437,7 +10437,7 @@
               </a:spcBef>
               <a:buFontTx/>
               <a:buNone/>
-              <a:defRPr sz="8400" b="1">
+              <a:defRPr sz="6000" b="1">
                 <a:solidFill>
                   <a:schemeClr val="accent1"/>
                 </a:solidFill>
@@ -10459,7 +10459,7 @@
           <p:cNvPr id="8" name="kpi_label_1">
             <a:extLst>
               <a:ext uri="{FF2B5EF4-FFF2-40B4-BE49-F238E27FC236}">
-                <a16:creationId xmlns:a16="http://schemas.microsoft.com/office/drawing/2014/main" id="{4715256A-5514-0DA0-47E1-D679D1C2F719}"/>
+                <a16:creationId xmlns:a16="http://schemas.microsoft.com/office/drawing/2014/main" id="{4D788DEA-F146-EC39-0304-D13326F44CC4}"/>
               </a:ext>
             </a:extLst>
           </p:cNvPr>
@@ -10472,8 +10472,8 @@
         </p:nvSpPr>
         <p:spPr>
           <a:xfrm>
-            <a:off x="853677" y="3787263"/>
-            <a:ext cx="3857479" cy="790162"/>
+            <a:off x="831634" y="3794563"/>
+            <a:ext cx="3901565" cy="808410"/>
           </a:xfrm>
           <a:prstGeom prst="rect">
             <a:avLst/>
@@ -10490,7 +10490,7 @@
               </a:spcBef>
               <a:buFontTx/>
               <a:buNone/>
-              <a:defRPr sz="1800"/>
+              <a:defRPr sz="2000"/>
             </a:lvl1pPr>
           </a:lstStyle>
           <a:p>
@@ -10507,7 +10507,7 @@
           <p:cNvPr id="9" name="kpi_value_2">
             <a:extLst>
               <a:ext uri="{FF2B5EF4-FFF2-40B4-BE49-F238E27FC236}">
-                <a16:creationId xmlns:a16="http://schemas.microsoft.com/office/drawing/2014/main" id="{C6BE758F-4FB6-62DC-29F3-38DB2B023A6E}"/>
+                <a16:creationId xmlns:a16="http://schemas.microsoft.com/office/drawing/2014/main" id="{CAF84662-67F6-D06A-7AC0-6B0AAD213173}"/>
               </a:ext>
             </a:extLst>
           </p:cNvPr>
@@ -10520,8 +10520,8 @@
         </p:nvSpPr>
         <p:spPr>
           <a:xfrm>
-            <a:off x="5240182" y="2364973"/>
-            <a:ext cx="3857479" cy="1422291"/>
+            <a:off x="5218139" y="2339424"/>
+            <a:ext cx="3901565" cy="1455138"/>
           </a:xfrm>
           <a:prstGeom prst="rect">
             <a:avLst/>
@@ -10538,7 +10538,7 @@
               </a:spcBef>
               <a:buFontTx/>
               <a:buNone/>
-              <a:defRPr sz="8400" b="1">
+              <a:defRPr sz="6000" b="1">
                 <a:solidFill>
                   <a:schemeClr val="accent1"/>
                 </a:solidFill>
@@ -10560,7 +10560,7 @@
           <p:cNvPr id="10" name="kpi_label_2">
             <a:extLst>
               <a:ext uri="{FF2B5EF4-FFF2-40B4-BE49-F238E27FC236}">
-                <a16:creationId xmlns:a16="http://schemas.microsoft.com/office/drawing/2014/main" id="{794595AF-D0E8-DBE7-E7A0-86810E4266B4}"/>
+                <a16:creationId xmlns:a16="http://schemas.microsoft.com/office/drawing/2014/main" id="{FE660A28-29E4-C7C8-36EB-FB7E35BC59BB}"/>
               </a:ext>
             </a:extLst>
           </p:cNvPr>
@@ -10573,8 +10573,8 @@
         </p:nvSpPr>
         <p:spPr>
           <a:xfrm>
-            <a:off x="5240182" y="3787263"/>
-            <a:ext cx="3857479" cy="790162"/>
+            <a:off x="5218139" y="3794563"/>
+            <a:ext cx="3901565" cy="808410"/>
           </a:xfrm>
           <a:prstGeom prst="rect">
             <a:avLst/>
@@ -10591,7 +10591,7 @@
               </a:spcBef>
               <a:buFontTx/>
               <a:buNone/>
-              <a:defRPr sz="1800"/>
+              <a:defRPr sz="2000"/>
             </a:lvl1pPr>
           </a:lstStyle>
           <a:p>
@@ -10608,7 +10608,7 @@
           <p:cNvPr id="11" name="source">
             <a:extLst>
               <a:ext uri="{FF2B5EF4-FFF2-40B4-BE49-F238E27FC236}">
-                <a16:creationId xmlns:a16="http://schemas.microsoft.com/office/drawing/2014/main" id="{DA5C9C04-0A44-8CC9-C859-D072E78FFB38}"/>
+                <a16:creationId xmlns:a16="http://schemas.microsoft.com/office/drawing/2014/main" id="{4B4D03DD-E3DA-B2CD-13A4-4397A935E045}"/>
               </a:ext>
             </a:extLst>
           </p:cNvPr>
@@ -10663,7 +10663,7 @@
     </p:spTree>
     <p:extLst>
       <p:ext uri="{BB962C8B-B14F-4D97-AF65-F5344CB8AC3E}">
-        <p14:creationId xmlns:p14="http://schemas.microsoft.com/office/powerpoint/2010/main" val="3555923673"/>
+        <p14:creationId xmlns:p14="http://schemas.microsoft.com/office/powerpoint/2010/main" val="3243616742"/>
       </p:ext>
     </p:extLst>
   </p:cSld>
@@ -10737,7 +10737,7 @@
           <a:bodyPr/>
           <a:lstStyle/>
           <a:p>
-            <a:fld id="{74813003-FBAE-4237-BD99-D6E83252122A}" type="datetimeFigureOut">
+            <a:fld id="{26B7F381-F10E-4587-B886-8036B7268BA3}" type="datetimeFigureOut">
               <a:rPr lang="en-US" smtClean="0"/>
               <a:t>10/3/2026</a:t>
             </a:fld>
@@ -10779,7 +10779,7 @@
           <a:bodyPr/>
           <a:lstStyle/>
           <a:p>
-            <a:fld id="{BEFED7E7-52D0-4F8A-AF4C-DA16AD6E5F6D}" type="slidenum">
+            <a:fld id="{C8D4D1C8-8C5D-4FFA-950C-FD08A0718FA9}" type="slidenum">
               <a:rPr lang="en-US" smtClean="0"/>
               <a:t>‹#›</a:t>
             </a:fld>
@@ -10792,7 +10792,7 @@
           <p:cNvPr id="6" name="body">
             <a:extLst>
               <a:ext uri="{FF2B5EF4-FFF2-40B4-BE49-F238E27FC236}">
-                <a16:creationId xmlns:a16="http://schemas.microsoft.com/office/drawing/2014/main" id="{5DC12C3D-E099-4F93-38D9-5D6A929DED44}"/>
+                <a16:creationId xmlns:a16="http://schemas.microsoft.com/office/drawing/2014/main" id="{C6363E06-25CF-EC18-E079-8335B8820181}"/>
               </a:ext>
             </a:extLst>
           </p:cNvPr>
@@ -10832,7 +10832,7 @@
           <p:cNvPr id="7" name="kpi_value_1">
             <a:extLst>
               <a:ext uri="{FF2B5EF4-FFF2-40B4-BE49-F238E27FC236}">
-                <a16:creationId xmlns:a16="http://schemas.microsoft.com/office/drawing/2014/main" id="{8FABE050-CA4A-ED65-6F5E-2DF9B6BB6BE5}"/>
+                <a16:creationId xmlns:a16="http://schemas.microsoft.com/office/drawing/2014/main" id="{B56C5BD2-DDB9-5C64-5840-CCD60A89DDC3}"/>
               </a:ext>
             </a:extLst>
           </p:cNvPr>
@@ -10845,8 +10845,8 @@
         </p:nvSpPr>
         <p:spPr>
           <a:xfrm>
-            <a:off x="853677" y="2364973"/>
-            <a:ext cx="1664227" cy="1422291"/>
+            <a:off x="831633" y="2339424"/>
+            <a:ext cx="1708312" cy="1455138"/>
           </a:xfrm>
           <a:prstGeom prst="rect">
             <a:avLst/>
@@ -10885,7 +10885,7 @@
           <p:cNvPr id="8" name="kpi_label_1">
             <a:extLst>
               <a:ext uri="{FF2B5EF4-FFF2-40B4-BE49-F238E27FC236}">
-                <a16:creationId xmlns:a16="http://schemas.microsoft.com/office/drawing/2014/main" id="{C67E1B47-8FCD-BC4F-F4E3-82D29232FB69}"/>
+                <a16:creationId xmlns:a16="http://schemas.microsoft.com/office/drawing/2014/main" id="{1ED65C79-F072-AD8A-5B1F-BCACE5DFEFC5}"/>
               </a:ext>
             </a:extLst>
           </p:cNvPr>
@@ -10898,8 +10898,8 @@
         </p:nvSpPr>
         <p:spPr>
           <a:xfrm>
-            <a:off x="853677" y="3787263"/>
-            <a:ext cx="1664227" cy="790162"/>
+            <a:off x="831633" y="3794563"/>
+            <a:ext cx="1708312" cy="808410"/>
           </a:xfrm>
           <a:prstGeom prst="rect">
             <a:avLst/>
@@ -10916,7 +10916,7 @@
               </a:spcBef>
               <a:buFontTx/>
               <a:buNone/>
-              <a:defRPr sz="1800"/>
+              <a:defRPr sz="2000"/>
             </a:lvl1pPr>
           </a:lstStyle>
           <a:p>
@@ -10933,7 +10933,7 @@
           <p:cNvPr id="9" name="kpi_value_2">
             <a:extLst>
               <a:ext uri="{FF2B5EF4-FFF2-40B4-BE49-F238E27FC236}">
-                <a16:creationId xmlns:a16="http://schemas.microsoft.com/office/drawing/2014/main" id="{67BB1FDE-63B4-243B-0100-BBD88EC118EB}"/>
+                <a16:creationId xmlns:a16="http://schemas.microsoft.com/office/drawing/2014/main" id="{84141D7D-E3D3-95D8-5CD8-FD58B96000AB}"/>
               </a:ext>
             </a:extLst>
           </p:cNvPr>
@@ -10946,8 +10946,8 @@
         </p:nvSpPr>
         <p:spPr>
           <a:xfrm>
-            <a:off x="3046930" y="2364973"/>
-            <a:ext cx="1664227" cy="1422291"/>
+            <a:off x="3024886" y="2339424"/>
+            <a:ext cx="1708312" cy="1455138"/>
           </a:xfrm>
           <a:prstGeom prst="rect">
             <a:avLst/>
@@ -10986,7 +10986,7 @@
           <p:cNvPr id="10" name="kpi_label_2">
             <a:extLst>
               <a:ext uri="{FF2B5EF4-FFF2-40B4-BE49-F238E27FC236}">
-                <a16:creationId xmlns:a16="http://schemas.microsoft.com/office/drawing/2014/main" id="{0129BA1A-27F3-8954-1819-2E78A0E2CCFA}"/>
+                <a16:creationId xmlns:a16="http://schemas.microsoft.com/office/drawing/2014/main" id="{474585F9-CE8D-F640-E19C-A8D3400539C4}"/>
               </a:ext>
             </a:extLst>
           </p:cNvPr>
@@ -10999,8 +10999,8 @@
         </p:nvSpPr>
         <p:spPr>
           <a:xfrm>
-            <a:off x="3046930" y="3787263"/>
-            <a:ext cx="1664227" cy="790162"/>
+            <a:off x="3024886" y="3794563"/>
+            <a:ext cx="1708312" cy="808410"/>
           </a:xfrm>
           <a:prstGeom prst="rect">
             <a:avLst/>
@@ -11017,7 +11017,7 @@
               </a:spcBef>
               <a:buFontTx/>
               <a:buNone/>
-              <a:defRPr sz="1800"/>
+              <a:defRPr sz="2000"/>
             </a:lvl1pPr>
           </a:lstStyle>
           <a:p>
@@ -11034,7 +11034,7 @@
           <p:cNvPr id="11" name="kpi_value_3">
             <a:extLst>
               <a:ext uri="{FF2B5EF4-FFF2-40B4-BE49-F238E27FC236}">
-                <a16:creationId xmlns:a16="http://schemas.microsoft.com/office/drawing/2014/main" id="{C64B378E-6EF5-BEC5-7904-4802CB281463}"/>
+                <a16:creationId xmlns:a16="http://schemas.microsoft.com/office/drawing/2014/main" id="{75A02CF4-9A01-1087-9CF4-4CC5A94CDB49}"/>
               </a:ext>
             </a:extLst>
           </p:cNvPr>
@@ -11047,8 +11047,8 @@
         </p:nvSpPr>
         <p:spPr>
           <a:xfrm>
-            <a:off x="5240182" y="2364973"/>
-            <a:ext cx="1664227" cy="1422291"/>
+            <a:off x="5218138" y="2339424"/>
+            <a:ext cx="1708312" cy="1455138"/>
           </a:xfrm>
           <a:prstGeom prst="rect">
             <a:avLst/>
@@ -11087,7 +11087,7 @@
           <p:cNvPr id="12" name="kpi_label_3">
             <a:extLst>
               <a:ext uri="{FF2B5EF4-FFF2-40B4-BE49-F238E27FC236}">
-                <a16:creationId xmlns:a16="http://schemas.microsoft.com/office/drawing/2014/main" id="{C5050F63-7D54-64E8-5074-210DBD3A275E}"/>
+                <a16:creationId xmlns:a16="http://schemas.microsoft.com/office/drawing/2014/main" id="{48AD110E-0BB7-C13D-C3B9-F4E3C3F77111}"/>
               </a:ext>
             </a:extLst>
           </p:cNvPr>
@@ -11100,8 +11100,8 @@
         </p:nvSpPr>
         <p:spPr>
           <a:xfrm>
-            <a:off x="5240182" y="3787263"/>
-            <a:ext cx="1664227" cy="790162"/>
+            <a:off x="5218138" y="3794563"/>
+            <a:ext cx="1708312" cy="808410"/>
           </a:xfrm>
           <a:prstGeom prst="rect">
             <a:avLst/>
@@ -11118,7 +11118,7 @@
               </a:spcBef>
               <a:buFontTx/>
               <a:buNone/>
-              <a:defRPr sz="1800"/>
+              <a:defRPr sz="2000"/>
             </a:lvl1pPr>
           </a:lstStyle>
           <a:p>
@@ -11135,7 +11135,7 @@
           <p:cNvPr id="13" name="kpi_value_4">
             <a:extLst>
               <a:ext uri="{FF2B5EF4-FFF2-40B4-BE49-F238E27FC236}">
-                <a16:creationId xmlns:a16="http://schemas.microsoft.com/office/drawing/2014/main" id="{BFBA4ED8-25AE-B035-B3A4-48C880CE8B83}"/>
+                <a16:creationId xmlns:a16="http://schemas.microsoft.com/office/drawing/2014/main" id="{C2BBDB68-83A4-D060-AF54-013FC58A28D5}"/>
               </a:ext>
             </a:extLst>
           </p:cNvPr>
@@ -11148,8 +11148,8 @@
         </p:nvSpPr>
         <p:spPr>
           <a:xfrm>
-            <a:off x="7433434" y="2364973"/>
-            <a:ext cx="1664227" cy="1422291"/>
+            <a:off x="7411391" y="2339424"/>
+            <a:ext cx="1708312" cy="1455138"/>
           </a:xfrm>
           <a:prstGeom prst="rect">
             <a:avLst/>
@@ -11188,7 +11188,7 @@
           <p:cNvPr id="14" name="kpi_label_4">
             <a:extLst>
               <a:ext uri="{FF2B5EF4-FFF2-40B4-BE49-F238E27FC236}">
-                <a16:creationId xmlns:a16="http://schemas.microsoft.com/office/drawing/2014/main" id="{2E99CC18-3456-362E-52D3-A82A8F3D4503}"/>
+                <a16:creationId xmlns:a16="http://schemas.microsoft.com/office/drawing/2014/main" id="{67FDBE63-9CF4-8EF6-1D9F-1E4F05465073}"/>
               </a:ext>
             </a:extLst>
           </p:cNvPr>
@@ -11201,8 +11201,8 @@
         </p:nvSpPr>
         <p:spPr>
           <a:xfrm>
-            <a:off x="7433434" y="3787263"/>
-            <a:ext cx="1664227" cy="790162"/>
+            <a:off x="7411391" y="3794563"/>
+            <a:ext cx="1708312" cy="808410"/>
           </a:xfrm>
           <a:prstGeom prst="rect">
             <a:avLst/>
@@ -11219,7 +11219,7 @@
               </a:spcBef>
               <a:buFontTx/>
               <a:buNone/>
-              <a:defRPr sz="1800"/>
+              <a:defRPr sz="2000"/>
             </a:lvl1pPr>
           </a:lstStyle>
           <a:p>
@@ -11236,7 +11236,7 @@
           <p:cNvPr id="15" name="source">
             <a:extLst>
               <a:ext uri="{FF2B5EF4-FFF2-40B4-BE49-F238E27FC236}">
-                <a16:creationId xmlns:a16="http://schemas.microsoft.com/office/drawing/2014/main" id="{DC26E801-EA62-676E-CD89-478754A4D60F}"/>
+                <a16:creationId xmlns:a16="http://schemas.microsoft.com/office/drawing/2014/main" id="{E696BF10-17FB-1AB6-5684-8F87C6D9472D}"/>
               </a:ext>
             </a:extLst>
           </p:cNvPr>
@@ -11291,7 +11291,7 @@
     </p:spTree>
     <p:extLst>
       <p:ext uri="{BB962C8B-B14F-4D97-AF65-F5344CB8AC3E}">
-        <p14:creationId xmlns:p14="http://schemas.microsoft.com/office/powerpoint/2010/main" val="1654788017"/>
+        <p14:creationId xmlns:p14="http://schemas.microsoft.com/office/powerpoint/2010/main" val="3043958282"/>
       </p:ext>
     </p:extLst>
   </p:cSld>
@@ -11365,7 +11365,7 @@
           <a:bodyPr/>
           <a:lstStyle/>
           <a:p>
-            <a:fld id="{74813003-FBAE-4237-BD99-D6E83252122A}" type="datetimeFigureOut">
+            <a:fld id="{26B7F381-F10E-4587-B886-8036B7268BA3}" type="datetimeFigureOut">
               <a:rPr lang="en-US" smtClean="0"/>
               <a:t>10/3/2026</a:t>
             </a:fld>
@@ -11407,7 +11407,7 @@
           <a:bodyPr/>
           <a:lstStyle/>
           <a:p>
-            <a:fld id="{BEFED7E7-52D0-4F8A-AF4C-DA16AD6E5F6D}" type="slidenum">
+            <a:fld id="{C8D4D1C8-8C5D-4FFA-950C-FD08A0718FA9}" type="slidenum">
               <a:rPr lang="en-US" smtClean="0"/>
               <a:t>‹#›</a:t>
             </a:fld>
@@ -11420,7 +11420,7 @@
           <p:cNvPr id="6" name="body">
             <a:extLst>
               <a:ext uri="{FF2B5EF4-FFF2-40B4-BE49-F238E27FC236}">
-                <a16:creationId xmlns:a16="http://schemas.microsoft.com/office/drawing/2014/main" id="{7F6B45DC-26A3-98C9-81D5-2433B2226569}"/>
+                <a16:creationId xmlns:a16="http://schemas.microsoft.com/office/drawing/2014/main" id="{48913B7D-6B6C-E6CF-172F-95EDB69588C3}"/>
               </a:ext>
             </a:extLst>
           </p:cNvPr>
@@ -11460,7 +11460,7 @@
           <p:cNvPr id="7" name="quote">
             <a:extLst>
               <a:ext uri="{FF2B5EF4-FFF2-40B4-BE49-F238E27FC236}">
-                <a16:creationId xmlns:a16="http://schemas.microsoft.com/office/drawing/2014/main" id="{C38B29F6-065B-49B0-691C-B4766FBA1ACA}"/>
+                <a16:creationId xmlns:a16="http://schemas.microsoft.com/office/drawing/2014/main" id="{2FB0F04F-142D-9AD5-5DEC-DB191761ECD8}"/>
               </a:ext>
             </a:extLst>
           </p:cNvPr>
@@ -11473,8 +11473,8 @@
         </p:nvSpPr>
         <p:spPr>
           <a:xfrm>
-            <a:off x="6011678" y="2364973"/>
-            <a:ext cx="3085983" cy="2350411"/>
+            <a:off x="5989635" y="2339425"/>
+            <a:ext cx="3130069" cy="2580343"/>
           </a:xfrm>
           <a:prstGeom prst="rect">
             <a:avLst/>
@@ -11491,7 +11491,7 @@
               </a:spcBef>
               <a:buFontTx/>
               <a:buNone/>
-              <a:defRPr sz="2400" i="1">
+              <a:defRPr sz="2000" i="1">
                 <a:latin typeface="+mj-lt"/>
               </a:defRPr>
             </a:lvl1pPr>
@@ -11510,7 +11510,7 @@
           <p:cNvPr id="8" name="attribution">
             <a:extLst>
               <a:ext uri="{FF2B5EF4-FFF2-40B4-BE49-F238E27FC236}">
-                <a16:creationId xmlns:a16="http://schemas.microsoft.com/office/drawing/2014/main" id="{1A102A7C-A32F-AC52-20E8-6A95DA001CF0}"/>
+                <a16:creationId xmlns:a16="http://schemas.microsoft.com/office/drawing/2014/main" id="{7AF60576-D5AA-7D61-9C62-2454ED46A390}"/>
               </a:ext>
             </a:extLst>
           </p:cNvPr>
@@ -11523,8 +11523,8 @@
         </p:nvSpPr>
         <p:spPr>
           <a:xfrm>
-            <a:off x="6011678" y="5124151"/>
-            <a:ext cx="3085983" cy="281027"/>
+            <a:off x="5989635" y="4919768"/>
+            <a:ext cx="3130069" cy="510959"/>
           </a:xfrm>
           <a:prstGeom prst="rect">
             <a:avLst/>
@@ -11541,7 +11541,7 @@
               </a:spcBef>
               <a:buFontTx/>
               <a:buNone/>
-              <a:defRPr sz="1400"/>
+              <a:defRPr sz="2000"/>
             </a:lvl1pPr>
           </a:lstStyle>
           <a:p>
@@ -11558,7 +11558,7 @@
           <p:cNvPr id="9" name="source">
             <a:extLst>
               <a:ext uri="{FF2B5EF4-FFF2-40B4-BE49-F238E27FC236}">
-                <a16:creationId xmlns:a16="http://schemas.microsoft.com/office/drawing/2014/main" id="{6B321751-58F9-3054-AB3F-E51D59545116}"/>
+                <a16:creationId xmlns:a16="http://schemas.microsoft.com/office/drawing/2014/main" id="{CD69D0E2-2BD0-800B-FCF2-89D055B55C41}"/>
               </a:ext>
             </a:extLst>
           </p:cNvPr>
@@ -11613,7 +11613,7 @@
     </p:spTree>
     <p:extLst>
       <p:ext uri="{BB962C8B-B14F-4D97-AF65-F5344CB8AC3E}">
-        <p14:creationId xmlns:p14="http://schemas.microsoft.com/office/powerpoint/2010/main" val="1290891430"/>
+        <p14:creationId xmlns:p14="http://schemas.microsoft.com/office/powerpoint/2010/main" val="354886383"/>
       </p:ext>
     </p:extLst>
   </p:cSld>
@@ -11687,7 +11687,7 @@
           <a:bodyPr/>
           <a:lstStyle/>
           <a:p>
-            <a:fld id="{74813003-FBAE-4237-BD99-D6E83252122A}" type="datetimeFigureOut">
+            <a:fld id="{26B7F381-F10E-4587-B886-8036B7268BA3}" type="datetimeFigureOut">
               <a:rPr lang="en-US" smtClean="0"/>
               <a:t>10/3/2026</a:t>
             </a:fld>
@@ -11729,7 +11729,7 @@
           <a:bodyPr/>
           <a:lstStyle/>
           <a:p>
-            <a:fld id="{BEFED7E7-52D0-4F8A-AF4C-DA16AD6E5F6D}" type="slidenum">
+            <a:fld id="{C8D4D1C8-8C5D-4FFA-950C-FD08A0718FA9}" type="slidenum">
               <a:rPr lang="en-US" smtClean="0"/>
               <a:t>‹#›</a:t>
             </a:fld>
@@ -11742,7 +11742,7 @@
           <p:cNvPr id="6" name="item_1_title">
             <a:extLst>
               <a:ext uri="{FF2B5EF4-FFF2-40B4-BE49-F238E27FC236}">
-                <a16:creationId xmlns:a16="http://schemas.microsoft.com/office/drawing/2014/main" id="{91A57423-F4A2-844D-2615-DB274EC5FA0D}"/>
+                <a16:creationId xmlns:a16="http://schemas.microsoft.com/office/drawing/2014/main" id="{733F5616-4C7D-D196-7842-FF5137393441}"/>
               </a:ext>
             </a:extLst>
           </p:cNvPr>
@@ -11755,8 +11755,8 @@
         </p:nvSpPr>
         <p:spPr>
           <a:xfrm>
-            <a:off x="853677" y="2364972"/>
-            <a:ext cx="2395311" cy="894178"/>
+            <a:off x="831633" y="2339424"/>
+            <a:ext cx="2439396" cy="909206"/>
           </a:xfrm>
         </p:spPr>
         <p:txBody>
@@ -11770,7 +11770,7 @@
               </a:spcBef>
               <a:buFontTx/>
               <a:buNone/>
-              <a:defRPr sz="2200" b="1">
+              <a:defRPr sz="2000" b="1">
                 <a:solidFill>
                   <a:schemeClr val="accent1"/>
                 </a:solidFill>
@@ -11792,7 +11792,7 @@
           <p:cNvPr id="7" name="item_1">
             <a:extLst>
               <a:ext uri="{FF2B5EF4-FFF2-40B4-BE49-F238E27FC236}">
-                <a16:creationId xmlns:a16="http://schemas.microsoft.com/office/drawing/2014/main" id="{90A982F5-2777-EC1D-BCED-B77D2BCB2DFA}"/>
+                <a16:creationId xmlns:a16="http://schemas.microsoft.com/office/drawing/2014/main" id="{BBD9CF87-263F-6AAC-19F4-5B46AEE0EDE9}"/>
               </a:ext>
             </a:extLst>
           </p:cNvPr>
@@ -11805,8 +11805,8 @@
         </p:nvSpPr>
         <p:spPr>
           <a:xfrm>
-            <a:off x="853677" y="3259150"/>
-            <a:ext cx="2395311" cy="2146028"/>
+            <a:off x="831633" y="3248632"/>
+            <a:ext cx="2439396" cy="2182095"/>
           </a:xfrm>
           <a:prstGeom prst="rect">
             <a:avLst/>
@@ -11840,7 +11840,7 @@
           <p:cNvPr id="8" name="item_2_title">
             <a:extLst>
               <a:ext uri="{FF2B5EF4-FFF2-40B4-BE49-F238E27FC236}">
-                <a16:creationId xmlns:a16="http://schemas.microsoft.com/office/drawing/2014/main" id="{35057DD1-3A17-F0B9-A7A8-685EF78E5B4F}"/>
+                <a16:creationId xmlns:a16="http://schemas.microsoft.com/office/drawing/2014/main" id="{DD31341B-0A4B-7C33-054F-D524D383C4E8}"/>
               </a:ext>
             </a:extLst>
           </p:cNvPr>
@@ -11853,8 +11853,8 @@
         </p:nvSpPr>
         <p:spPr>
           <a:xfrm>
-            <a:off x="3778014" y="2364972"/>
-            <a:ext cx="2395311" cy="894178"/>
+            <a:off x="3755970" y="2339424"/>
+            <a:ext cx="2439396" cy="909206"/>
           </a:xfrm>
           <a:prstGeom prst="rect">
             <a:avLst/>
@@ -11871,7 +11871,7 @@
               </a:spcBef>
               <a:buFontTx/>
               <a:buNone/>
-              <a:defRPr sz="2200" b="1">
+              <a:defRPr sz="2000" b="1">
                 <a:solidFill>
                   <a:schemeClr val="accent1"/>
                 </a:solidFill>
@@ -11893,7 +11893,7 @@
           <p:cNvPr id="9" name="item_2">
             <a:extLst>
               <a:ext uri="{FF2B5EF4-FFF2-40B4-BE49-F238E27FC236}">
-                <a16:creationId xmlns:a16="http://schemas.microsoft.com/office/drawing/2014/main" id="{2758B46C-1AA9-EDBD-BE0E-DBFADD8396DF}"/>
+                <a16:creationId xmlns:a16="http://schemas.microsoft.com/office/drawing/2014/main" id="{E56C6F0D-0F8D-8E95-EE25-BCF49DD6541A}"/>
               </a:ext>
             </a:extLst>
           </p:cNvPr>
@@ -11906,8 +11906,8 @@
         </p:nvSpPr>
         <p:spPr>
           <a:xfrm>
-            <a:off x="3778014" y="3259150"/>
-            <a:ext cx="2395311" cy="2146028"/>
+            <a:off x="3755970" y="3248632"/>
+            <a:ext cx="2439396" cy="2182095"/>
           </a:xfrm>
           <a:prstGeom prst="rect">
             <a:avLst/>
@@ -11941,7 +11941,7 @@
           <p:cNvPr id="10" name="item_3_title">
             <a:extLst>
               <a:ext uri="{FF2B5EF4-FFF2-40B4-BE49-F238E27FC236}">
-                <a16:creationId xmlns:a16="http://schemas.microsoft.com/office/drawing/2014/main" id="{9789DC8A-BA1F-743F-9823-FCE281CEB91A}"/>
+                <a16:creationId xmlns:a16="http://schemas.microsoft.com/office/drawing/2014/main" id="{E5FA44D2-A718-7CBA-0E74-BB3752668DB0}"/>
               </a:ext>
             </a:extLst>
           </p:cNvPr>
@@ -11954,8 +11954,8 @@
         </p:nvSpPr>
         <p:spPr>
           <a:xfrm>
-            <a:off x="6702350" y="2364972"/>
-            <a:ext cx="2395311" cy="894178"/>
+            <a:off x="6680306" y="2339424"/>
+            <a:ext cx="2439396" cy="909206"/>
           </a:xfrm>
           <a:prstGeom prst="rect">
             <a:avLst/>
@@ -11972,7 +11972,7 @@
               </a:spcBef>
               <a:buFontTx/>
               <a:buNone/>
-              <a:defRPr sz="2200" b="1">
+              <a:defRPr sz="2000" b="1">
                 <a:solidFill>
                   <a:schemeClr val="accent1"/>
                 </a:solidFill>
@@ -11994,7 +11994,7 @@
           <p:cNvPr id="11" name="item_3">
             <a:extLst>
               <a:ext uri="{FF2B5EF4-FFF2-40B4-BE49-F238E27FC236}">
-                <a16:creationId xmlns:a16="http://schemas.microsoft.com/office/drawing/2014/main" id="{6E6C58B6-092A-5D3F-8B69-E93AC2EC14DD}"/>
+                <a16:creationId xmlns:a16="http://schemas.microsoft.com/office/drawing/2014/main" id="{3D7BFF9A-B511-3472-2C80-D80260AA324F}"/>
               </a:ext>
             </a:extLst>
           </p:cNvPr>
@@ -12007,8 +12007,8 @@
         </p:nvSpPr>
         <p:spPr>
           <a:xfrm>
-            <a:off x="6702350" y="3259150"/>
-            <a:ext cx="2395311" cy="2146028"/>
+            <a:off x="6680306" y="3248632"/>
+            <a:ext cx="2439396" cy="2182095"/>
           </a:xfrm>
           <a:prstGeom prst="rect">
             <a:avLst/>
@@ -12042,7 +12042,7 @@
           <p:cNvPr id="12" name="source">
             <a:extLst>
               <a:ext uri="{FF2B5EF4-FFF2-40B4-BE49-F238E27FC236}">
-                <a16:creationId xmlns:a16="http://schemas.microsoft.com/office/drawing/2014/main" id="{640970F5-A544-D435-EC0B-6463E6C03DC2}"/>
+                <a16:creationId xmlns:a16="http://schemas.microsoft.com/office/drawing/2014/main" id="{0C1B152B-8377-DCB4-8F93-09FBCBB7E080}"/>
               </a:ext>
             </a:extLst>
           </p:cNvPr>
@@ -12097,7 +12097,7 @@
     </p:spTree>
     <p:extLst>
       <p:ext uri="{BB962C8B-B14F-4D97-AF65-F5344CB8AC3E}">
-        <p14:creationId xmlns:p14="http://schemas.microsoft.com/office/powerpoint/2010/main" val="1859438848"/>
+        <p14:creationId xmlns:p14="http://schemas.microsoft.com/office/powerpoint/2010/main" val="7822430"/>
       </p:ext>
     </p:extLst>
   </p:cSld>
@@ -12171,7 +12171,7 @@
           <a:bodyPr/>
           <a:lstStyle/>
           <a:p>
-            <a:fld id="{74813003-FBAE-4237-BD99-D6E83252122A}" type="datetimeFigureOut">
+            <a:fld id="{26B7F381-F10E-4587-B886-8036B7268BA3}" type="datetimeFigureOut">
               <a:rPr lang="en-US" smtClean="0"/>
               <a:t>10/3/2026</a:t>
             </a:fld>
@@ -12213,7 +12213,7 @@
           <a:bodyPr/>
           <a:lstStyle/>
           <a:p>
-            <a:fld id="{BEFED7E7-52D0-4F8A-AF4C-DA16AD6E5F6D}" type="slidenum">
+            <a:fld id="{C8D4D1C8-8C5D-4FFA-950C-FD08A0718FA9}" type="slidenum">
               <a:rPr lang="en-US" smtClean="0"/>
               <a:t>‹#›</a:t>
             </a:fld>
@@ -12226,7 +12226,7 @@
           <p:cNvPr id="6" name="item_1_title">
             <a:extLst>
               <a:ext uri="{FF2B5EF4-FFF2-40B4-BE49-F238E27FC236}">
-                <a16:creationId xmlns:a16="http://schemas.microsoft.com/office/drawing/2014/main" id="{F43AE4EB-FC1F-14E1-269B-0D5FCAB41136}"/>
+                <a16:creationId xmlns:a16="http://schemas.microsoft.com/office/drawing/2014/main" id="{5871EA8D-4CAA-008D-8F55-F60EDAF588A9}"/>
               </a:ext>
             </a:extLst>
           </p:cNvPr>
@@ -12239,8 +12239,8 @@
         </p:nvSpPr>
         <p:spPr>
           <a:xfrm>
-            <a:off x="853677" y="2364972"/>
-            <a:ext cx="3857479" cy="894178"/>
+            <a:off x="831634" y="2339424"/>
+            <a:ext cx="3901565" cy="909206"/>
           </a:xfrm>
         </p:spPr>
         <p:txBody>
@@ -12254,7 +12254,7 @@
               </a:spcBef>
               <a:buFontTx/>
               <a:buNone/>
-              <a:defRPr sz="2200" b="1">
+              <a:defRPr sz="2000" b="1">
                 <a:solidFill>
                   <a:schemeClr val="accent1"/>
                 </a:solidFill>
@@ -12276,7 +12276,7 @@
           <p:cNvPr id="7" name="item_1">
             <a:extLst>
               <a:ext uri="{FF2B5EF4-FFF2-40B4-BE49-F238E27FC236}">
-                <a16:creationId xmlns:a16="http://schemas.microsoft.com/office/drawing/2014/main" id="{36C03609-08BF-DCBC-D26F-2D72F7F0D8F1}"/>
+                <a16:creationId xmlns:a16="http://schemas.microsoft.com/office/drawing/2014/main" id="{F44961D4-CEB4-97E1-5A00-511E7857BF37}"/>
               </a:ext>
             </a:extLst>
           </p:cNvPr>
@@ -12289,8 +12289,8 @@
         </p:nvSpPr>
         <p:spPr>
           <a:xfrm>
-            <a:off x="853677" y="3259150"/>
-            <a:ext cx="3857479" cy="2146028"/>
+            <a:off x="831634" y="3248632"/>
+            <a:ext cx="3901565" cy="2182095"/>
           </a:xfrm>
           <a:prstGeom prst="rect">
             <a:avLst/>
@@ -12324,7 +12324,7 @@
           <p:cNvPr id="8" name="item_2_title">
             <a:extLst>
               <a:ext uri="{FF2B5EF4-FFF2-40B4-BE49-F238E27FC236}">
-                <a16:creationId xmlns:a16="http://schemas.microsoft.com/office/drawing/2014/main" id="{0B44F3B2-FC55-CFA4-AE7B-CFD29DADE652}"/>
+                <a16:creationId xmlns:a16="http://schemas.microsoft.com/office/drawing/2014/main" id="{CAB6CB27-A985-665D-A147-CE2280888685}"/>
               </a:ext>
             </a:extLst>
           </p:cNvPr>
@@ -12337,8 +12337,8 @@
         </p:nvSpPr>
         <p:spPr>
           <a:xfrm>
-            <a:off x="5240182" y="2364972"/>
-            <a:ext cx="3857479" cy="894178"/>
+            <a:off x="5218139" y="2339424"/>
+            <a:ext cx="3901565" cy="909206"/>
           </a:xfrm>
           <a:prstGeom prst="rect">
             <a:avLst/>
@@ -12355,7 +12355,7 @@
               </a:spcBef>
               <a:buFontTx/>
               <a:buNone/>
-              <a:defRPr sz="2200" b="1">
+              <a:defRPr sz="2000" b="1">
                 <a:solidFill>
                   <a:schemeClr val="accent1"/>
                 </a:solidFill>
@@ -12377,7 +12377,7 @@
           <p:cNvPr id="9" name="item_2">
             <a:extLst>
               <a:ext uri="{FF2B5EF4-FFF2-40B4-BE49-F238E27FC236}">
-                <a16:creationId xmlns:a16="http://schemas.microsoft.com/office/drawing/2014/main" id="{76753FB3-B692-12F3-8044-9D36590F7063}"/>
+                <a16:creationId xmlns:a16="http://schemas.microsoft.com/office/drawing/2014/main" id="{1FBA00A4-AC4E-D4E8-73EC-CEFE3762F40C}"/>
               </a:ext>
             </a:extLst>
           </p:cNvPr>
@@ -12390,8 +12390,8 @@
         </p:nvSpPr>
         <p:spPr>
           <a:xfrm>
-            <a:off x="5240182" y="3259150"/>
-            <a:ext cx="3857479" cy="2146028"/>
+            <a:off x="5218139" y="3248632"/>
+            <a:ext cx="3901565" cy="2182095"/>
           </a:xfrm>
           <a:prstGeom prst="rect">
             <a:avLst/>
@@ -12425,7 +12425,7 @@
           <p:cNvPr id="10" name="source">
             <a:extLst>
               <a:ext uri="{FF2B5EF4-FFF2-40B4-BE49-F238E27FC236}">
-                <a16:creationId xmlns:a16="http://schemas.microsoft.com/office/drawing/2014/main" id="{20BCD27E-A1EE-519D-AF24-A085AD31AF09}"/>
+                <a16:creationId xmlns:a16="http://schemas.microsoft.com/office/drawing/2014/main" id="{FFB57355-4750-10EA-0F44-8115A6B4C312}"/>
               </a:ext>
             </a:extLst>
           </p:cNvPr>
@@ -12480,7 +12480,7 @@
     </p:spTree>
     <p:extLst>
       <p:ext uri="{BB962C8B-B14F-4D97-AF65-F5344CB8AC3E}">
-        <p14:creationId xmlns:p14="http://schemas.microsoft.com/office/powerpoint/2010/main" val="3286982317"/>
+        <p14:creationId xmlns:p14="http://schemas.microsoft.com/office/powerpoint/2010/main" val="53766075"/>
       </p:ext>
     </p:extLst>
   </p:cSld>
@@ -12554,7 +12554,7 @@
           <a:bodyPr/>
           <a:lstStyle/>
           <a:p>
-            <a:fld id="{74813003-FBAE-4237-BD99-D6E83252122A}" type="datetimeFigureOut">
+            <a:fld id="{26B7F381-F10E-4587-B886-8036B7268BA3}" type="datetimeFigureOut">
               <a:rPr lang="en-US" smtClean="0"/>
               <a:t>10/3/2026</a:t>
             </a:fld>
@@ -12596,7 +12596,7 @@
           <a:bodyPr/>
           <a:lstStyle/>
           <a:p>
-            <a:fld id="{BEFED7E7-52D0-4F8A-AF4C-DA16AD6E5F6D}" type="slidenum">
+            <a:fld id="{C8D4D1C8-8C5D-4FFA-950C-FD08A0718FA9}" type="slidenum">
               <a:rPr lang="en-US" smtClean="0"/>
               <a:t>‹#›</a:t>
             </a:fld>
@@ -12609,7 +12609,7 @@
           <p:cNvPr id="6" name="chart">
             <a:extLst>
               <a:ext uri="{FF2B5EF4-FFF2-40B4-BE49-F238E27FC236}">
-                <a16:creationId xmlns:a16="http://schemas.microsoft.com/office/drawing/2014/main" id="{D7B9DC84-3623-F1F2-DDBA-5855F75247AF}"/>
+                <a16:creationId xmlns:a16="http://schemas.microsoft.com/office/drawing/2014/main" id="{C4DBBCEF-F1E9-6E0B-10F1-15DF2CFEA6FF}"/>
               </a:ext>
             </a:extLst>
           </p:cNvPr>
@@ -12639,7 +12639,7 @@
           <p:cNvPr id="7" name="body">
             <a:extLst>
               <a:ext uri="{FF2B5EF4-FFF2-40B4-BE49-F238E27FC236}">
-                <a16:creationId xmlns:a16="http://schemas.microsoft.com/office/drawing/2014/main" id="{813FF903-0043-BB6B-53FB-7511B4B5E6D0}"/>
+                <a16:creationId xmlns:a16="http://schemas.microsoft.com/office/drawing/2014/main" id="{607A6861-D515-63C2-F921-341152BB7E79}"/>
               </a:ext>
             </a:extLst>
           </p:cNvPr>
@@ -12682,7 +12682,7 @@
           <p:cNvPr id="8" name="source">
             <a:extLst>
               <a:ext uri="{FF2B5EF4-FFF2-40B4-BE49-F238E27FC236}">
-                <a16:creationId xmlns:a16="http://schemas.microsoft.com/office/drawing/2014/main" id="{971FF5AA-E4E3-72B8-A601-16A43B763528}"/>
+                <a16:creationId xmlns:a16="http://schemas.microsoft.com/office/drawing/2014/main" id="{10D0D055-2213-86BD-5DE9-6DBBF0C70C22}"/>
               </a:ext>
             </a:extLst>
           </p:cNvPr>
@@ -12737,7 +12737,7 @@
     </p:spTree>
     <p:extLst>
       <p:ext uri="{BB962C8B-B14F-4D97-AF65-F5344CB8AC3E}">
-        <p14:creationId xmlns:p14="http://schemas.microsoft.com/office/powerpoint/2010/main" val="3940143007"/>
+        <p14:creationId xmlns:p14="http://schemas.microsoft.com/office/powerpoint/2010/main" val="1205430755"/>
       </p:ext>
     </p:extLst>
   </p:cSld>
@@ -12811,7 +12811,7 @@
           <a:bodyPr/>
           <a:lstStyle/>
           <a:p>
-            <a:fld id="{74813003-FBAE-4237-BD99-D6E83252122A}" type="datetimeFigureOut">
+            <a:fld id="{26B7F381-F10E-4587-B886-8036B7268BA3}" type="datetimeFigureOut">
               <a:rPr lang="en-US" smtClean="0"/>
               <a:t>10/3/2026</a:t>
             </a:fld>
@@ -12853,7 +12853,7 @@
           <a:bodyPr/>
           <a:lstStyle/>
           <a:p>
-            <a:fld id="{BEFED7E7-52D0-4F8A-AF4C-DA16AD6E5F6D}" type="slidenum">
+            <a:fld id="{C8D4D1C8-8C5D-4FFA-950C-FD08A0718FA9}" type="slidenum">
               <a:rPr lang="en-US" smtClean="0"/>
               <a:t>‹#›</a:t>
             </a:fld>
@@ -12866,7 +12866,7 @@
           <p:cNvPr id="6" name="item_1_title">
             <a:extLst>
               <a:ext uri="{FF2B5EF4-FFF2-40B4-BE49-F238E27FC236}">
-                <a16:creationId xmlns:a16="http://schemas.microsoft.com/office/drawing/2014/main" id="{7F88008E-0AEB-B4C1-0419-0B4CCB6B37AB}"/>
+                <a16:creationId xmlns:a16="http://schemas.microsoft.com/office/drawing/2014/main" id="{680394A1-C191-643A-7607-A416EF25ABBF}"/>
               </a:ext>
             </a:extLst>
           </p:cNvPr>
@@ -12879,8 +12879,8 @@
         </p:nvSpPr>
         <p:spPr>
           <a:xfrm>
-            <a:off x="853677" y="2364972"/>
-            <a:ext cx="3857479" cy="356920"/>
+            <a:off x="831634" y="2339424"/>
+            <a:ext cx="3901565" cy="371948"/>
           </a:xfrm>
         </p:spPr>
         <p:txBody>
@@ -12894,7 +12894,7 @@
               </a:spcBef>
               <a:buFontTx/>
               <a:buNone/>
-              <a:defRPr sz="2200" b="1">
+              <a:defRPr sz="2000" b="1">
                 <a:solidFill>
                   <a:schemeClr val="accent1"/>
                 </a:solidFill>
@@ -12916,7 +12916,7 @@
           <p:cNvPr id="7" name="item_1">
             <a:extLst>
               <a:ext uri="{FF2B5EF4-FFF2-40B4-BE49-F238E27FC236}">
-                <a16:creationId xmlns:a16="http://schemas.microsoft.com/office/drawing/2014/main" id="{B7379AD1-6B40-6DB8-ED89-71EDF3E43603}"/>
+                <a16:creationId xmlns:a16="http://schemas.microsoft.com/office/drawing/2014/main" id="{0932471A-14ED-8F68-F724-AA0333B07585}"/>
               </a:ext>
             </a:extLst>
           </p:cNvPr>
@@ -12929,8 +12929,8 @@
         </p:nvSpPr>
         <p:spPr>
           <a:xfrm>
-            <a:off x="853677" y="2721892"/>
-            <a:ext cx="3857479" cy="856608"/>
+            <a:off x="831634" y="2711373"/>
+            <a:ext cx="3901565" cy="892675"/>
           </a:xfrm>
           <a:prstGeom prst="rect">
             <a:avLst/>
@@ -12964,7 +12964,7 @@
           <p:cNvPr id="8" name="item_2_title">
             <a:extLst>
               <a:ext uri="{FF2B5EF4-FFF2-40B4-BE49-F238E27FC236}">
-                <a16:creationId xmlns:a16="http://schemas.microsoft.com/office/drawing/2014/main" id="{135B88B1-0CE5-B856-B358-D174FFC7BE99}"/>
+                <a16:creationId xmlns:a16="http://schemas.microsoft.com/office/drawing/2014/main" id="{4C0CC2CA-8E00-7CC4-0CC8-65722B131508}"/>
               </a:ext>
             </a:extLst>
           </p:cNvPr>
@@ -12977,8 +12977,8 @@
         </p:nvSpPr>
         <p:spPr>
           <a:xfrm>
-            <a:off x="5240182" y="2364972"/>
-            <a:ext cx="3857479" cy="356920"/>
+            <a:off x="5218139" y="2339424"/>
+            <a:ext cx="3901565" cy="371948"/>
           </a:xfrm>
           <a:prstGeom prst="rect">
             <a:avLst/>
@@ -12995,7 +12995,7 @@
               </a:spcBef>
               <a:buFontTx/>
               <a:buNone/>
-              <a:defRPr sz="2200" b="1">
+              <a:defRPr sz="2000" b="1">
                 <a:solidFill>
                   <a:schemeClr val="accent1"/>
                 </a:solidFill>
@@ -13017,7 +13017,7 @@
           <p:cNvPr id="9" name="item_2">
             <a:extLst>
               <a:ext uri="{FF2B5EF4-FFF2-40B4-BE49-F238E27FC236}">
-                <a16:creationId xmlns:a16="http://schemas.microsoft.com/office/drawing/2014/main" id="{18A0F9F2-F50D-DB54-84E5-09C229CB57E8}"/>
+                <a16:creationId xmlns:a16="http://schemas.microsoft.com/office/drawing/2014/main" id="{14A74B9F-F7BE-8776-4C8C-D94E5DAB0C4E}"/>
               </a:ext>
             </a:extLst>
           </p:cNvPr>
@@ -13030,8 +13030,8 @@
         </p:nvSpPr>
         <p:spPr>
           <a:xfrm>
-            <a:off x="5240182" y="2721892"/>
-            <a:ext cx="3857479" cy="856608"/>
+            <a:off x="5218139" y="2711373"/>
+            <a:ext cx="3901565" cy="892675"/>
           </a:xfrm>
           <a:prstGeom prst="rect">
             <a:avLst/>
@@ -13065,7 +13065,7 @@
           <p:cNvPr id="10" name="item_3_title">
             <a:extLst>
               <a:ext uri="{FF2B5EF4-FFF2-40B4-BE49-F238E27FC236}">
-                <a16:creationId xmlns:a16="http://schemas.microsoft.com/office/drawing/2014/main" id="{6A2F3E40-C52A-282A-75AA-4D63E9D73968}"/>
+                <a16:creationId xmlns:a16="http://schemas.microsoft.com/office/drawing/2014/main" id="{8A85D9F6-6293-A2F7-06FD-1CFDA67C9A58}"/>
               </a:ext>
             </a:extLst>
           </p:cNvPr>
@@ -13078,8 +13078,8 @@
         </p:nvSpPr>
         <p:spPr>
           <a:xfrm>
-            <a:off x="853677" y="4191650"/>
-            <a:ext cx="3857479" cy="356920"/>
+            <a:off x="831634" y="4166103"/>
+            <a:ext cx="3901565" cy="371948"/>
           </a:xfrm>
           <a:prstGeom prst="rect">
             <a:avLst/>
@@ -13096,7 +13096,7 @@
               </a:spcBef>
               <a:buFontTx/>
               <a:buNone/>
-              <a:defRPr sz="2200" b="1">
+              <a:defRPr sz="2000" b="1">
                 <a:solidFill>
                   <a:schemeClr val="accent1"/>
                 </a:solidFill>
@@ -13118,7 +13118,7 @@
           <p:cNvPr id="11" name="item_3">
             <a:extLst>
               <a:ext uri="{FF2B5EF4-FFF2-40B4-BE49-F238E27FC236}">
-                <a16:creationId xmlns:a16="http://schemas.microsoft.com/office/drawing/2014/main" id="{32D218BD-9783-C068-8286-66BB8DBD4033}"/>
+                <a16:creationId xmlns:a16="http://schemas.microsoft.com/office/drawing/2014/main" id="{989A72AA-0A6F-A76B-A42A-DB911BC3F15C}"/>
               </a:ext>
             </a:extLst>
           </p:cNvPr>
@@ -13131,8 +13131,8 @@
         </p:nvSpPr>
         <p:spPr>
           <a:xfrm>
-            <a:off x="853677" y="4548570"/>
-            <a:ext cx="3857479" cy="856608"/>
+            <a:off x="831634" y="4538052"/>
+            <a:ext cx="3901565" cy="892675"/>
           </a:xfrm>
           <a:prstGeom prst="rect">
             <a:avLst/>
@@ -13166,7 +13166,7 @@
           <p:cNvPr id="12" name="item_4_title">
             <a:extLst>
               <a:ext uri="{FF2B5EF4-FFF2-40B4-BE49-F238E27FC236}">
-                <a16:creationId xmlns:a16="http://schemas.microsoft.com/office/drawing/2014/main" id="{9CD711CE-B28E-1D6A-E235-69C507F0F533}"/>
+                <a16:creationId xmlns:a16="http://schemas.microsoft.com/office/drawing/2014/main" id="{77AA9CC8-5888-7BBA-61B4-639E57C24BD2}"/>
               </a:ext>
             </a:extLst>
           </p:cNvPr>
@@ -13179,8 +13179,8 @@
         </p:nvSpPr>
         <p:spPr>
           <a:xfrm>
-            <a:off x="5240182" y="4191650"/>
-            <a:ext cx="3857479" cy="356920"/>
+            <a:off x="5218139" y="4166103"/>
+            <a:ext cx="3901565" cy="371948"/>
           </a:xfrm>
           <a:prstGeom prst="rect">
             <a:avLst/>
@@ -13197,7 +13197,7 @@
               </a:spcBef>
               <a:buFontTx/>
               <a:buNone/>
-              <a:defRPr sz="2200" b="1">
+              <a:defRPr sz="2000" b="1">
                 <a:solidFill>
                   <a:schemeClr val="accent1"/>
                 </a:solidFill>
@@ -13219,7 +13219,7 @@
           <p:cNvPr id="13" name="item_4">
             <a:extLst>
               <a:ext uri="{FF2B5EF4-FFF2-40B4-BE49-F238E27FC236}">
-                <a16:creationId xmlns:a16="http://schemas.microsoft.com/office/drawing/2014/main" id="{909A3707-2B21-0535-0459-3F9EA199A4CA}"/>
+                <a16:creationId xmlns:a16="http://schemas.microsoft.com/office/drawing/2014/main" id="{F7A6C1E2-E499-83F7-2235-6BD13E8ADB3A}"/>
               </a:ext>
             </a:extLst>
           </p:cNvPr>
@@ -13232,8 +13232,8 @@
         </p:nvSpPr>
         <p:spPr>
           <a:xfrm>
-            <a:off x="5240182" y="4548570"/>
-            <a:ext cx="3857479" cy="856608"/>
+            <a:off x="5218139" y="4538052"/>
+            <a:ext cx="3901565" cy="892675"/>
           </a:xfrm>
           <a:prstGeom prst="rect">
             <a:avLst/>
@@ -13267,7 +13267,7 @@
           <p:cNvPr id="14" name="source">
             <a:extLst>
               <a:ext uri="{FF2B5EF4-FFF2-40B4-BE49-F238E27FC236}">
-                <a16:creationId xmlns:a16="http://schemas.microsoft.com/office/drawing/2014/main" id="{1C63B70D-DDCA-3FEA-AB62-F80927AF4FC5}"/>
+                <a16:creationId xmlns:a16="http://schemas.microsoft.com/office/drawing/2014/main" id="{D6988254-F148-0205-E006-86B59CAF54FE}"/>
               </a:ext>
             </a:extLst>
           </p:cNvPr>
@@ -13322,7 +13322,7 @@
     </p:spTree>
     <p:extLst>
       <p:ext uri="{BB962C8B-B14F-4D97-AF65-F5344CB8AC3E}">
-        <p14:creationId xmlns:p14="http://schemas.microsoft.com/office/powerpoint/2010/main" val="2284444942"/>
+        <p14:creationId xmlns:p14="http://schemas.microsoft.com/office/powerpoint/2010/main" val="2290125734"/>
       </p:ext>
     </p:extLst>
   </p:cSld>
@@ -14014,7 +14014,7 @@
             </a:lvl1pPr>
           </a:lstStyle>
           <a:p>
-            <a:fld id="{74813003-FBAE-4237-BD99-D6E83252122A}" type="datetimeFigureOut">
+            <a:fld id="{26B7F381-F10E-4587-B886-8036B7268BA3}" type="datetimeFigureOut">
               <a:rPr lang="en-US" smtClean="0"/>
               <a:t>10/3/2026</a:t>
             </a:fld>
@@ -14090,7 +14090,7 @@
             </a:lvl1pPr>
           </a:lstStyle>
           <a:p>
-            <a:fld id="{BEFED7E7-52D0-4F8A-AF4C-DA16AD6E5F6D}" type="slidenum">
+            <a:fld id="{C8D4D1C8-8C5D-4FFA-950C-FD08A0718FA9}" type="slidenum">
               <a:rPr lang="en-US" smtClean="0"/>
               <a:t>‹#›</a:t>
             </a:fld>
@@ -14101,7 +14101,7 @@
     </p:spTree>
     <p:extLst>
       <p:ext uri="{BB962C8B-B14F-4D97-AF65-F5344CB8AC3E}">
-        <p14:creationId xmlns:p14="http://schemas.microsoft.com/office/powerpoint/2010/main" val="3782725968"/>
+        <p14:creationId xmlns:p14="http://schemas.microsoft.com/office/powerpoint/2010/main" val="2016352715"/>
       </p:ext>
     </p:extLst>
   </p:cSld>

</xml_diff>

<commit_message>
Polish templates for the projector demo (overnight Part 4)
The owner presents on a projector and favours dark templates. Dark templates are
now held to 7:1 body / 4.5:1 large text on the export (stricter QA, gate kept at
0.90): creative dark roles are derived for 8.5:1 and classic dark accents for
7.4:1 against the background the master really paints (Facet paints bg2, which
caused its 4.35). Nile Night glow and Papyrus lotus corners get spec-driven
strength (edge variance about doubles, content stays calm). Templates may name
favourite variants (layout_bias), a 0.015 bonus among passing candidates only,
never counted in recorded scores. Modulo gets its own 766 pt measure: beauty
0.9007 -> 0.9143. Full QA: all 16 templates pass with zero hard violations.
</commit_message>
<xml_diff>
--- a/design/templates/facet-dark/template.pptx
+++ b/design/templates/facet-dark/template.pptx
@@ -826,9 +826,9 @@
           <a:bodyPr/>
           <a:lstStyle/>
           <a:p>
-            <a:fld id="{26B7F381-F10E-4587-B886-8036B7268BA3}" type="datetimeFigureOut">
+            <a:fld id="{4A588302-F725-4E0D-AD75-D9B0BA2EF836}" type="datetimeFigureOut">
               <a:rPr lang="en-US" smtClean="0"/>
-              <a:t>10/3/2026</a:t>
+              <a:t>10/4/2026</a:t>
             </a:fld>
             <a:endParaRPr lang="en-US"/>
           </a:p>
@@ -868,7 +868,7 @@
           <a:bodyPr/>
           <a:lstStyle/>
           <a:p>
-            <a:fld id="{C8D4D1C8-8C5D-4FFA-950C-FD08A0718FA9}" type="slidenum">
+            <a:fld id="{7293683F-31E2-46C4-A5EC-E1CFD9E8730E}" type="slidenum">
               <a:rPr lang="en-US" smtClean="0"/>
               <a:t>‹#›</a:t>
             </a:fld>
@@ -879,7 +879,7 @@
     </p:spTree>
     <p:extLst>
       <p:ext uri="{BB962C8B-B14F-4D97-AF65-F5344CB8AC3E}">
-        <p14:creationId xmlns:p14="http://schemas.microsoft.com/office/powerpoint/2010/main" val="1183391218"/>
+        <p14:creationId xmlns:p14="http://schemas.microsoft.com/office/powerpoint/2010/main" val="8254187"/>
       </p:ext>
     </p:extLst>
   </p:cSld>
@@ -953,9 +953,9 @@
           <a:bodyPr/>
           <a:lstStyle/>
           <a:p>
-            <a:fld id="{26B7F381-F10E-4587-B886-8036B7268BA3}" type="datetimeFigureOut">
+            <a:fld id="{4A588302-F725-4E0D-AD75-D9B0BA2EF836}" type="datetimeFigureOut">
               <a:rPr lang="en-US" smtClean="0"/>
-              <a:t>10/3/2026</a:t>
+              <a:t>10/4/2026</a:t>
             </a:fld>
             <a:endParaRPr lang="en-US"/>
           </a:p>
@@ -995,7 +995,7 @@
           <a:bodyPr/>
           <a:lstStyle/>
           <a:p>
-            <a:fld id="{C8D4D1C8-8C5D-4FFA-950C-FD08A0718FA9}" type="slidenum">
+            <a:fld id="{7293683F-31E2-46C4-A5EC-E1CFD9E8730E}" type="slidenum">
               <a:rPr lang="en-US" smtClean="0"/>
               <a:t>‹#›</a:t>
             </a:fld>
@@ -1008,7 +1008,7 @@
           <p:cNvPr id="6" name="body">
             <a:extLst>
               <a:ext uri="{FF2B5EF4-FFF2-40B4-BE49-F238E27FC236}">
-                <a16:creationId xmlns:a16="http://schemas.microsoft.com/office/drawing/2014/main" id="{9C9EC024-062E-D56C-5295-14A2C28735A7}"/>
+                <a16:creationId xmlns:a16="http://schemas.microsoft.com/office/drawing/2014/main" id="{739605BC-EC23-A18B-B8E5-ADB1F6BB7D99}"/>
               </a:ext>
             </a:extLst>
           </p:cNvPr>
@@ -1048,7 +1048,7 @@
           <p:cNvPr id="7" name="source">
             <a:extLst>
               <a:ext uri="{FF2B5EF4-FFF2-40B4-BE49-F238E27FC236}">
-                <a16:creationId xmlns:a16="http://schemas.microsoft.com/office/drawing/2014/main" id="{B882BDD1-7279-01EB-B01F-4F26D7CDBF2B}"/>
+                <a16:creationId xmlns:a16="http://schemas.microsoft.com/office/drawing/2014/main" id="{5BDD0C65-FCFC-4C5A-BBF0-87E1AED016EE}"/>
               </a:ext>
             </a:extLst>
           </p:cNvPr>
@@ -1070,7 +1070,10 @@
             </a:avLst>
           </a:prstGeom>
           <a:solidFill>
-            <a:schemeClr val="accent1"/>
+            <a:schemeClr val="accent1">
+              <a:lumMod val="70000"/>
+              <a:lumOff val="30000"/>
+            </a:schemeClr>
           </a:solidFill>
         </p:spPr>
         <p:txBody>
@@ -1103,7 +1106,7 @@
     </p:spTree>
     <p:extLst>
       <p:ext uri="{BB962C8B-B14F-4D97-AF65-F5344CB8AC3E}">
-        <p14:creationId xmlns:p14="http://schemas.microsoft.com/office/powerpoint/2010/main" val="4262518983"/>
+        <p14:creationId xmlns:p14="http://schemas.microsoft.com/office/powerpoint/2010/main" val="441915665"/>
       </p:ext>
     </p:extLst>
   </p:cSld>
@@ -1177,9 +1180,9 @@
           <a:bodyPr/>
           <a:lstStyle/>
           <a:p>
-            <a:fld id="{26B7F381-F10E-4587-B886-8036B7268BA3}" type="datetimeFigureOut">
+            <a:fld id="{4A588302-F725-4E0D-AD75-D9B0BA2EF836}" type="datetimeFigureOut">
               <a:rPr lang="en-US" smtClean="0"/>
-              <a:t>10/3/2026</a:t>
+              <a:t>10/4/2026</a:t>
             </a:fld>
             <a:endParaRPr lang="en-US"/>
           </a:p>
@@ -1219,7 +1222,7 @@
           <a:bodyPr/>
           <a:lstStyle/>
           <a:p>
-            <a:fld id="{C8D4D1C8-8C5D-4FFA-950C-FD08A0718FA9}" type="slidenum">
+            <a:fld id="{7293683F-31E2-46C4-A5EC-E1CFD9E8730E}" type="slidenum">
               <a:rPr lang="en-US" smtClean="0"/>
               <a:t>‹#›</a:t>
             </a:fld>
@@ -1232,7 +1235,7 @@
           <p:cNvPr id="6" name="body">
             <a:extLst>
               <a:ext uri="{FF2B5EF4-FFF2-40B4-BE49-F238E27FC236}">
-                <a16:creationId xmlns:a16="http://schemas.microsoft.com/office/drawing/2014/main" id="{B7A1DA59-320F-B5AA-B3F4-7B9C78FB5B36}"/>
+                <a16:creationId xmlns:a16="http://schemas.microsoft.com/office/drawing/2014/main" id="{7D04707C-A1DA-DFBD-9C4E-00CCDD730937}"/>
               </a:ext>
             </a:extLst>
           </p:cNvPr>
@@ -1275,7 +1278,7 @@
     </p:spTree>
     <p:extLst>
       <p:ext uri="{BB962C8B-B14F-4D97-AF65-F5344CB8AC3E}">
-        <p14:creationId xmlns:p14="http://schemas.microsoft.com/office/powerpoint/2010/main" val="2746796488"/>
+        <p14:creationId xmlns:p14="http://schemas.microsoft.com/office/powerpoint/2010/main" val="281794677"/>
       </p:ext>
     </p:extLst>
   </p:cSld>
@@ -1351,7 +1354,7 @@
           <p:cNvPr id="6" name="section_number">
             <a:extLst>
               <a:ext uri="{FF2B5EF4-FFF2-40B4-BE49-F238E27FC236}">
-                <a16:creationId xmlns:a16="http://schemas.microsoft.com/office/drawing/2014/main" id="{DF35805A-5A40-8CA5-91C7-CC874ED83579}"/>
+                <a16:creationId xmlns:a16="http://schemas.microsoft.com/office/drawing/2014/main" id="{FF93BFFE-D6D6-3B20-5CFA-226AA6424A23}"/>
               </a:ext>
             </a:extLst>
           </p:cNvPr>
@@ -1404,7 +1407,7 @@
           <p:cNvPr id="7" name="subtitle">
             <a:extLst>
               <a:ext uri="{FF2B5EF4-FFF2-40B4-BE49-F238E27FC236}">
-                <a16:creationId xmlns:a16="http://schemas.microsoft.com/office/drawing/2014/main" id="{8B999D09-A412-6754-DE86-96ABC9584364}"/>
+                <a16:creationId xmlns:a16="http://schemas.microsoft.com/office/drawing/2014/main" id="{DA61C031-4859-0D15-62EB-6A9EC3A82386}"/>
               </a:ext>
             </a:extLst>
           </p:cNvPr>
@@ -1454,7 +1457,7 @@
     </p:spTree>
     <p:extLst>
       <p:ext uri="{BB962C8B-B14F-4D97-AF65-F5344CB8AC3E}">
-        <p14:creationId xmlns:p14="http://schemas.microsoft.com/office/powerpoint/2010/main" val="1049055003"/>
+        <p14:creationId xmlns:p14="http://schemas.microsoft.com/office/powerpoint/2010/main" val="95153423"/>
       </p:ext>
     </p:extLst>
   </p:cSld>
@@ -1528,9 +1531,9 @@
           <a:bodyPr/>
           <a:lstStyle/>
           <a:p>
-            <a:fld id="{26B7F381-F10E-4587-B886-8036B7268BA3}" type="datetimeFigureOut">
+            <a:fld id="{4A588302-F725-4E0D-AD75-D9B0BA2EF836}" type="datetimeFigureOut">
               <a:rPr lang="en-US" smtClean="0"/>
-              <a:t>10/3/2026</a:t>
+              <a:t>10/4/2026</a:t>
             </a:fld>
             <a:endParaRPr lang="en-US"/>
           </a:p>
@@ -1570,7 +1573,7 @@
           <a:bodyPr/>
           <a:lstStyle/>
           <a:p>
-            <a:fld id="{C8D4D1C8-8C5D-4FFA-950C-FD08A0718FA9}" type="slidenum">
+            <a:fld id="{7293683F-31E2-46C4-A5EC-E1CFD9E8730E}" type="slidenum">
               <a:rPr lang="en-US" smtClean="0"/>
               <a:t>‹#›</a:t>
             </a:fld>
@@ -1583,7 +1586,7 @@
           <p:cNvPr id="6" name="item_1_title">
             <a:extLst>
               <a:ext uri="{FF2B5EF4-FFF2-40B4-BE49-F238E27FC236}">
-                <a16:creationId xmlns:a16="http://schemas.microsoft.com/office/drawing/2014/main" id="{099ED3A7-5ED8-0946-16DB-E967C959E47E}"/>
+                <a16:creationId xmlns:a16="http://schemas.microsoft.com/office/drawing/2014/main" id="{91179027-60DE-CDBD-6706-B257C85E9668}"/>
               </a:ext>
             </a:extLst>
           </p:cNvPr>
@@ -1613,7 +1616,10 @@
               <a:buNone/>
               <a:defRPr sz="2000" b="1">
                 <a:solidFill>
-                  <a:schemeClr val="accent1"/>
+                  <a:schemeClr val="accent1">
+                    <a:lumMod val="70000"/>
+                    <a:lumOff val="30000"/>
+                  </a:schemeClr>
                 </a:solidFill>
                 <a:latin typeface="+mj-lt"/>
               </a:defRPr>
@@ -1633,7 +1639,7 @@
           <p:cNvPr id="7" name="item_1">
             <a:extLst>
               <a:ext uri="{FF2B5EF4-FFF2-40B4-BE49-F238E27FC236}">
-                <a16:creationId xmlns:a16="http://schemas.microsoft.com/office/drawing/2014/main" id="{7BF2CCB5-FA95-6CF3-E2BF-9745C7223AEF}"/>
+                <a16:creationId xmlns:a16="http://schemas.microsoft.com/office/drawing/2014/main" id="{16329CEB-DFC8-4305-0BE0-F9900751D10E}"/>
               </a:ext>
             </a:extLst>
           </p:cNvPr>
@@ -1681,7 +1687,7 @@
           <p:cNvPr id="8" name="item_2_title">
             <a:extLst>
               <a:ext uri="{FF2B5EF4-FFF2-40B4-BE49-F238E27FC236}">
-                <a16:creationId xmlns:a16="http://schemas.microsoft.com/office/drawing/2014/main" id="{653751BA-BC73-5499-CF4C-F8E2035CB522}"/>
+                <a16:creationId xmlns:a16="http://schemas.microsoft.com/office/drawing/2014/main" id="{52ECD359-F078-9169-E89C-8C005C67481A}"/>
               </a:ext>
             </a:extLst>
           </p:cNvPr>
@@ -1714,7 +1720,10 @@
               <a:buNone/>
               <a:defRPr sz="2000" b="1">
                 <a:solidFill>
-                  <a:schemeClr val="accent1"/>
+                  <a:schemeClr val="accent1">
+                    <a:lumMod val="70000"/>
+                    <a:lumOff val="30000"/>
+                  </a:schemeClr>
                 </a:solidFill>
                 <a:latin typeface="+mj-lt"/>
               </a:defRPr>
@@ -1734,7 +1743,7 @@
           <p:cNvPr id="9" name="item_2">
             <a:extLst>
               <a:ext uri="{FF2B5EF4-FFF2-40B4-BE49-F238E27FC236}">
-                <a16:creationId xmlns:a16="http://schemas.microsoft.com/office/drawing/2014/main" id="{98CCEA9E-ECD6-6834-5C5A-24BC83D9EEDE}"/>
+                <a16:creationId xmlns:a16="http://schemas.microsoft.com/office/drawing/2014/main" id="{A262D1EF-C452-08F6-9BED-DE9A3AF49D90}"/>
               </a:ext>
             </a:extLst>
           </p:cNvPr>
@@ -1782,7 +1791,7 @@
           <p:cNvPr id="10" name="item_3_title">
             <a:extLst>
               <a:ext uri="{FF2B5EF4-FFF2-40B4-BE49-F238E27FC236}">
-                <a16:creationId xmlns:a16="http://schemas.microsoft.com/office/drawing/2014/main" id="{26D9F120-817E-8864-A7E8-4C2F9F081058}"/>
+                <a16:creationId xmlns:a16="http://schemas.microsoft.com/office/drawing/2014/main" id="{91CBAE64-B59C-DD82-B29D-A09EA7397372}"/>
               </a:ext>
             </a:extLst>
           </p:cNvPr>
@@ -1815,7 +1824,10 @@
               <a:buNone/>
               <a:defRPr sz="2000" b="1">
                 <a:solidFill>
-                  <a:schemeClr val="accent1"/>
+                  <a:schemeClr val="accent1">
+                    <a:lumMod val="70000"/>
+                    <a:lumOff val="30000"/>
+                  </a:schemeClr>
                 </a:solidFill>
                 <a:latin typeface="+mj-lt"/>
               </a:defRPr>
@@ -1835,7 +1847,7 @@
           <p:cNvPr id="11" name="item_3">
             <a:extLst>
               <a:ext uri="{FF2B5EF4-FFF2-40B4-BE49-F238E27FC236}">
-                <a16:creationId xmlns:a16="http://schemas.microsoft.com/office/drawing/2014/main" id="{FEDF8FCE-DD20-8EA3-392E-9C510C5A7B3B}"/>
+                <a16:creationId xmlns:a16="http://schemas.microsoft.com/office/drawing/2014/main" id="{86C1CD9F-0B70-D09A-C9FE-EFB7531047AB}"/>
               </a:ext>
             </a:extLst>
           </p:cNvPr>
@@ -1883,7 +1895,7 @@
           <p:cNvPr id="12" name="item_4_title">
             <a:extLst>
               <a:ext uri="{FF2B5EF4-FFF2-40B4-BE49-F238E27FC236}">
-                <a16:creationId xmlns:a16="http://schemas.microsoft.com/office/drawing/2014/main" id="{11267FBB-8474-3129-F95C-463DE2970F4E}"/>
+                <a16:creationId xmlns:a16="http://schemas.microsoft.com/office/drawing/2014/main" id="{797F605C-E658-023E-49C4-B01F0E8907D6}"/>
               </a:ext>
             </a:extLst>
           </p:cNvPr>
@@ -1916,7 +1928,10 @@
               <a:buNone/>
               <a:defRPr sz="2000" b="1">
                 <a:solidFill>
-                  <a:schemeClr val="accent1"/>
+                  <a:schemeClr val="accent1">
+                    <a:lumMod val="70000"/>
+                    <a:lumOff val="30000"/>
+                  </a:schemeClr>
                 </a:solidFill>
                 <a:latin typeface="+mj-lt"/>
               </a:defRPr>
@@ -1936,7 +1951,7 @@
           <p:cNvPr id="13" name="item_4">
             <a:extLst>
               <a:ext uri="{FF2B5EF4-FFF2-40B4-BE49-F238E27FC236}">
-                <a16:creationId xmlns:a16="http://schemas.microsoft.com/office/drawing/2014/main" id="{E691977C-9DCE-D016-DFB1-B0D5EF715562}"/>
+                <a16:creationId xmlns:a16="http://schemas.microsoft.com/office/drawing/2014/main" id="{84BCAEC1-9C44-CCDB-F068-429E64485272}"/>
               </a:ext>
             </a:extLst>
           </p:cNvPr>
@@ -1984,7 +1999,7 @@
           <p:cNvPr id="14" name="source">
             <a:extLst>
               <a:ext uri="{FF2B5EF4-FFF2-40B4-BE49-F238E27FC236}">
-                <a16:creationId xmlns:a16="http://schemas.microsoft.com/office/drawing/2014/main" id="{2E47E91C-AF4F-0B99-D888-09BEDFF83C98}"/>
+                <a16:creationId xmlns:a16="http://schemas.microsoft.com/office/drawing/2014/main" id="{C5D7E60A-ADF1-9613-B35E-155907B607B2}"/>
               </a:ext>
             </a:extLst>
           </p:cNvPr>
@@ -2006,7 +2021,10 @@
             </a:avLst>
           </a:prstGeom>
           <a:solidFill>
-            <a:schemeClr val="accent1"/>
+            <a:schemeClr val="accent1">
+              <a:lumMod val="70000"/>
+              <a:lumOff val="30000"/>
+            </a:schemeClr>
           </a:solidFill>
         </p:spPr>
         <p:txBody>
@@ -2039,7 +2057,7 @@
     </p:spTree>
     <p:extLst>
       <p:ext uri="{BB962C8B-B14F-4D97-AF65-F5344CB8AC3E}">
-        <p14:creationId xmlns:p14="http://schemas.microsoft.com/office/powerpoint/2010/main" val="3066513673"/>
+        <p14:creationId xmlns:p14="http://schemas.microsoft.com/office/powerpoint/2010/main" val="1435838845"/>
       </p:ext>
     </p:extLst>
   </p:cSld>
@@ -2113,9 +2131,9 @@
           <a:bodyPr/>
           <a:lstStyle/>
           <a:p>
-            <a:fld id="{26B7F381-F10E-4587-B886-8036B7268BA3}" type="datetimeFigureOut">
+            <a:fld id="{4A588302-F725-4E0D-AD75-D9B0BA2EF836}" type="datetimeFigureOut">
               <a:rPr lang="en-US" smtClean="0"/>
-              <a:t>10/3/2026</a:t>
+              <a:t>10/4/2026</a:t>
             </a:fld>
             <a:endParaRPr lang="en-US"/>
           </a:p>
@@ -2155,7 +2173,7 @@
           <a:bodyPr/>
           <a:lstStyle/>
           <a:p>
-            <a:fld id="{C8D4D1C8-8C5D-4FFA-950C-FD08A0718FA9}" type="slidenum">
+            <a:fld id="{7293683F-31E2-46C4-A5EC-E1CFD9E8730E}" type="slidenum">
               <a:rPr lang="en-US" smtClean="0"/>
               <a:t>‹#›</a:t>
             </a:fld>
@@ -2168,7 +2186,7 @@
           <p:cNvPr id="6" name="body">
             <a:extLst>
               <a:ext uri="{FF2B5EF4-FFF2-40B4-BE49-F238E27FC236}">
-                <a16:creationId xmlns:a16="http://schemas.microsoft.com/office/drawing/2014/main" id="{86BBE796-5FA3-C998-4156-464C4EC0307D}"/>
+                <a16:creationId xmlns:a16="http://schemas.microsoft.com/office/drawing/2014/main" id="{5D292C7B-D1B2-3417-6BFA-80ECE63A1793}"/>
               </a:ext>
             </a:extLst>
           </p:cNvPr>
@@ -2213,7 +2231,7 @@
           <p:cNvPr id="7" name="source">
             <a:extLst>
               <a:ext uri="{FF2B5EF4-FFF2-40B4-BE49-F238E27FC236}">
-                <a16:creationId xmlns:a16="http://schemas.microsoft.com/office/drawing/2014/main" id="{33A3DE09-AAEA-4FDA-35F6-9EED03596787}"/>
+                <a16:creationId xmlns:a16="http://schemas.microsoft.com/office/drawing/2014/main" id="{530A8835-F3EC-7D30-401E-FC766AE36FA6}"/>
               </a:ext>
             </a:extLst>
           </p:cNvPr>
@@ -2235,7 +2253,10 @@
             </a:avLst>
           </a:prstGeom>
           <a:solidFill>
-            <a:schemeClr val="accent1"/>
+            <a:schemeClr val="accent1">
+              <a:lumMod val="70000"/>
+              <a:lumOff val="30000"/>
+            </a:schemeClr>
           </a:solidFill>
         </p:spPr>
         <p:txBody>
@@ -2268,7 +2289,7 @@
     </p:spTree>
     <p:extLst>
       <p:ext uri="{BB962C8B-B14F-4D97-AF65-F5344CB8AC3E}">
-        <p14:creationId xmlns:p14="http://schemas.microsoft.com/office/powerpoint/2010/main" val="813020238"/>
+        <p14:creationId xmlns:p14="http://schemas.microsoft.com/office/powerpoint/2010/main" val="304500035"/>
       </p:ext>
     </p:extLst>
   </p:cSld>
@@ -2342,9 +2363,9 @@
           <a:bodyPr/>
           <a:lstStyle/>
           <a:p>
-            <a:fld id="{26B7F381-F10E-4587-B886-8036B7268BA3}" type="datetimeFigureOut">
+            <a:fld id="{4A588302-F725-4E0D-AD75-D9B0BA2EF836}" type="datetimeFigureOut">
               <a:rPr lang="en-US" smtClean="0"/>
-              <a:t>10/3/2026</a:t>
+              <a:t>10/4/2026</a:t>
             </a:fld>
             <a:endParaRPr lang="en-US"/>
           </a:p>
@@ -2384,7 +2405,7 @@
           <a:bodyPr/>
           <a:lstStyle/>
           <a:p>
-            <a:fld id="{C8D4D1C8-8C5D-4FFA-950C-FD08A0718FA9}" type="slidenum">
+            <a:fld id="{7293683F-31E2-46C4-A5EC-E1CFD9E8730E}" type="slidenum">
               <a:rPr lang="en-US" smtClean="0"/>
               <a:t>‹#›</a:t>
             </a:fld>
@@ -2397,7 +2418,7 @@
           <p:cNvPr id="6" name="item_1_title">
             <a:extLst>
               <a:ext uri="{FF2B5EF4-FFF2-40B4-BE49-F238E27FC236}">
-                <a16:creationId xmlns:a16="http://schemas.microsoft.com/office/drawing/2014/main" id="{CB82C127-10AC-A4C9-19B9-C2B7C35123F5}"/>
+                <a16:creationId xmlns:a16="http://schemas.microsoft.com/office/drawing/2014/main" id="{7A026111-776B-F7F6-6BC4-03015763C25F}"/>
               </a:ext>
             </a:extLst>
           </p:cNvPr>
@@ -2427,7 +2448,10 @@
               <a:buNone/>
               <a:defRPr sz="2000" b="1">
                 <a:solidFill>
-                  <a:schemeClr val="accent1"/>
+                  <a:schemeClr val="accent1">
+                    <a:lumMod val="70000"/>
+                    <a:lumOff val="30000"/>
+                  </a:schemeClr>
                 </a:solidFill>
                 <a:latin typeface="+mj-lt"/>
               </a:defRPr>
@@ -2447,7 +2471,7 @@
           <p:cNvPr id="7" name="item_1">
             <a:extLst>
               <a:ext uri="{FF2B5EF4-FFF2-40B4-BE49-F238E27FC236}">
-                <a16:creationId xmlns:a16="http://schemas.microsoft.com/office/drawing/2014/main" id="{C70BDAE8-EC80-5F04-DE55-AB38E56EC288}"/>
+                <a16:creationId xmlns:a16="http://schemas.microsoft.com/office/drawing/2014/main" id="{8375B78F-EAE6-0637-3CD7-B2071B9D36F4}"/>
               </a:ext>
             </a:extLst>
           </p:cNvPr>
@@ -2495,7 +2519,7 @@
           <p:cNvPr id="8" name="item_2_title">
             <a:extLst>
               <a:ext uri="{FF2B5EF4-FFF2-40B4-BE49-F238E27FC236}">
-                <a16:creationId xmlns:a16="http://schemas.microsoft.com/office/drawing/2014/main" id="{435E9CBC-D7AD-FCAB-53FF-B7A49FD2CCD1}"/>
+                <a16:creationId xmlns:a16="http://schemas.microsoft.com/office/drawing/2014/main" id="{12A462D4-D428-4819-C6D6-80781DAF4AC4}"/>
               </a:ext>
             </a:extLst>
           </p:cNvPr>
@@ -2528,7 +2552,10 @@
               <a:buNone/>
               <a:defRPr sz="2000" b="1">
                 <a:solidFill>
-                  <a:schemeClr val="accent1"/>
+                  <a:schemeClr val="accent1">
+                    <a:lumMod val="70000"/>
+                    <a:lumOff val="30000"/>
+                  </a:schemeClr>
                 </a:solidFill>
                 <a:latin typeface="+mj-lt"/>
               </a:defRPr>
@@ -2548,7 +2575,7 @@
           <p:cNvPr id="9" name="item_2">
             <a:extLst>
               <a:ext uri="{FF2B5EF4-FFF2-40B4-BE49-F238E27FC236}">
-                <a16:creationId xmlns:a16="http://schemas.microsoft.com/office/drawing/2014/main" id="{822E5604-47B1-CFB4-5A10-5902B5D4D29F}"/>
+                <a16:creationId xmlns:a16="http://schemas.microsoft.com/office/drawing/2014/main" id="{BD2E7656-314E-BB65-7CC4-3A7D7DD04899}"/>
               </a:ext>
             </a:extLst>
           </p:cNvPr>
@@ -2596,7 +2623,7 @@
           <p:cNvPr id="10" name="item_3_title">
             <a:extLst>
               <a:ext uri="{FF2B5EF4-FFF2-40B4-BE49-F238E27FC236}">
-                <a16:creationId xmlns:a16="http://schemas.microsoft.com/office/drawing/2014/main" id="{8D02C104-F8F3-853B-EA21-CF4376694627}"/>
+                <a16:creationId xmlns:a16="http://schemas.microsoft.com/office/drawing/2014/main" id="{CBE31371-D66B-CF9C-CDBB-2A256CFC8FA1}"/>
               </a:ext>
             </a:extLst>
           </p:cNvPr>
@@ -2629,7 +2656,10 @@
               <a:buNone/>
               <a:defRPr sz="2000" b="1">
                 <a:solidFill>
-                  <a:schemeClr val="accent1"/>
+                  <a:schemeClr val="accent1">
+                    <a:lumMod val="70000"/>
+                    <a:lumOff val="30000"/>
+                  </a:schemeClr>
                 </a:solidFill>
                 <a:latin typeface="+mj-lt"/>
               </a:defRPr>
@@ -2649,7 +2679,7 @@
           <p:cNvPr id="11" name="item_3">
             <a:extLst>
               <a:ext uri="{FF2B5EF4-FFF2-40B4-BE49-F238E27FC236}">
-                <a16:creationId xmlns:a16="http://schemas.microsoft.com/office/drawing/2014/main" id="{F01602EE-50BE-9113-FE96-97D391CC3D15}"/>
+                <a16:creationId xmlns:a16="http://schemas.microsoft.com/office/drawing/2014/main" id="{D782C7E9-C509-3EF1-070A-84B8EFFA21DF}"/>
               </a:ext>
             </a:extLst>
           </p:cNvPr>
@@ -2697,7 +2727,7 @@
           <p:cNvPr id="12" name="item_4_title">
             <a:extLst>
               <a:ext uri="{FF2B5EF4-FFF2-40B4-BE49-F238E27FC236}">
-                <a16:creationId xmlns:a16="http://schemas.microsoft.com/office/drawing/2014/main" id="{7328D983-2942-34F2-937F-EA0A9840EFCB}"/>
+                <a16:creationId xmlns:a16="http://schemas.microsoft.com/office/drawing/2014/main" id="{C936921B-2599-62B0-0379-47611327E97E}"/>
               </a:ext>
             </a:extLst>
           </p:cNvPr>
@@ -2730,7 +2760,10 @@
               <a:buNone/>
               <a:defRPr sz="2000" b="1">
                 <a:solidFill>
-                  <a:schemeClr val="accent1"/>
+                  <a:schemeClr val="accent1">
+                    <a:lumMod val="70000"/>
+                    <a:lumOff val="30000"/>
+                  </a:schemeClr>
                 </a:solidFill>
                 <a:latin typeface="+mj-lt"/>
               </a:defRPr>
@@ -2750,7 +2783,7 @@
           <p:cNvPr id="13" name="item_4">
             <a:extLst>
               <a:ext uri="{FF2B5EF4-FFF2-40B4-BE49-F238E27FC236}">
-                <a16:creationId xmlns:a16="http://schemas.microsoft.com/office/drawing/2014/main" id="{1AC3810F-F6DB-189A-DDB8-4C5C03D208FF}"/>
+                <a16:creationId xmlns:a16="http://schemas.microsoft.com/office/drawing/2014/main" id="{D1D18EED-3AFF-9DD1-547B-7367278061F7}"/>
               </a:ext>
             </a:extLst>
           </p:cNvPr>
@@ -2798,7 +2831,7 @@
           <p:cNvPr id="14" name="source">
             <a:extLst>
               <a:ext uri="{FF2B5EF4-FFF2-40B4-BE49-F238E27FC236}">
-                <a16:creationId xmlns:a16="http://schemas.microsoft.com/office/drawing/2014/main" id="{74F0914E-E37C-C396-BD1E-27245BB29D40}"/>
+                <a16:creationId xmlns:a16="http://schemas.microsoft.com/office/drawing/2014/main" id="{145BC1DC-2546-F843-B891-9754AF2D6B80}"/>
               </a:ext>
             </a:extLst>
           </p:cNvPr>
@@ -2820,7 +2853,10 @@
             </a:avLst>
           </a:prstGeom>
           <a:solidFill>
-            <a:schemeClr val="accent1"/>
+            <a:schemeClr val="accent1">
+              <a:lumMod val="70000"/>
+              <a:lumOff val="30000"/>
+            </a:schemeClr>
           </a:solidFill>
         </p:spPr>
         <p:txBody>
@@ -2853,7 +2889,7 @@
     </p:spTree>
     <p:extLst>
       <p:ext uri="{BB962C8B-B14F-4D97-AF65-F5344CB8AC3E}">
-        <p14:creationId xmlns:p14="http://schemas.microsoft.com/office/powerpoint/2010/main" val="1059659461"/>
+        <p14:creationId xmlns:p14="http://schemas.microsoft.com/office/powerpoint/2010/main" val="3572358399"/>
       </p:ext>
     </p:extLst>
   </p:cSld>
@@ -2927,9 +2963,9 @@
           <a:bodyPr/>
           <a:lstStyle/>
           <a:p>
-            <a:fld id="{26B7F381-F10E-4587-B886-8036B7268BA3}" type="datetimeFigureOut">
+            <a:fld id="{4A588302-F725-4E0D-AD75-D9B0BA2EF836}" type="datetimeFigureOut">
               <a:rPr lang="en-US" smtClean="0"/>
-              <a:t>10/3/2026</a:t>
+              <a:t>10/4/2026</a:t>
             </a:fld>
             <a:endParaRPr lang="en-US"/>
           </a:p>
@@ -2969,7 +3005,7 @@
           <a:bodyPr/>
           <a:lstStyle/>
           <a:p>
-            <a:fld id="{C8D4D1C8-8C5D-4FFA-950C-FD08A0718FA9}" type="slidenum">
+            <a:fld id="{7293683F-31E2-46C4-A5EC-E1CFD9E8730E}" type="slidenum">
               <a:rPr lang="en-US" smtClean="0"/>
               <a:t>‹#›</a:t>
             </a:fld>
@@ -2982,7 +3018,7 @@
           <p:cNvPr id="6" name="body">
             <a:extLst>
               <a:ext uri="{FF2B5EF4-FFF2-40B4-BE49-F238E27FC236}">
-                <a16:creationId xmlns:a16="http://schemas.microsoft.com/office/drawing/2014/main" id="{5115B060-CB87-46E8-2AA6-E75494D0C70E}"/>
+                <a16:creationId xmlns:a16="http://schemas.microsoft.com/office/drawing/2014/main" id="{0B399C46-4C86-EEBB-48BE-B073BCE8F4A8}"/>
               </a:ext>
             </a:extLst>
           </p:cNvPr>
@@ -2995,8 +3031,8 @@
         </p:nvSpPr>
         <p:spPr>
           <a:xfrm>
-            <a:off x="6179202" y="2677935"/>
-            <a:ext cx="3094800" cy="2414281"/>
+            <a:off x="6179203" y="2677935"/>
+            <a:ext cx="3094801" cy="2414281"/>
           </a:xfrm>
         </p:spPr>
         <p:txBody>
@@ -3022,7 +3058,7 @@
           <p:cNvPr id="7" name="kpi_value_1">
             <a:extLst>
               <a:ext uri="{FF2B5EF4-FFF2-40B4-BE49-F238E27FC236}">
-                <a16:creationId xmlns:a16="http://schemas.microsoft.com/office/drawing/2014/main" id="{CF55A9CE-6A05-4B6D-3F30-55190D0589CF}"/>
+                <a16:creationId xmlns:a16="http://schemas.microsoft.com/office/drawing/2014/main" id="{08D681F7-83A8-A9A9-B98E-854C7D9A51E4}"/>
               </a:ext>
             </a:extLst>
           </p:cNvPr>
@@ -3055,7 +3091,10 @@
               <a:buNone/>
               <a:defRPr sz="10800" b="1">
                 <a:solidFill>
-                  <a:schemeClr val="accent1"/>
+                  <a:schemeClr val="accent1">
+                    <a:lumMod val="70000"/>
+                    <a:lumOff val="30000"/>
+                  </a:schemeClr>
                 </a:solidFill>
                 <a:latin typeface="+mj-lt"/>
               </a:defRPr>
@@ -3075,7 +3114,7 @@
           <p:cNvPr id="8" name="kpi_label_1">
             <a:extLst>
               <a:ext uri="{FF2B5EF4-FFF2-40B4-BE49-F238E27FC236}">
-                <a16:creationId xmlns:a16="http://schemas.microsoft.com/office/drawing/2014/main" id="{E9392286-B90E-9A2A-C27F-4555D8A76535}"/>
+                <a16:creationId xmlns:a16="http://schemas.microsoft.com/office/drawing/2014/main" id="{CDD78CAB-E67F-4894-DBF7-6611A82C185D}"/>
               </a:ext>
             </a:extLst>
           </p:cNvPr>
@@ -3123,7 +3162,7 @@
           <p:cNvPr id="9" name="source">
             <a:extLst>
               <a:ext uri="{FF2B5EF4-FFF2-40B4-BE49-F238E27FC236}">
-                <a16:creationId xmlns:a16="http://schemas.microsoft.com/office/drawing/2014/main" id="{D8BDE8C9-6B57-321B-B324-800F3D51B52F}"/>
+                <a16:creationId xmlns:a16="http://schemas.microsoft.com/office/drawing/2014/main" id="{8FA477D2-3206-F509-FC5D-701D1378F1DD}"/>
               </a:ext>
             </a:extLst>
           </p:cNvPr>
@@ -3145,7 +3184,10 @@
             </a:avLst>
           </a:prstGeom>
           <a:solidFill>
-            <a:schemeClr val="accent1"/>
+            <a:schemeClr val="accent1">
+              <a:lumMod val="70000"/>
+              <a:lumOff val="30000"/>
+            </a:schemeClr>
           </a:solidFill>
         </p:spPr>
         <p:txBody>
@@ -3178,7 +3220,7 @@
     </p:spTree>
     <p:extLst>
       <p:ext uri="{BB962C8B-B14F-4D97-AF65-F5344CB8AC3E}">
-        <p14:creationId xmlns:p14="http://schemas.microsoft.com/office/powerpoint/2010/main" val="3570562179"/>
+        <p14:creationId xmlns:p14="http://schemas.microsoft.com/office/powerpoint/2010/main" val="2082337206"/>
       </p:ext>
     </p:extLst>
   </p:cSld>
@@ -3252,9 +3294,9 @@
           <a:bodyPr/>
           <a:lstStyle/>
           <a:p>
-            <a:fld id="{26B7F381-F10E-4587-B886-8036B7268BA3}" type="datetimeFigureOut">
+            <a:fld id="{4A588302-F725-4E0D-AD75-D9B0BA2EF836}" type="datetimeFigureOut">
               <a:rPr lang="en-US" smtClean="0"/>
-              <a:t>10/3/2026</a:t>
+              <a:t>10/4/2026</a:t>
             </a:fld>
             <a:endParaRPr lang="en-US"/>
           </a:p>
@@ -3294,7 +3336,7 @@
           <a:bodyPr/>
           <a:lstStyle/>
           <a:p>
-            <a:fld id="{C8D4D1C8-8C5D-4FFA-950C-FD08A0718FA9}" type="slidenum">
+            <a:fld id="{7293683F-31E2-46C4-A5EC-E1CFD9E8730E}" type="slidenum">
               <a:rPr lang="en-US" smtClean="0"/>
               <a:t>‹#›</a:t>
             </a:fld>
@@ -3307,7 +3349,7 @@
           <p:cNvPr id="6" name="body">
             <a:extLst>
               <a:ext uri="{FF2B5EF4-FFF2-40B4-BE49-F238E27FC236}">
-                <a16:creationId xmlns:a16="http://schemas.microsoft.com/office/drawing/2014/main" id="{4A02F0D3-845A-3B1A-ECF8-96E9BB2A7F9C}"/>
+                <a16:creationId xmlns:a16="http://schemas.microsoft.com/office/drawing/2014/main" id="{96DBDEB5-FC21-A876-5ED1-0EEF79BC3168}"/>
               </a:ext>
             </a:extLst>
           </p:cNvPr>
@@ -3347,7 +3389,7 @@
           <p:cNvPr id="7" name="kpi_value_1">
             <a:extLst>
               <a:ext uri="{FF2B5EF4-FFF2-40B4-BE49-F238E27FC236}">
-                <a16:creationId xmlns:a16="http://schemas.microsoft.com/office/drawing/2014/main" id="{B0239973-C0B1-5DC1-2CC8-2039AD9B257A}"/>
+                <a16:creationId xmlns:a16="http://schemas.microsoft.com/office/drawing/2014/main" id="{FBD5BCF9-4360-2C43-2D46-50B261AF6F09}"/>
               </a:ext>
             </a:extLst>
           </p:cNvPr>
@@ -3380,7 +3422,10 @@
               <a:buNone/>
               <a:defRPr sz="6000" b="1">
                 <a:solidFill>
-                  <a:schemeClr val="accent1"/>
+                  <a:schemeClr val="accent1">
+                    <a:lumMod val="70000"/>
+                    <a:lumOff val="30000"/>
+                  </a:schemeClr>
                 </a:solidFill>
                 <a:latin typeface="+mj-lt"/>
               </a:defRPr>
@@ -3400,7 +3445,7 @@
           <p:cNvPr id="8" name="kpi_label_1">
             <a:extLst>
               <a:ext uri="{FF2B5EF4-FFF2-40B4-BE49-F238E27FC236}">
-                <a16:creationId xmlns:a16="http://schemas.microsoft.com/office/drawing/2014/main" id="{8BF2E44B-5092-2A45-E4B0-A571342B34DE}"/>
+                <a16:creationId xmlns:a16="http://schemas.microsoft.com/office/drawing/2014/main" id="{099185E0-9C96-4B1D-8039-47B97A8DAD59}"/>
               </a:ext>
             </a:extLst>
           </p:cNvPr>
@@ -3448,7 +3493,7 @@
           <p:cNvPr id="9" name="kpi_value_2">
             <a:extLst>
               <a:ext uri="{FF2B5EF4-FFF2-40B4-BE49-F238E27FC236}">
-                <a16:creationId xmlns:a16="http://schemas.microsoft.com/office/drawing/2014/main" id="{D40F6B9D-CF05-016D-42EB-D43C53D79729}"/>
+                <a16:creationId xmlns:a16="http://schemas.microsoft.com/office/drawing/2014/main" id="{0BD42A51-1718-3C02-0F80-C71ADD899174}"/>
               </a:ext>
             </a:extLst>
           </p:cNvPr>
@@ -3481,7 +3526,10 @@
               <a:buNone/>
               <a:defRPr sz="6000" b="1">
                 <a:solidFill>
-                  <a:schemeClr val="accent1"/>
+                  <a:schemeClr val="accent1">
+                    <a:lumMod val="70000"/>
+                    <a:lumOff val="30000"/>
+                  </a:schemeClr>
                 </a:solidFill>
                 <a:latin typeface="+mj-lt"/>
               </a:defRPr>
@@ -3501,7 +3549,7 @@
           <p:cNvPr id="10" name="kpi_label_2">
             <a:extLst>
               <a:ext uri="{FF2B5EF4-FFF2-40B4-BE49-F238E27FC236}">
-                <a16:creationId xmlns:a16="http://schemas.microsoft.com/office/drawing/2014/main" id="{2CFBC110-B522-0851-C98F-E54D14A7F8D9}"/>
+                <a16:creationId xmlns:a16="http://schemas.microsoft.com/office/drawing/2014/main" id="{A7BC6042-B1CA-BBAC-ABEB-7608E1A03CDB}"/>
               </a:ext>
             </a:extLst>
           </p:cNvPr>
@@ -3549,7 +3597,7 @@
           <p:cNvPr id="11" name="kpi_value_3">
             <a:extLst>
               <a:ext uri="{FF2B5EF4-FFF2-40B4-BE49-F238E27FC236}">
-                <a16:creationId xmlns:a16="http://schemas.microsoft.com/office/drawing/2014/main" id="{0EF70FD3-DAFB-7FD3-A16F-B2F8009DDB0A}"/>
+                <a16:creationId xmlns:a16="http://schemas.microsoft.com/office/drawing/2014/main" id="{771903B5-E1B1-D7AD-7761-E3EFDB5E13CF}"/>
               </a:ext>
             </a:extLst>
           </p:cNvPr>
@@ -3582,7 +3630,10 @@
               <a:buNone/>
               <a:defRPr sz="6000" b="1">
                 <a:solidFill>
-                  <a:schemeClr val="accent1"/>
+                  <a:schemeClr val="accent1">
+                    <a:lumMod val="70000"/>
+                    <a:lumOff val="30000"/>
+                  </a:schemeClr>
                 </a:solidFill>
                 <a:latin typeface="+mj-lt"/>
               </a:defRPr>
@@ -3602,7 +3653,7 @@
           <p:cNvPr id="12" name="kpi_label_3">
             <a:extLst>
               <a:ext uri="{FF2B5EF4-FFF2-40B4-BE49-F238E27FC236}">
-                <a16:creationId xmlns:a16="http://schemas.microsoft.com/office/drawing/2014/main" id="{92A03E05-B9C3-8C61-E383-A0B438C3998B}"/>
+                <a16:creationId xmlns:a16="http://schemas.microsoft.com/office/drawing/2014/main" id="{03F4D1B3-AF54-F762-F4B9-D8A75E4DE36D}"/>
               </a:ext>
             </a:extLst>
           </p:cNvPr>
@@ -3650,7 +3701,7 @@
           <p:cNvPr id="13" name="kpi_value_4">
             <a:extLst>
               <a:ext uri="{FF2B5EF4-FFF2-40B4-BE49-F238E27FC236}">
-                <a16:creationId xmlns:a16="http://schemas.microsoft.com/office/drawing/2014/main" id="{B9D4728F-2CF6-1E02-349D-7F5AC1CCCBDC}"/>
+                <a16:creationId xmlns:a16="http://schemas.microsoft.com/office/drawing/2014/main" id="{452ED6C1-5F9A-DC89-7993-A216891B125F}"/>
               </a:ext>
             </a:extLst>
           </p:cNvPr>
@@ -3663,7 +3714,7 @@
         </p:nvSpPr>
         <p:spPr>
           <a:xfrm>
-            <a:off x="7455477" y="3786717"/>
+            <a:off x="7455478" y="3786717"/>
             <a:ext cx="1664227" cy="569081"/>
           </a:xfrm>
           <a:prstGeom prst="rect">
@@ -3683,7 +3734,10 @@
               <a:buNone/>
               <a:defRPr sz="6000" b="1">
                 <a:solidFill>
-                  <a:schemeClr val="accent1"/>
+                  <a:schemeClr val="accent1">
+                    <a:lumMod val="70000"/>
+                    <a:lumOff val="30000"/>
+                  </a:schemeClr>
                 </a:solidFill>
                 <a:latin typeface="+mj-lt"/>
               </a:defRPr>
@@ -3703,7 +3757,7 @@
           <p:cNvPr id="14" name="kpi_label_4">
             <a:extLst>
               <a:ext uri="{FF2B5EF4-FFF2-40B4-BE49-F238E27FC236}">
-                <a16:creationId xmlns:a16="http://schemas.microsoft.com/office/drawing/2014/main" id="{CC683DA5-4AE5-D205-DAC7-E9F5E9AC6D13}"/>
+                <a16:creationId xmlns:a16="http://schemas.microsoft.com/office/drawing/2014/main" id="{5B80CF22-D1F9-9541-098C-7672FB5624E4}"/>
               </a:ext>
             </a:extLst>
           </p:cNvPr>
@@ -3716,7 +3770,7 @@
         </p:nvSpPr>
         <p:spPr>
           <a:xfrm>
-            <a:off x="7455477" y="4355796"/>
+            <a:off x="7455478" y="4355796"/>
             <a:ext cx="1664227" cy="316156"/>
           </a:xfrm>
           <a:prstGeom prst="rect">
@@ -3751,7 +3805,7 @@
           <p:cNvPr id="15" name="source">
             <a:extLst>
               <a:ext uri="{FF2B5EF4-FFF2-40B4-BE49-F238E27FC236}">
-                <a16:creationId xmlns:a16="http://schemas.microsoft.com/office/drawing/2014/main" id="{0D550027-5297-6421-CE57-66A769827FEF}"/>
+                <a16:creationId xmlns:a16="http://schemas.microsoft.com/office/drawing/2014/main" id="{2E6B9578-D942-AAFC-6383-BAA951B0C90D}"/>
               </a:ext>
             </a:extLst>
           </p:cNvPr>
@@ -3773,7 +3827,10 @@
             </a:avLst>
           </a:prstGeom>
           <a:solidFill>
-            <a:schemeClr val="accent1"/>
+            <a:schemeClr val="accent1">
+              <a:lumMod val="70000"/>
+              <a:lumOff val="30000"/>
+            </a:schemeClr>
           </a:solidFill>
         </p:spPr>
         <p:txBody>
@@ -3806,7 +3863,7 @@
     </p:spTree>
     <p:extLst>
       <p:ext uri="{BB962C8B-B14F-4D97-AF65-F5344CB8AC3E}">
-        <p14:creationId xmlns:p14="http://schemas.microsoft.com/office/powerpoint/2010/main" val="3472289302"/>
+        <p14:creationId xmlns:p14="http://schemas.microsoft.com/office/powerpoint/2010/main" val="3702937082"/>
       </p:ext>
     </p:extLst>
   </p:cSld>
@@ -3880,9 +3937,9 @@
           <a:bodyPr/>
           <a:lstStyle/>
           <a:p>
-            <a:fld id="{26B7F381-F10E-4587-B886-8036B7268BA3}" type="datetimeFigureOut">
+            <a:fld id="{4A588302-F725-4E0D-AD75-D9B0BA2EF836}" type="datetimeFigureOut">
               <a:rPr lang="en-US" smtClean="0"/>
-              <a:t>10/3/2026</a:t>
+              <a:t>10/4/2026</a:t>
             </a:fld>
             <a:endParaRPr lang="en-US"/>
           </a:p>
@@ -3922,7 +3979,7 @@
           <a:bodyPr/>
           <a:lstStyle/>
           <a:p>
-            <a:fld id="{C8D4D1C8-8C5D-4FFA-950C-FD08A0718FA9}" type="slidenum">
+            <a:fld id="{7293683F-31E2-46C4-A5EC-E1CFD9E8730E}" type="slidenum">
               <a:rPr lang="en-US" smtClean="0"/>
               <a:t>‹#›</a:t>
             </a:fld>
@@ -3935,7 +3992,7 @@
           <p:cNvPr id="6" name="body">
             <a:extLst>
               <a:ext uri="{FF2B5EF4-FFF2-40B4-BE49-F238E27FC236}">
-                <a16:creationId xmlns:a16="http://schemas.microsoft.com/office/drawing/2014/main" id="{45CF22A6-5BB9-3933-D993-F33D4F955839}"/>
+                <a16:creationId xmlns:a16="http://schemas.microsoft.com/office/drawing/2014/main" id="{7388457C-6EE9-E682-73B7-817C272491C4}"/>
               </a:ext>
             </a:extLst>
           </p:cNvPr>
@@ -3975,7 +4032,7 @@
           <p:cNvPr id="7" name="kpi_value_1">
             <a:extLst>
               <a:ext uri="{FF2B5EF4-FFF2-40B4-BE49-F238E27FC236}">
-                <a16:creationId xmlns:a16="http://schemas.microsoft.com/office/drawing/2014/main" id="{F3E005A2-9C92-2B37-93BC-8E5028AB5382}"/>
+                <a16:creationId xmlns:a16="http://schemas.microsoft.com/office/drawing/2014/main" id="{3A48FA09-639D-DAED-CA9C-5DE19E054B10}"/>
               </a:ext>
             </a:extLst>
           </p:cNvPr>
@@ -4008,7 +4065,10 @@
               <a:buNone/>
               <a:defRPr sz="6000" b="1">
                 <a:solidFill>
-                  <a:schemeClr val="accent1"/>
+                  <a:schemeClr val="accent1">
+                    <a:lumMod val="70000"/>
+                    <a:lumOff val="30000"/>
+                  </a:schemeClr>
                 </a:solidFill>
                 <a:latin typeface="+mj-lt"/>
               </a:defRPr>
@@ -4028,7 +4088,7 @@
           <p:cNvPr id="8" name="kpi_label_1">
             <a:extLst>
               <a:ext uri="{FF2B5EF4-FFF2-40B4-BE49-F238E27FC236}">
-                <a16:creationId xmlns:a16="http://schemas.microsoft.com/office/drawing/2014/main" id="{C1F62EDF-2956-06C0-36EF-1051F7E60FEF}"/>
+                <a16:creationId xmlns:a16="http://schemas.microsoft.com/office/drawing/2014/main" id="{2B6F21C2-9CC0-6FF1-1ADE-6BD51D9E4ACC}"/>
               </a:ext>
             </a:extLst>
           </p:cNvPr>
@@ -4076,7 +4136,7 @@
           <p:cNvPr id="9" name="kpi_value_2">
             <a:extLst>
               <a:ext uri="{FF2B5EF4-FFF2-40B4-BE49-F238E27FC236}">
-                <a16:creationId xmlns:a16="http://schemas.microsoft.com/office/drawing/2014/main" id="{5B404464-8E57-37DF-ED93-1AA92077AA66}"/>
+                <a16:creationId xmlns:a16="http://schemas.microsoft.com/office/drawing/2014/main" id="{ADC60754-DA56-1AB4-DEBC-EB3810714A11}"/>
               </a:ext>
             </a:extLst>
           </p:cNvPr>
@@ -4109,7 +4169,10 @@
               <a:buNone/>
               <a:defRPr sz="6000" b="1">
                 <a:solidFill>
-                  <a:schemeClr val="accent1"/>
+                  <a:schemeClr val="accent1">
+                    <a:lumMod val="70000"/>
+                    <a:lumOff val="30000"/>
+                  </a:schemeClr>
                 </a:solidFill>
                 <a:latin typeface="+mj-lt"/>
               </a:defRPr>
@@ -4129,7 +4192,7 @@
           <p:cNvPr id="10" name="kpi_label_2">
             <a:extLst>
               <a:ext uri="{FF2B5EF4-FFF2-40B4-BE49-F238E27FC236}">
-                <a16:creationId xmlns:a16="http://schemas.microsoft.com/office/drawing/2014/main" id="{35FD6CBB-8AC1-834B-66C4-F1750A35FA3D}"/>
+                <a16:creationId xmlns:a16="http://schemas.microsoft.com/office/drawing/2014/main" id="{9AD8B5C9-CECF-B4D4-006D-921BC420BAD7}"/>
               </a:ext>
             </a:extLst>
           </p:cNvPr>
@@ -4177,7 +4240,7 @@
           <p:cNvPr id="11" name="source">
             <a:extLst>
               <a:ext uri="{FF2B5EF4-FFF2-40B4-BE49-F238E27FC236}">
-                <a16:creationId xmlns:a16="http://schemas.microsoft.com/office/drawing/2014/main" id="{B157EB0A-08FB-8F5E-1B9D-FAC1CAE1948B}"/>
+                <a16:creationId xmlns:a16="http://schemas.microsoft.com/office/drawing/2014/main" id="{1F794EF0-4B42-3B6E-9A8E-712F96144BAF}"/>
               </a:ext>
             </a:extLst>
           </p:cNvPr>
@@ -4199,7 +4262,10 @@
             </a:avLst>
           </a:prstGeom>
           <a:solidFill>
-            <a:schemeClr val="accent1"/>
+            <a:schemeClr val="accent1">
+              <a:lumMod val="70000"/>
+              <a:lumOff val="30000"/>
+            </a:schemeClr>
           </a:solidFill>
         </p:spPr>
         <p:txBody>
@@ -4232,7 +4298,7 @@
     </p:spTree>
     <p:extLst>
       <p:ext uri="{BB962C8B-B14F-4D97-AF65-F5344CB8AC3E}">
-        <p14:creationId xmlns:p14="http://schemas.microsoft.com/office/powerpoint/2010/main" val="2512687381"/>
+        <p14:creationId xmlns:p14="http://schemas.microsoft.com/office/powerpoint/2010/main" val="406150877"/>
       </p:ext>
     </p:extLst>
   </p:cSld>
@@ -4306,9 +4372,9 @@
           <a:bodyPr/>
           <a:lstStyle/>
           <a:p>
-            <a:fld id="{26B7F381-F10E-4587-B886-8036B7268BA3}" type="datetimeFigureOut">
+            <a:fld id="{4A588302-F725-4E0D-AD75-D9B0BA2EF836}" type="datetimeFigureOut">
               <a:rPr lang="en-US" smtClean="0"/>
-              <a:t>10/3/2026</a:t>
+              <a:t>10/4/2026</a:t>
             </a:fld>
             <a:endParaRPr lang="en-US"/>
           </a:p>
@@ -4348,7 +4414,7 @@
           <a:bodyPr/>
           <a:lstStyle/>
           <a:p>
-            <a:fld id="{C8D4D1C8-8C5D-4FFA-950C-FD08A0718FA9}" type="slidenum">
+            <a:fld id="{7293683F-31E2-46C4-A5EC-E1CFD9E8730E}" type="slidenum">
               <a:rPr lang="en-US" smtClean="0"/>
               <a:t>‹#›</a:t>
             </a:fld>
@@ -4361,7 +4427,7 @@
           <p:cNvPr id="6" name="body">
             <a:extLst>
               <a:ext uri="{FF2B5EF4-FFF2-40B4-BE49-F238E27FC236}">
-                <a16:creationId xmlns:a16="http://schemas.microsoft.com/office/drawing/2014/main" id="{9B605351-DB64-0863-52D4-C7F0B2853A91}"/>
+                <a16:creationId xmlns:a16="http://schemas.microsoft.com/office/drawing/2014/main" id="{2562B9D5-48D5-F69F-2114-F7AB188CA105}"/>
               </a:ext>
             </a:extLst>
           </p:cNvPr>
@@ -4401,7 +4467,7 @@
           <p:cNvPr id="7" name="kpi_value_1">
             <a:extLst>
               <a:ext uri="{FF2B5EF4-FFF2-40B4-BE49-F238E27FC236}">
-                <a16:creationId xmlns:a16="http://schemas.microsoft.com/office/drawing/2014/main" id="{789ED6AB-D2D7-C66B-B193-D8F21C57E559}"/>
+                <a16:creationId xmlns:a16="http://schemas.microsoft.com/office/drawing/2014/main" id="{876A2962-1C99-CA92-325A-E57FFD3951EB}"/>
               </a:ext>
             </a:extLst>
           </p:cNvPr>
@@ -4414,8 +4480,8 @@
         </p:nvSpPr>
         <p:spPr>
           <a:xfrm>
-            <a:off x="787548" y="2288330"/>
-            <a:ext cx="2177822" cy="321265"/>
+            <a:off x="787549" y="2288330"/>
+            <a:ext cx="2177823" cy="321265"/>
           </a:xfrm>
           <a:prstGeom prst="rect">
             <a:avLst/>
@@ -4434,7 +4500,10 @@
               <a:buNone/>
               <a:defRPr sz="6000" b="1">
                 <a:solidFill>
-                  <a:schemeClr val="accent1"/>
+                  <a:schemeClr val="accent1">
+                    <a:lumMod val="70000"/>
+                    <a:lumOff val="30000"/>
+                  </a:schemeClr>
                 </a:solidFill>
                 <a:latin typeface="+mj-lt"/>
               </a:defRPr>
@@ -4454,7 +4523,7 @@
           <p:cNvPr id="8" name="kpi_label_1">
             <a:extLst>
               <a:ext uri="{FF2B5EF4-FFF2-40B4-BE49-F238E27FC236}">
-                <a16:creationId xmlns:a16="http://schemas.microsoft.com/office/drawing/2014/main" id="{058AD109-593F-79CB-F551-71CEF9E67001}"/>
+                <a16:creationId xmlns:a16="http://schemas.microsoft.com/office/drawing/2014/main" id="{15CFCB9D-B219-64EF-3213-16530B75B7D1}"/>
               </a:ext>
             </a:extLst>
           </p:cNvPr>
@@ -4502,7 +4571,7 @@
           <p:cNvPr id="9" name="kpi_value_2">
             <a:extLst>
               <a:ext uri="{FF2B5EF4-FFF2-40B4-BE49-F238E27FC236}">
-                <a16:creationId xmlns:a16="http://schemas.microsoft.com/office/drawing/2014/main" id="{21E7E175-6E2A-B855-77DC-0C017882BA14}"/>
+                <a16:creationId xmlns:a16="http://schemas.microsoft.com/office/drawing/2014/main" id="{CDD48438-9A83-DA6A-B9F4-7912E9486DED}"/>
               </a:ext>
             </a:extLst>
           </p:cNvPr>
@@ -4515,8 +4584,8 @@
         </p:nvSpPr>
         <p:spPr>
           <a:xfrm>
-            <a:off x="787548" y="2992814"/>
-            <a:ext cx="2177822" cy="321265"/>
+            <a:off x="787549" y="2992814"/>
+            <a:ext cx="2177823" cy="321265"/>
           </a:xfrm>
           <a:prstGeom prst="rect">
             <a:avLst/>
@@ -4535,7 +4604,10 @@
               <a:buNone/>
               <a:defRPr sz="6000" b="1">
                 <a:solidFill>
-                  <a:schemeClr val="accent1"/>
+                  <a:schemeClr val="accent1">
+                    <a:lumMod val="70000"/>
+                    <a:lumOff val="30000"/>
+                  </a:schemeClr>
                 </a:solidFill>
                 <a:latin typeface="+mj-lt"/>
               </a:defRPr>
@@ -4555,7 +4627,7 @@
           <p:cNvPr id="10" name="kpi_label_2">
             <a:extLst>
               <a:ext uri="{FF2B5EF4-FFF2-40B4-BE49-F238E27FC236}">
-                <a16:creationId xmlns:a16="http://schemas.microsoft.com/office/drawing/2014/main" id="{067DB137-1919-CAE7-19A2-9707EED1436F}"/>
+                <a16:creationId xmlns:a16="http://schemas.microsoft.com/office/drawing/2014/main" id="{355F4CF3-4FDE-F5C0-2DAB-FD452C1B4083}"/>
               </a:ext>
             </a:extLst>
           </p:cNvPr>
@@ -4603,7 +4675,7 @@
           <p:cNvPr id="11" name="kpi_value_3">
             <a:extLst>
               <a:ext uri="{FF2B5EF4-FFF2-40B4-BE49-F238E27FC236}">
-                <a16:creationId xmlns:a16="http://schemas.microsoft.com/office/drawing/2014/main" id="{CBDBE9F9-594F-68EC-A5CB-815E6E62CC1F}"/>
+                <a16:creationId xmlns:a16="http://schemas.microsoft.com/office/drawing/2014/main" id="{53DB76C3-41E6-7116-2761-54D663F98343}"/>
               </a:ext>
             </a:extLst>
           </p:cNvPr>
@@ -4616,8 +4688,8 @@
         </p:nvSpPr>
         <p:spPr>
           <a:xfrm>
-            <a:off x="787548" y="3697299"/>
-            <a:ext cx="2177822" cy="321265"/>
+            <a:off x="787549" y="3697299"/>
+            <a:ext cx="2177823" cy="321265"/>
           </a:xfrm>
           <a:prstGeom prst="rect">
             <a:avLst/>
@@ -4636,7 +4708,10 @@
               <a:buNone/>
               <a:defRPr sz="6000" b="1">
                 <a:solidFill>
-                  <a:schemeClr val="accent1"/>
+                  <a:schemeClr val="accent1">
+                    <a:lumMod val="70000"/>
+                    <a:lumOff val="30000"/>
+                  </a:schemeClr>
                 </a:solidFill>
                 <a:latin typeface="+mj-lt"/>
               </a:defRPr>
@@ -4656,7 +4731,7 @@
           <p:cNvPr id="12" name="kpi_label_3">
             <a:extLst>
               <a:ext uri="{FF2B5EF4-FFF2-40B4-BE49-F238E27FC236}">
-                <a16:creationId xmlns:a16="http://schemas.microsoft.com/office/drawing/2014/main" id="{E95B0704-BDE7-F839-CC95-71D56274EED3}"/>
+                <a16:creationId xmlns:a16="http://schemas.microsoft.com/office/drawing/2014/main" id="{69DF828F-8B06-EEF3-FE93-5C7829760E8A}"/>
               </a:ext>
             </a:extLst>
           </p:cNvPr>
@@ -4704,7 +4779,7 @@
           <p:cNvPr id="13" name="kpi_value_4">
             <a:extLst>
               <a:ext uri="{FF2B5EF4-FFF2-40B4-BE49-F238E27FC236}">
-                <a16:creationId xmlns:a16="http://schemas.microsoft.com/office/drawing/2014/main" id="{F0243AB2-22EE-7A2C-61BF-BF4731E1AF74}"/>
+                <a16:creationId xmlns:a16="http://schemas.microsoft.com/office/drawing/2014/main" id="{EBF04F86-4C2D-5BED-B2ED-F68A093EB31C}"/>
               </a:ext>
             </a:extLst>
           </p:cNvPr>
@@ -4717,8 +4792,8 @@
         </p:nvSpPr>
         <p:spPr>
           <a:xfrm>
-            <a:off x="787548" y="4401783"/>
-            <a:ext cx="2177822" cy="321265"/>
+            <a:off x="787549" y="4401783"/>
+            <a:ext cx="2177823" cy="321265"/>
           </a:xfrm>
           <a:prstGeom prst="rect">
             <a:avLst/>
@@ -4737,7 +4812,10 @@
               <a:buNone/>
               <a:defRPr sz="6000" b="1">
                 <a:solidFill>
-                  <a:schemeClr val="accent1"/>
+                  <a:schemeClr val="accent1">
+                    <a:lumMod val="70000"/>
+                    <a:lumOff val="30000"/>
+                  </a:schemeClr>
                 </a:solidFill>
                 <a:latin typeface="+mj-lt"/>
               </a:defRPr>
@@ -4757,7 +4835,7 @@
           <p:cNvPr id="14" name="kpi_label_4">
             <a:extLst>
               <a:ext uri="{FF2B5EF4-FFF2-40B4-BE49-F238E27FC236}">
-                <a16:creationId xmlns:a16="http://schemas.microsoft.com/office/drawing/2014/main" id="{4037D0AE-D5A1-9339-CEB7-F157241186B5}"/>
+                <a16:creationId xmlns:a16="http://schemas.microsoft.com/office/drawing/2014/main" id="{27978192-F432-64C7-F62D-191BC5DD2F32}"/>
               </a:ext>
             </a:extLst>
           </p:cNvPr>
@@ -4805,7 +4883,7 @@
           <p:cNvPr id="15" name="source">
             <a:extLst>
               <a:ext uri="{FF2B5EF4-FFF2-40B4-BE49-F238E27FC236}">
-                <a16:creationId xmlns:a16="http://schemas.microsoft.com/office/drawing/2014/main" id="{5744B48C-899F-8342-1352-359816CFED06}"/>
+                <a16:creationId xmlns:a16="http://schemas.microsoft.com/office/drawing/2014/main" id="{CE383324-245A-E302-74AF-3C2238669852}"/>
               </a:ext>
             </a:extLst>
           </p:cNvPr>
@@ -4827,7 +4905,10 @@
             </a:avLst>
           </a:prstGeom>
           <a:solidFill>
-            <a:schemeClr val="accent1"/>
+            <a:schemeClr val="accent1">
+              <a:lumMod val="70000"/>
+              <a:lumOff val="30000"/>
+            </a:schemeClr>
           </a:solidFill>
         </p:spPr>
         <p:txBody>
@@ -4860,7 +4941,7 @@
     </p:spTree>
     <p:extLst>
       <p:ext uri="{BB962C8B-B14F-4D97-AF65-F5344CB8AC3E}">
-        <p14:creationId xmlns:p14="http://schemas.microsoft.com/office/powerpoint/2010/main" val="4028751659"/>
+        <p14:creationId xmlns:p14="http://schemas.microsoft.com/office/powerpoint/2010/main" val="3670832107"/>
       </p:ext>
     </p:extLst>
   </p:cSld>
@@ -4934,9 +5015,9 @@
           <a:bodyPr/>
           <a:lstStyle/>
           <a:p>
-            <a:fld id="{26B7F381-F10E-4587-B886-8036B7268BA3}" type="datetimeFigureOut">
+            <a:fld id="{4A588302-F725-4E0D-AD75-D9B0BA2EF836}" type="datetimeFigureOut">
               <a:rPr lang="en-US" smtClean="0"/>
-              <a:t>10/3/2026</a:t>
+              <a:t>10/4/2026</a:t>
             </a:fld>
             <a:endParaRPr lang="en-US"/>
           </a:p>
@@ -4976,7 +5057,7 @@
           <a:bodyPr/>
           <a:lstStyle/>
           <a:p>
-            <a:fld id="{C8D4D1C8-8C5D-4FFA-950C-FD08A0718FA9}" type="slidenum">
+            <a:fld id="{7293683F-31E2-46C4-A5EC-E1CFD9E8730E}" type="slidenum">
               <a:rPr lang="en-US" smtClean="0"/>
               <a:t>‹#›</a:t>
             </a:fld>
@@ -4989,7 +5070,7 @@
           <p:cNvPr id="6" name="item_1_title">
             <a:extLst>
               <a:ext uri="{FF2B5EF4-FFF2-40B4-BE49-F238E27FC236}">
-                <a16:creationId xmlns:a16="http://schemas.microsoft.com/office/drawing/2014/main" id="{A7606C95-1DAA-814C-F71B-A10FF6BE4A76}"/>
+                <a16:creationId xmlns:a16="http://schemas.microsoft.com/office/drawing/2014/main" id="{64622062-4C90-6B50-D944-61658B4F0448}"/>
               </a:ext>
             </a:extLst>
           </p:cNvPr>
@@ -5019,7 +5100,10 @@
               <a:buNone/>
               <a:defRPr sz="2000" b="1">
                 <a:solidFill>
-                  <a:schemeClr val="accent1"/>
+                  <a:schemeClr val="accent1">
+                    <a:lumMod val="70000"/>
+                    <a:lumOff val="30000"/>
+                  </a:schemeClr>
                 </a:solidFill>
                 <a:latin typeface="+mj-lt"/>
               </a:defRPr>
@@ -5039,7 +5123,7 @@
           <p:cNvPr id="7" name="item_1">
             <a:extLst>
               <a:ext uri="{FF2B5EF4-FFF2-40B4-BE49-F238E27FC236}">
-                <a16:creationId xmlns:a16="http://schemas.microsoft.com/office/drawing/2014/main" id="{C983904D-4C83-BF98-2389-E4640EED472C}"/>
+                <a16:creationId xmlns:a16="http://schemas.microsoft.com/office/drawing/2014/main" id="{081832FE-C7D4-27EE-D7CC-7F9ACF6BE3FE}"/>
               </a:ext>
             </a:extLst>
           </p:cNvPr>
@@ -5087,7 +5171,7 @@
           <p:cNvPr id="8" name="item_2_title">
             <a:extLst>
               <a:ext uri="{FF2B5EF4-FFF2-40B4-BE49-F238E27FC236}">
-                <a16:creationId xmlns:a16="http://schemas.microsoft.com/office/drawing/2014/main" id="{766FF3D8-7AD1-4B23-159F-1A857F68B71B}"/>
+                <a16:creationId xmlns:a16="http://schemas.microsoft.com/office/drawing/2014/main" id="{C248CD53-5800-A9B0-7A76-AB92414BFE47}"/>
               </a:ext>
             </a:extLst>
           </p:cNvPr>
@@ -5120,7 +5204,10 @@
               <a:buNone/>
               <a:defRPr sz="2000" b="1">
                 <a:solidFill>
-                  <a:schemeClr val="accent1"/>
+                  <a:schemeClr val="accent1">
+                    <a:lumMod val="70000"/>
+                    <a:lumOff val="30000"/>
+                  </a:schemeClr>
                 </a:solidFill>
                 <a:latin typeface="+mj-lt"/>
               </a:defRPr>
@@ -5140,7 +5227,7 @@
           <p:cNvPr id="9" name="item_2">
             <a:extLst>
               <a:ext uri="{FF2B5EF4-FFF2-40B4-BE49-F238E27FC236}">
-                <a16:creationId xmlns:a16="http://schemas.microsoft.com/office/drawing/2014/main" id="{DF670475-66DE-C4B2-B0E9-6231FBC461F1}"/>
+                <a16:creationId xmlns:a16="http://schemas.microsoft.com/office/drawing/2014/main" id="{6DBEBACA-D2BF-7547-7354-E947F05FE754}"/>
               </a:ext>
             </a:extLst>
           </p:cNvPr>
@@ -5188,7 +5275,7 @@
           <p:cNvPr id="10" name="item_3_title">
             <a:extLst>
               <a:ext uri="{FF2B5EF4-FFF2-40B4-BE49-F238E27FC236}">
-                <a16:creationId xmlns:a16="http://schemas.microsoft.com/office/drawing/2014/main" id="{08727338-C9C6-F3C7-0A96-DF8D521A1E57}"/>
+                <a16:creationId xmlns:a16="http://schemas.microsoft.com/office/drawing/2014/main" id="{0570CB97-8E4B-2A9E-AE33-00211FF8333E}"/>
               </a:ext>
             </a:extLst>
           </p:cNvPr>
@@ -5221,7 +5308,10 @@
               <a:buNone/>
               <a:defRPr sz="2000" b="1">
                 <a:solidFill>
-                  <a:schemeClr val="accent1"/>
+                  <a:schemeClr val="accent1">
+                    <a:lumMod val="70000"/>
+                    <a:lumOff val="30000"/>
+                  </a:schemeClr>
                 </a:solidFill>
                 <a:latin typeface="+mj-lt"/>
               </a:defRPr>
@@ -5241,7 +5331,7 @@
           <p:cNvPr id="11" name="item_3">
             <a:extLst>
               <a:ext uri="{FF2B5EF4-FFF2-40B4-BE49-F238E27FC236}">
-                <a16:creationId xmlns:a16="http://schemas.microsoft.com/office/drawing/2014/main" id="{E2850BE1-98D0-5448-5952-0AEF28A8A74B}"/>
+                <a16:creationId xmlns:a16="http://schemas.microsoft.com/office/drawing/2014/main" id="{B44023C7-5600-8FE0-7D94-4EDA8AB9B647}"/>
               </a:ext>
             </a:extLst>
           </p:cNvPr>
@@ -5289,7 +5379,7 @@
           <p:cNvPr id="12" name="item_4_title">
             <a:extLst>
               <a:ext uri="{FF2B5EF4-FFF2-40B4-BE49-F238E27FC236}">
-                <a16:creationId xmlns:a16="http://schemas.microsoft.com/office/drawing/2014/main" id="{807586DF-7BC3-F188-22C7-66F8C7055BA4}"/>
+                <a16:creationId xmlns:a16="http://schemas.microsoft.com/office/drawing/2014/main" id="{8B68C180-3B5B-3621-C3D7-4D95C90405A7}"/>
               </a:ext>
             </a:extLst>
           </p:cNvPr>
@@ -5322,7 +5412,10 @@
               <a:buNone/>
               <a:defRPr sz="2000" b="1">
                 <a:solidFill>
-                  <a:schemeClr val="accent1"/>
+                  <a:schemeClr val="accent1">
+                    <a:lumMod val="70000"/>
+                    <a:lumOff val="30000"/>
+                  </a:schemeClr>
                 </a:solidFill>
                 <a:latin typeface="+mj-lt"/>
               </a:defRPr>
@@ -5342,7 +5435,7 @@
           <p:cNvPr id="13" name="item_4">
             <a:extLst>
               <a:ext uri="{FF2B5EF4-FFF2-40B4-BE49-F238E27FC236}">
-                <a16:creationId xmlns:a16="http://schemas.microsoft.com/office/drawing/2014/main" id="{390BA500-B99E-4B5D-5AEC-EED99136C4D3}"/>
+                <a16:creationId xmlns:a16="http://schemas.microsoft.com/office/drawing/2014/main" id="{D0E26456-E9DD-E754-8912-DAFB3369A339}"/>
               </a:ext>
             </a:extLst>
           </p:cNvPr>
@@ -5390,7 +5483,7 @@
           <p:cNvPr id="14" name="source">
             <a:extLst>
               <a:ext uri="{FF2B5EF4-FFF2-40B4-BE49-F238E27FC236}">
-                <a16:creationId xmlns:a16="http://schemas.microsoft.com/office/drawing/2014/main" id="{E26020ED-BDCC-7B61-23D0-39964F443A33}"/>
+                <a16:creationId xmlns:a16="http://schemas.microsoft.com/office/drawing/2014/main" id="{5511407B-6FA2-0698-F599-B8B4012A4E75}"/>
               </a:ext>
             </a:extLst>
           </p:cNvPr>
@@ -5412,7 +5505,10 @@
             </a:avLst>
           </a:prstGeom>
           <a:solidFill>
-            <a:schemeClr val="accent1"/>
+            <a:schemeClr val="accent1">
+              <a:lumMod val="70000"/>
+              <a:lumOff val="30000"/>
+            </a:schemeClr>
           </a:solidFill>
         </p:spPr>
         <p:txBody>
@@ -5445,7 +5541,7 @@
     </p:spTree>
     <p:extLst>
       <p:ext uri="{BB962C8B-B14F-4D97-AF65-F5344CB8AC3E}">
-        <p14:creationId xmlns:p14="http://schemas.microsoft.com/office/powerpoint/2010/main" val="293900728"/>
+        <p14:creationId xmlns:p14="http://schemas.microsoft.com/office/powerpoint/2010/main" val="4031033175"/>
       </p:ext>
     </p:extLst>
   </p:cSld>
@@ -5519,9 +5615,9 @@
           <a:bodyPr/>
           <a:lstStyle/>
           <a:p>
-            <a:fld id="{26B7F381-F10E-4587-B886-8036B7268BA3}" type="datetimeFigureOut">
+            <a:fld id="{4A588302-F725-4E0D-AD75-D9B0BA2EF836}" type="datetimeFigureOut">
               <a:rPr lang="en-US" smtClean="0"/>
-              <a:t>10/3/2026</a:t>
+              <a:t>10/4/2026</a:t>
             </a:fld>
             <a:endParaRPr lang="en-US"/>
           </a:p>
@@ -5561,7 +5657,7 @@
           <a:bodyPr/>
           <a:lstStyle/>
           <a:p>
-            <a:fld id="{C8D4D1C8-8C5D-4FFA-950C-FD08A0718FA9}" type="slidenum">
+            <a:fld id="{7293683F-31E2-46C4-A5EC-E1CFD9E8730E}" type="slidenum">
               <a:rPr lang="en-US" smtClean="0"/>
               <a:t>‹#›</a:t>
             </a:fld>
@@ -5574,7 +5670,7 @@
           <p:cNvPr id="6" name="marker_1">
             <a:extLst>
               <a:ext uri="{FF2B5EF4-FFF2-40B4-BE49-F238E27FC236}">
-                <a16:creationId xmlns:a16="http://schemas.microsoft.com/office/drawing/2014/main" id="{14CBB1D0-2C7E-B749-A80F-A76763246774}"/>
+                <a16:creationId xmlns:a16="http://schemas.microsoft.com/office/drawing/2014/main" id="{BB3AB750-43DB-C354-20D3-F82F111F6E31}"/>
               </a:ext>
             </a:extLst>
           </p:cNvPr>
@@ -5594,7 +5690,10 @@
             <a:avLst/>
           </a:prstGeom>
           <a:solidFill>
-            <a:schemeClr val="accent1"/>
+            <a:schemeClr val="accent1">
+              <a:lumMod val="70000"/>
+              <a:lumOff val="30000"/>
+            </a:schemeClr>
           </a:solidFill>
         </p:spPr>
         <p:txBody>
@@ -5630,7 +5729,7 @@
           <p:cNvPr id="7" name="item_1_title">
             <a:extLst>
               <a:ext uri="{FF2B5EF4-FFF2-40B4-BE49-F238E27FC236}">
-                <a16:creationId xmlns:a16="http://schemas.microsoft.com/office/drawing/2014/main" id="{31923198-A9E6-4A2B-6B8D-D9C581B56BB8}"/>
+                <a16:creationId xmlns:a16="http://schemas.microsoft.com/office/drawing/2014/main" id="{989F88AE-1505-B65D-DF05-D1C6A178EF95}"/>
               </a:ext>
             </a:extLst>
           </p:cNvPr>
@@ -5663,7 +5762,10 @@
               <a:buNone/>
               <a:defRPr sz="2000" b="1">
                 <a:solidFill>
-                  <a:schemeClr val="accent1"/>
+                  <a:schemeClr val="accent1">
+                    <a:lumMod val="70000"/>
+                    <a:lumOff val="30000"/>
+                  </a:schemeClr>
                 </a:solidFill>
                 <a:latin typeface="+mj-lt"/>
               </a:defRPr>
@@ -5683,7 +5785,7 @@
           <p:cNvPr id="8" name="item_1">
             <a:extLst>
               <a:ext uri="{FF2B5EF4-FFF2-40B4-BE49-F238E27FC236}">
-                <a16:creationId xmlns:a16="http://schemas.microsoft.com/office/drawing/2014/main" id="{887FBC3A-5674-A713-4D1E-9298D1437FC1}"/>
+                <a16:creationId xmlns:a16="http://schemas.microsoft.com/office/drawing/2014/main" id="{4E30C014-CDDB-867F-A1AA-A157D17ECA2A}"/>
               </a:ext>
             </a:extLst>
           </p:cNvPr>
@@ -5731,7 +5833,7 @@
           <p:cNvPr id="9" name="marker_2">
             <a:extLst>
               <a:ext uri="{FF2B5EF4-FFF2-40B4-BE49-F238E27FC236}">
-                <a16:creationId xmlns:a16="http://schemas.microsoft.com/office/drawing/2014/main" id="{D2F1487B-72B1-37AA-9262-5DA5E9EE7524}"/>
+                <a16:creationId xmlns:a16="http://schemas.microsoft.com/office/drawing/2014/main" id="{FC21AA7D-7E23-53A0-40BE-ADD25C575A99}"/>
               </a:ext>
             </a:extLst>
           </p:cNvPr>
@@ -5751,7 +5853,10 @@
             <a:avLst/>
           </a:prstGeom>
           <a:solidFill>
-            <a:schemeClr val="accent1"/>
+            <a:schemeClr val="accent1">
+              <a:lumMod val="70000"/>
+              <a:lumOff val="30000"/>
+            </a:schemeClr>
           </a:solidFill>
         </p:spPr>
         <p:txBody>
@@ -5787,7 +5892,7 @@
           <p:cNvPr id="10" name="item_2_title">
             <a:extLst>
               <a:ext uri="{FF2B5EF4-FFF2-40B4-BE49-F238E27FC236}">
-                <a16:creationId xmlns:a16="http://schemas.microsoft.com/office/drawing/2014/main" id="{98AF1A03-D4E8-4709-B583-26EF6B175A95}"/>
+                <a16:creationId xmlns:a16="http://schemas.microsoft.com/office/drawing/2014/main" id="{F474729E-FCE0-3BD7-9F49-06853B48C8C7}"/>
               </a:ext>
             </a:extLst>
           </p:cNvPr>
@@ -5820,7 +5925,10 @@
               <a:buNone/>
               <a:defRPr sz="2000" b="1">
                 <a:solidFill>
-                  <a:schemeClr val="accent1"/>
+                  <a:schemeClr val="accent1">
+                    <a:lumMod val="70000"/>
+                    <a:lumOff val="30000"/>
+                  </a:schemeClr>
                 </a:solidFill>
                 <a:latin typeface="+mj-lt"/>
               </a:defRPr>
@@ -5840,7 +5948,7 @@
           <p:cNvPr id="11" name="item_2">
             <a:extLst>
               <a:ext uri="{FF2B5EF4-FFF2-40B4-BE49-F238E27FC236}">
-                <a16:creationId xmlns:a16="http://schemas.microsoft.com/office/drawing/2014/main" id="{183EECB4-AE09-8F8F-7B9E-1D497DEA6593}"/>
+                <a16:creationId xmlns:a16="http://schemas.microsoft.com/office/drawing/2014/main" id="{45E6F5AC-1856-BCA1-3799-8AC9746F188F}"/>
               </a:ext>
             </a:extLst>
           </p:cNvPr>
@@ -5888,7 +5996,7 @@
           <p:cNvPr id="12" name="source">
             <a:extLst>
               <a:ext uri="{FF2B5EF4-FFF2-40B4-BE49-F238E27FC236}">
-                <a16:creationId xmlns:a16="http://schemas.microsoft.com/office/drawing/2014/main" id="{5E8511AD-1B89-6C54-E0FB-537210790DBF}"/>
+                <a16:creationId xmlns:a16="http://schemas.microsoft.com/office/drawing/2014/main" id="{2D308B28-D134-B7EE-CF3E-AF50B52EAAF3}"/>
               </a:ext>
             </a:extLst>
           </p:cNvPr>
@@ -5910,7 +6018,10 @@
             </a:avLst>
           </a:prstGeom>
           <a:solidFill>
-            <a:schemeClr val="accent1"/>
+            <a:schemeClr val="accent1">
+              <a:lumMod val="70000"/>
+              <a:lumOff val="30000"/>
+            </a:schemeClr>
           </a:solidFill>
         </p:spPr>
         <p:txBody>
@@ -5943,7 +6054,7 @@
     </p:spTree>
     <p:extLst>
       <p:ext uri="{BB962C8B-B14F-4D97-AF65-F5344CB8AC3E}">
-        <p14:creationId xmlns:p14="http://schemas.microsoft.com/office/powerpoint/2010/main" val="1248967992"/>
+        <p14:creationId xmlns:p14="http://schemas.microsoft.com/office/powerpoint/2010/main" val="1203049592"/>
       </p:ext>
     </p:extLst>
   </p:cSld>
@@ -6017,9 +6128,9 @@
           <a:bodyPr/>
           <a:lstStyle/>
           <a:p>
-            <a:fld id="{26B7F381-F10E-4587-B886-8036B7268BA3}" type="datetimeFigureOut">
+            <a:fld id="{4A588302-F725-4E0D-AD75-D9B0BA2EF836}" type="datetimeFigureOut">
               <a:rPr lang="en-US" smtClean="0"/>
-              <a:t>10/3/2026</a:t>
+              <a:t>10/4/2026</a:t>
             </a:fld>
             <a:endParaRPr lang="en-US"/>
           </a:p>
@@ -6059,7 +6170,7 @@
           <a:bodyPr/>
           <a:lstStyle/>
           <a:p>
-            <a:fld id="{C8D4D1C8-8C5D-4FFA-950C-FD08A0718FA9}" type="slidenum">
+            <a:fld id="{7293683F-31E2-46C4-A5EC-E1CFD9E8730E}" type="slidenum">
               <a:rPr lang="en-US" smtClean="0"/>
               <a:t>‹#›</a:t>
             </a:fld>
@@ -6072,7 +6183,7 @@
           <p:cNvPr id="6" name="item_1_title">
             <a:extLst>
               <a:ext uri="{FF2B5EF4-FFF2-40B4-BE49-F238E27FC236}">
-                <a16:creationId xmlns:a16="http://schemas.microsoft.com/office/drawing/2014/main" id="{A66F4B1D-19F6-6762-36D8-D11FA335D019}"/>
+                <a16:creationId xmlns:a16="http://schemas.microsoft.com/office/drawing/2014/main" id="{03109D91-787D-239A-15E9-5F4617F549C5}"/>
               </a:ext>
             </a:extLst>
           </p:cNvPr>
@@ -6102,7 +6213,10 @@
               <a:buNone/>
               <a:defRPr sz="2000" b="1">
                 <a:solidFill>
-                  <a:schemeClr val="accent1"/>
+                  <a:schemeClr val="accent1">
+                    <a:lumMod val="70000"/>
+                    <a:lumOff val="30000"/>
+                  </a:schemeClr>
                 </a:solidFill>
                 <a:latin typeface="+mj-lt"/>
               </a:defRPr>
@@ -6122,7 +6236,7 @@
           <p:cNvPr id="7" name="item_1">
             <a:extLst>
               <a:ext uri="{FF2B5EF4-FFF2-40B4-BE49-F238E27FC236}">
-                <a16:creationId xmlns:a16="http://schemas.microsoft.com/office/drawing/2014/main" id="{A263FFF8-6947-C6A0-5C42-6BB851036126}"/>
+                <a16:creationId xmlns:a16="http://schemas.microsoft.com/office/drawing/2014/main" id="{4CE3E0DF-C5BC-CAC0-B8E1-8080531E69FB}"/>
               </a:ext>
             </a:extLst>
           </p:cNvPr>
@@ -6170,7 +6284,7 @@
           <p:cNvPr id="8" name="item_2_title">
             <a:extLst>
               <a:ext uri="{FF2B5EF4-FFF2-40B4-BE49-F238E27FC236}">
-                <a16:creationId xmlns:a16="http://schemas.microsoft.com/office/drawing/2014/main" id="{082CD3A4-340D-E67E-FA9F-9A28CD9416C9}"/>
+                <a16:creationId xmlns:a16="http://schemas.microsoft.com/office/drawing/2014/main" id="{FC1A6653-06BA-6049-987B-970A331E57DA}"/>
               </a:ext>
             </a:extLst>
           </p:cNvPr>
@@ -6203,7 +6317,10 @@
               <a:buNone/>
               <a:defRPr sz="2000" b="1">
                 <a:solidFill>
-                  <a:schemeClr val="accent1"/>
+                  <a:schemeClr val="accent1">
+                    <a:lumMod val="70000"/>
+                    <a:lumOff val="30000"/>
+                  </a:schemeClr>
                 </a:solidFill>
                 <a:latin typeface="+mj-lt"/>
               </a:defRPr>
@@ -6223,7 +6340,7 @@
           <p:cNvPr id="9" name="item_2">
             <a:extLst>
               <a:ext uri="{FF2B5EF4-FFF2-40B4-BE49-F238E27FC236}">
-                <a16:creationId xmlns:a16="http://schemas.microsoft.com/office/drawing/2014/main" id="{EA924E16-6D15-B4F0-8A94-7CD592170700}"/>
+                <a16:creationId xmlns:a16="http://schemas.microsoft.com/office/drawing/2014/main" id="{726F8AAD-B2E1-36A3-C3CD-21ADA6E18267}"/>
               </a:ext>
             </a:extLst>
           </p:cNvPr>
@@ -6271,7 +6388,7 @@
           <p:cNvPr id="10" name="item_3_title">
             <a:extLst>
               <a:ext uri="{FF2B5EF4-FFF2-40B4-BE49-F238E27FC236}">
-                <a16:creationId xmlns:a16="http://schemas.microsoft.com/office/drawing/2014/main" id="{0D817769-5C9D-1A71-A1D2-B0C4CA7A419B}"/>
+                <a16:creationId xmlns:a16="http://schemas.microsoft.com/office/drawing/2014/main" id="{E305E644-80FB-3A9B-173D-17ADCFCFA7A2}"/>
               </a:ext>
             </a:extLst>
           </p:cNvPr>
@@ -6304,7 +6421,10 @@
               <a:buNone/>
               <a:defRPr sz="2000" b="1">
                 <a:solidFill>
-                  <a:schemeClr val="accent1"/>
+                  <a:schemeClr val="accent1">
+                    <a:lumMod val="70000"/>
+                    <a:lumOff val="30000"/>
+                  </a:schemeClr>
                 </a:solidFill>
                 <a:latin typeface="+mj-lt"/>
               </a:defRPr>
@@ -6324,7 +6444,7 @@
           <p:cNvPr id="11" name="item_3">
             <a:extLst>
               <a:ext uri="{FF2B5EF4-FFF2-40B4-BE49-F238E27FC236}">
-                <a16:creationId xmlns:a16="http://schemas.microsoft.com/office/drawing/2014/main" id="{83006CB0-99EB-5CC7-5914-F6E5ADAF9C83}"/>
+                <a16:creationId xmlns:a16="http://schemas.microsoft.com/office/drawing/2014/main" id="{C28B7619-B0A1-1743-91C9-A05FCDDC08B6}"/>
               </a:ext>
             </a:extLst>
           </p:cNvPr>
@@ -6372,7 +6492,7 @@
           <p:cNvPr id="12" name="item_4_title">
             <a:extLst>
               <a:ext uri="{FF2B5EF4-FFF2-40B4-BE49-F238E27FC236}">
-                <a16:creationId xmlns:a16="http://schemas.microsoft.com/office/drawing/2014/main" id="{EB59D658-6E6D-8C42-0075-D3883F0933E7}"/>
+                <a16:creationId xmlns:a16="http://schemas.microsoft.com/office/drawing/2014/main" id="{BA14F294-F45E-0DCD-7DD3-62D0EF5C5F8E}"/>
               </a:ext>
             </a:extLst>
           </p:cNvPr>
@@ -6405,7 +6525,10 @@
               <a:buNone/>
               <a:defRPr sz="2000" b="1">
                 <a:solidFill>
-                  <a:schemeClr val="accent1"/>
+                  <a:schemeClr val="accent1">
+                    <a:lumMod val="70000"/>
+                    <a:lumOff val="30000"/>
+                  </a:schemeClr>
                 </a:solidFill>
                 <a:latin typeface="+mj-lt"/>
               </a:defRPr>
@@ -6425,7 +6548,7 @@
           <p:cNvPr id="13" name="item_4">
             <a:extLst>
               <a:ext uri="{FF2B5EF4-FFF2-40B4-BE49-F238E27FC236}">
-                <a16:creationId xmlns:a16="http://schemas.microsoft.com/office/drawing/2014/main" id="{F79CBF55-483D-2A25-954D-0939568EF304}"/>
+                <a16:creationId xmlns:a16="http://schemas.microsoft.com/office/drawing/2014/main" id="{545F48EB-CD8B-6440-CE2B-0236A2673E09}"/>
               </a:ext>
             </a:extLst>
           </p:cNvPr>
@@ -6473,7 +6596,7 @@
           <p:cNvPr id="14" name="source">
             <a:extLst>
               <a:ext uri="{FF2B5EF4-FFF2-40B4-BE49-F238E27FC236}">
-                <a16:creationId xmlns:a16="http://schemas.microsoft.com/office/drawing/2014/main" id="{D213DFB0-2533-9B2C-70B2-64655D39A0EF}"/>
+                <a16:creationId xmlns:a16="http://schemas.microsoft.com/office/drawing/2014/main" id="{B65B96BB-08FD-14BA-4965-7BFDB6283AD2}"/>
               </a:ext>
             </a:extLst>
           </p:cNvPr>
@@ -6495,7 +6618,10 @@
             </a:avLst>
           </a:prstGeom>
           <a:solidFill>
-            <a:schemeClr val="accent1"/>
+            <a:schemeClr val="accent1">
+              <a:lumMod val="70000"/>
+              <a:lumOff val="30000"/>
+            </a:schemeClr>
           </a:solidFill>
         </p:spPr>
         <p:txBody>
@@ -6528,7 +6654,7 @@
     </p:spTree>
     <p:extLst>
       <p:ext uri="{BB962C8B-B14F-4D97-AF65-F5344CB8AC3E}">
-        <p14:creationId xmlns:p14="http://schemas.microsoft.com/office/powerpoint/2010/main" val="3295304285"/>
+        <p14:creationId xmlns:p14="http://schemas.microsoft.com/office/powerpoint/2010/main" val="57340076"/>
       </p:ext>
     </p:extLst>
   </p:cSld>
@@ -6602,9 +6728,9 @@
           <a:bodyPr/>
           <a:lstStyle/>
           <a:p>
-            <a:fld id="{26B7F381-F10E-4587-B886-8036B7268BA3}" type="datetimeFigureOut">
+            <a:fld id="{4A588302-F725-4E0D-AD75-D9B0BA2EF836}" type="datetimeFigureOut">
               <a:rPr lang="en-US" smtClean="0"/>
-              <a:t>10/3/2026</a:t>
+              <a:t>10/4/2026</a:t>
             </a:fld>
             <a:endParaRPr lang="en-US"/>
           </a:p>
@@ -6644,7 +6770,7 @@
           <a:bodyPr/>
           <a:lstStyle/>
           <a:p>
-            <a:fld id="{C8D4D1C8-8C5D-4FFA-950C-FD08A0718FA9}" type="slidenum">
+            <a:fld id="{7293683F-31E2-46C4-A5EC-E1CFD9E8730E}" type="slidenum">
               <a:rPr lang="en-US" smtClean="0"/>
               <a:t>‹#›</a:t>
             </a:fld>
@@ -6657,7 +6783,7 @@
           <p:cNvPr id="6" name="item_1_title">
             <a:extLst>
               <a:ext uri="{FF2B5EF4-FFF2-40B4-BE49-F238E27FC236}">
-                <a16:creationId xmlns:a16="http://schemas.microsoft.com/office/drawing/2014/main" id="{A82B557C-F9E6-2909-95B2-F3324198C925}"/>
+                <a16:creationId xmlns:a16="http://schemas.microsoft.com/office/drawing/2014/main" id="{B89B4E4C-0BAA-C846-A961-9AA1BDBBF51D}"/>
               </a:ext>
             </a:extLst>
           </p:cNvPr>
@@ -6687,7 +6813,10 @@
               <a:buNone/>
               <a:defRPr sz="2000" b="1">
                 <a:solidFill>
-                  <a:schemeClr val="accent1"/>
+                  <a:schemeClr val="accent1">
+                    <a:lumMod val="70000"/>
+                    <a:lumOff val="30000"/>
+                  </a:schemeClr>
                 </a:solidFill>
                 <a:latin typeface="+mj-lt"/>
               </a:defRPr>
@@ -6707,7 +6836,7 @@
           <p:cNvPr id="7" name="item_1">
             <a:extLst>
               <a:ext uri="{FF2B5EF4-FFF2-40B4-BE49-F238E27FC236}">
-                <a16:creationId xmlns:a16="http://schemas.microsoft.com/office/drawing/2014/main" id="{1759F181-5CBF-9AAF-E2D2-1A0C3FB9CC85}"/>
+                <a16:creationId xmlns:a16="http://schemas.microsoft.com/office/drawing/2014/main" id="{9020611C-207F-0E20-AC03-116D638D9A4D}"/>
               </a:ext>
             </a:extLst>
           </p:cNvPr>
@@ -6755,7 +6884,7 @@
           <p:cNvPr id="8" name="item_2_title">
             <a:extLst>
               <a:ext uri="{FF2B5EF4-FFF2-40B4-BE49-F238E27FC236}">
-                <a16:creationId xmlns:a16="http://schemas.microsoft.com/office/drawing/2014/main" id="{985234E0-875D-62EE-D7B5-9B5E1C770BA0}"/>
+                <a16:creationId xmlns:a16="http://schemas.microsoft.com/office/drawing/2014/main" id="{B15B4988-A8DB-B80C-349C-1ACA2BADCCA8}"/>
               </a:ext>
             </a:extLst>
           </p:cNvPr>
@@ -6788,7 +6917,10 @@
               <a:buNone/>
               <a:defRPr sz="2000" b="1">
                 <a:solidFill>
-                  <a:schemeClr val="accent1"/>
+                  <a:schemeClr val="accent1">
+                    <a:lumMod val="70000"/>
+                    <a:lumOff val="30000"/>
+                  </a:schemeClr>
                 </a:solidFill>
                 <a:latin typeface="+mj-lt"/>
               </a:defRPr>
@@ -6808,7 +6940,7 @@
           <p:cNvPr id="9" name="item_2">
             <a:extLst>
               <a:ext uri="{FF2B5EF4-FFF2-40B4-BE49-F238E27FC236}">
-                <a16:creationId xmlns:a16="http://schemas.microsoft.com/office/drawing/2014/main" id="{E2C2FD0F-7CF8-73CD-6AA8-A9CDB1FF5447}"/>
+                <a16:creationId xmlns:a16="http://schemas.microsoft.com/office/drawing/2014/main" id="{18078075-0BC6-4F73-4220-76F1FF7D158D}"/>
               </a:ext>
             </a:extLst>
           </p:cNvPr>
@@ -6856,7 +6988,7 @@
           <p:cNvPr id="10" name="item_3_title">
             <a:extLst>
               <a:ext uri="{FF2B5EF4-FFF2-40B4-BE49-F238E27FC236}">
-                <a16:creationId xmlns:a16="http://schemas.microsoft.com/office/drawing/2014/main" id="{6534B3C1-DD7D-67BF-014C-D43E33DB2CEC}"/>
+                <a16:creationId xmlns:a16="http://schemas.microsoft.com/office/drawing/2014/main" id="{58BF6E1D-86AB-F3CE-503E-ABDF2C4731AB}"/>
               </a:ext>
             </a:extLst>
           </p:cNvPr>
@@ -6889,7 +7021,10 @@
               <a:buNone/>
               <a:defRPr sz="2000" b="1">
                 <a:solidFill>
-                  <a:schemeClr val="accent1"/>
+                  <a:schemeClr val="accent1">
+                    <a:lumMod val="70000"/>
+                    <a:lumOff val="30000"/>
+                  </a:schemeClr>
                 </a:solidFill>
                 <a:latin typeface="+mj-lt"/>
               </a:defRPr>
@@ -6909,7 +7044,7 @@
           <p:cNvPr id="11" name="item_3">
             <a:extLst>
               <a:ext uri="{FF2B5EF4-FFF2-40B4-BE49-F238E27FC236}">
-                <a16:creationId xmlns:a16="http://schemas.microsoft.com/office/drawing/2014/main" id="{F2674D97-6271-5B56-1671-6A0E757AA5A3}"/>
+                <a16:creationId xmlns:a16="http://schemas.microsoft.com/office/drawing/2014/main" id="{0E37BF14-5BDC-3D4A-5D31-7DF4009E98B7}"/>
               </a:ext>
             </a:extLst>
           </p:cNvPr>
@@ -6957,7 +7092,7 @@
           <p:cNvPr id="12" name="item_4_title">
             <a:extLst>
               <a:ext uri="{FF2B5EF4-FFF2-40B4-BE49-F238E27FC236}">
-                <a16:creationId xmlns:a16="http://schemas.microsoft.com/office/drawing/2014/main" id="{CA4EB01F-6326-7CD2-2B1F-2B46B09543B6}"/>
+                <a16:creationId xmlns:a16="http://schemas.microsoft.com/office/drawing/2014/main" id="{3846B97A-5D8A-3275-1901-DDE2E3CC6382}"/>
               </a:ext>
             </a:extLst>
           </p:cNvPr>
@@ -6990,7 +7125,10 @@
               <a:buNone/>
               <a:defRPr sz="2000" b="1">
                 <a:solidFill>
-                  <a:schemeClr val="accent1"/>
+                  <a:schemeClr val="accent1">
+                    <a:lumMod val="70000"/>
+                    <a:lumOff val="30000"/>
+                  </a:schemeClr>
                 </a:solidFill>
                 <a:latin typeface="+mj-lt"/>
               </a:defRPr>
@@ -7010,7 +7148,7 @@
           <p:cNvPr id="13" name="item_4">
             <a:extLst>
               <a:ext uri="{FF2B5EF4-FFF2-40B4-BE49-F238E27FC236}">
-                <a16:creationId xmlns:a16="http://schemas.microsoft.com/office/drawing/2014/main" id="{AB8B51CF-0A59-0149-BCEF-8F147FBA4342}"/>
+                <a16:creationId xmlns:a16="http://schemas.microsoft.com/office/drawing/2014/main" id="{4BC4C3D2-A5A1-32AC-F2C2-3C2F71EC90EF}"/>
               </a:ext>
             </a:extLst>
           </p:cNvPr>
@@ -7058,7 +7196,7 @@
           <p:cNvPr id="14" name="source">
             <a:extLst>
               <a:ext uri="{FF2B5EF4-FFF2-40B4-BE49-F238E27FC236}">
-                <a16:creationId xmlns:a16="http://schemas.microsoft.com/office/drawing/2014/main" id="{8A94C8F4-FF07-CFAF-B12A-BC3F6660AE5C}"/>
+                <a16:creationId xmlns:a16="http://schemas.microsoft.com/office/drawing/2014/main" id="{CA183611-4046-D214-6DB3-EE52AE4CE5DB}"/>
               </a:ext>
             </a:extLst>
           </p:cNvPr>
@@ -7080,7 +7218,10 @@
             </a:avLst>
           </a:prstGeom>
           <a:solidFill>
-            <a:schemeClr val="accent1"/>
+            <a:schemeClr val="accent1">
+              <a:lumMod val="70000"/>
+              <a:lumOff val="30000"/>
+            </a:schemeClr>
           </a:solidFill>
         </p:spPr>
         <p:txBody>
@@ -7113,7 +7254,7 @@
     </p:spTree>
     <p:extLst>
       <p:ext uri="{BB962C8B-B14F-4D97-AF65-F5344CB8AC3E}">
-        <p14:creationId xmlns:p14="http://schemas.microsoft.com/office/powerpoint/2010/main" val="2081088695"/>
+        <p14:creationId xmlns:p14="http://schemas.microsoft.com/office/powerpoint/2010/main" val="3037260572"/>
       </p:ext>
     </p:extLst>
   </p:cSld>
@@ -7187,9 +7328,9 @@
           <a:bodyPr/>
           <a:lstStyle/>
           <a:p>
-            <a:fld id="{26B7F381-F10E-4587-B886-8036B7268BA3}" type="datetimeFigureOut">
+            <a:fld id="{4A588302-F725-4E0D-AD75-D9B0BA2EF836}" type="datetimeFigureOut">
               <a:rPr lang="en-US" smtClean="0"/>
-              <a:t>10/3/2026</a:t>
+              <a:t>10/4/2026</a:t>
             </a:fld>
             <a:endParaRPr lang="en-US"/>
           </a:p>
@@ -7229,7 +7370,7 @@
           <a:bodyPr/>
           <a:lstStyle/>
           <a:p>
-            <a:fld id="{C8D4D1C8-8C5D-4FFA-950C-FD08A0718FA9}" type="slidenum">
+            <a:fld id="{7293683F-31E2-46C4-A5EC-E1CFD9E8730E}" type="slidenum">
               <a:rPr lang="en-US" smtClean="0"/>
               <a:t>‹#›</a:t>
             </a:fld>
@@ -7242,7 +7383,7 @@
           <p:cNvPr id="6" name="kpi_value_1">
             <a:extLst>
               <a:ext uri="{FF2B5EF4-FFF2-40B4-BE49-F238E27FC236}">
-                <a16:creationId xmlns:a16="http://schemas.microsoft.com/office/drawing/2014/main" id="{FE02A1D8-B591-2A41-6217-49EA82328153}"/>
+                <a16:creationId xmlns:a16="http://schemas.microsoft.com/office/drawing/2014/main" id="{402FE89B-61D4-26F1-4083-76FFAEEEAD5F}"/>
               </a:ext>
             </a:extLst>
           </p:cNvPr>
@@ -7272,7 +7413,10 @@
               <a:buNone/>
               <a:defRPr sz="10800" b="1">
                 <a:solidFill>
-                  <a:schemeClr val="accent1"/>
+                  <a:schemeClr val="accent1">
+                    <a:lumMod val="70000"/>
+                    <a:lumOff val="30000"/>
+                  </a:schemeClr>
                 </a:solidFill>
                 <a:latin typeface="+mj-lt"/>
               </a:defRPr>
@@ -7292,7 +7436,7 @@
           <p:cNvPr id="7" name="kpi_label_1">
             <a:extLst>
               <a:ext uri="{FF2B5EF4-FFF2-40B4-BE49-F238E27FC236}">
-                <a16:creationId xmlns:a16="http://schemas.microsoft.com/office/drawing/2014/main" id="{382DAD34-C861-6147-B9D2-A7CC0C008190}"/>
+                <a16:creationId xmlns:a16="http://schemas.microsoft.com/office/drawing/2014/main" id="{E1D353EA-69D6-856C-7CC1-B514CC9DC26C}"/>
               </a:ext>
             </a:extLst>
           </p:cNvPr>
@@ -7340,7 +7484,7 @@
           <p:cNvPr id="8" name="quote">
             <a:extLst>
               <a:ext uri="{FF2B5EF4-FFF2-40B4-BE49-F238E27FC236}">
-                <a16:creationId xmlns:a16="http://schemas.microsoft.com/office/drawing/2014/main" id="{8A056F37-A2FB-8C95-E56F-898FB3F85079}"/>
+                <a16:creationId xmlns:a16="http://schemas.microsoft.com/office/drawing/2014/main" id="{EBD9503A-B471-3E81-F6EB-DFEBDDA5E4AB}"/>
               </a:ext>
             </a:extLst>
           </p:cNvPr>
@@ -7390,7 +7534,7 @@
           <p:cNvPr id="9" name="attribution">
             <a:extLst>
               <a:ext uri="{FF2B5EF4-FFF2-40B4-BE49-F238E27FC236}">
-                <a16:creationId xmlns:a16="http://schemas.microsoft.com/office/drawing/2014/main" id="{D937CD50-2404-C18F-DAD7-4E34FBF9128E}"/>
+                <a16:creationId xmlns:a16="http://schemas.microsoft.com/office/drawing/2014/main" id="{F081F24F-48E6-72F5-95F9-C9BA49704311}"/>
               </a:ext>
             </a:extLst>
           </p:cNvPr>
@@ -7438,7 +7582,7 @@
           <p:cNvPr id="10" name="item_1_title">
             <a:extLst>
               <a:ext uri="{FF2B5EF4-FFF2-40B4-BE49-F238E27FC236}">
-                <a16:creationId xmlns:a16="http://schemas.microsoft.com/office/drawing/2014/main" id="{73B9E58C-0E95-CF30-40FD-15B6E9C4F5B2}"/>
+                <a16:creationId xmlns:a16="http://schemas.microsoft.com/office/drawing/2014/main" id="{35E72D4F-7CE3-E3DA-6216-61D7C2BF0A25}"/>
               </a:ext>
             </a:extLst>
           </p:cNvPr>
@@ -7471,7 +7615,10 @@
               <a:buNone/>
               <a:defRPr sz="2000" b="1">
                 <a:solidFill>
-                  <a:schemeClr val="accent1"/>
+                  <a:schemeClr val="accent1">
+                    <a:lumMod val="70000"/>
+                    <a:lumOff val="30000"/>
+                  </a:schemeClr>
                 </a:solidFill>
                 <a:latin typeface="+mj-lt"/>
               </a:defRPr>
@@ -7491,7 +7638,7 @@
           <p:cNvPr id="11" name="item_1">
             <a:extLst>
               <a:ext uri="{FF2B5EF4-FFF2-40B4-BE49-F238E27FC236}">
-                <a16:creationId xmlns:a16="http://schemas.microsoft.com/office/drawing/2014/main" id="{EBC12DED-1740-2DA4-328D-94CFD931D04C}"/>
+                <a16:creationId xmlns:a16="http://schemas.microsoft.com/office/drawing/2014/main" id="{5A4004BF-299A-95CD-44E2-01EE0B3D004C}"/>
               </a:ext>
             </a:extLst>
           </p:cNvPr>
@@ -7539,7 +7686,7 @@
           <p:cNvPr id="12" name="source">
             <a:extLst>
               <a:ext uri="{FF2B5EF4-FFF2-40B4-BE49-F238E27FC236}">
-                <a16:creationId xmlns:a16="http://schemas.microsoft.com/office/drawing/2014/main" id="{7D1FE783-D7E1-EFAC-3662-617F994FC883}"/>
+                <a16:creationId xmlns:a16="http://schemas.microsoft.com/office/drawing/2014/main" id="{7849B5BF-14EB-4AAF-B0CF-6A372149C832}"/>
               </a:ext>
             </a:extLst>
           </p:cNvPr>
@@ -7561,7 +7708,10 @@
             </a:avLst>
           </a:prstGeom>
           <a:solidFill>
-            <a:schemeClr val="accent1"/>
+            <a:schemeClr val="accent1">
+              <a:lumMod val="70000"/>
+              <a:lumOff val="30000"/>
+            </a:schemeClr>
           </a:solidFill>
         </p:spPr>
         <p:txBody>
@@ -7594,7 +7744,7 @@
     </p:spTree>
     <p:extLst>
       <p:ext uri="{BB962C8B-B14F-4D97-AF65-F5344CB8AC3E}">
-        <p14:creationId xmlns:p14="http://schemas.microsoft.com/office/powerpoint/2010/main" val="2916170524"/>
+        <p14:creationId xmlns:p14="http://schemas.microsoft.com/office/powerpoint/2010/main" val="2122837516"/>
       </p:ext>
     </p:extLst>
   </p:cSld>
@@ -7668,9 +7818,9 @@
           <a:bodyPr/>
           <a:lstStyle/>
           <a:p>
-            <a:fld id="{26B7F381-F10E-4587-B886-8036B7268BA3}" type="datetimeFigureOut">
+            <a:fld id="{4A588302-F725-4E0D-AD75-D9B0BA2EF836}" type="datetimeFigureOut">
               <a:rPr lang="en-US" smtClean="0"/>
-              <a:t>10/3/2026</a:t>
+              <a:t>10/4/2026</a:t>
             </a:fld>
             <a:endParaRPr lang="en-US"/>
           </a:p>
@@ -7710,7 +7860,7 @@
           <a:bodyPr/>
           <a:lstStyle/>
           <a:p>
-            <a:fld id="{C8D4D1C8-8C5D-4FFA-950C-FD08A0718FA9}" type="slidenum">
+            <a:fld id="{7293683F-31E2-46C4-A5EC-E1CFD9E8730E}" type="slidenum">
               <a:rPr lang="en-US" smtClean="0"/>
               <a:t>‹#›</a:t>
             </a:fld>
@@ -7723,7 +7873,7 @@
           <p:cNvPr id="6" name="item_1_title">
             <a:extLst>
               <a:ext uri="{FF2B5EF4-FFF2-40B4-BE49-F238E27FC236}">
-                <a16:creationId xmlns:a16="http://schemas.microsoft.com/office/drawing/2014/main" id="{4CE38480-4F6E-8CCA-03BE-2AFD8984B10A}"/>
+                <a16:creationId xmlns:a16="http://schemas.microsoft.com/office/drawing/2014/main" id="{34E1793F-A0EE-9423-7B35-C97B44E3F637}"/>
               </a:ext>
             </a:extLst>
           </p:cNvPr>
@@ -7753,7 +7903,10 @@
               <a:buNone/>
               <a:defRPr sz="2000" b="1">
                 <a:solidFill>
-                  <a:schemeClr val="accent1"/>
+                  <a:schemeClr val="accent1">
+                    <a:lumMod val="70000"/>
+                    <a:lumOff val="30000"/>
+                  </a:schemeClr>
                 </a:solidFill>
                 <a:latin typeface="+mj-lt"/>
               </a:defRPr>
@@ -7773,7 +7926,7 @@
           <p:cNvPr id="7" name="item_1">
             <a:extLst>
               <a:ext uri="{FF2B5EF4-FFF2-40B4-BE49-F238E27FC236}">
-                <a16:creationId xmlns:a16="http://schemas.microsoft.com/office/drawing/2014/main" id="{4518BC07-8CF6-A598-542A-F143B970ADA2}"/>
+                <a16:creationId xmlns:a16="http://schemas.microsoft.com/office/drawing/2014/main" id="{FA737172-EB2A-B56D-D154-2931E8E02AA8}"/>
               </a:ext>
             </a:extLst>
           </p:cNvPr>
@@ -7821,7 +7974,7 @@
           <p:cNvPr id="8" name="item_2_title">
             <a:extLst>
               <a:ext uri="{FF2B5EF4-FFF2-40B4-BE49-F238E27FC236}">
-                <a16:creationId xmlns:a16="http://schemas.microsoft.com/office/drawing/2014/main" id="{980F8E42-F78B-9FED-66EF-E8452D57B8D1}"/>
+                <a16:creationId xmlns:a16="http://schemas.microsoft.com/office/drawing/2014/main" id="{F3087EDF-6653-5074-EF46-C6C4271662D4}"/>
               </a:ext>
             </a:extLst>
           </p:cNvPr>
@@ -7854,7 +8007,10 @@
               <a:buNone/>
               <a:defRPr sz="2000" b="1">
                 <a:solidFill>
-                  <a:schemeClr val="accent1"/>
+                  <a:schemeClr val="accent1">
+                    <a:lumMod val="70000"/>
+                    <a:lumOff val="30000"/>
+                  </a:schemeClr>
                 </a:solidFill>
                 <a:latin typeface="+mj-lt"/>
               </a:defRPr>
@@ -7874,7 +8030,7 @@
           <p:cNvPr id="9" name="item_2">
             <a:extLst>
               <a:ext uri="{FF2B5EF4-FFF2-40B4-BE49-F238E27FC236}">
-                <a16:creationId xmlns:a16="http://schemas.microsoft.com/office/drawing/2014/main" id="{37B211D8-27A4-3CAA-E7DD-74CFC3175072}"/>
+                <a16:creationId xmlns:a16="http://schemas.microsoft.com/office/drawing/2014/main" id="{AB9B8371-DB50-EC43-D911-66F23DC582A2}"/>
               </a:ext>
             </a:extLst>
           </p:cNvPr>
@@ -7922,7 +8078,7 @@
           <p:cNvPr id="10" name="item_3_title">
             <a:extLst>
               <a:ext uri="{FF2B5EF4-FFF2-40B4-BE49-F238E27FC236}">
-                <a16:creationId xmlns:a16="http://schemas.microsoft.com/office/drawing/2014/main" id="{90A760BD-0709-7BC5-6878-C12217801D43}"/>
+                <a16:creationId xmlns:a16="http://schemas.microsoft.com/office/drawing/2014/main" id="{287FCC47-3B09-3A9C-BFD7-735C82618DA2}"/>
               </a:ext>
             </a:extLst>
           </p:cNvPr>
@@ -7935,7 +8091,7 @@
         </p:nvSpPr>
         <p:spPr>
           <a:xfrm>
-            <a:off x="6680306" y="2339424"/>
+            <a:off x="6680307" y="2339424"/>
             <a:ext cx="2439396" cy="909206"/>
           </a:xfrm>
           <a:prstGeom prst="rect">
@@ -7955,7 +8111,10 @@
               <a:buNone/>
               <a:defRPr sz="2000" b="1">
                 <a:solidFill>
-                  <a:schemeClr val="accent1"/>
+                  <a:schemeClr val="accent1">
+                    <a:lumMod val="70000"/>
+                    <a:lumOff val="30000"/>
+                  </a:schemeClr>
                 </a:solidFill>
                 <a:latin typeface="+mj-lt"/>
               </a:defRPr>
@@ -7975,7 +8134,7 @@
           <p:cNvPr id="11" name="item_3">
             <a:extLst>
               <a:ext uri="{FF2B5EF4-FFF2-40B4-BE49-F238E27FC236}">
-                <a16:creationId xmlns:a16="http://schemas.microsoft.com/office/drawing/2014/main" id="{82955BC4-66A5-6D0B-8D44-865A6FBAA95B}"/>
+                <a16:creationId xmlns:a16="http://schemas.microsoft.com/office/drawing/2014/main" id="{C91D9FFC-1B10-1A02-457A-81DF12A9B522}"/>
               </a:ext>
             </a:extLst>
           </p:cNvPr>
@@ -7988,7 +8147,7 @@
         </p:nvSpPr>
         <p:spPr>
           <a:xfrm>
-            <a:off x="6680306" y="3248632"/>
+            <a:off x="6680307" y="3248632"/>
             <a:ext cx="2439396" cy="2182095"/>
           </a:xfrm>
           <a:prstGeom prst="rect">
@@ -8023,7 +8182,7 @@
           <p:cNvPr id="12" name="source">
             <a:extLst>
               <a:ext uri="{FF2B5EF4-FFF2-40B4-BE49-F238E27FC236}">
-                <a16:creationId xmlns:a16="http://schemas.microsoft.com/office/drawing/2014/main" id="{DD4AC4BA-5C71-F09B-BD24-20E58D1B22C0}"/>
+                <a16:creationId xmlns:a16="http://schemas.microsoft.com/office/drawing/2014/main" id="{D16FB1B5-B0D6-99BC-4E51-47C1AEF3E9E0}"/>
               </a:ext>
             </a:extLst>
           </p:cNvPr>
@@ -8045,7 +8204,10 @@
             </a:avLst>
           </a:prstGeom>
           <a:solidFill>
-            <a:schemeClr val="accent1"/>
+            <a:schemeClr val="accent1">
+              <a:lumMod val="70000"/>
+              <a:lumOff val="30000"/>
+            </a:schemeClr>
           </a:solidFill>
         </p:spPr>
         <p:txBody>
@@ -8078,7 +8240,7 @@
     </p:spTree>
     <p:extLst>
       <p:ext uri="{BB962C8B-B14F-4D97-AF65-F5344CB8AC3E}">
-        <p14:creationId xmlns:p14="http://schemas.microsoft.com/office/powerpoint/2010/main" val="3279616881"/>
+        <p14:creationId xmlns:p14="http://schemas.microsoft.com/office/powerpoint/2010/main" val="3284821050"/>
       </p:ext>
     </p:extLst>
   </p:cSld>
@@ -8152,9 +8314,9 @@
           <a:bodyPr/>
           <a:lstStyle/>
           <a:p>
-            <a:fld id="{26B7F381-F10E-4587-B886-8036B7268BA3}" type="datetimeFigureOut">
+            <a:fld id="{4A588302-F725-4E0D-AD75-D9B0BA2EF836}" type="datetimeFigureOut">
               <a:rPr lang="en-US" smtClean="0"/>
-              <a:t>10/3/2026</a:t>
+              <a:t>10/4/2026</a:t>
             </a:fld>
             <a:endParaRPr lang="en-US"/>
           </a:p>
@@ -8194,7 +8356,7 @@
           <a:bodyPr/>
           <a:lstStyle/>
           <a:p>
-            <a:fld id="{C8D4D1C8-8C5D-4FFA-950C-FD08A0718FA9}" type="slidenum">
+            <a:fld id="{7293683F-31E2-46C4-A5EC-E1CFD9E8730E}" type="slidenum">
               <a:rPr lang="en-US" smtClean="0"/>
               <a:t>‹#›</a:t>
             </a:fld>
@@ -8207,7 +8369,7 @@
           <p:cNvPr id="6" name="marker_1">
             <a:extLst>
               <a:ext uri="{FF2B5EF4-FFF2-40B4-BE49-F238E27FC236}">
-                <a16:creationId xmlns:a16="http://schemas.microsoft.com/office/drawing/2014/main" id="{C61F946C-C802-6F70-BF0B-6BCD5556267F}"/>
+                <a16:creationId xmlns:a16="http://schemas.microsoft.com/office/drawing/2014/main" id="{60C83E5F-4E56-66AF-968E-6782C84F52F8}"/>
               </a:ext>
             </a:extLst>
           </p:cNvPr>
@@ -8227,7 +8389,10 @@
             <a:avLst/>
           </a:prstGeom>
           <a:solidFill>
-            <a:schemeClr val="accent1"/>
+            <a:schemeClr val="accent1">
+              <a:lumMod val="70000"/>
+              <a:lumOff val="30000"/>
+            </a:schemeClr>
           </a:solidFill>
         </p:spPr>
         <p:txBody>
@@ -8263,7 +8428,7 @@
           <p:cNvPr id="7" name="item_1_title">
             <a:extLst>
               <a:ext uri="{FF2B5EF4-FFF2-40B4-BE49-F238E27FC236}">
-                <a16:creationId xmlns:a16="http://schemas.microsoft.com/office/drawing/2014/main" id="{F611958B-6E13-5990-86E3-13F2831BF46F}"/>
+                <a16:creationId xmlns:a16="http://schemas.microsoft.com/office/drawing/2014/main" id="{92E2FC0C-EF20-C720-9AA2-0C79B961812F}"/>
               </a:ext>
             </a:extLst>
           </p:cNvPr>
@@ -8296,7 +8461,10 @@
               <a:buNone/>
               <a:defRPr sz="2000" b="1">
                 <a:solidFill>
-                  <a:schemeClr val="accent1"/>
+                  <a:schemeClr val="accent1">
+                    <a:lumMod val="70000"/>
+                    <a:lumOff val="30000"/>
+                  </a:schemeClr>
                 </a:solidFill>
                 <a:latin typeface="+mj-lt"/>
               </a:defRPr>
@@ -8316,7 +8484,7 @@
           <p:cNvPr id="8" name="item_1">
             <a:extLst>
               <a:ext uri="{FF2B5EF4-FFF2-40B4-BE49-F238E27FC236}">
-                <a16:creationId xmlns:a16="http://schemas.microsoft.com/office/drawing/2014/main" id="{B84976C9-C14C-6CB0-BCC5-AD3BDE6A7F50}"/>
+                <a16:creationId xmlns:a16="http://schemas.microsoft.com/office/drawing/2014/main" id="{57DB2C27-C98A-F5A2-90C2-D0972648CC93}"/>
               </a:ext>
             </a:extLst>
           </p:cNvPr>
@@ -8364,7 +8532,7 @@
           <p:cNvPr id="9" name="marker_2">
             <a:extLst>
               <a:ext uri="{FF2B5EF4-FFF2-40B4-BE49-F238E27FC236}">
-                <a16:creationId xmlns:a16="http://schemas.microsoft.com/office/drawing/2014/main" id="{3FA7B98F-0A0B-B9FB-B7E8-96766BCB2D8F}"/>
+                <a16:creationId xmlns:a16="http://schemas.microsoft.com/office/drawing/2014/main" id="{F851B2CA-42FC-A15A-84A5-C2D70F3FA7B8}"/>
               </a:ext>
             </a:extLst>
           </p:cNvPr>
@@ -8384,7 +8552,10 @@
             <a:avLst/>
           </a:prstGeom>
           <a:solidFill>
-            <a:schemeClr val="accent1"/>
+            <a:schemeClr val="accent1">
+              <a:lumMod val="70000"/>
+              <a:lumOff val="30000"/>
+            </a:schemeClr>
           </a:solidFill>
         </p:spPr>
         <p:txBody>
@@ -8420,7 +8591,7 @@
           <p:cNvPr id="10" name="item_2_title">
             <a:extLst>
               <a:ext uri="{FF2B5EF4-FFF2-40B4-BE49-F238E27FC236}">
-                <a16:creationId xmlns:a16="http://schemas.microsoft.com/office/drawing/2014/main" id="{2FB787C2-FD44-4C6E-771A-509805599D76}"/>
+                <a16:creationId xmlns:a16="http://schemas.microsoft.com/office/drawing/2014/main" id="{5D6F5282-8210-30C4-C19A-FFD9DC6A5995}"/>
               </a:ext>
             </a:extLst>
           </p:cNvPr>
@@ -8453,7 +8624,10 @@
               <a:buNone/>
               <a:defRPr sz="2000" b="1">
                 <a:solidFill>
-                  <a:schemeClr val="accent1"/>
+                  <a:schemeClr val="accent1">
+                    <a:lumMod val="70000"/>
+                    <a:lumOff val="30000"/>
+                  </a:schemeClr>
                 </a:solidFill>
                 <a:latin typeface="+mj-lt"/>
               </a:defRPr>
@@ -8473,7 +8647,7 @@
           <p:cNvPr id="11" name="item_2">
             <a:extLst>
               <a:ext uri="{FF2B5EF4-FFF2-40B4-BE49-F238E27FC236}">
-                <a16:creationId xmlns:a16="http://schemas.microsoft.com/office/drawing/2014/main" id="{215EE49E-AFDC-BFDB-B13A-F376F5CDAEF0}"/>
+                <a16:creationId xmlns:a16="http://schemas.microsoft.com/office/drawing/2014/main" id="{576F9746-C0E5-AB4F-F9DD-E111D3C65AA6}"/>
               </a:ext>
             </a:extLst>
           </p:cNvPr>
@@ -8521,7 +8695,7 @@
           <p:cNvPr id="12" name="source">
             <a:extLst>
               <a:ext uri="{FF2B5EF4-FFF2-40B4-BE49-F238E27FC236}">
-                <a16:creationId xmlns:a16="http://schemas.microsoft.com/office/drawing/2014/main" id="{ED015F40-2362-9BD0-7EF3-090FAFF50D08}"/>
+                <a16:creationId xmlns:a16="http://schemas.microsoft.com/office/drawing/2014/main" id="{37357E9A-015D-53C7-28A7-EF37756F5E45}"/>
               </a:ext>
             </a:extLst>
           </p:cNvPr>
@@ -8543,7 +8717,10 @@
             </a:avLst>
           </a:prstGeom>
           <a:solidFill>
-            <a:schemeClr val="accent1"/>
+            <a:schemeClr val="accent1">
+              <a:lumMod val="70000"/>
+              <a:lumOff val="30000"/>
+            </a:schemeClr>
           </a:solidFill>
         </p:spPr>
         <p:txBody>
@@ -8576,7 +8753,7 @@
     </p:spTree>
     <p:extLst>
       <p:ext uri="{BB962C8B-B14F-4D97-AF65-F5344CB8AC3E}">
-        <p14:creationId xmlns:p14="http://schemas.microsoft.com/office/powerpoint/2010/main" val="783422959"/>
+        <p14:creationId xmlns:p14="http://schemas.microsoft.com/office/powerpoint/2010/main" val="2637841129"/>
       </p:ext>
     </p:extLst>
   </p:cSld>
@@ -8650,9 +8827,9 @@
           <a:bodyPr/>
           <a:lstStyle/>
           <a:p>
-            <a:fld id="{26B7F381-F10E-4587-B886-8036B7268BA3}" type="datetimeFigureOut">
+            <a:fld id="{4A588302-F725-4E0D-AD75-D9B0BA2EF836}" type="datetimeFigureOut">
               <a:rPr lang="en-US" smtClean="0"/>
-              <a:t>10/3/2026</a:t>
+              <a:t>10/4/2026</a:t>
             </a:fld>
             <a:endParaRPr lang="en-US"/>
           </a:p>
@@ -8692,7 +8869,7 @@
           <a:bodyPr/>
           <a:lstStyle/>
           <a:p>
-            <a:fld id="{C8D4D1C8-8C5D-4FFA-950C-FD08A0718FA9}" type="slidenum">
+            <a:fld id="{7293683F-31E2-46C4-A5EC-E1CFD9E8730E}" type="slidenum">
               <a:rPr lang="en-US" smtClean="0"/>
               <a:t>‹#›</a:t>
             </a:fld>
@@ -8705,7 +8882,7 @@
           <p:cNvPr id="6" name="kpi_value_1">
             <a:extLst>
               <a:ext uri="{FF2B5EF4-FFF2-40B4-BE49-F238E27FC236}">
-                <a16:creationId xmlns:a16="http://schemas.microsoft.com/office/drawing/2014/main" id="{AD8E9D6D-0766-05A6-1AC0-C482D5329549}"/>
+                <a16:creationId xmlns:a16="http://schemas.microsoft.com/office/drawing/2014/main" id="{E7B8FA05-4907-3C0E-CD27-8A8708A6CF98}"/>
               </a:ext>
             </a:extLst>
           </p:cNvPr>
@@ -8735,7 +8912,10 @@
               <a:buNone/>
               <a:defRPr sz="10800" b="1">
                 <a:solidFill>
-                  <a:schemeClr val="accent1"/>
+                  <a:schemeClr val="accent1">
+                    <a:lumMod val="70000"/>
+                    <a:lumOff val="30000"/>
+                  </a:schemeClr>
                 </a:solidFill>
                 <a:latin typeface="+mj-lt"/>
               </a:defRPr>
@@ -8755,7 +8935,7 @@
           <p:cNvPr id="7" name="kpi_label_1">
             <a:extLst>
               <a:ext uri="{FF2B5EF4-FFF2-40B4-BE49-F238E27FC236}">
-                <a16:creationId xmlns:a16="http://schemas.microsoft.com/office/drawing/2014/main" id="{379ACE35-00F9-CD5E-8344-395E40325889}"/>
+                <a16:creationId xmlns:a16="http://schemas.microsoft.com/office/drawing/2014/main" id="{D290D188-D639-A5D0-937E-389999A73455}"/>
               </a:ext>
             </a:extLst>
           </p:cNvPr>
@@ -8803,7 +8983,7 @@
           <p:cNvPr id="8" name="quote">
             <a:extLst>
               <a:ext uri="{FF2B5EF4-FFF2-40B4-BE49-F238E27FC236}">
-                <a16:creationId xmlns:a16="http://schemas.microsoft.com/office/drawing/2014/main" id="{CD6C2888-1AFC-3C38-B671-A65BE0509541}"/>
+                <a16:creationId xmlns:a16="http://schemas.microsoft.com/office/drawing/2014/main" id="{3A4D421C-0C2F-82BB-3E43-1AFB8B53CF6F}"/>
               </a:ext>
             </a:extLst>
           </p:cNvPr>
@@ -8853,7 +9033,7 @@
           <p:cNvPr id="9" name="attribution">
             <a:extLst>
               <a:ext uri="{FF2B5EF4-FFF2-40B4-BE49-F238E27FC236}">
-                <a16:creationId xmlns:a16="http://schemas.microsoft.com/office/drawing/2014/main" id="{E3F22928-B66C-F0B3-162D-5BE8ADCE5AFC}"/>
+                <a16:creationId xmlns:a16="http://schemas.microsoft.com/office/drawing/2014/main" id="{669B4B67-A9C3-636B-4B0A-976EF4D0C710}"/>
               </a:ext>
             </a:extLst>
           </p:cNvPr>
@@ -8901,7 +9081,7 @@
           <p:cNvPr id="10" name="item_1_title">
             <a:extLst>
               <a:ext uri="{FF2B5EF4-FFF2-40B4-BE49-F238E27FC236}">
-                <a16:creationId xmlns:a16="http://schemas.microsoft.com/office/drawing/2014/main" id="{E51C3FB3-811E-FE83-FA03-EF2F99B67A8A}"/>
+                <a16:creationId xmlns:a16="http://schemas.microsoft.com/office/drawing/2014/main" id="{5B7FA17C-189B-AE49-9659-28FF2E3DAE82}"/>
               </a:ext>
             </a:extLst>
           </p:cNvPr>
@@ -8934,7 +9114,10 @@
               <a:buNone/>
               <a:defRPr sz="2000" b="1">
                 <a:solidFill>
-                  <a:schemeClr val="accent1"/>
+                  <a:schemeClr val="accent1">
+                    <a:lumMod val="70000"/>
+                    <a:lumOff val="30000"/>
+                  </a:schemeClr>
                 </a:solidFill>
                 <a:latin typeface="+mj-lt"/>
               </a:defRPr>
@@ -8954,7 +9137,7 @@
           <p:cNvPr id="11" name="item_1">
             <a:extLst>
               <a:ext uri="{FF2B5EF4-FFF2-40B4-BE49-F238E27FC236}">
-                <a16:creationId xmlns:a16="http://schemas.microsoft.com/office/drawing/2014/main" id="{8FFC08C0-2827-28EC-DAE6-578D1625477E}"/>
+                <a16:creationId xmlns:a16="http://schemas.microsoft.com/office/drawing/2014/main" id="{FB06789D-7B61-015C-15A7-2EFD52D7725B}"/>
               </a:ext>
             </a:extLst>
           </p:cNvPr>
@@ -9002,7 +9185,7 @@
           <p:cNvPr id="12" name="source">
             <a:extLst>
               <a:ext uri="{FF2B5EF4-FFF2-40B4-BE49-F238E27FC236}">
-                <a16:creationId xmlns:a16="http://schemas.microsoft.com/office/drawing/2014/main" id="{64B61E8B-EF79-B9D8-0C8F-26ABAC7897B9}"/>
+                <a16:creationId xmlns:a16="http://schemas.microsoft.com/office/drawing/2014/main" id="{D88C732C-237C-5BE4-1E86-9CB7F6F833EC}"/>
               </a:ext>
             </a:extLst>
           </p:cNvPr>
@@ -9024,7 +9207,10 @@
             </a:avLst>
           </a:prstGeom>
           <a:solidFill>
-            <a:schemeClr val="accent1"/>
+            <a:schemeClr val="accent1">
+              <a:lumMod val="70000"/>
+              <a:lumOff val="30000"/>
+            </a:schemeClr>
           </a:solidFill>
         </p:spPr>
         <p:txBody>
@@ -9057,7 +9243,7 @@
     </p:spTree>
     <p:extLst>
       <p:ext uri="{BB962C8B-B14F-4D97-AF65-F5344CB8AC3E}">
-        <p14:creationId xmlns:p14="http://schemas.microsoft.com/office/powerpoint/2010/main" val="2749940874"/>
+        <p14:creationId xmlns:p14="http://schemas.microsoft.com/office/powerpoint/2010/main" val="4209549327"/>
       </p:ext>
     </p:extLst>
   </p:cSld>
@@ -9131,9 +9317,9 @@
           <a:bodyPr/>
           <a:lstStyle/>
           <a:p>
-            <a:fld id="{26B7F381-F10E-4587-B886-8036B7268BA3}" type="datetimeFigureOut">
+            <a:fld id="{4A588302-F725-4E0D-AD75-D9B0BA2EF836}" type="datetimeFigureOut">
               <a:rPr lang="en-US" smtClean="0"/>
-              <a:t>10/3/2026</a:t>
+              <a:t>10/4/2026</a:t>
             </a:fld>
             <a:endParaRPr lang="en-US"/>
           </a:p>
@@ -9173,7 +9359,7 @@
           <a:bodyPr/>
           <a:lstStyle/>
           <a:p>
-            <a:fld id="{C8D4D1C8-8C5D-4FFA-950C-FD08A0718FA9}" type="slidenum">
+            <a:fld id="{7293683F-31E2-46C4-A5EC-E1CFD9E8730E}" type="slidenum">
               <a:rPr lang="en-US" smtClean="0"/>
               <a:t>‹#›</a:t>
             </a:fld>
@@ -9186,7 +9372,7 @@
           <p:cNvPr id="6" name="marker_1">
             <a:extLst>
               <a:ext uri="{FF2B5EF4-FFF2-40B4-BE49-F238E27FC236}">
-                <a16:creationId xmlns:a16="http://schemas.microsoft.com/office/drawing/2014/main" id="{E369C00B-C8FC-DCAB-1D0B-E135C9E51053}"/>
+                <a16:creationId xmlns:a16="http://schemas.microsoft.com/office/drawing/2014/main" id="{963CF4CF-5433-5955-E94F-F0F8EC1A09AF}"/>
               </a:ext>
             </a:extLst>
           </p:cNvPr>
@@ -9206,7 +9392,10 @@
             <a:avLst/>
           </a:prstGeom>
           <a:solidFill>
-            <a:schemeClr val="accent1"/>
+            <a:schemeClr val="accent1">
+              <a:lumMod val="70000"/>
+              <a:lumOff val="30000"/>
+            </a:schemeClr>
           </a:solidFill>
         </p:spPr>
         <p:txBody>
@@ -9242,7 +9431,7 @@
           <p:cNvPr id="7" name="item_1">
             <a:extLst>
               <a:ext uri="{FF2B5EF4-FFF2-40B4-BE49-F238E27FC236}">
-                <a16:creationId xmlns:a16="http://schemas.microsoft.com/office/drawing/2014/main" id="{AD2B44E2-2616-6658-A638-333575E7B8DA}"/>
+                <a16:creationId xmlns:a16="http://schemas.microsoft.com/office/drawing/2014/main" id="{FA766DFB-297B-C9BE-E6BF-96D451512AD8}"/>
               </a:ext>
             </a:extLst>
           </p:cNvPr>
@@ -9255,8 +9444,8 @@
         </p:nvSpPr>
         <p:spPr>
           <a:xfrm>
-            <a:off x="1360660" y="2288330"/>
-            <a:ext cx="7803129" cy="510959"/>
+            <a:off x="1360659" y="2288330"/>
+            <a:ext cx="7803130" cy="510959"/>
           </a:xfrm>
           <a:prstGeom prst="rect">
             <a:avLst/>
@@ -9290,7 +9479,7 @@
           <p:cNvPr id="8" name="marker_2">
             <a:extLst>
               <a:ext uri="{FF2B5EF4-FFF2-40B4-BE49-F238E27FC236}">
-                <a16:creationId xmlns:a16="http://schemas.microsoft.com/office/drawing/2014/main" id="{A52A2BFB-AE7A-1311-6EDF-A79F2F5C897F}"/>
+                <a16:creationId xmlns:a16="http://schemas.microsoft.com/office/drawing/2014/main" id="{0E04673D-22F6-A39B-BE67-E03A2C703F32}"/>
               </a:ext>
             </a:extLst>
           </p:cNvPr>
@@ -9310,7 +9499,10 @@
             <a:avLst/>
           </a:prstGeom>
           <a:solidFill>
-            <a:schemeClr val="accent1"/>
+            <a:schemeClr val="accent1">
+              <a:lumMod val="70000"/>
+              <a:lumOff val="30000"/>
+            </a:schemeClr>
           </a:solidFill>
         </p:spPr>
         <p:txBody>
@@ -9346,7 +9538,7 @@
           <p:cNvPr id="9" name="item_2">
             <a:extLst>
               <a:ext uri="{FF2B5EF4-FFF2-40B4-BE49-F238E27FC236}">
-                <a16:creationId xmlns:a16="http://schemas.microsoft.com/office/drawing/2014/main" id="{DDD97C91-5FC5-BFD9-73D2-798AB3EB0978}"/>
+                <a16:creationId xmlns:a16="http://schemas.microsoft.com/office/drawing/2014/main" id="{FB87A894-3043-92F9-555A-BB850E5020DF}"/>
               </a:ext>
             </a:extLst>
           </p:cNvPr>
@@ -9359,8 +9551,8 @@
         </p:nvSpPr>
         <p:spPr>
           <a:xfrm>
-            <a:off x="1360660" y="3182508"/>
-            <a:ext cx="7803129" cy="510959"/>
+            <a:off x="1360659" y="3182508"/>
+            <a:ext cx="7803130" cy="510959"/>
           </a:xfrm>
           <a:prstGeom prst="rect">
             <a:avLst/>
@@ -9394,7 +9586,7 @@
           <p:cNvPr id="10" name="marker_3">
             <a:extLst>
               <a:ext uri="{FF2B5EF4-FFF2-40B4-BE49-F238E27FC236}">
-                <a16:creationId xmlns:a16="http://schemas.microsoft.com/office/drawing/2014/main" id="{3D4F3060-6909-A303-CF0D-60A550C8CD97}"/>
+                <a16:creationId xmlns:a16="http://schemas.microsoft.com/office/drawing/2014/main" id="{894DF9F2-EA6F-66A5-22E6-B563351A69A9}"/>
               </a:ext>
             </a:extLst>
           </p:cNvPr>
@@ -9414,7 +9606,10 @@
             <a:avLst/>
           </a:prstGeom>
           <a:solidFill>
-            <a:schemeClr val="accent1"/>
+            <a:schemeClr val="accent1">
+              <a:lumMod val="70000"/>
+              <a:lumOff val="30000"/>
+            </a:schemeClr>
           </a:solidFill>
         </p:spPr>
         <p:txBody>
@@ -9450,7 +9645,7 @@
           <p:cNvPr id="11" name="item_3">
             <a:extLst>
               <a:ext uri="{FF2B5EF4-FFF2-40B4-BE49-F238E27FC236}">
-                <a16:creationId xmlns:a16="http://schemas.microsoft.com/office/drawing/2014/main" id="{DAB1D38D-C39C-639B-9D87-179B00ED3D14}"/>
+                <a16:creationId xmlns:a16="http://schemas.microsoft.com/office/drawing/2014/main" id="{A1FF1DA0-CEBC-D3F4-6409-AD1321EE940D}"/>
               </a:ext>
             </a:extLst>
           </p:cNvPr>
@@ -9463,8 +9658,8 @@
         </p:nvSpPr>
         <p:spPr>
           <a:xfrm>
-            <a:off x="1360660" y="4076686"/>
-            <a:ext cx="7803129" cy="510959"/>
+            <a:off x="1360659" y="4076686"/>
+            <a:ext cx="7803130" cy="510959"/>
           </a:xfrm>
           <a:prstGeom prst="rect">
             <a:avLst/>
@@ -9498,7 +9693,7 @@
           <p:cNvPr id="12" name="marker_4">
             <a:extLst>
               <a:ext uri="{FF2B5EF4-FFF2-40B4-BE49-F238E27FC236}">
-                <a16:creationId xmlns:a16="http://schemas.microsoft.com/office/drawing/2014/main" id="{3D826790-F8CB-4162-8EC9-BD989836C59A}"/>
+                <a16:creationId xmlns:a16="http://schemas.microsoft.com/office/drawing/2014/main" id="{ABF77887-30EC-C067-C4CC-73D84D53CB02}"/>
               </a:ext>
             </a:extLst>
           </p:cNvPr>
@@ -9518,7 +9713,10 @@
             <a:avLst/>
           </a:prstGeom>
           <a:solidFill>
-            <a:schemeClr val="accent1"/>
+            <a:schemeClr val="accent1">
+              <a:lumMod val="70000"/>
+              <a:lumOff val="30000"/>
+            </a:schemeClr>
           </a:solidFill>
         </p:spPr>
         <p:txBody>
@@ -9554,7 +9752,7 @@
           <p:cNvPr id="13" name="item_4">
             <a:extLst>
               <a:ext uri="{FF2B5EF4-FFF2-40B4-BE49-F238E27FC236}">
-                <a16:creationId xmlns:a16="http://schemas.microsoft.com/office/drawing/2014/main" id="{74AD0345-7031-D2C7-F004-D782EB800CAC}"/>
+                <a16:creationId xmlns:a16="http://schemas.microsoft.com/office/drawing/2014/main" id="{5E357B81-633F-0E79-4345-685ED67E090B}"/>
               </a:ext>
             </a:extLst>
           </p:cNvPr>
@@ -9567,8 +9765,8 @@
         </p:nvSpPr>
         <p:spPr>
           <a:xfrm>
-            <a:off x="1360660" y="4970864"/>
-            <a:ext cx="7803129" cy="510959"/>
+            <a:off x="1360659" y="4970864"/>
+            <a:ext cx="7803130" cy="510959"/>
           </a:xfrm>
           <a:prstGeom prst="rect">
             <a:avLst/>
@@ -9602,7 +9800,7 @@
           <p:cNvPr id="14" name="source">
             <a:extLst>
               <a:ext uri="{FF2B5EF4-FFF2-40B4-BE49-F238E27FC236}">
-                <a16:creationId xmlns:a16="http://schemas.microsoft.com/office/drawing/2014/main" id="{96038124-6942-2C15-E20C-01D5ED7609B4}"/>
+                <a16:creationId xmlns:a16="http://schemas.microsoft.com/office/drawing/2014/main" id="{24456804-685F-8665-D364-72C1A0C71837}"/>
               </a:ext>
             </a:extLst>
           </p:cNvPr>
@@ -9624,7 +9822,10 @@
             </a:avLst>
           </a:prstGeom>
           <a:solidFill>
-            <a:schemeClr val="accent1"/>
+            <a:schemeClr val="accent1">
+              <a:lumMod val="70000"/>
+              <a:lumOff val="30000"/>
+            </a:schemeClr>
           </a:solidFill>
         </p:spPr>
         <p:txBody>
@@ -9657,7 +9858,7 @@
     </p:spTree>
     <p:extLst>
       <p:ext uri="{BB962C8B-B14F-4D97-AF65-F5344CB8AC3E}">
-        <p14:creationId xmlns:p14="http://schemas.microsoft.com/office/powerpoint/2010/main" val="1121562776"/>
+        <p14:creationId xmlns:p14="http://schemas.microsoft.com/office/powerpoint/2010/main" val="2132626280"/>
       </p:ext>
     </p:extLst>
   </p:cSld>
@@ -9731,9 +9932,9 @@
           <a:bodyPr/>
           <a:lstStyle/>
           <a:p>
-            <a:fld id="{26B7F381-F10E-4587-B886-8036B7268BA3}" type="datetimeFigureOut">
+            <a:fld id="{4A588302-F725-4E0D-AD75-D9B0BA2EF836}" type="datetimeFigureOut">
               <a:rPr lang="en-US" smtClean="0"/>
-              <a:t>10/3/2026</a:t>
+              <a:t>10/4/2026</a:t>
             </a:fld>
             <a:endParaRPr lang="en-US"/>
           </a:p>
@@ -9773,7 +9974,7 @@
           <a:bodyPr/>
           <a:lstStyle/>
           <a:p>
-            <a:fld id="{C8D4D1C8-8C5D-4FFA-950C-FD08A0718FA9}" type="slidenum">
+            <a:fld id="{7293683F-31E2-46C4-A5EC-E1CFD9E8730E}" type="slidenum">
               <a:rPr lang="en-US" smtClean="0"/>
               <a:t>‹#›</a:t>
             </a:fld>
@@ -9786,7 +9987,7 @@
           <p:cNvPr id="6" name="decisions_title">
             <a:extLst>
               <a:ext uri="{FF2B5EF4-FFF2-40B4-BE49-F238E27FC236}">
-                <a16:creationId xmlns:a16="http://schemas.microsoft.com/office/drawing/2014/main" id="{38C87AFA-5448-81C5-553E-453440B80969}"/>
+                <a16:creationId xmlns:a16="http://schemas.microsoft.com/office/drawing/2014/main" id="{C42B7A47-0EDC-C740-4D0D-6B4AFD41514F}"/>
               </a:ext>
             </a:extLst>
           </p:cNvPr>
@@ -9816,7 +10017,10 @@
               <a:buNone/>
               <a:defRPr sz="2000" b="1">
                 <a:solidFill>
-                  <a:schemeClr val="accent1"/>
+                  <a:schemeClr val="accent1">
+                    <a:lumMod val="70000"/>
+                    <a:lumOff val="30000"/>
+                  </a:schemeClr>
                 </a:solidFill>
                 <a:latin typeface="+mj-lt"/>
               </a:defRPr>
@@ -9836,7 +10040,7 @@
           <p:cNvPr id="7" name="decisions">
             <a:extLst>
               <a:ext uri="{FF2B5EF4-FFF2-40B4-BE49-F238E27FC236}">
-                <a16:creationId xmlns:a16="http://schemas.microsoft.com/office/drawing/2014/main" id="{C53CF140-2C51-CCB4-D38D-FAB64B60224A}"/>
+                <a16:creationId xmlns:a16="http://schemas.microsoft.com/office/drawing/2014/main" id="{954968AF-6D1B-2B76-007E-5F32BC7BF368}"/>
               </a:ext>
             </a:extLst>
           </p:cNvPr>
@@ -9879,7 +10083,7 @@
           <p:cNvPr id="8" name="item_1_title">
             <a:extLst>
               <a:ext uri="{FF2B5EF4-FFF2-40B4-BE49-F238E27FC236}">
-                <a16:creationId xmlns:a16="http://schemas.microsoft.com/office/drawing/2014/main" id="{FD48DA34-9606-6508-046A-FB86B8AF79EC}"/>
+                <a16:creationId xmlns:a16="http://schemas.microsoft.com/office/drawing/2014/main" id="{22B51A2D-915A-5D11-4B20-082A93A43214}"/>
               </a:ext>
             </a:extLst>
           </p:cNvPr>
@@ -9912,7 +10116,10 @@
               <a:buNone/>
               <a:defRPr sz="2000" b="1">
                 <a:solidFill>
-                  <a:schemeClr val="accent1"/>
+                  <a:schemeClr val="accent1">
+                    <a:lumMod val="70000"/>
+                    <a:lumOff val="30000"/>
+                  </a:schemeClr>
                 </a:solidFill>
                 <a:latin typeface="+mj-lt"/>
               </a:defRPr>
@@ -9932,7 +10139,7 @@
           <p:cNvPr id="9" name="item_1">
             <a:extLst>
               <a:ext uri="{FF2B5EF4-FFF2-40B4-BE49-F238E27FC236}">
-                <a16:creationId xmlns:a16="http://schemas.microsoft.com/office/drawing/2014/main" id="{14F949A1-5C63-33B6-29AD-70BD34E9FAEA}"/>
+                <a16:creationId xmlns:a16="http://schemas.microsoft.com/office/drawing/2014/main" id="{C8A83C1C-B03D-8AA2-719E-10B85DDC1A13}"/>
               </a:ext>
             </a:extLst>
           </p:cNvPr>
@@ -9980,7 +10187,7 @@
           <p:cNvPr id="10" name="item_2_title">
             <a:extLst>
               <a:ext uri="{FF2B5EF4-FFF2-40B4-BE49-F238E27FC236}">
-                <a16:creationId xmlns:a16="http://schemas.microsoft.com/office/drawing/2014/main" id="{9A9F334B-3F03-2EB8-9F24-273066F32895}"/>
+                <a16:creationId xmlns:a16="http://schemas.microsoft.com/office/drawing/2014/main" id="{D5D645BD-7B6D-8D56-769C-A684D3CA0A7C}"/>
               </a:ext>
             </a:extLst>
           </p:cNvPr>
@@ -10013,7 +10220,10 @@
               <a:buNone/>
               <a:defRPr sz="2000" b="1">
                 <a:solidFill>
-                  <a:schemeClr val="accent1"/>
+                  <a:schemeClr val="accent1">
+                    <a:lumMod val="70000"/>
+                    <a:lumOff val="30000"/>
+                  </a:schemeClr>
                 </a:solidFill>
                 <a:latin typeface="+mj-lt"/>
               </a:defRPr>
@@ -10033,7 +10243,7 @@
           <p:cNvPr id="11" name="item_2">
             <a:extLst>
               <a:ext uri="{FF2B5EF4-FFF2-40B4-BE49-F238E27FC236}">
-                <a16:creationId xmlns:a16="http://schemas.microsoft.com/office/drawing/2014/main" id="{D248CECD-9157-1D59-4DDA-D6B7F121B2AB}"/>
+                <a16:creationId xmlns:a16="http://schemas.microsoft.com/office/drawing/2014/main" id="{5FFC41F5-0FDE-3205-A400-E51C8ECC74A6}"/>
               </a:ext>
             </a:extLst>
           </p:cNvPr>
@@ -10081,7 +10291,7 @@
           <p:cNvPr id="12" name="item_3_title">
             <a:extLst>
               <a:ext uri="{FF2B5EF4-FFF2-40B4-BE49-F238E27FC236}">
-                <a16:creationId xmlns:a16="http://schemas.microsoft.com/office/drawing/2014/main" id="{8ACE4377-C6B2-27C4-21CA-BEDEB3EB9004}"/>
+                <a16:creationId xmlns:a16="http://schemas.microsoft.com/office/drawing/2014/main" id="{FA749B09-3FAC-0C4F-C96E-0A13DD17C62F}"/>
               </a:ext>
             </a:extLst>
           </p:cNvPr>
@@ -10094,7 +10304,7 @@
         </p:nvSpPr>
         <p:spPr>
           <a:xfrm>
-            <a:off x="6680306" y="2339425"/>
+            <a:off x="6680307" y="2339425"/>
             <a:ext cx="2439396" cy="503445"/>
           </a:xfrm>
           <a:prstGeom prst="rect">
@@ -10114,7 +10324,10 @@
               <a:buNone/>
               <a:defRPr sz="2000" b="1">
                 <a:solidFill>
-                  <a:schemeClr val="accent1"/>
+                  <a:schemeClr val="accent1">
+                    <a:lumMod val="70000"/>
+                    <a:lumOff val="30000"/>
+                  </a:schemeClr>
                 </a:solidFill>
                 <a:latin typeface="+mj-lt"/>
               </a:defRPr>
@@ -10134,7 +10347,7 @@
           <p:cNvPr id="13" name="item_3">
             <a:extLst>
               <a:ext uri="{FF2B5EF4-FFF2-40B4-BE49-F238E27FC236}">
-                <a16:creationId xmlns:a16="http://schemas.microsoft.com/office/drawing/2014/main" id="{B9E6C604-4268-92AF-2C86-C1F50AA770C3}"/>
+                <a16:creationId xmlns:a16="http://schemas.microsoft.com/office/drawing/2014/main" id="{9FAE3789-9621-E110-5A2E-2068E3371D2F}"/>
               </a:ext>
             </a:extLst>
           </p:cNvPr>
@@ -10147,7 +10360,7 @@
         </p:nvSpPr>
         <p:spPr>
           <a:xfrm>
-            <a:off x="6680306" y="2842869"/>
+            <a:off x="6680307" y="2842869"/>
             <a:ext cx="2439396" cy="1208268"/>
           </a:xfrm>
           <a:prstGeom prst="rect">
@@ -10182,7 +10395,7 @@
           <p:cNvPr id="14" name="source">
             <a:extLst>
               <a:ext uri="{FF2B5EF4-FFF2-40B4-BE49-F238E27FC236}">
-                <a16:creationId xmlns:a16="http://schemas.microsoft.com/office/drawing/2014/main" id="{13430725-B331-F185-F040-74553DA61CE7}"/>
+                <a16:creationId xmlns:a16="http://schemas.microsoft.com/office/drawing/2014/main" id="{806971F2-3895-6CA2-7AA2-334AD9F17912}"/>
               </a:ext>
             </a:extLst>
           </p:cNvPr>
@@ -10204,7 +10417,10 @@
             </a:avLst>
           </a:prstGeom>
           <a:solidFill>
-            <a:schemeClr val="accent1"/>
+            <a:schemeClr val="accent1">
+              <a:lumMod val="70000"/>
+              <a:lumOff val="30000"/>
+            </a:schemeClr>
           </a:solidFill>
         </p:spPr>
         <p:txBody>
@@ -10237,7 +10453,7 @@
     </p:spTree>
     <p:extLst>
       <p:ext uri="{BB962C8B-B14F-4D97-AF65-F5344CB8AC3E}">
-        <p14:creationId xmlns:p14="http://schemas.microsoft.com/office/powerpoint/2010/main" val="2332867634"/>
+        <p14:creationId xmlns:p14="http://schemas.microsoft.com/office/powerpoint/2010/main" val="3813882047"/>
       </p:ext>
     </p:extLst>
   </p:cSld>
@@ -10311,9 +10527,9 @@
           <a:bodyPr/>
           <a:lstStyle/>
           <a:p>
-            <a:fld id="{26B7F381-F10E-4587-B886-8036B7268BA3}" type="datetimeFigureOut">
+            <a:fld id="{4A588302-F725-4E0D-AD75-D9B0BA2EF836}" type="datetimeFigureOut">
               <a:rPr lang="en-US" smtClean="0"/>
-              <a:t>10/3/2026</a:t>
+              <a:t>10/4/2026</a:t>
             </a:fld>
             <a:endParaRPr lang="en-US"/>
           </a:p>
@@ -10353,7 +10569,7 @@
           <a:bodyPr/>
           <a:lstStyle/>
           <a:p>
-            <a:fld id="{C8D4D1C8-8C5D-4FFA-950C-FD08A0718FA9}" type="slidenum">
+            <a:fld id="{7293683F-31E2-46C4-A5EC-E1CFD9E8730E}" type="slidenum">
               <a:rPr lang="en-US" smtClean="0"/>
               <a:t>‹#›</a:t>
             </a:fld>
@@ -10366,7 +10582,7 @@
           <p:cNvPr id="6" name="body">
             <a:extLst>
               <a:ext uri="{FF2B5EF4-FFF2-40B4-BE49-F238E27FC236}">
-                <a16:creationId xmlns:a16="http://schemas.microsoft.com/office/drawing/2014/main" id="{3E2A8ED6-E850-0065-8C6E-7F87F5C300B9}"/>
+                <a16:creationId xmlns:a16="http://schemas.microsoft.com/office/drawing/2014/main" id="{D4C06091-68D1-DF55-FA83-E1B34BF244E6}"/>
               </a:ext>
             </a:extLst>
           </p:cNvPr>
@@ -10406,7 +10622,7 @@
           <p:cNvPr id="7" name="kpi_value_1">
             <a:extLst>
               <a:ext uri="{FF2B5EF4-FFF2-40B4-BE49-F238E27FC236}">
-                <a16:creationId xmlns:a16="http://schemas.microsoft.com/office/drawing/2014/main" id="{D8D1CCE9-7479-07B1-6861-0F2A7777D42E}"/>
+                <a16:creationId xmlns:a16="http://schemas.microsoft.com/office/drawing/2014/main" id="{11DE3C58-1E17-A898-D80C-E5484C7ED764}"/>
               </a:ext>
             </a:extLst>
           </p:cNvPr>
@@ -10439,7 +10655,10 @@
               <a:buNone/>
               <a:defRPr sz="6000" b="1">
                 <a:solidFill>
-                  <a:schemeClr val="accent1"/>
+                  <a:schemeClr val="accent1">
+                    <a:lumMod val="70000"/>
+                    <a:lumOff val="30000"/>
+                  </a:schemeClr>
                 </a:solidFill>
                 <a:latin typeface="+mj-lt"/>
               </a:defRPr>
@@ -10459,7 +10678,7 @@
           <p:cNvPr id="8" name="kpi_label_1">
             <a:extLst>
               <a:ext uri="{FF2B5EF4-FFF2-40B4-BE49-F238E27FC236}">
-                <a16:creationId xmlns:a16="http://schemas.microsoft.com/office/drawing/2014/main" id="{4D788DEA-F146-EC39-0304-D13326F44CC4}"/>
+                <a16:creationId xmlns:a16="http://schemas.microsoft.com/office/drawing/2014/main" id="{7F6741B6-9482-6384-2482-77522A15ED4A}"/>
               </a:ext>
             </a:extLst>
           </p:cNvPr>
@@ -10507,7 +10726,7 @@
           <p:cNvPr id="9" name="kpi_value_2">
             <a:extLst>
               <a:ext uri="{FF2B5EF4-FFF2-40B4-BE49-F238E27FC236}">
-                <a16:creationId xmlns:a16="http://schemas.microsoft.com/office/drawing/2014/main" id="{CAF84662-67F6-D06A-7AC0-6B0AAD213173}"/>
+                <a16:creationId xmlns:a16="http://schemas.microsoft.com/office/drawing/2014/main" id="{238CE13B-F589-84CB-534D-A062CAB50AB8}"/>
               </a:ext>
             </a:extLst>
           </p:cNvPr>
@@ -10540,7 +10759,10 @@
               <a:buNone/>
               <a:defRPr sz="6000" b="1">
                 <a:solidFill>
-                  <a:schemeClr val="accent1"/>
+                  <a:schemeClr val="accent1">
+                    <a:lumMod val="70000"/>
+                    <a:lumOff val="30000"/>
+                  </a:schemeClr>
                 </a:solidFill>
                 <a:latin typeface="+mj-lt"/>
               </a:defRPr>
@@ -10560,7 +10782,7 @@
           <p:cNvPr id="10" name="kpi_label_2">
             <a:extLst>
               <a:ext uri="{FF2B5EF4-FFF2-40B4-BE49-F238E27FC236}">
-                <a16:creationId xmlns:a16="http://schemas.microsoft.com/office/drawing/2014/main" id="{FE660A28-29E4-C7C8-36EB-FB7E35BC59BB}"/>
+                <a16:creationId xmlns:a16="http://schemas.microsoft.com/office/drawing/2014/main" id="{030146C4-EB92-990D-00EE-39206AFD06EE}"/>
               </a:ext>
             </a:extLst>
           </p:cNvPr>
@@ -10608,7 +10830,7 @@
           <p:cNvPr id="11" name="source">
             <a:extLst>
               <a:ext uri="{FF2B5EF4-FFF2-40B4-BE49-F238E27FC236}">
-                <a16:creationId xmlns:a16="http://schemas.microsoft.com/office/drawing/2014/main" id="{4B4D03DD-E3DA-B2CD-13A4-4397A935E045}"/>
+                <a16:creationId xmlns:a16="http://schemas.microsoft.com/office/drawing/2014/main" id="{4708D630-788A-6E90-F774-E25D9287FCBD}"/>
               </a:ext>
             </a:extLst>
           </p:cNvPr>
@@ -10630,7 +10852,10 @@
             </a:avLst>
           </a:prstGeom>
           <a:solidFill>
-            <a:schemeClr val="accent1"/>
+            <a:schemeClr val="accent1">
+              <a:lumMod val="70000"/>
+              <a:lumOff val="30000"/>
+            </a:schemeClr>
           </a:solidFill>
         </p:spPr>
         <p:txBody>
@@ -10663,7 +10888,7 @@
     </p:spTree>
     <p:extLst>
       <p:ext uri="{BB962C8B-B14F-4D97-AF65-F5344CB8AC3E}">
-        <p14:creationId xmlns:p14="http://schemas.microsoft.com/office/powerpoint/2010/main" val="3243616742"/>
+        <p14:creationId xmlns:p14="http://schemas.microsoft.com/office/powerpoint/2010/main" val="3712920820"/>
       </p:ext>
     </p:extLst>
   </p:cSld>
@@ -10737,9 +10962,9 @@
           <a:bodyPr/>
           <a:lstStyle/>
           <a:p>
-            <a:fld id="{26B7F381-F10E-4587-B886-8036B7268BA3}" type="datetimeFigureOut">
+            <a:fld id="{4A588302-F725-4E0D-AD75-D9B0BA2EF836}" type="datetimeFigureOut">
               <a:rPr lang="en-US" smtClean="0"/>
-              <a:t>10/3/2026</a:t>
+              <a:t>10/4/2026</a:t>
             </a:fld>
             <a:endParaRPr lang="en-US"/>
           </a:p>
@@ -10779,7 +11004,7 @@
           <a:bodyPr/>
           <a:lstStyle/>
           <a:p>
-            <a:fld id="{C8D4D1C8-8C5D-4FFA-950C-FD08A0718FA9}" type="slidenum">
+            <a:fld id="{7293683F-31E2-46C4-A5EC-E1CFD9E8730E}" type="slidenum">
               <a:rPr lang="en-US" smtClean="0"/>
               <a:t>‹#›</a:t>
             </a:fld>
@@ -10792,7 +11017,7 @@
           <p:cNvPr id="6" name="body">
             <a:extLst>
               <a:ext uri="{FF2B5EF4-FFF2-40B4-BE49-F238E27FC236}">
-                <a16:creationId xmlns:a16="http://schemas.microsoft.com/office/drawing/2014/main" id="{C6363E06-25CF-EC18-E079-8335B8820181}"/>
+                <a16:creationId xmlns:a16="http://schemas.microsoft.com/office/drawing/2014/main" id="{C8F73DBE-3BC3-B1C6-38AE-FDAD19D7ED0D}"/>
               </a:ext>
             </a:extLst>
           </p:cNvPr>
@@ -10832,7 +11057,7 @@
           <p:cNvPr id="7" name="kpi_value_1">
             <a:extLst>
               <a:ext uri="{FF2B5EF4-FFF2-40B4-BE49-F238E27FC236}">
-                <a16:creationId xmlns:a16="http://schemas.microsoft.com/office/drawing/2014/main" id="{B56C5BD2-DDB9-5C64-5840-CCD60A89DDC3}"/>
+                <a16:creationId xmlns:a16="http://schemas.microsoft.com/office/drawing/2014/main" id="{10FD2692-E688-1C36-2B22-2C87CA283FFE}"/>
               </a:ext>
             </a:extLst>
           </p:cNvPr>
@@ -10865,7 +11090,10 @@
               <a:buNone/>
               <a:defRPr sz="6000" b="1">
                 <a:solidFill>
-                  <a:schemeClr val="accent1"/>
+                  <a:schemeClr val="accent1">
+                    <a:lumMod val="70000"/>
+                    <a:lumOff val="30000"/>
+                  </a:schemeClr>
                 </a:solidFill>
                 <a:latin typeface="+mj-lt"/>
               </a:defRPr>
@@ -10885,7 +11113,7 @@
           <p:cNvPr id="8" name="kpi_label_1">
             <a:extLst>
               <a:ext uri="{FF2B5EF4-FFF2-40B4-BE49-F238E27FC236}">
-                <a16:creationId xmlns:a16="http://schemas.microsoft.com/office/drawing/2014/main" id="{1ED65C79-F072-AD8A-5B1F-BCACE5DFEFC5}"/>
+                <a16:creationId xmlns:a16="http://schemas.microsoft.com/office/drawing/2014/main" id="{4FA32764-F329-A697-23D4-EC5DABE0B153}"/>
               </a:ext>
             </a:extLst>
           </p:cNvPr>
@@ -10933,7 +11161,7 @@
           <p:cNvPr id="9" name="kpi_value_2">
             <a:extLst>
               <a:ext uri="{FF2B5EF4-FFF2-40B4-BE49-F238E27FC236}">
-                <a16:creationId xmlns:a16="http://schemas.microsoft.com/office/drawing/2014/main" id="{84141D7D-E3D3-95D8-5CD8-FD58B96000AB}"/>
+                <a16:creationId xmlns:a16="http://schemas.microsoft.com/office/drawing/2014/main" id="{592280AE-2950-FF13-B222-501FAFD64CE8}"/>
               </a:ext>
             </a:extLst>
           </p:cNvPr>
@@ -10966,7 +11194,10 @@
               <a:buNone/>
               <a:defRPr sz="6000" b="1">
                 <a:solidFill>
-                  <a:schemeClr val="accent1"/>
+                  <a:schemeClr val="accent1">
+                    <a:lumMod val="70000"/>
+                    <a:lumOff val="30000"/>
+                  </a:schemeClr>
                 </a:solidFill>
                 <a:latin typeface="+mj-lt"/>
               </a:defRPr>
@@ -10986,7 +11217,7 @@
           <p:cNvPr id="10" name="kpi_label_2">
             <a:extLst>
               <a:ext uri="{FF2B5EF4-FFF2-40B4-BE49-F238E27FC236}">
-                <a16:creationId xmlns:a16="http://schemas.microsoft.com/office/drawing/2014/main" id="{474585F9-CE8D-F640-E19C-A8D3400539C4}"/>
+                <a16:creationId xmlns:a16="http://schemas.microsoft.com/office/drawing/2014/main" id="{21D056E8-460B-FAFB-B4EE-7F80D000733C}"/>
               </a:ext>
             </a:extLst>
           </p:cNvPr>
@@ -11034,7 +11265,7 @@
           <p:cNvPr id="11" name="kpi_value_3">
             <a:extLst>
               <a:ext uri="{FF2B5EF4-FFF2-40B4-BE49-F238E27FC236}">
-                <a16:creationId xmlns:a16="http://schemas.microsoft.com/office/drawing/2014/main" id="{75A02CF4-9A01-1087-9CF4-4CC5A94CDB49}"/>
+                <a16:creationId xmlns:a16="http://schemas.microsoft.com/office/drawing/2014/main" id="{4E18AEC7-9E55-B958-DD03-BB0FD6340FB1}"/>
               </a:ext>
             </a:extLst>
           </p:cNvPr>
@@ -11067,7 +11298,10 @@
               <a:buNone/>
               <a:defRPr sz="6000" b="1">
                 <a:solidFill>
-                  <a:schemeClr val="accent1"/>
+                  <a:schemeClr val="accent1">
+                    <a:lumMod val="70000"/>
+                    <a:lumOff val="30000"/>
+                  </a:schemeClr>
                 </a:solidFill>
                 <a:latin typeface="+mj-lt"/>
               </a:defRPr>
@@ -11087,7 +11321,7 @@
           <p:cNvPr id="12" name="kpi_label_3">
             <a:extLst>
               <a:ext uri="{FF2B5EF4-FFF2-40B4-BE49-F238E27FC236}">
-                <a16:creationId xmlns:a16="http://schemas.microsoft.com/office/drawing/2014/main" id="{48AD110E-0BB7-C13D-C3B9-F4E3C3F77111}"/>
+                <a16:creationId xmlns:a16="http://schemas.microsoft.com/office/drawing/2014/main" id="{2F574C6D-C645-4E96-6935-2E946DE26250}"/>
               </a:ext>
             </a:extLst>
           </p:cNvPr>
@@ -11135,7 +11369,7 @@
           <p:cNvPr id="13" name="kpi_value_4">
             <a:extLst>
               <a:ext uri="{FF2B5EF4-FFF2-40B4-BE49-F238E27FC236}">
-                <a16:creationId xmlns:a16="http://schemas.microsoft.com/office/drawing/2014/main" id="{C2BBDB68-83A4-D060-AF54-013FC58A28D5}"/>
+                <a16:creationId xmlns:a16="http://schemas.microsoft.com/office/drawing/2014/main" id="{1527819B-CEC9-5351-B3F5-252A6E838903}"/>
               </a:ext>
             </a:extLst>
           </p:cNvPr>
@@ -11168,7 +11402,10 @@
               <a:buNone/>
               <a:defRPr sz="6000" b="1">
                 <a:solidFill>
-                  <a:schemeClr val="accent1"/>
+                  <a:schemeClr val="accent1">
+                    <a:lumMod val="70000"/>
+                    <a:lumOff val="30000"/>
+                  </a:schemeClr>
                 </a:solidFill>
                 <a:latin typeface="+mj-lt"/>
               </a:defRPr>
@@ -11188,7 +11425,7 @@
           <p:cNvPr id="14" name="kpi_label_4">
             <a:extLst>
               <a:ext uri="{FF2B5EF4-FFF2-40B4-BE49-F238E27FC236}">
-                <a16:creationId xmlns:a16="http://schemas.microsoft.com/office/drawing/2014/main" id="{67FDBE63-9CF4-8EF6-1D9F-1E4F05465073}"/>
+                <a16:creationId xmlns:a16="http://schemas.microsoft.com/office/drawing/2014/main" id="{5E279B4F-C210-048B-2B81-E7CD3E69407B}"/>
               </a:ext>
             </a:extLst>
           </p:cNvPr>
@@ -11236,7 +11473,7 @@
           <p:cNvPr id="15" name="source">
             <a:extLst>
               <a:ext uri="{FF2B5EF4-FFF2-40B4-BE49-F238E27FC236}">
-                <a16:creationId xmlns:a16="http://schemas.microsoft.com/office/drawing/2014/main" id="{E696BF10-17FB-1AB6-5684-8F87C6D9472D}"/>
+                <a16:creationId xmlns:a16="http://schemas.microsoft.com/office/drawing/2014/main" id="{4688261E-5E66-C4C3-4C7D-98F7568244C2}"/>
               </a:ext>
             </a:extLst>
           </p:cNvPr>
@@ -11258,7 +11495,10 @@
             </a:avLst>
           </a:prstGeom>
           <a:solidFill>
-            <a:schemeClr val="accent1"/>
+            <a:schemeClr val="accent1">
+              <a:lumMod val="70000"/>
+              <a:lumOff val="30000"/>
+            </a:schemeClr>
           </a:solidFill>
         </p:spPr>
         <p:txBody>
@@ -11291,7 +11531,7 @@
     </p:spTree>
     <p:extLst>
       <p:ext uri="{BB962C8B-B14F-4D97-AF65-F5344CB8AC3E}">
-        <p14:creationId xmlns:p14="http://schemas.microsoft.com/office/powerpoint/2010/main" val="3043958282"/>
+        <p14:creationId xmlns:p14="http://schemas.microsoft.com/office/powerpoint/2010/main" val="1164474886"/>
       </p:ext>
     </p:extLst>
   </p:cSld>
@@ -11365,9 +11605,9 @@
           <a:bodyPr/>
           <a:lstStyle/>
           <a:p>
-            <a:fld id="{26B7F381-F10E-4587-B886-8036B7268BA3}" type="datetimeFigureOut">
+            <a:fld id="{4A588302-F725-4E0D-AD75-D9B0BA2EF836}" type="datetimeFigureOut">
               <a:rPr lang="en-US" smtClean="0"/>
-              <a:t>10/3/2026</a:t>
+              <a:t>10/4/2026</a:t>
             </a:fld>
             <a:endParaRPr lang="en-US"/>
           </a:p>
@@ -11407,7 +11647,7 @@
           <a:bodyPr/>
           <a:lstStyle/>
           <a:p>
-            <a:fld id="{C8D4D1C8-8C5D-4FFA-950C-FD08A0718FA9}" type="slidenum">
+            <a:fld id="{7293683F-31E2-46C4-A5EC-E1CFD9E8730E}" type="slidenum">
               <a:rPr lang="en-US" smtClean="0"/>
               <a:t>‹#›</a:t>
             </a:fld>
@@ -11420,7 +11660,7 @@
           <p:cNvPr id="6" name="body">
             <a:extLst>
               <a:ext uri="{FF2B5EF4-FFF2-40B4-BE49-F238E27FC236}">
-                <a16:creationId xmlns:a16="http://schemas.microsoft.com/office/drawing/2014/main" id="{48913B7D-6B6C-E6CF-172F-95EDB69588C3}"/>
+                <a16:creationId xmlns:a16="http://schemas.microsoft.com/office/drawing/2014/main" id="{E6D3E776-3CDE-515C-DDE6-B60A7B50D27C}"/>
               </a:ext>
             </a:extLst>
           </p:cNvPr>
@@ -11460,7 +11700,7 @@
           <p:cNvPr id="7" name="quote">
             <a:extLst>
               <a:ext uri="{FF2B5EF4-FFF2-40B4-BE49-F238E27FC236}">
-                <a16:creationId xmlns:a16="http://schemas.microsoft.com/office/drawing/2014/main" id="{2FB0F04F-142D-9AD5-5DEC-DB191761ECD8}"/>
+                <a16:creationId xmlns:a16="http://schemas.microsoft.com/office/drawing/2014/main" id="{4F1A4B14-4255-D5DC-3261-6FB609BA82A8}"/>
               </a:ext>
             </a:extLst>
           </p:cNvPr>
@@ -11510,7 +11750,7 @@
           <p:cNvPr id="8" name="attribution">
             <a:extLst>
               <a:ext uri="{FF2B5EF4-FFF2-40B4-BE49-F238E27FC236}">
-                <a16:creationId xmlns:a16="http://schemas.microsoft.com/office/drawing/2014/main" id="{7AF60576-D5AA-7D61-9C62-2454ED46A390}"/>
+                <a16:creationId xmlns:a16="http://schemas.microsoft.com/office/drawing/2014/main" id="{B3CBFB2B-52F9-9662-05AD-95CF098FB2E3}"/>
               </a:ext>
             </a:extLst>
           </p:cNvPr>
@@ -11558,7 +11798,7 @@
           <p:cNvPr id="9" name="source">
             <a:extLst>
               <a:ext uri="{FF2B5EF4-FFF2-40B4-BE49-F238E27FC236}">
-                <a16:creationId xmlns:a16="http://schemas.microsoft.com/office/drawing/2014/main" id="{CD69D0E2-2BD0-800B-FCF2-89D055B55C41}"/>
+                <a16:creationId xmlns:a16="http://schemas.microsoft.com/office/drawing/2014/main" id="{B05FE362-9CAC-7910-0BA1-44D43634AC14}"/>
               </a:ext>
             </a:extLst>
           </p:cNvPr>
@@ -11580,7 +11820,10 @@
             </a:avLst>
           </a:prstGeom>
           <a:solidFill>
-            <a:schemeClr val="accent1"/>
+            <a:schemeClr val="accent1">
+              <a:lumMod val="70000"/>
+              <a:lumOff val="30000"/>
+            </a:schemeClr>
           </a:solidFill>
         </p:spPr>
         <p:txBody>
@@ -11613,7 +11856,7 @@
     </p:spTree>
     <p:extLst>
       <p:ext uri="{BB962C8B-B14F-4D97-AF65-F5344CB8AC3E}">
-        <p14:creationId xmlns:p14="http://schemas.microsoft.com/office/powerpoint/2010/main" val="354886383"/>
+        <p14:creationId xmlns:p14="http://schemas.microsoft.com/office/powerpoint/2010/main" val="3835575344"/>
       </p:ext>
     </p:extLst>
   </p:cSld>
@@ -11687,9 +11930,9 @@
           <a:bodyPr/>
           <a:lstStyle/>
           <a:p>
-            <a:fld id="{26B7F381-F10E-4587-B886-8036B7268BA3}" type="datetimeFigureOut">
+            <a:fld id="{4A588302-F725-4E0D-AD75-D9B0BA2EF836}" type="datetimeFigureOut">
               <a:rPr lang="en-US" smtClean="0"/>
-              <a:t>10/3/2026</a:t>
+              <a:t>10/4/2026</a:t>
             </a:fld>
             <a:endParaRPr lang="en-US"/>
           </a:p>
@@ -11729,7 +11972,7 @@
           <a:bodyPr/>
           <a:lstStyle/>
           <a:p>
-            <a:fld id="{C8D4D1C8-8C5D-4FFA-950C-FD08A0718FA9}" type="slidenum">
+            <a:fld id="{7293683F-31E2-46C4-A5EC-E1CFD9E8730E}" type="slidenum">
               <a:rPr lang="en-US" smtClean="0"/>
               <a:t>‹#›</a:t>
             </a:fld>
@@ -11742,7 +11985,7 @@
           <p:cNvPr id="6" name="item_1_title">
             <a:extLst>
               <a:ext uri="{FF2B5EF4-FFF2-40B4-BE49-F238E27FC236}">
-                <a16:creationId xmlns:a16="http://schemas.microsoft.com/office/drawing/2014/main" id="{733F5616-4C7D-D196-7842-FF5137393441}"/>
+                <a16:creationId xmlns:a16="http://schemas.microsoft.com/office/drawing/2014/main" id="{A64C5502-B90E-065D-3C48-905CDD48C23B}"/>
               </a:ext>
             </a:extLst>
           </p:cNvPr>
@@ -11772,7 +12015,10 @@
               <a:buNone/>
               <a:defRPr sz="2000" b="1">
                 <a:solidFill>
-                  <a:schemeClr val="accent1"/>
+                  <a:schemeClr val="accent1">
+                    <a:lumMod val="70000"/>
+                    <a:lumOff val="30000"/>
+                  </a:schemeClr>
                 </a:solidFill>
                 <a:latin typeface="+mj-lt"/>
               </a:defRPr>
@@ -11792,7 +12038,7 @@
           <p:cNvPr id="7" name="item_1">
             <a:extLst>
               <a:ext uri="{FF2B5EF4-FFF2-40B4-BE49-F238E27FC236}">
-                <a16:creationId xmlns:a16="http://schemas.microsoft.com/office/drawing/2014/main" id="{BBD9CF87-263F-6AAC-19F4-5B46AEE0EDE9}"/>
+                <a16:creationId xmlns:a16="http://schemas.microsoft.com/office/drawing/2014/main" id="{A0A6A0E0-2B6B-219A-8110-EF96699F7676}"/>
               </a:ext>
             </a:extLst>
           </p:cNvPr>
@@ -11840,7 +12086,7 @@
           <p:cNvPr id="8" name="item_2_title">
             <a:extLst>
               <a:ext uri="{FF2B5EF4-FFF2-40B4-BE49-F238E27FC236}">
-                <a16:creationId xmlns:a16="http://schemas.microsoft.com/office/drawing/2014/main" id="{DD31341B-0A4B-7C33-054F-D524D383C4E8}"/>
+                <a16:creationId xmlns:a16="http://schemas.microsoft.com/office/drawing/2014/main" id="{B2D04CEE-F581-B8AD-1DDC-67E936FC06F9}"/>
               </a:ext>
             </a:extLst>
           </p:cNvPr>
@@ -11873,7 +12119,10 @@
               <a:buNone/>
               <a:defRPr sz="2000" b="1">
                 <a:solidFill>
-                  <a:schemeClr val="accent1"/>
+                  <a:schemeClr val="accent1">
+                    <a:lumMod val="70000"/>
+                    <a:lumOff val="30000"/>
+                  </a:schemeClr>
                 </a:solidFill>
                 <a:latin typeface="+mj-lt"/>
               </a:defRPr>
@@ -11893,7 +12142,7 @@
           <p:cNvPr id="9" name="item_2">
             <a:extLst>
               <a:ext uri="{FF2B5EF4-FFF2-40B4-BE49-F238E27FC236}">
-                <a16:creationId xmlns:a16="http://schemas.microsoft.com/office/drawing/2014/main" id="{E56C6F0D-0F8D-8E95-EE25-BCF49DD6541A}"/>
+                <a16:creationId xmlns:a16="http://schemas.microsoft.com/office/drawing/2014/main" id="{6CE38689-E09C-6402-6DCD-AA7F4BB407C5}"/>
               </a:ext>
             </a:extLst>
           </p:cNvPr>
@@ -11941,7 +12190,7 @@
           <p:cNvPr id="10" name="item_3_title">
             <a:extLst>
               <a:ext uri="{FF2B5EF4-FFF2-40B4-BE49-F238E27FC236}">
-                <a16:creationId xmlns:a16="http://schemas.microsoft.com/office/drawing/2014/main" id="{E5FA44D2-A718-7CBA-0E74-BB3752668DB0}"/>
+                <a16:creationId xmlns:a16="http://schemas.microsoft.com/office/drawing/2014/main" id="{2838A631-C0C8-D056-201B-8A2DB1FE0E48}"/>
               </a:ext>
             </a:extLst>
           </p:cNvPr>
@@ -11954,7 +12203,7 @@
         </p:nvSpPr>
         <p:spPr>
           <a:xfrm>
-            <a:off x="6680306" y="2339424"/>
+            <a:off x="6680307" y="2339424"/>
             <a:ext cx="2439396" cy="909206"/>
           </a:xfrm>
           <a:prstGeom prst="rect">
@@ -11974,7 +12223,10 @@
               <a:buNone/>
               <a:defRPr sz="2000" b="1">
                 <a:solidFill>
-                  <a:schemeClr val="accent1"/>
+                  <a:schemeClr val="accent1">
+                    <a:lumMod val="70000"/>
+                    <a:lumOff val="30000"/>
+                  </a:schemeClr>
                 </a:solidFill>
                 <a:latin typeface="+mj-lt"/>
               </a:defRPr>
@@ -11994,7 +12246,7 @@
           <p:cNvPr id="11" name="item_3">
             <a:extLst>
               <a:ext uri="{FF2B5EF4-FFF2-40B4-BE49-F238E27FC236}">
-                <a16:creationId xmlns:a16="http://schemas.microsoft.com/office/drawing/2014/main" id="{3D7BFF9A-B511-3472-2C80-D80260AA324F}"/>
+                <a16:creationId xmlns:a16="http://schemas.microsoft.com/office/drawing/2014/main" id="{DF5C8BA8-C002-6376-776E-F45B102C9E1B}"/>
               </a:ext>
             </a:extLst>
           </p:cNvPr>
@@ -12007,7 +12259,7 @@
         </p:nvSpPr>
         <p:spPr>
           <a:xfrm>
-            <a:off x="6680306" y="3248632"/>
+            <a:off x="6680307" y="3248632"/>
             <a:ext cx="2439396" cy="2182095"/>
           </a:xfrm>
           <a:prstGeom prst="rect">
@@ -12042,7 +12294,7 @@
           <p:cNvPr id="12" name="source">
             <a:extLst>
               <a:ext uri="{FF2B5EF4-FFF2-40B4-BE49-F238E27FC236}">
-                <a16:creationId xmlns:a16="http://schemas.microsoft.com/office/drawing/2014/main" id="{0C1B152B-8377-DCB4-8F93-09FBCBB7E080}"/>
+                <a16:creationId xmlns:a16="http://schemas.microsoft.com/office/drawing/2014/main" id="{10CFB050-CFAE-FD39-8AA7-53A0AE6ADE9A}"/>
               </a:ext>
             </a:extLst>
           </p:cNvPr>
@@ -12064,7 +12316,10 @@
             </a:avLst>
           </a:prstGeom>
           <a:solidFill>
-            <a:schemeClr val="accent1"/>
+            <a:schemeClr val="accent1">
+              <a:lumMod val="70000"/>
+              <a:lumOff val="30000"/>
+            </a:schemeClr>
           </a:solidFill>
         </p:spPr>
         <p:txBody>
@@ -12097,7 +12352,7 @@
     </p:spTree>
     <p:extLst>
       <p:ext uri="{BB962C8B-B14F-4D97-AF65-F5344CB8AC3E}">
-        <p14:creationId xmlns:p14="http://schemas.microsoft.com/office/powerpoint/2010/main" val="7822430"/>
+        <p14:creationId xmlns:p14="http://schemas.microsoft.com/office/powerpoint/2010/main" val="2121949333"/>
       </p:ext>
     </p:extLst>
   </p:cSld>
@@ -12171,9 +12426,9 @@
           <a:bodyPr/>
           <a:lstStyle/>
           <a:p>
-            <a:fld id="{26B7F381-F10E-4587-B886-8036B7268BA3}" type="datetimeFigureOut">
+            <a:fld id="{4A588302-F725-4E0D-AD75-D9B0BA2EF836}" type="datetimeFigureOut">
               <a:rPr lang="en-US" smtClean="0"/>
-              <a:t>10/3/2026</a:t>
+              <a:t>10/4/2026</a:t>
             </a:fld>
             <a:endParaRPr lang="en-US"/>
           </a:p>
@@ -12213,7 +12468,7 @@
           <a:bodyPr/>
           <a:lstStyle/>
           <a:p>
-            <a:fld id="{C8D4D1C8-8C5D-4FFA-950C-FD08A0718FA9}" type="slidenum">
+            <a:fld id="{7293683F-31E2-46C4-A5EC-E1CFD9E8730E}" type="slidenum">
               <a:rPr lang="en-US" smtClean="0"/>
               <a:t>‹#›</a:t>
             </a:fld>
@@ -12226,7 +12481,7 @@
           <p:cNvPr id="6" name="item_1_title">
             <a:extLst>
               <a:ext uri="{FF2B5EF4-FFF2-40B4-BE49-F238E27FC236}">
-                <a16:creationId xmlns:a16="http://schemas.microsoft.com/office/drawing/2014/main" id="{5871EA8D-4CAA-008D-8F55-F60EDAF588A9}"/>
+                <a16:creationId xmlns:a16="http://schemas.microsoft.com/office/drawing/2014/main" id="{6A8F246C-56E0-3844-0BEA-BEA7267A7CDC}"/>
               </a:ext>
             </a:extLst>
           </p:cNvPr>
@@ -12256,7 +12511,10 @@
               <a:buNone/>
               <a:defRPr sz="2000" b="1">
                 <a:solidFill>
-                  <a:schemeClr val="accent1"/>
+                  <a:schemeClr val="accent1">
+                    <a:lumMod val="70000"/>
+                    <a:lumOff val="30000"/>
+                  </a:schemeClr>
                 </a:solidFill>
                 <a:latin typeface="+mj-lt"/>
               </a:defRPr>
@@ -12276,7 +12534,7 @@
           <p:cNvPr id="7" name="item_1">
             <a:extLst>
               <a:ext uri="{FF2B5EF4-FFF2-40B4-BE49-F238E27FC236}">
-                <a16:creationId xmlns:a16="http://schemas.microsoft.com/office/drawing/2014/main" id="{F44961D4-CEB4-97E1-5A00-511E7857BF37}"/>
+                <a16:creationId xmlns:a16="http://schemas.microsoft.com/office/drawing/2014/main" id="{B224B50D-F245-CBAE-279B-5218C4F7BF17}"/>
               </a:ext>
             </a:extLst>
           </p:cNvPr>
@@ -12324,7 +12582,7 @@
           <p:cNvPr id="8" name="item_2_title">
             <a:extLst>
               <a:ext uri="{FF2B5EF4-FFF2-40B4-BE49-F238E27FC236}">
-                <a16:creationId xmlns:a16="http://schemas.microsoft.com/office/drawing/2014/main" id="{CAB6CB27-A985-665D-A147-CE2280888685}"/>
+                <a16:creationId xmlns:a16="http://schemas.microsoft.com/office/drawing/2014/main" id="{612B7A64-A1ED-DA2D-3AD9-E4F981E43845}"/>
               </a:ext>
             </a:extLst>
           </p:cNvPr>
@@ -12357,7 +12615,10 @@
               <a:buNone/>
               <a:defRPr sz="2000" b="1">
                 <a:solidFill>
-                  <a:schemeClr val="accent1"/>
+                  <a:schemeClr val="accent1">
+                    <a:lumMod val="70000"/>
+                    <a:lumOff val="30000"/>
+                  </a:schemeClr>
                 </a:solidFill>
                 <a:latin typeface="+mj-lt"/>
               </a:defRPr>
@@ -12377,7 +12638,7 @@
           <p:cNvPr id="9" name="item_2">
             <a:extLst>
               <a:ext uri="{FF2B5EF4-FFF2-40B4-BE49-F238E27FC236}">
-                <a16:creationId xmlns:a16="http://schemas.microsoft.com/office/drawing/2014/main" id="{1FBA00A4-AC4E-D4E8-73EC-CEFE3762F40C}"/>
+                <a16:creationId xmlns:a16="http://schemas.microsoft.com/office/drawing/2014/main" id="{1BEE4174-F490-12E0-F8FC-E94C2D5CB1AF}"/>
               </a:ext>
             </a:extLst>
           </p:cNvPr>
@@ -12425,7 +12686,7 @@
           <p:cNvPr id="10" name="source">
             <a:extLst>
               <a:ext uri="{FF2B5EF4-FFF2-40B4-BE49-F238E27FC236}">
-                <a16:creationId xmlns:a16="http://schemas.microsoft.com/office/drawing/2014/main" id="{FFB57355-4750-10EA-0F44-8115A6B4C312}"/>
+                <a16:creationId xmlns:a16="http://schemas.microsoft.com/office/drawing/2014/main" id="{0E4DBF7B-97EE-6746-92CE-00AE24D2BCD5}"/>
               </a:ext>
             </a:extLst>
           </p:cNvPr>
@@ -12447,7 +12708,10 @@
             </a:avLst>
           </a:prstGeom>
           <a:solidFill>
-            <a:schemeClr val="accent1"/>
+            <a:schemeClr val="accent1">
+              <a:lumMod val="70000"/>
+              <a:lumOff val="30000"/>
+            </a:schemeClr>
           </a:solidFill>
         </p:spPr>
         <p:txBody>
@@ -12480,7 +12744,7 @@
     </p:spTree>
     <p:extLst>
       <p:ext uri="{BB962C8B-B14F-4D97-AF65-F5344CB8AC3E}">
-        <p14:creationId xmlns:p14="http://schemas.microsoft.com/office/powerpoint/2010/main" val="53766075"/>
+        <p14:creationId xmlns:p14="http://schemas.microsoft.com/office/powerpoint/2010/main" val="1684775254"/>
       </p:ext>
     </p:extLst>
   </p:cSld>
@@ -12554,9 +12818,9 @@
           <a:bodyPr/>
           <a:lstStyle/>
           <a:p>
-            <a:fld id="{26B7F381-F10E-4587-B886-8036B7268BA3}" type="datetimeFigureOut">
+            <a:fld id="{4A588302-F725-4E0D-AD75-D9B0BA2EF836}" type="datetimeFigureOut">
               <a:rPr lang="en-US" smtClean="0"/>
-              <a:t>10/3/2026</a:t>
+              <a:t>10/4/2026</a:t>
             </a:fld>
             <a:endParaRPr lang="en-US"/>
           </a:p>
@@ -12596,7 +12860,7 @@
           <a:bodyPr/>
           <a:lstStyle/>
           <a:p>
-            <a:fld id="{C8D4D1C8-8C5D-4FFA-950C-FD08A0718FA9}" type="slidenum">
+            <a:fld id="{7293683F-31E2-46C4-A5EC-E1CFD9E8730E}" type="slidenum">
               <a:rPr lang="en-US" smtClean="0"/>
               <a:t>‹#›</a:t>
             </a:fld>
@@ -12609,7 +12873,7 @@
           <p:cNvPr id="6" name="chart">
             <a:extLst>
               <a:ext uri="{FF2B5EF4-FFF2-40B4-BE49-F238E27FC236}">
-                <a16:creationId xmlns:a16="http://schemas.microsoft.com/office/drawing/2014/main" id="{C4DBBCEF-F1E9-6E0B-10F1-15DF2CFEA6FF}"/>
+                <a16:creationId xmlns:a16="http://schemas.microsoft.com/office/drawing/2014/main" id="{CB7101A4-0092-D61F-C054-14B7DF496134}"/>
               </a:ext>
             </a:extLst>
           </p:cNvPr>
@@ -12639,7 +12903,7 @@
           <p:cNvPr id="7" name="body">
             <a:extLst>
               <a:ext uri="{FF2B5EF4-FFF2-40B4-BE49-F238E27FC236}">
-                <a16:creationId xmlns:a16="http://schemas.microsoft.com/office/drawing/2014/main" id="{607A6861-D515-63C2-F921-341152BB7E79}"/>
+                <a16:creationId xmlns:a16="http://schemas.microsoft.com/office/drawing/2014/main" id="{3AA28652-2A2D-1211-3D94-EB67AFEA31CC}"/>
               </a:ext>
             </a:extLst>
           </p:cNvPr>
@@ -12682,7 +12946,7 @@
           <p:cNvPr id="8" name="source">
             <a:extLst>
               <a:ext uri="{FF2B5EF4-FFF2-40B4-BE49-F238E27FC236}">
-                <a16:creationId xmlns:a16="http://schemas.microsoft.com/office/drawing/2014/main" id="{10D0D055-2213-86BD-5DE9-6DBBF0C70C22}"/>
+                <a16:creationId xmlns:a16="http://schemas.microsoft.com/office/drawing/2014/main" id="{FEBF0405-F911-9DF0-5D0F-A8320AB33FD1}"/>
               </a:ext>
             </a:extLst>
           </p:cNvPr>
@@ -12704,7 +12968,10 @@
             </a:avLst>
           </a:prstGeom>
           <a:solidFill>
-            <a:schemeClr val="accent1"/>
+            <a:schemeClr val="accent1">
+              <a:lumMod val="70000"/>
+              <a:lumOff val="30000"/>
+            </a:schemeClr>
           </a:solidFill>
         </p:spPr>
         <p:txBody>
@@ -12737,7 +13004,7 @@
     </p:spTree>
     <p:extLst>
       <p:ext uri="{BB962C8B-B14F-4D97-AF65-F5344CB8AC3E}">
-        <p14:creationId xmlns:p14="http://schemas.microsoft.com/office/powerpoint/2010/main" val="1205430755"/>
+        <p14:creationId xmlns:p14="http://schemas.microsoft.com/office/powerpoint/2010/main" val="427987081"/>
       </p:ext>
     </p:extLst>
   </p:cSld>
@@ -12811,9 +13078,9 @@
           <a:bodyPr/>
           <a:lstStyle/>
           <a:p>
-            <a:fld id="{26B7F381-F10E-4587-B886-8036B7268BA3}" type="datetimeFigureOut">
+            <a:fld id="{4A588302-F725-4E0D-AD75-D9B0BA2EF836}" type="datetimeFigureOut">
               <a:rPr lang="en-US" smtClean="0"/>
-              <a:t>10/3/2026</a:t>
+              <a:t>10/4/2026</a:t>
             </a:fld>
             <a:endParaRPr lang="en-US"/>
           </a:p>
@@ -12853,7 +13120,7 @@
           <a:bodyPr/>
           <a:lstStyle/>
           <a:p>
-            <a:fld id="{C8D4D1C8-8C5D-4FFA-950C-FD08A0718FA9}" type="slidenum">
+            <a:fld id="{7293683F-31E2-46C4-A5EC-E1CFD9E8730E}" type="slidenum">
               <a:rPr lang="en-US" smtClean="0"/>
               <a:t>‹#›</a:t>
             </a:fld>
@@ -12866,7 +13133,7 @@
           <p:cNvPr id="6" name="item_1_title">
             <a:extLst>
               <a:ext uri="{FF2B5EF4-FFF2-40B4-BE49-F238E27FC236}">
-                <a16:creationId xmlns:a16="http://schemas.microsoft.com/office/drawing/2014/main" id="{680394A1-C191-643A-7607-A416EF25ABBF}"/>
+                <a16:creationId xmlns:a16="http://schemas.microsoft.com/office/drawing/2014/main" id="{24B1CF45-48FA-F0B1-F7AF-69F6356D9A3D}"/>
               </a:ext>
             </a:extLst>
           </p:cNvPr>
@@ -12896,7 +13163,10 @@
               <a:buNone/>
               <a:defRPr sz="2000" b="1">
                 <a:solidFill>
-                  <a:schemeClr val="accent1"/>
+                  <a:schemeClr val="accent1">
+                    <a:lumMod val="70000"/>
+                    <a:lumOff val="30000"/>
+                  </a:schemeClr>
                 </a:solidFill>
                 <a:latin typeface="+mj-lt"/>
               </a:defRPr>
@@ -12916,7 +13186,7 @@
           <p:cNvPr id="7" name="item_1">
             <a:extLst>
               <a:ext uri="{FF2B5EF4-FFF2-40B4-BE49-F238E27FC236}">
-                <a16:creationId xmlns:a16="http://schemas.microsoft.com/office/drawing/2014/main" id="{0932471A-14ED-8F68-F724-AA0333B07585}"/>
+                <a16:creationId xmlns:a16="http://schemas.microsoft.com/office/drawing/2014/main" id="{D8203FF8-6DE9-EAC8-5170-36CEE6BA80BA}"/>
               </a:ext>
             </a:extLst>
           </p:cNvPr>
@@ -12964,7 +13234,7 @@
           <p:cNvPr id="8" name="item_2_title">
             <a:extLst>
               <a:ext uri="{FF2B5EF4-FFF2-40B4-BE49-F238E27FC236}">
-                <a16:creationId xmlns:a16="http://schemas.microsoft.com/office/drawing/2014/main" id="{4C0CC2CA-8E00-7CC4-0CC8-65722B131508}"/>
+                <a16:creationId xmlns:a16="http://schemas.microsoft.com/office/drawing/2014/main" id="{4C727235-E93B-9734-B2CB-2793669D7E1E}"/>
               </a:ext>
             </a:extLst>
           </p:cNvPr>
@@ -12997,7 +13267,10 @@
               <a:buNone/>
               <a:defRPr sz="2000" b="1">
                 <a:solidFill>
-                  <a:schemeClr val="accent1"/>
+                  <a:schemeClr val="accent1">
+                    <a:lumMod val="70000"/>
+                    <a:lumOff val="30000"/>
+                  </a:schemeClr>
                 </a:solidFill>
                 <a:latin typeface="+mj-lt"/>
               </a:defRPr>
@@ -13017,7 +13290,7 @@
           <p:cNvPr id="9" name="item_2">
             <a:extLst>
               <a:ext uri="{FF2B5EF4-FFF2-40B4-BE49-F238E27FC236}">
-                <a16:creationId xmlns:a16="http://schemas.microsoft.com/office/drawing/2014/main" id="{14A74B9F-F7BE-8776-4C8C-D94E5DAB0C4E}"/>
+                <a16:creationId xmlns:a16="http://schemas.microsoft.com/office/drawing/2014/main" id="{B3F31011-3BFB-1965-F108-8183CCD16440}"/>
               </a:ext>
             </a:extLst>
           </p:cNvPr>
@@ -13065,7 +13338,7 @@
           <p:cNvPr id="10" name="item_3_title">
             <a:extLst>
               <a:ext uri="{FF2B5EF4-FFF2-40B4-BE49-F238E27FC236}">
-                <a16:creationId xmlns:a16="http://schemas.microsoft.com/office/drawing/2014/main" id="{8A85D9F6-6293-A2F7-06FD-1CFDA67C9A58}"/>
+                <a16:creationId xmlns:a16="http://schemas.microsoft.com/office/drawing/2014/main" id="{AF1579B0-FEFD-E356-2EC5-6E7ADBD0D3F3}"/>
               </a:ext>
             </a:extLst>
           </p:cNvPr>
@@ -13098,7 +13371,10 @@
               <a:buNone/>
               <a:defRPr sz="2000" b="1">
                 <a:solidFill>
-                  <a:schemeClr val="accent1"/>
+                  <a:schemeClr val="accent1">
+                    <a:lumMod val="70000"/>
+                    <a:lumOff val="30000"/>
+                  </a:schemeClr>
                 </a:solidFill>
                 <a:latin typeface="+mj-lt"/>
               </a:defRPr>
@@ -13118,7 +13394,7 @@
           <p:cNvPr id="11" name="item_3">
             <a:extLst>
               <a:ext uri="{FF2B5EF4-FFF2-40B4-BE49-F238E27FC236}">
-                <a16:creationId xmlns:a16="http://schemas.microsoft.com/office/drawing/2014/main" id="{989A72AA-0A6F-A76B-A42A-DB911BC3F15C}"/>
+                <a16:creationId xmlns:a16="http://schemas.microsoft.com/office/drawing/2014/main" id="{B7E760E3-AED7-F17D-FB3D-27CDED57BF82}"/>
               </a:ext>
             </a:extLst>
           </p:cNvPr>
@@ -13166,7 +13442,7 @@
           <p:cNvPr id="12" name="item_4_title">
             <a:extLst>
               <a:ext uri="{FF2B5EF4-FFF2-40B4-BE49-F238E27FC236}">
-                <a16:creationId xmlns:a16="http://schemas.microsoft.com/office/drawing/2014/main" id="{77AA9CC8-5888-7BBA-61B4-639E57C24BD2}"/>
+                <a16:creationId xmlns:a16="http://schemas.microsoft.com/office/drawing/2014/main" id="{A6DA847E-2278-A3CF-2D1B-155F619F8AC9}"/>
               </a:ext>
             </a:extLst>
           </p:cNvPr>
@@ -13199,7 +13475,10 @@
               <a:buNone/>
               <a:defRPr sz="2000" b="1">
                 <a:solidFill>
-                  <a:schemeClr val="accent1"/>
+                  <a:schemeClr val="accent1">
+                    <a:lumMod val="70000"/>
+                    <a:lumOff val="30000"/>
+                  </a:schemeClr>
                 </a:solidFill>
                 <a:latin typeface="+mj-lt"/>
               </a:defRPr>
@@ -13219,7 +13498,7 @@
           <p:cNvPr id="13" name="item_4">
             <a:extLst>
               <a:ext uri="{FF2B5EF4-FFF2-40B4-BE49-F238E27FC236}">
-                <a16:creationId xmlns:a16="http://schemas.microsoft.com/office/drawing/2014/main" id="{F7A6C1E2-E499-83F7-2235-6BD13E8ADB3A}"/>
+                <a16:creationId xmlns:a16="http://schemas.microsoft.com/office/drawing/2014/main" id="{C705781C-90D7-B9C2-14CA-71464753C1AE}"/>
               </a:ext>
             </a:extLst>
           </p:cNvPr>
@@ -13267,7 +13546,7 @@
           <p:cNvPr id="14" name="source">
             <a:extLst>
               <a:ext uri="{FF2B5EF4-FFF2-40B4-BE49-F238E27FC236}">
-                <a16:creationId xmlns:a16="http://schemas.microsoft.com/office/drawing/2014/main" id="{D6988254-F148-0205-E006-86B59CAF54FE}"/>
+                <a16:creationId xmlns:a16="http://schemas.microsoft.com/office/drawing/2014/main" id="{107E23D1-C7B8-50E6-929B-3D8AFEE5E243}"/>
               </a:ext>
             </a:extLst>
           </p:cNvPr>
@@ -13289,7 +13568,10 @@
             </a:avLst>
           </a:prstGeom>
           <a:solidFill>
-            <a:schemeClr val="accent1"/>
+            <a:schemeClr val="accent1">
+              <a:lumMod val="70000"/>
+              <a:lumOff val="30000"/>
+            </a:schemeClr>
           </a:solidFill>
         </p:spPr>
         <p:txBody>
@@ -13322,7 +13604,7 @@
     </p:spTree>
     <p:extLst>
       <p:ext uri="{BB962C8B-B14F-4D97-AF65-F5344CB8AC3E}">
-        <p14:creationId xmlns:p14="http://schemas.microsoft.com/office/powerpoint/2010/main" val="2290125734"/>
+        <p14:creationId xmlns:p14="http://schemas.microsoft.com/office/powerpoint/2010/main" val="4253273725"/>
       </p:ext>
     </p:extLst>
   </p:cSld>
@@ -14014,9 +14296,9 @@
             </a:lvl1pPr>
           </a:lstStyle>
           <a:p>
-            <a:fld id="{26B7F381-F10E-4587-B886-8036B7268BA3}" type="datetimeFigureOut">
+            <a:fld id="{4A588302-F725-4E0D-AD75-D9B0BA2EF836}" type="datetimeFigureOut">
               <a:rPr lang="en-US" smtClean="0"/>
-              <a:t>10/3/2026</a:t>
+              <a:t>10/4/2026</a:t>
             </a:fld>
             <a:endParaRPr lang="en-US"/>
           </a:p>
@@ -14090,7 +14372,7 @@
             </a:lvl1pPr>
           </a:lstStyle>
           <a:p>
-            <a:fld id="{C8D4D1C8-8C5D-4FFA-950C-FD08A0718FA9}" type="slidenum">
+            <a:fld id="{7293683F-31E2-46C4-A5EC-E1CFD9E8730E}" type="slidenum">
               <a:rPr lang="en-US" smtClean="0"/>
               <a:t>‹#›</a:t>
             </a:fld>
@@ -14101,7 +14383,7 @@
     </p:spTree>
     <p:extLst>
       <p:ext uri="{BB962C8B-B14F-4D97-AF65-F5344CB8AC3E}">
-        <p14:creationId xmlns:p14="http://schemas.microsoft.com/office/powerpoint/2010/main" val="2016352715"/>
+        <p14:creationId xmlns:p14="http://schemas.microsoft.com/office/powerpoint/2010/main" val="313549687"/>
       </p:ext>
     </p:extLst>
   </p:cSld>

</xml_diff>